<commit_message>
Switch Q2/Q5/Q11 ranking methodology to simple top-3 selection %
Replaces the weighted Borda-style scoring (1st=3pts, 2nd=2pts, 3rd=1pt,
% of 600-point pool) with simple top-3 mention rates (% of respondents
who placed each option anywhere in their top 3) on the Q2 overall slide,
the Q2 Banking-vs-Insurance segment slide, Q5, and Q11.

Updates chart values, data label formats, and footnote methodology text
throughout, and revises finding statements where the new method changes
the story: Q5's top barrier flips from legal/privacy to data
standardization, and Q2's Banking segment becomes an exact tie between
onboarding/KYC and payment/wire.

Co-Authored-By: Claude Sonnet 5 <noreply@anthropic.com>
Claude-Session: https://claude.ai/code/session_01F6YKjZtdH33RrHLpCiLALg
</commit_message>
<xml_diff>
--- a/Fraud in 2026 - Full Results.pptx
+++ b/Fraud in 2026 - Full Results.pptx
@@ -2518,7 +2518,7 @@
           </c:spPr>
           <c:invertIfNegative val="0"/>
           <c:dLbls>
-            <c:numFmt formatCode="0.0&quot;%&quot;" sourceLinked="0"/>
+            <c:numFmt formatCode="0&quot;%&quot;" sourceLinked="0"/>
             <c:txPr>
               <a:bodyPr/>
               <a:lstStyle/>
@@ -2557,10 +2557,10 @@
                     <c:v>Payment innovation (RTP, stablecoins, agentic payments)</c:v>
                   </c:pt>
                   <c:pt idx="3">
-                    <c:v>AML modernization initiatives</c:v>
+                    <c:v>Liability &amp; reimbursement changes</c:v>
                   </c:pt>
                   <c:pt idx="4">
-                    <c:v>Liability &amp; reimbursement changes</c:v>
+                    <c:v>AML modernization initiatives</c:v>
                   </c:pt>
                   <c:pt idx="5">
                     <c:v>Open Banking / consumer-driven initiatives</c:v>
@@ -2576,29 +2576,29 @@
                 <c:formatCode>General</c:formatCode>
                 <c:ptCount val="6"/>
                 <c:pt idx="0">
-                  <c:v>25</c:v>
+                  <c:v>71</c:v>
                 </c:pt>
                 <c:pt idx="1">
-                  <c:v>21.8</c:v>
+                  <c:v>66</c:v>
                 </c:pt>
                 <c:pt idx="2">
-                  <c:v>20.5</c:v>
+                  <c:v>65</c:v>
                 </c:pt>
                 <c:pt idx="3">
-                  <c:v>11.2</c:v>
+                  <c:v>36</c:v>
                 </c:pt>
                 <c:pt idx="4">
-                  <c:v>10.8</c:v>
+                  <c:v>33</c:v>
                 </c:pt>
                 <c:pt idx="5">
-                  <c:v>10.7</c:v>
+                  <c:v>29</c:v>
                 </c:pt>
               </c:numCache>
             </c:numRef>
           </c:val>
         </c:ser>
         <c:dLbls>
-          <c:numFmt formatCode="0.0&quot;%&quot;" sourceLinked="0"/>
+          <c:numFmt formatCode="0&quot;%&quot;" sourceLinked="0"/>
           <c:txPr>
             <a:bodyPr/>
             <a:lstStyle/>
@@ -3123,7 +3123,7 @@
           </c:spPr>
           <c:invertIfNegative val="0"/>
           <c:dLbls>
-            <c:numFmt formatCode="0.0&quot;%&quot;" sourceLinked="0"/>
+            <c:numFmt formatCode="0&quot;%&quot;" sourceLinked="0"/>
             <c:txPr>
               <a:bodyPr/>
               <a:lstStyle/>
@@ -3181,29 +3181,29 @@
                 <c:formatCode>General</c:formatCode>
                 <c:ptCount val="6"/>
                 <c:pt idx="0">
-                  <c:v>25</c:v>
+                  <c:v>70</c:v>
                 </c:pt>
                 <c:pt idx="1">
-                  <c:v>20.8</c:v>
+                  <c:v>64</c:v>
                 </c:pt>
                 <c:pt idx="2">
-                  <c:v>18.7</c:v>
+                  <c:v>53</c:v>
                 </c:pt>
                 <c:pt idx="3">
-                  <c:v>17.3</c:v>
+                  <c:v>52</c:v>
                 </c:pt>
                 <c:pt idx="4">
-                  <c:v>12.8</c:v>
+                  <c:v>43</c:v>
                 </c:pt>
                 <c:pt idx="5">
-                  <c:v>4.3</c:v>
+                  <c:v>15</c:v>
                 </c:pt>
               </c:numCache>
             </c:numRef>
           </c:val>
         </c:ser>
         <c:dLbls>
-          <c:numFmt formatCode="0.0&quot;%&quot;" sourceLinked="0"/>
+          <c:numFmt formatCode="0&quot;%&quot;" sourceLinked="0"/>
           <c:txPr>
             <a:bodyPr/>
             <a:lstStyle/>
@@ -3368,7 +3368,7 @@
           </c:spPr>
           <c:invertIfNegative val="0"/>
           <c:dLbls>
-            <c:numFmt formatCode="0.0&quot;%&quot;" sourceLinked="0"/>
+            <c:numFmt formatCode="0&quot;%&quot;" sourceLinked="0"/>
             <c:txPr>
               <a:bodyPr/>
               <a:lstStyle/>
@@ -3426,29 +3426,29 @@
                 <c:formatCode>General</c:formatCode>
                 <c:ptCount val="6"/>
                 <c:pt idx="0">
-                  <c:v>28</c:v>
+                  <c:v>73</c:v>
                 </c:pt>
                 <c:pt idx="1">
-                  <c:v>24.7</c:v>
+                  <c:v>73</c:v>
                 </c:pt>
                 <c:pt idx="2">
-                  <c:v>17.1</c:v>
+                  <c:v>48</c:v>
                 </c:pt>
                 <c:pt idx="3">
-                  <c:v>14.4</c:v>
+                  <c:v>47</c:v>
                 </c:pt>
                 <c:pt idx="4">
-                  <c:v>10.7</c:v>
+                  <c:v>40</c:v>
                 </c:pt>
                 <c:pt idx="5">
-                  <c:v>3.8</c:v>
+                  <c:v>15</c:v>
                 </c:pt>
               </c:numCache>
             </c:numRef>
           </c:val>
         </c:ser>
         <c:dLbls>
-          <c:numFmt formatCode="0.0&quot;%&quot;" sourceLinked="0"/>
+          <c:numFmt formatCode="0&quot;%&quot;" sourceLinked="0"/>
           <c:txPr>
             <a:bodyPr/>
             <a:lstStyle/>
@@ -3613,7 +3613,7 @@
           </c:spPr>
           <c:invertIfNegative val="0"/>
           <c:dLbls>
-            <c:numFmt formatCode="0.0&quot;%&quot;" sourceLinked="0"/>
+            <c:numFmt formatCode="0&quot;%&quot;" sourceLinked="0"/>
             <c:txPr>
               <a:bodyPr/>
               <a:lstStyle/>
@@ -3671,29 +3671,29 @@
                 <c:formatCode>General</c:formatCode>
                 <c:ptCount val="6"/>
                 <c:pt idx="0">
-                  <c:v>26</c:v>
+                  <c:v>72</c:v>
                 </c:pt>
                 <c:pt idx="1">
-                  <c:v>23.3</c:v>
+                  <c:v>64</c:v>
                 </c:pt>
                 <c:pt idx="2">
-                  <c:v>19.3</c:v>
+                  <c:v>60</c:v>
                 </c:pt>
                 <c:pt idx="3">
-                  <c:v>16</c:v>
+                  <c:v>52</c:v>
                 </c:pt>
                 <c:pt idx="4">
-                  <c:v>9.3</c:v>
+                  <c:v>36</c:v>
                 </c:pt>
                 <c:pt idx="5">
-                  <c:v>6</c:v>
+                  <c:v>16</c:v>
                 </c:pt>
               </c:numCache>
             </c:numRef>
           </c:val>
         </c:ser>
         <c:dLbls>
-          <c:numFmt formatCode="0.0&quot;%&quot;" sourceLinked="0"/>
+          <c:numFmt formatCode="0&quot;%&quot;" sourceLinked="0"/>
           <c:txPr>
             <a:bodyPr/>
             <a:lstStyle/>
@@ -4427,7 +4427,7 @@
           </c:spPr>
           <c:invertIfNegative val="0"/>
           <c:dLbls>
-            <c:numFmt formatCode="0.0&quot;%&quot;" sourceLinked="0"/>
+            <c:numFmt formatCode="0&quot;%&quot;" sourceLinked="0"/>
             <c:txPr>
               <a:bodyPr/>
               <a:lstStyle/>
@@ -4457,10 +4457,10 @@
                 <c:ptCount val="6"/>
                 <c:lvl>
                   <c:pt idx="0">
-                    <c:v>Legal, privacy or regulatory constraints</c:v>
+                    <c:v>Limited data standardization &amp; poor quality</c:v>
                   </c:pt>
                   <c:pt idx="1">
-                    <c:v>Limited data standardization &amp; poor quality</c:v>
+                    <c:v>Legal, privacy or regulatory constraints</c:v>
                   </c:pt>
                   <c:pt idx="2">
                     <c:v>Lack of external industry participation</c:v>
@@ -4485,29 +4485,29 @@
                 <c:formatCode>General</c:formatCode>
                 <c:ptCount val="6"/>
                 <c:pt idx="0">
-                  <c:v>28.7</c:v>
+                  <c:v>77</c:v>
                 </c:pt>
                 <c:pt idx="1">
-                  <c:v>25</c:v>
+                  <c:v>73</c:v>
                 </c:pt>
                 <c:pt idx="2">
-                  <c:v>19.3</c:v>
+                  <c:v>60</c:v>
                 </c:pt>
                 <c:pt idx="3">
-                  <c:v>10.3</c:v>
+                  <c:v>36</c:v>
                 </c:pt>
                 <c:pt idx="4">
-                  <c:v>9</c:v>
+                  <c:v>27</c:v>
                 </c:pt>
                 <c:pt idx="5">
-                  <c:v>7.2</c:v>
+                  <c:v>26</c:v>
                 </c:pt>
               </c:numCache>
             </c:numRef>
           </c:val>
         </c:ser>
         <c:dLbls>
-          <c:numFmt formatCode="0.0&quot;%&quot;" sourceLinked="0"/>
+          <c:numFmt formatCode="0&quot;%&quot;" sourceLinked="0"/>
           <c:txPr>
             <a:bodyPr/>
             <a:lstStyle/>
@@ -8169,7 +8169,7 @@
                 <a:ea typeface="Calibri" pitchFamily="34" charset="-122"/>
                 <a:cs typeface="Calibri" pitchFamily="34" charset="-120"/>
               </a:rPr>
-              <a:t>What's blocking sharing is structural — legal rules and messy data — not unwillingness.</a:t>
+              <a:t>What's blocking sharing is structural — messy, inconsistent data even more than legal rules — not unwillingness.</a:t>
             </a:r>
             <a:endParaRPr lang="en-US" sz="1350" dirty="0"/>
           </a:p>
@@ -8371,7 +8371,7 @@
                 <a:ea typeface="Calibri" pitchFamily="34" charset="-122"/>
                 <a:cs typeface="Calibri" pitchFamily="34" charset="-120"/>
               </a:rPr>
-              <a:t>Ranked top 3, weighted Borda-style (1st=3pts, 2nd=2pts, 3rd=1pt), shown as % of the 600-point pool.  </a:t>
+              <a:t>Ranked top 3 — shown as % of respondents who placed the option anywhere in their top 3 (not mutually exclusive; bars don't sum to 100%).  </a:t>
             </a:r>
             <a:pPr algn="l" indent="0" marL="0">
               <a:lnSpc>
@@ -13601,7 +13601,7 @@
                 <a:ea typeface="Calibri" pitchFamily="34" charset="-122"/>
                 <a:cs typeface="Calibri" pitchFamily="34" charset="-120"/>
               </a:rPr>
-              <a:t>Ranked top 3, weighted Borda-style (1st=3pts, 2nd=2pts, 3rd=1pt), shown as % of the 600-point pool.  </a:t>
+              <a:t>Ranked top 3 — shown as % of respondents who placed the option anywhere in their top 3 (not mutually exclusive; bars don't sum to 100%).  </a:t>
             </a:r>
             <a:pPr algn="l" indent="0" marL="0">
               <a:lnSpc>
@@ -16132,7 +16132,7 @@
                 <a:ea typeface="Calibri" pitchFamily="34" charset="-122"/>
                 <a:cs typeface="Calibri" pitchFamily="34" charset="-120"/>
               </a:rPr>
-              <a:t>Ranked top 3, weighted Borda-style (1st=3pts, 2nd=2pts, 3rd=1pt), shown as % of the 600-point pool.  </a:t>
+              <a:t>Ranked top 3 — shown as % of respondents who placed the option anywhere in their top 3 (not mutually exclusive; bars don't sum to 100%).  </a:t>
             </a:r>
             <a:pPr algn="l" indent="0" marL="0">
               <a:lnSpc>
@@ -16449,7 +16449,7 @@
                 <a:ea typeface="Calibri" pitchFamily="34" charset="-122"/>
                 <a:cs typeface="Calibri" pitchFamily="34" charset="-120"/>
               </a:rPr>
-              <a:t>The overall #1 area masks a real split: Banking's top exposure is onboarding/KYC, but Insurance's is contact center and claims.</a:t>
+              <a:t>The overall #1 area masks a real split: Banking's top exposure is an exact tie between onboarding/KYC and payment/wire, while Insurance's is contact center and claims.</a:t>
             </a:r>
             <a:endParaRPr lang="en-US" sz="1350" dirty="0"/>
           </a:p>
@@ -16531,7 +16531,7 @@
                 <a:ea typeface="Calibri" pitchFamily="34" charset="-122"/>
                 <a:cs typeface="Calibri" pitchFamily="34" charset="-120"/>
               </a:rPr>
-              <a:t>“Which area of your organization has experienced the greatest increase in vulnerability to fraud enabled by deepfakes and other advanced or frontier AI capabilities over the past 12 months? (Banking vs. Insurance, weighted score)”</a:t>
+              <a:t>“Which area of your organization has experienced the greatest increase in vulnerability to fraud enabled by deepfakes and other advanced or frontier AI capabilities over the past 12 months? (Banking vs. Insurance, % selecting in top 3)”</a:t>
             </a:r>
             <a:endParaRPr lang="en-US" sz="1000" dirty="0"/>
           </a:p>
@@ -16744,7 +16744,7 @@
                 <a:ea typeface="Calibri" pitchFamily="34" charset="-122"/>
                 <a:cs typeface="Calibri" pitchFamily="34" charset="-120"/>
               </a:rPr>
-              <a:t>Each panel is sorted independently by its own weighted score. Values are % of that segment's own point pool (Banking = 450 pts, Insurance = 150 pts) — segments are not comparable in absolute points, only in rank order and share of their own pool.</a:t>
+              <a:t>Each panel is sorted independently. Values are % of that segment's respondents who placed the option anywhere in their top 3 (not mutually exclusive). Banking n=75, Insurance n=25 — bases differ, so compare rank order and share within each segment, not raw counts. Banking's top two areas are tied at 73%.</a:t>
             </a:r>
             <a:endParaRPr lang="en-US" sz="900" dirty="0"/>
           </a:p>

</xml_diff>

<commit_message>
Drop gray Other-markets bucket on Q3 sector x region slide
Insurance now uses the same region-to-color mapping as Banking
(United States, Canada, Europe, Australia, Singapore) instead of a
separate gray catch-all bucket. Regions with no reliable Insurance
sample (UK n=2, Australia n=1, Singapore n=0) are simply omitted
rather than lumped together.

Since that drops ~3 respondents' worth of data from the Insurance
bars, their stacked totals no longer equal the full-sample sector
percentages shown elsewhere (64%, 48%, 40%, 44%) — category labels
now say "US & Canada only" with the correct reduced total (56%, 44%,
36%, 40%) so the bar height matches its own label, and the footnote
spells out why.

Co-Authored-By: Claude Sonnet 5 <noreply@anthropic.com>
Claude-Session: https://claude.ai/code/session_01F6YKjZtdH33RrHLpCiLALg
</commit_message>
<xml_diff>
--- a/Fraud in 2026 - Full Results.pptx
+++ b/Fraud in 2026 - Full Results.pptx
@@ -4707,25 +4707,25 @@
                     <c:v>Staff awareness &amp; training — Banking (49%)</c:v>
                   </c:pt>
                   <c:pt idx="1">
-                    <c:v>Staff awareness &amp; training — Insurance (64%)</c:v>
+                    <c:v>Staff awareness &amp; training — Insurance (US &amp; Canada only, 56%)</c:v>
                   </c:pt>
                   <c:pt idx="2">
                     <c:v>ID verification / prevention — Banking (51%)</c:v>
                   </c:pt>
                   <c:pt idx="3">
-                    <c:v>ID verification / prevention — Insurance (48%)</c:v>
+                    <c:v>ID verification / prevention — Insurance (US &amp; Canada only, 44%)</c:v>
                   </c:pt>
                   <c:pt idx="4">
                     <c:v>Fraud detection technology — Banking (48%)</c:v>
                   </c:pt>
                   <c:pt idx="5">
-                    <c:v>Fraud detection technology — Insurance (40%)</c:v>
+                    <c:v>Fraud detection technology — Insurance (US &amp; Canada only, 36%)</c:v>
                   </c:pt>
                   <c:pt idx="6">
                     <c:v>3rd-party intel / consortium — Banking (43%)</c:v>
                   </c:pt>
                   <c:pt idx="7">
-                    <c:v>3rd-party intel / consortium — Insurance (44%)</c:v>
+                    <c:v>3rd-party intel / consortium — Insurance (US &amp; Canada only, 40%)</c:v>
                   </c:pt>
                 </c:lvl>
               </c:multiLvlStrCache>
@@ -4821,25 +4821,25 @@
                     <c:v>Staff awareness &amp; training — Banking (49%)</c:v>
                   </c:pt>
                   <c:pt idx="1">
-                    <c:v>Staff awareness &amp; training — Insurance (64%)</c:v>
+                    <c:v>Staff awareness &amp; training — Insurance (US &amp; Canada only, 56%)</c:v>
                   </c:pt>
                   <c:pt idx="2">
                     <c:v>ID verification / prevention — Banking (51%)</c:v>
                   </c:pt>
                   <c:pt idx="3">
-                    <c:v>ID verification / prevention — Insurance (48%)</c:v>
+                    <c:v>ID verification / prevention — Insurance (US &amp; Canada only, 44%)</c:v>
                   </c:pt>
                   <c:pt idx="4">
                     <c:v>Fraud detection technology — Banking (48%)</c:v>
                   </c:pt>
                   <c:pt idx="5">
-                    <c:v>Fraud detection technology — Insurance (40%)</c:v>
+                    <c:v>Fraud detection technology — Insurance (US &amp; Canada only, 36%)</c:v>
                   </c:pt>
                   <c:pt idx="6">
                     <c:v>3rd-party intel / consortium — Banking (43%)</c:v>
                   </c:pt>
                   <c:pt idx="7">
-                    <c:v>3rd-party intel / consortium — Insurance (44%)</c:v>
+                    <c:v>3rd-party intel / consortium — Insurance (US &amp; Canada only, 40%)</c:v>
                   </c:pt>
                 </c:lvl>
               </c:multiLvlStrCache>
@@ -4935,25 +4935,25 @@
                     <c:v>Staff awareness &amp; training — Banking (49%)</c:v>
                   </c:pt>
                   <c:pt idx="1">
-                    <c:v>Staff awareness &amp; training — Insurance (64%)</c:v>
+                    <c:v>Staff awareness &amp; training — Insurance (US &amp; Canada only, 56%)</c:v>
                   </c:pt>
                   <c:pt idx="2">
                     <c:v>ID verification / prevention — Banking (51%)</c:v>
                   </c:pt>
                   <c:pt idx="3">
-                    <c:v>ID verification / prevention — Insurance (48%)</c:v>
+                    <c:v>ID verification / prevention — Insurance (US &amp; Canada only, 44%)</c:v>
                   </c:pt>
                   <c:pt idx="4">
                     <c:v>Fraud detection technology — Banking (48%)</c:v>
                   </c:pt>
                   <c:pt idx="5">
-                    <c:v>Fraud detection technology — Insurance (40%)</c:v>
+                    <c:v>Fraud detection technology — Insurance (US &amp; Canada only, 36%)</c:v>
                   </c:pt>
                   <c:pt idx="6">
                     <c:v>3rd-party intel / consortium — Banking (43%)</c:v>
                   </c:pt>
                   <c:pt idx="7">
-                    <c:v>3rd-party intel / consortium — Insurance (44%)</c:v>
+                    <c:v>3rd-party intel / consortium — Insurance (US &amp; Canada only, 40%)</c:v>
                   </c:pt>
                 </c:lvl>
               </c:multiLvlStrCache>
@@ -5049,25 +5049,25 @@
                     <c:v>Staff awareness &amp; training — Banking (49%)</c:v>
                   </c:pt>
                   <c:pt idx="1">
-                    <c:v>Staff awareness &amp; training — Insurance (64%)</c:v>
+                    <c:v>Staff awareness &amp; training — Insurance (US &amp; Canada only, 56%)</c:v>
                   </c:pt>
                   <c:pt idx="2">
                     <c:v>ID verification / prevention — Banking (51%)</c:v>
                   </c:pt>
                   <c:pt idx="3">
-                    <c:v>ID verification / prevention — Insurance (48%)</c:v>
+                    <c:v>ID verification / prevention — Insurance (US &amp; Canada only, 44%)</c:v>
                   </c:pt>
                   <c:pt idx="4">
                     <c:v>Fraud detection technology — Banking (48%)</c:v>
                   </c:pt>
                   <c:pt idx="5">
-                    <c:v>Fraud detection technology — Insurance (40%)</c:v>
+                    <c:v>Fraud detection technology — Insurance (US &amp; Canada only, 36%)</c:v>
                   </c:pt>
                   <c:pt idx="6">
                     <c:v>3rd-party intel / consortium — Banking (43%)</c:v>
                   </c:pt>
                   <c:pt idx="7">
-                    <c:v>3rd-party intel / consortium — Insurance (44%)</c:v>
+                    <c:v>3rd-party intel / consortium — Insurance (US &amp; Canada only, 40%)</c:v>
                   </c:pt>
                 </c:lvl>
               </c:multiLvlStrCache>
@@ -5163,25 +5163,25 @@
                     <c:v>Staff awareness &amp; training — Banking (49%)</c:v>
                   </c:pt>
                   <c:pt idx="1">
-                    <c:v>Staff awareness &amp; training — Insurance (64%)</c:v>
+                    <c:v>Staff awareness &amp; training — Insurance (US &amp; Canada only, 56%)</c:v>
                   </c:pt>
                   <c:pt idx="2">
                     <c:v>ID verification / prevention — Banking (51%)</c:v>
                   </c:pt>
                   <c:pt idx="3">
-                    <c:v>ID verification / prevention — Insurance (48%)</c:v>
+                    <c:v>ID verification / prevention — Insurance (US &amp; Canada only, 44%)</c:v>
                   </c:pt>
                   <c:pt idx="4">
                     <c:v>Fraud detection technology — Banking (48%)</c:v>
                   </c:pt>
                   <c:pt idx="5">
-                    <c:v>Fraud detection technology — Insurance (40%)</c:v>
+                    <c:v>Fraud detection technology — Insurance (US &amp; Canada only, 36%)</c:v>
                   </c:pt>
                   <c:pt idx="6">
                     <c:v>3rd-party intel / consortium — Banking (43%)</c:v>
                   </c:pt>
                   <c:pt idx="7">
-                    <c:v>3rd-party intel / consortium — Insurance (44%)</c:v>
+                    <c:v>3rd-party intel / consortium — Insurance (US &amp; Canada only, 40%)</c:v>
                   </c:pt>
                 </c:lvl>
               </c:multiLvlStrCache>
@@ -5216,120 +5216,6 @@
                 </c:pt>
                 <c:pt idx="7">
                   <c:v>0</c:v>
-                </c:pt>
-              </c:numCache>
-            </c:numRef>
-          </c:val>
-        </c:ser>
-        <c:ser>
-          <c:idx val="5"/>
-          <c:order val="5"/>
-          <c:tx>
-            <c:strRef>
-              <c:f>Sheet1!$G$1</c:f>
-              <c:strCache>
-                <c:ptCount val="1"/>
-                <c:pt idx="0">
-                  <c:v>Other markets (Insurance: UK/AU/SG)</c:v>
-                </c:pt>
-              </c:strCache>
-            </c:strRef>
-          </c:tx>
-          <c:spPr>
-            <a:solidFill>
-              <a:srgbClr val="D0D0CE"/>
-            </a:solidFill>
-            <a:effectLst/>
-          </c:spPr>
-          <c:invertIfNegative val="0"/>
-          <c:dLbls>
-            <c:numFmt formatCode="#,##0" sourceLinked="0"/>
-            <c:txPr>
-              <a:bodyPr/>
-              <a:lstStyle/>
-              <a:p>
-                <a:pPr>
-                  <a:defRPr b="0" i="0" strike="noStrike" sz="600" u="none">
-                    <a:solidFill>
-                      <a:srgbClr val="FFFFFF"/>
-                    </a:solidFill>
-                    <a:latin typeface="Arial"/>
-                  </a:defRPr>
-                </a:pPr>
-              </a:p>
-            </c:txPr>
-            <c:dLblPos val="ctr"/>
-            <c:showLegendKey val="0"/>
-            <c:showVal val="1"/>
-            <c:showCatName val="0"/>
-            <c:showSerName val="0"/>
-            <c:showPercent val="0"/>
-            <c:showBubbleSize val="0"/>
-            <c:showLeaderLines val="0"/>
-          </c:dLbls>
-          <c:cat>
-            <c:multiLvlStrRef>
-              <c:f>Sheet1!$A$2:$A$9</c:f>
-              <c:multiLvlStrCache>
-                <c:ptCount val="8"/>
-                <c:lvl>
-                  <c:pt idx="0">
-                    <c:v>Staff awareness &amp; training — Banking (49%)</c:v>
-                  </c:pt>
-                  <c:pt idx="1">
-                    <c:v>Staff awareness &amp; training — Insurance (64%)</c:v>
-                  </c:pt>
-                  <c:pt idx="2">
-                    <c:v>ID verification / prevention — Banking (51%)</c:v>
-                  </c:pt>
-                  <c:pt idx="3">
-                    <c:v>ID verification / prevention — Insurance (48%)</c:v>
-                  </c:pt>
-                  <c:pt idx="4">
-                    <c:v>Fraud detection technology — Banking (48%)</c:v>
-                  </c:pt>
-                  <c:pt idx="5">
-                    <c:v>Fraud detection technology — Insurance (40%)</c:v>
-                  </c:pt>
-                  <c:pt idx="6">
-                    <c:v>3rd-party intel / consortium — Banking (43%)</c:v>
-                  </c:pt>
-                  <c:pt idx="7">
-                    <c:v>3rd-party intel / consortium — Insurance (44%)</c:v>
-                  </c:pt>
-                </c:lvl>
-              </c:multiLvlStrCache>
-            </c:multiLvlStrRef>
-          </c:cat>
-          <c:val>
-            <c:numRef>
-              <c:f>Sheet1!$G$2:$G$9</c:f>
-              <c:numCache>
-                <c:formatCode>General</c:formatCode>
-                <c:ptCount val="8"/>
-                <c:pt idx="0">
-                  <c:v>0</c:v>
-                </c:pt>
-                <c:pt idx="1">
-                  <c:v>8</c:v>
-                </c:pt>
-                <c:pt idx="2">
-                  <c:v>0</c:v>
-                </c:pt>
-                <c:pt idx="3">
-                  <c:v>4</c:v>
-                </c:pt>
-                <c:pt idx="4">
-                  <c:v>0</c:v>
-                </c:pt>
-                <c:pt idx="5">
-                  <c:v>4</c:v>
-                </c:pt>
-                <c:pt idx="6">
-                  <c:v>0</c:v>
-                </c:pt>
-                <c:pt idx="7">
-                  <c:v>4</c:v>
                 </c:pt>
               </c:numCache>
             </c:numRef>
@@ -19018,7 +18904,7 @@
         <p:spPr>
           <a:xfrm>
             <a:off x="502006" y="5276088"/>
-            <a:ext cx="11188598" cy="457200"/>
+            <a:ext cx="11188598" cy="566928"/>
           </a:xfrm>
           <a:prstGeom prst="rect">
             <a:avLst/>
@@ -19062,7 +18948,7 @@
                 <a:ea typeface="Calibri" pitchFamily="34" charset="-122"/>
                 <a:cs typeface="Calibri" pitchFamily="34" charset="-120"/>
               </a:rPr>
-              <a:t>The % in each category label is the full sector-level figure; stacked region segments are rounded to the nearest whole percent and may sum to within ±1pt of that total. Banking/Australia (n=7) and Banking/Singapore (n=4) are thin samples shown directionally. Insurance's “Other markets” bucket combines UK (n=2), Australia (n=1), and Singapore (n=0) — too thin individually to break out.</a:t>
+              <a:t>The % in each Banking category label is the full sector-level figure; stacked region segments are rounded to the nearest whole percent and may sum to within ±1pt of that total. Banking/Australia (n=7) and Banking/Singapore (n=4) are thin samples shown directionally. Insurance bars reflect only its United States and Canada respondents (n=22 of 25) — UK (n=2), Australia (n=1), and Singapore (n=0) are excluded here for insufficient individual sample size, so Insurance's stacked totals run below the full-sample figures shown on the previous slide (64%, 48%, 40%, 44%).</a:t>
             </a:r>
             <a:endParaRPr lang="en-US" sz="850" dirty="0"/>
           </a:p>
@@ -19076,8 +18962,8 @@
         </p:nvSpPr>
         <p:spPr>
           <a:xfrm>
-            <a:off x="502006" y="5779008"/>
-            <a:ext cx="11188598" cy="365760"/>
+            <a:off x="502006" y="5897880"/>
+            <a:ext cx="11188598" cy="320040"/>
           </a:xfrm>
           <a:prstGeom prst="rect">
             <a:avLst/>

</xml_diff>

<commit_message>
Convert Q4 region breakdown to a stacked bar chart
Each government-action bar now stacks its 5 regions' contributions
(as % of the full 100-respondent sample) instead of showing 5
clustered region-relative bars per action. Segments sum exactly to
the already-published overall Q4 figures (35%, 26%, 14%, 13%, 9%,
3%), so no exclusions were needed here (unlike Q3/Q5/Q7, this
question isn't split by sector, and every region's respondents are
already part of the same undivided 100-person base).

Co-Authored-By: Claude Sonnet 5 <noreply@anthropic.com>
Claude-Session: https://claude.ai/code/session_01F6YKjZtdH33RrHLpCiLALg
</commit_message>
<xml_diff>
--- a/Fraud in 2026 - Full Results.pptx
+++ b/Fraud in 2026 - Full Results.pptx
@@ -1598,7 +1598,7 @@
       <c:layout/>
       <c:barChart>
         <c:barDir val="bar"/>
-        <c:grouping val="clustered"/>
+        <c:grouping val="stacked"/>
         <c:varyColors val="0"/>
         <c:ser>
           <c:idx val="0"/>
@@ -1630,13 +1630,14 @@
                 <a:pPr>
                   <a:defRPr b="0" i="0" strike="noStrike" sz="650" u="none">
                     <a:solidFill>
-                      <a:srgbClr val="000000"/>
+                      <a:srgbClr val="FFFFFF"/>
                     </a:solidFill>
                     <a:latin typeface="Arial"/>
                   </a:defRPr>
                 </a:pPr>
               </a:p>
             </c:txPr>
+            <c:dLblPos val="ctr"/>
             <c:showLegendKey val="0"/>
             <c:showVal val="1"/>
             <c:showCatName val="0"/>
@@ -1652,22 +1653,22 @@
                 <c:ptCount val="6"/>
                 <c:lvl>
                   <c:pt idx="0">
-                    <c:v>Centralized fraud info-sharing platform / utility</c:v>
+                    <c:v>Centralized fraud info-sharing platform / utility (35%)</c:v>
                   </c:pt>
                   <c:pt idx="1">
-                    <c:v>Clearer legal &amp; regulatory frameworks</c:v>
+                    <c:v>Clearer legal &amp; regulatory frameworks (26%)</c:v>
                   </c:pt>
                   <c:pt idx="2">
-                    <c:v>Common data standards &amp; definitions</c:v>
+                    <c:v>Common data standards &amp; definitions (14%)</c:v>
                   </c:pt>
                   <c:pt idx="3">
-                    <c:v>Greater public-private collaboration</c:v>
+                    <c:v>Greater public-private collaboration (13%)</c:v>
                   </c:pt>
                   <c:pt idx="4">
-                    <c:v>Prioritized industry use cases</c:v>
+                    <c:v>Prioritized industry use cases (9%)</c:v>
                   </c:pt>
                   <c:pt idx="5">
-                    <c:v>Funding or incentives</c:v>
+                    <c:v>Funding or incentives (3%)</c:v>
                   </c:pt>
                 </c:lvl>
               </c:multiLvlStrCache>
@@ -1680,22 +1681,22 @@
                 <c:formatCode>General</c:formatCode>
                 <c:ptCount val="6"/>
                 <c:pt idx="0">
-                  <c:v>36</c:v>
+                  <c:v>16</c:v>
                 </c:pt>
                 <c:pt idx="1">
-                  <c:v>16</c:v>
+                  <c:v>7</c:v>
                 </c:pt>
                 <c:pt idx="2">
-                  <c:v>18</c:v>
+                  <c:v>8</c:v>
                 </c:pt>
                 <c:pt idx="3">
-                  <c:v>20</c:v>
+                  <c:v>9</c:v>
                 </c:pt>
                 <c:pt idx="4">
-                  <c:v>5</c:v>
+                  <c:v>2</c:v>
                 </c:pt>
                 <c:pt idx="5">
-                  <c:v>5</c:v>
+                  <c:v>2</c:v>
                 </c:pt>
               </c:numCache>
             </c:numRef>
@@ -1731,13 +1732,14 @@
                 <a:pPr>
                   <a:defRPr b="0" i="0" strike="noStrike" sz="650" u="none">
                     <a:solidFill>
-                      <a:srgbClr val="000000"/>
+                      <a:srgbClr val="FFFFFF"/>
                     </a:solidFill>
                     <a:latin typeface="Arial"/>
                   </a:defRPr>
                 </a:pPr>
               </a:p>
             </c:txPr>
+            <c:dLblPos val="ctr"/>
             <c:showLegendKey val="0"/>
             <c:showVal val="1"/>
             <c:showCatName val="0"/>
@@ -1753,22 +1755,22 @@
                 <c:ptCount val="6"/>
                 <c:lvl>
                   <c:pt idx="0">
-                    <c:v>Centralized fraud info-sharing platform / utility</c:v>
+                    <c:v>Centralized fraud info-sharing platform / utility (35%)</c:v>
                   </c:pt>
                   <c:pt idx="1">
-                    <c:v>Clearer legal &amp; regulatory frameworks</c:v>
+                    <c:v>Clearer legal &amp; regulatory frameworks (26%)</c:v>
                   </c:pt>
                   <c:pt idx="2">
-                    <c:v>Common data standards &amp; definitions</c:v>
+                    <c:v>Common data standards &amp; definitions (14%)</c:v>
                   </c:pt>
                   <c:pt idx="3">
-                    <c:v>Greater public-private collaboration</c:v>
+                    <c:v>Greater public-private collaboration (13%)</c:v>
                   </c:pt>
                   <c:pt idx="4">
-                    <c:v>Prioritized industry use cases</c:v>
+                    <c:v>Prioritized industry use cases (9%)</c:v>
                   </c:pt>
                   <c:pt idx="5">
-                    <c:v>Funding or incentives</c:v>
+                    <c:v>Funding or incentives (3%)</c:v>
                   </c:pt>
                 </c:lvl>
               </c:multiLvlStrCache>
@@ -1781,19 +1783,19 @@
                 <c:formatCode>General</c:formatCode>
                 <c:ptCount val="6"/>
                 <c:pt idx="0">
-                  <c:v>33</c:v>
+                  <c:v>10</c:v>
                 </c:pt>
                 <c:pt idx="1">
-                  <c:v>40</c:v>
+                  <c:v>12</c:v>
                 </c:pt>
                 <c:pt idx="2">
-                  <c:v>7</c:v>
+                  <c:v>2</c:v>
                 </c:pt>
                 <c:pt idx="3">
-                  <c:v>7</c:v>
+                  <c:v>2</c:v>
                 </c:pt>
                 <c:pt idx="4">
-                  <c:v>13</c:v>
+                  <c:v>4</c:v>
                 </c:pt>
                 <c:pt idx="5">
                   <c:v>0</c:v>
@@ -1832,13 +1834,14 @@
                 <a:pPr>
                   <a:defRPr b="0" i="0" strike="noStrike" sz="650" u="none">
                     <a:solidFill>
-                      <a:srgbClr val="000000"/>
+                      <a:srgbClr val="FFFFFF"/>
                     </a:solidFill>
                     <a:latin typeface="Arial"/>
                   </a:defRPr>
                 </a:pPr>
               </a:p>
             </c:txPr>
+            <c:dLblPos val="ctr"/>
             <c:showLegendKey val="0"/>
             <c:showVal val="1"/>
             <c:showCatName val="0"/>
@@ -1854,22 +1857,22 @@
                 <c:ptCount val="6"/>
                 <c:lvl>
                   <c:pt idx="0">
-                    <c:v>Centralized fraud info-sharing platform / utility</c:v>
+                    <c:v>Centralized fraud info-sharing platform / utility (35%)</c:v>
                   </c:pt>
                   <c:pt idx="1">
-                    <c:v>Clearer legal &amp; regulatory frameworks</c:v>
+                    <c:v>Clearer legal &amp; regulatory frameworks (26%)</c:v>
                   </c:pt>
                   <c:pt idx="2">
-                    <c:v>Common data standards &amp; definitions</c:v>
+                    <c:v>Common data standards &amp; definitions (14%)</c:v>
                   </c:pt>
                   <c:pt idx="3">
-                    <c:v>Greater public-private collaboration</c:v>
+                    <c:v>Greater public-private collaboration (13%)</c:v>
                   </c:pt>
                   <c:pt idx="4">
-                    <c:v>Prioritized industry use cases</c:v>
+                    <c:v>Prioritized industry use cases (9%)</c:v>
                   </c:pt>
                   <c:pt idx="5">
-                    <c:v>Funding or incentives</c:v>
+                    <c:v>Funding or incentives (3%)</c:v>
                   </c:pt>
                 </c:lvl>
               </c:multiLvlStrCache>
@@ -1882,22 +1885,22 @@
                 <c:formatCode>General</c:formatCode>
                 <c:ptCount val="6"/>
                 <c:pt idx="0">
-                  <c:v>36</c:v>
+                  <c:v>5</c:v>
                 </c:pt>
                 <c:pt idx="1">
-                  <c:v>29</c:v>
+                  <c:v>4</c:v>
                 </c:pt>
                 <c:pt idx="2">
-                  <c:v>14</c:v>
+                  <c:v>2</c:v>
                 </c:pt>
                 <c:pt idx="3">
-                  <c:v>7</c:v>
+                  <c:v>1</c:v>
                 </c:pt>
                 <c:pt idx="4">
-                  <c:v>7</c:v>
+                  <c:v>1</c:v>
                 </c:pt>
                 <c:pt idx="5">
-                  <c:v>7</c:v>
+                  <c:v>1</c:v>
                 </c:pt>
               </c:numCache>
             </c:numRef>
@@ -1933,13 +1936,14 @@
                 <a:pPr>
                   <a:defRPr b="0" i="0" strike="noStrike" sz="650" u="none">
                     <a:solidFill>
-                      <a:srgbClr val="000000"/>
+                      <a:srgbClr val="FFFFFF"/>
                     </a:solidFill>
                     <a:latin typeface="Arial"/>
                   </a:defRPr>
                 </a:pPr>
               </a:p>
             </c:txPr>
+            <c:dLblPos val="ctr"/>
             <c:showLegendKey val="0"/>
             <c:showVal val="1"/>
             <c:showCatName val="0"/>
@@ -1955,22 +1959,22 @@
                 <c:ptCount val="6"/>
                 <c:lvl>
                   <c:pt idx="0">
-                    <c:v>Centralized fraud info-sharing platform / utility</c:v>
+                    <c:v>Centralized fraud info-sharing platform / utility (35%)</c:v>
                   </c:pt>
                   <c:pt idx="1">
-                    <c:v>Clearer legal &amp; regulatory frameworks</c:v>
+                    <c:v>Clearer legal &amp; regulatory frameworks (26%)</c:v>
                   </c:pt>
                   <c:pt idx="2">
-                    <c:v>Common data standards &amp; definitions</c:v>
+                    <c:v>Common data standards &amp; definitions (14%)</c:v>
                   </c:pt>
                   <c:pt idx="3">
-                    <c:v>Greater public-private collaboration</c:v>
+                    <c:v>Greater public-private collaboration (13%)</c:v>
                   </c:pt>
                   <c:pt idx="4">
-                    <c:v>Prioritized industry use cases</c:v>
+                    <c:v>Prioritized industry use cases (9%)</c:v>
                   </c:pt>
                   <c:pt idx="5">
-                    <c:v>Funding or incentives</c:v>
+                    <c:v>Funding or incentives (3%)</c:v>
                   </c:pt>
                 </c:lvl>
               </c:multiLvlStrCache>
@@ -1983,19 +1987,19 @@
                 <c:formatCode>General</c:formatCode>
                 <c:ptCount val="6"/>
                 <c:pt idx="0">
-                  <c:v>25</c:v>
+                  <c:v>2</c:v>
                 </c:pt>
                 <c:pt idx="1">
-                  <c:v>38</c:v>
+                  <c:v>3</c:v>
                 </c:pt>
                 <c:pt idx="2">
                   <c:v>0</c:v>
                 </c:pt>
                 <c:pt idx="3">
-                  <c:v>12</c:v>
+                  <c:v>1</c:v>
                 </c:pt>
                 <c:pt idx="4">
-                  <c:v>25</c:v>
+                  <c:v>2</c:v>
                 </c:pt>
                 <c:pt idx="5">
                   <c:v>0</c:v>
@@ -2034,13 +2038,14 @@
                 <a:pPr>
                   <a:defRPr b="0" i="0" strike="noStrike" sz="650" u="none">
                     <a:solidFill>
-                      <a:srgbClr val="000000"/>
+                      <a:srgbClr val="FFFFFF"/>
                     </a:solidFill>
                     <a:latin typeface="Arial"/>
                   </a:defRPr>
                 </a:pPr>
               </a:p>
             </c:txPr>
+            <c:dLblPos val="ctr"/>
             <c:showLegendKey val="0"/>
             <c:showVal val="1"/>
             <c:showCatName val="0"/>
@@ -2056,22 +2061,22 @@
                 <c:ptCount val="6"/>
                 <c:lvl>
                   <c:pt idx="0">
-                    <c:v>Centralized fraud info-sharing platform / utility</c:v>
+                    <c:v>Centralized fraud info-sharing platform / utility (35%)</c:v>
                   </c:pt>
                   <c:pt idx="1">
-                    <c:v>Clearer legal &amp; regulatory frameworks</c:v>
+                    <c:v>Clearer legal &amp; regulatory frameworks (26%)</c:v>
                   </c:pt>
                   <c:pt idx="2">
-                    <c:v>Common data standards &amp; definitions</c:v>
+                    <c:v>Common data standards &amp; definitions (14%)</c:v>
                   </c:pt>
                   <c:pt idx="3">
-                    <c:v>Greater public-private collaboration</c:v>
+                    <c:v>Greater public-private collaboration (13%)</c:v>
                   </c:pt>
                   <c:pt idx="4">
-                    <c:v>Prioritized industry use cases</c:v>
+                    <c:v>Prioritized industry use cases (9%)</c:v>
                   </c:pt>
                   <c:pt idx="5">
-                    <c:v>Funding or incentives</c:v>
+                    <c:v>Funding or incentives (3%)</c:v>
                   </c:pt>
                 </c:lvl>
               </c:multiLvlStrCache>
@@ -2084,13 +2089,13 @@
                 <c:formatCode>General</c:formatCode>
                 <c:ptCount val="6"/>
                 <c:pt idx="0">
-                  <c:v>50</c:v>
+                  <c:v>2</c:v>
                 </c:pt>
                 <c:pt idx="1">
                   <c:v>0</c:v>
                 </c:pt>
                 <c:pt idx="2">
-                  <c:v>50</c:v>
+                  <c:v>2</c:v>
                 </c:pt>
                 <c:pt idx="3">
                   <c:v>0</c:v>
@@ -2114,13 +2119,14 @@
               <a:pPr>
                 <a:defRPr b="0" i="0" strike="noStrike" sz="650" u="none">
                   <a:solidFill>
-                    <a:srgbClr val="000000"/>
+                    <a:srgbClr val="FFFFFF"/>
                   </a:solidFill>
                   <a:latin typeface="Arial"/>
                 </a:defRPr>
               </a:pPr>
             </a:p>
           </c:txPr>
+          <c:dLblPos val="ctr"/>
           <c:showLegendKey val="0"/>
           <c:showVal val="1"/>
           <c:showCatName val="0"/>
@@ -2130,7 +2136,7 @@
           <c:showLeaderLines val="0"/>
         </c:dLbls>
         <c:gapWidth val="40"/>
-        <c:overlap val="0"/>
+        <c:overlap val="100"/>
         <c:axId val="2094734554"/>
         <c:axId val="2094734552"/>
         <c:axId val="2094734556"/>
@@ -13278,7 +13284,7 @@
                 <a:ea typeface="Calibri" pitchFamily="34" charset="-122"/>
                 <a:cs typeface="Calibri" pitchFamily="34" charset="-120"/>
               </a:rPr>
-              <a:t>Single select. Australia (n=8) and Singapore (n=4) are thin samples, shown directionally.  </a:t>
+              <a:t>Single select — % shown is each region's share of the full 100-respondent sample, so segments sum to the overall figure in each category label. Australia (n=8) and Singapore (n=4) are thin samples, shown directionally.  </a:t>
             </a:r>
             <a:pPr algn="l" indent="0" marL="0">
               <a:lnSpc>

</xml_diff>

<commit_message>
Hide 0% segment labels on stacked bar charts; add missing % sign
All four stacked charts (Q3, Q4, Q5, Q7 sector/region breakdowns) now
use a 4-section number format (0"%";-0"%";;@) so zero-value region
segments render with no label instead of a distracting "0%".

Also fixes a bug: Q3, Q5, and Q7's stacked charts had no
dataLabelFormatCode set at all, so their segment labels were showing
bare numbers (e.g. "23") instead of percentages ("23%"). Only Q4 had
the format code. All four are now consistent.

Co-Authored-By: Claude Sonnet 5 <noreply@anthropic.com>
Claude-Session: https://claude.ai/code/session_01F6YKjZtdH33RrHLpCiLALg
</commit_message>
<xml_diff>
--- a/Fraud in 2026 - Full Results.pptx
+++ b/Fraud in 2026 - Full Results.pptx
@@ -528,7 +528,7 @@
           </c:spPr>
           <c:invertIfNegative val="0"/>
           <c:dLbls>
-            <c:numFmt formatCode="#,##0" sourceLinked="0"/>
+            <c:numFmt formatCode="0&quot;%&quot;;-0&quot;%&quot;;;@" sourceLinked="0"/>
             <c:txPr>
               <a:bodyPr/>
               <a:lstStyle/>
@@ -666,7 +666,7 @@
           </c:spPr>
           <c:invertIfNegative val="0"/>
           <c:dLbls>
-            <c:numFmt formatCode="#,##0" sourceLinked="0"/>
+            <c:numFmt formatCode="0&quot;%&quot;;-0&quot;%&quot;;;@" sourceLinked="0"/>
             <c:txPr>
               <a:bodyPr/>
               <a:lstStyle/>
@@ -804,7 +804,7 @@
           </c:spPr>
           <c:invertIfNegative val="0"/>
           <c:dLbls>
-            <c:numFmt formatCode="#,##0" sourceLinked="0"/>
+            <c:numFmt formatCode="0&quot;%&quot;;-0&quot;%&quot;;;@" sourceLinked="0"/>
             <c:txPr>
               <a:bodyPr/>
               <a:lstStyle/>
@@ -942,7 +942,7 @@
           </c:spPr>
           <c:invertIfNegative val="0"/>
           <c:dLbls>
-            <c:numFmt formatCode="#,##0" sourceLinked="0"/>
+            <c:numFmt formatCode="0&quot;%&quot;;-0&quot;%&quot;;;@" sourceLinked="0"/>
             <c:txPr>
               <a:bodyPr/>
               <a:lstStyle/>
@@ -1080,7 +1080,7 @@
           </c:spPr>
           <c:invertIfNegative val="0"/>
           <c:dLbls>
-            <c:numFmt formatCode="#,##0" sourceLinked="0"/>
+            <c:numFmt formatCode="0&quot;%&quot;;-0&quot;%&quot;;;@" sourceLinked="0"/>
             <c:txPr>
               <a:bodyPr/>
               <a:lstStyle/>
@@ -1197,7 +1197,7 @@
           </c:val>
         </c:ser>
         <c:dLbls>
-          <c:numFmt formatCode="#,##0" sourceLinked="0"/>
+          <c:numFmt formatCode="0&quot;%&quot;;-0&quot;%&quot;;;@" sourceLinked="0"/>
           <c:txPr>
             <a:bodyPr/>
             <a:lstStyle/>
@@ -1622,7 +1622,7 @@
           </c:spPr>
           <c:invertIfNegative val="0"/>
           <c:dLbls>
-            <c:numFmt formatCode="0&quot;%&quot;" sourceLinked="0"/>
+            <c:numFmt formatCode="0&quot;%&quot;;-0&quot;%&quot;;;@" sourceLinked="0"/>
             <c:txPr>
               <a:bodyPr/>
               <a:lstStyle/>
@@ -1724,7 +1724,7 @@
           </c:spPr>
           <c:invertIfNegative val="0"/>
           <c:dLbls>
-            <c:numFmt formatCode="0&quot;%&quot;" sourceLinked="0"/>
+            <c:numFmt formatCode="0&quot;%&quot;;-0&quot;%&quot;;;@" sourceLinked="0"/>
             <c:txPr>
               <a:bodyPr/>
               <a:lstStyle/>
@@ -1826,7 +1826,7 @@
           </c:spPr>
           <c:invertIfNegative val="0"/>
           <c:dLbls>
-            <c:numFmt formatCode="0&quot;%&quot;" sourceLinked="0"/>
+            <c:numFmt formatCode="0&quot;%&quot;;-0&quot;%&quot;;;@" sourceLinked="0"/>
             <c:txPr>
               <a:bodyPr/>
               <a:lstStyle/>
@@ -1928,7 +1928,7 @@
           </c:spPr>
           <c:invertIfNegative val="0"/>
           <c:dLbls>
-            <c:numFmt formatCode="0&quot;%&quot;" sourceLinked="0"/>
+            <c:numFmt formatCode="0&quot;%&quot;;-0&quot;%&quot;;;@" sourceLinked="0"/>
             <c:txPr>
               <a:bodyPr/>
               <a:lstStyle/>
@@ -2030,7 +2030,7 @@
           </c:spPr>
           <c:invertIfNegative val="0"/>
           <c:dLbls>
-            <c:numFmt formatCode="0&quot;%&quot;" sourceLinked="0"/>
+            <c:numFmt formatCode="0&quot;%&quot;;-0&quot;%&quot;;;@" sourceLinked="0"/>
             <c:txPr>
               <a:bodyPr/>
               <a:lstStyle/>
@@ -2111,7 +2111,7 @@
           </c:val>
         </c:ser>
         <c:dLbls>
-          <c:numFmt formatCode="0&quot;%&quot;" sourceLinked="0"/>
+          <c:numFmt formatCode="0&quot;%&quot;;-0&quot;%&quot;;;@" sourceLinked="0"/>
           <c:txPr>
             <a:bodyPr/>
             <a:lstStyle/>
@@ -3350,7 +3350,7 @@
           </c:spPr>
           <c:invertIfNegative val="0"/>
           <c:dLbls>
-            <c:numFmt formatCode="#,##0" sourceLinked="0"/>
+            <c:numFmt formatCode="0&quot;%&quot;;-0&quot;%&quot;;;@" sourceLinked="0"/>
             <c:txPr>
               <a:bodyPr/>
               <a:lstStyle/>
@@ -3464,7 +3464,7 @@
           </c:spPr>
           <c:invertIfNegative val="0"/>
           <c:dLbls>
-            <c:numFmt formatCode="#,##0" sourceLinked="0"/>
+            <c:numFmt formatCode="0&quot;%&quot;;-0&quot;%&quot;;;@" sourceLinked="0"/>
             <c:txPr>
               <a:bodyPr/>
               <a:lstStyle/>
@@ -3578,7 +3578,7 @@
           </c:spPr>
           <c:invertIfNegative val="0"/>
           <c:dLbls>
-            <c:numFmt formatCode="#,##0" sourceLinked="0"/>
+            <c:numFmt formatCode="0&quot;%&quot;;-0&quot;%&quot;;;@" sourceLinked="0"/>
             <c:txPr>
               <a:bodyPr/>
               <a:lstStyle/>
@@ -3692,7 +3692,7 @@
           </c:spPr>
           <c:invertIfNegative val="0"/>
           <c:dLbls>
-            <c:numFmt formatCode="#,##0" sourceLinked="0"/>
+            <c:numFmt formatCode="0&quot;%&quot;;-0&quot;%&quot;;;@" sourceLinked="0"/>
             <c:txPr>
               <a:bodyPr/>
               <a:lstStyle/>
@@ -3806,7 +3806,7 @@
           </c:spPr>
           <c:invertIfNegative val="0"/>
           <c:dLbls>
-            <c:numFmt formatCode="#,##0" sourceLinked="0"/>
+            <c:numFmt formatCode="0&quot;%&quot;;-0&quot;%&quot;;;@" sourceLinked="0"/>
             <c:txPr>
               <a:bodyPr/>
               <a:lstStyle/>
@@ -3899,7 +3899,7 @@
           </c:val>
         </c:ser>
         <c:dLbls>
-          <c:numFmt formatCode="#,##0" sourceLinked="0"/>
+          <c:numFmt formatCode="0&quot;%&quot;;-0&quot;%&quot;;;@" sourceLinked="0"/>
           <c:txPr>
             <a:bodyPr/>
             <a:lstStyle/>
@@ -6923,7 +6923,7 @@
           </c:spPr>
           <c:invertIfNegative val="0"/>
           <c:dLbls>
-            <c:numFmt formatCode="#,##0" sourceLinked="0"/>
+            <c:numFmt formatCode="0&quot;%&quot;;-0&quot;%&quot;;;@" sourceLinked="0"/>
             <c:txPr>
               <a:bodyPr/>
               <a:lstStyle/>
@@ -7037,7 +7037,7 @@
           </c:spPr>
           <c:invertIfNegative val="0"/>
           <c:dLbls>
-            <c:numFmt formatCode="#,##0" sourceLinked="0"/>
+            <c:numFmt formatCode="0&quot;%&quot;;-0&quot;%&quot;;;@" sourceLinked="0"/>
             <c:txPr>
               <a:bodyPr/>
               <a:lstStyle/>
@@ -7151,7 +7151,7 @@
           </c:spPr>
           <c:invertIfNegative val="0"/>
           <c:dLbls>
-            <c:numFmt formatCode="#,##0" sourceLinked="0"/>
+            <c:numFmt formatCode="0&quot;%&quot;;-0&quot;%&quot;;;@" sourceLinked="0"/>
             <c:txPr>
               <a:bodyPr/>
               <a:lstStyle/>
@@ -7265,7 +7265,7 @@
           </c:spPr>
           <c:invertIfNegative val="0"/>
           <c:dLbls>
-            <c:numFmt formatCode="#,##0" sourceLinked="0"/>
+            <c:numFmt formatCode="0&quot;%&quot;;-0&quot;%&quot;;;@" sourceLinked="0"/>
             <c:txPr>
               <a:bodyPr/>
               <a:lstStyle/>
@@ -7379,7 +7379,7 @@
           </c:spPr>
           <c:invertIfNegative val="0"/>
           <c:dLbls>
-            <c:numFmt formatCode="#,##0" sourceLinked="0"/>
+            <c:numFmt formatCode="0&quot;%&quot;;-0&quot;%&quot;;;@" sourceLinked="0"/>
             <c:txPr>
               <a:bodyPr/>
               <a:lstStyle/>
@@ -7472,7 +7472,7 @@
           </c:val>
         </c:ser>
         <c:dLbls>
-          <c:numFmt formatCode="#,##0" sourceLinked="0"/>
+          <c:numFmt formatCode="0&quot;%&quot;;-0&quot;%&quot;;;@" sourceLinked="0"/>
           <c:txPr>
             <a:bodyPr/>
             <a:lstStyle/>

</xml_diff>

<commit_message>
Test: show Insurance UK/Australia respondents on Q3 sector x region slide
Slide 9 now includes Insurance's 2 UK and 1 Australia respondents as
their own (thin) stacked segments instead of excluding them, so
Insurance's bars now match the true full-sample percentages (64%,
48%, 40%, 44%) instead of the reduced "US & Canada only" totals.
Footnote flags these segments as extremely thin (1-2 respondents
each) and notes Insurance had zero Singapore respondents.

This is a trial run per request, to compare against the "US & Canada
only" treatment still used on Q5/Q7 -- Q5 and Q7 have not been
changed yet, pending feedback on this approach.

Co-Authored-By: Claude Sonnet 5 <noreply@anthropic.com>
Claude-Session: https://claude.ai/code/session_01F6YKjZtdH33RrHLpCiLALg
</commit_message>
<xml_diff>
--- a/Fraud in 2026 - Full Results.pptx
+++ b/Fraud in 2026 - Full Results.pptx
@@ -8571,25 +8571,25 @@
                     <c:v>Staff awareness &amp; training — Banking (49%)</c:v>
                   </c:pt>
                   <c:pt idx="1">
-                    <c:v>Staff awareness &amp; training — Insurance (US &amp; Canada only, 56%)</c:v>
+                    <c:v>Staff awareness &amp; training — Insurance (64%)</c:v>
                   </c:pt>
                   <c:pt idx="2">
                     <c:v>ID verification / prevention — Banking (51%)</c:v>
                   </c:pt>
                   <c:pt idx="3">
-                    <c:v>ID verification / prevention — Insurance (US &amp; Canada only, 44%)</c:v>
+                    <c:v>ID verification / prevention — Insurance (48%)</c:v>
                   </c:pt>
                   <c:pt idx="4">
                     <c:v>Fraud detection technology — Banking (48%)</c:v>
                   </c:pt>
                   <c:pt idx="5">
-                    <c:v>Fraud detection technology — Insurance (US &amp; Canada only, 36%)</c:v>
+                    <c:v>Fraud detection technology — Insurance (40%)</c:v>
                   </c:pt>
                   <c:pt idx="6">
                     <c:v>3rd-party intel / consortium — Banking (43%)</c:v>
                   </c:pt>
                   <c:pt idx="7">
-                    <c:v>3rd-party intel / consortium — Insurance (US &amp; Canada only, 40%)</c:v>
+                    <c:v>3rd-party intel / consortium — Insurance (44%)</c:v>
                   </c:pt>
                 </c:lvl>
               </c:multiLvlStrCache>
@@ -8685,25 +8685,25 @@
                     <c:v>Staff awareness &amp; training — Banking (49%)</c:v>
                   </c:pt>
                   <c:pt idx="1">
-                    <c:v>Staff awareness &amp; training — Insurance (US &amp; Canada only, 56%)</c:v>
+                    <c:v>Staff awareness &amp; training — Insurance (64%)</c:v>
                   </c:pt>
                   <c:pt idx="2">
                     <c:v>ID verification / prevention — Banking (51%)</c:v>
                   </c:pt>
                   <c:pt idx="3">
-                    <c:v>ID verification / prevention — Insurance (US &amp; Canada only, 44%)</c:v>
+                    <c:v>ID verification / prevention — Insurance (48%)</c:v>
                   </c:pt>
                   <c:pt idx="4">
                     <c:v>Fraud detection technology — Banking (48%)</c:v>
                   </c:pt>
                   <c:pt idx="5">
-                    <c:v>Fraud detection technology — Insurance (US &amp; Canada only, 36%)</c:v>
+                    <c:v>Fraud detection technology — Insurance (40%)</c:v>
                   </c:pt>
                   <c:pt idx="6">
                     <c:v>3rd-party intel / consortium — Banking (43%)</c:v>
                   </c:pt>
                   <c:pt idx="7">
-                    <c:v>3rd-party intel / consortium — Insurance (US &amp; Canada only, 40%)</c:v>
+                    <c:v>3rd-party intel / consortium — Insurance (44%)</c:v>
                   </c:pt>
                 </c:lvl>
               </c:multiLvlStrCache>
@@ -8799,25 +8799,25 @@
                     <c:v>Staff awareness &amp; training — Banking (49%)</c:v>
                   </c:pt>
                   <c:pt idx="1">
-                    <c:v>Staff awareness &amp; training — Insurance (US &amp; Canada only, 56%)</c:v>
+                    <c:v>Staff awareness &amp; training — Insurance (64%)</c:v>
                   </c:pt>
                   <c:pt idx="2">
                     <c:v>ID verification / prevention — Banking (51%)</c:v>
                   </c:pt>
                   <c:pt idx="3">
-                    <c:v>ID verification / prevention — Insurance (US &amp; Canada only, 44%)</c:v>
+                    <c:v>ID verification / prevention — Insurance (48%)</c:v>
                   </c:pt>
                   <c:pt idx="4">
                     <c:v>Fraud detection technology — Banking (48%)</c:v>
                   </c:pt>
                   <c:pt idx="5">
-                    <c:v>Fraud detection technology — Insurance (US &amp; Canada only, 36%)</c:v>
+                    <c:v>Fraud detection technology — Insurance (40%)</c:v>
                   </c:pt>
                   <c:pt idx="6">
                     <c:v>3rd-party intel / consortium — Banking (43%)</c:v>
                   </c:pt>
                   <c:pt idx="7">
-                    <c:v>3rd-party intel / consortium — Insurance (US &amp; Canada only, 40%)</c:v>
+                    <c:v>3rd-party intel / consortium — Insurance (44%)</c:v>
                   </c:pt>
                 </c:lvl>
               </c:multiLvlStrCache>
@@ -8833,13 +8833,13 @@
                   <c:v>5</c:v>
                 </c:pt>
                 <c:pt idx="1">
-                  <c:v>0</c:v>
+                  <c:v>4</c:v>
                 </c:pt>
                 <c:pt idx="2">
                   <c:v>8</c:v>
                 </c:pt>
                 <c:pt idx="3">
-                  <c:v>0</c:v>
+                  <c:v>4</c:v>
                 </c:pt>
                 <c:pt idx="4">
                   <c:v>8</c:v>
@@ -8851,7 +8851,7 @@
                   <c:v>7</c:v>
                 </c:pt>
                 <c:pt idx="7">
-                  <c:v>0</c:v>
+                  <c:v>4</c:v>
                 </c:pt>
               </c:numCache>
             </c:numRef>
@@ -8913,25 +8913,25 @@
                     <c:v>Staff awareness &amp; training — Banking (49%)</c:v>
                   </c:pt>
                   <c:pt idx="1">
-                    <c:v>Staff awareness &amp; training — Insurance (US &amp; Canada only, 56%)</c:v>
+                    <c:v>Staff awareness &amp; training — Insurance (64%)</c:v>
                   </c:pt>
                   <c:pt idx="2">
                     <c:v>ID verification / prevention — Banking (51%)</c:v>
                   </c:pt>
                   <c:pt idx="3">
-                    <c:v>ID verification / prevention — Insurance (US &amp; Canada only, 44%)</c:v>
+                    <c:v>ID verification / prevention — Insurance (48%)</c:v>
                   </c:pt>
                   <c:pt idx="4">
                     <c:v>Fraud detection technology — Banking (48%)</c:v>
                   </c:pt>
                   <c:pt idx="5">
-                    <c:v>Fraud detection technology — Insurance (US &amp; Canada only, 36%)</c:v>
+                    <c:v>Fraud detection technology — Insurance (40%)</c:v>
                   </c:pt>
                   <c:pt idx="6">
                     <c:v>3rd-party intel / consortium — Banking (43%)</c:v>
                   </c:pt>
                   <c:pt idx="7">
-                    <c:v>3rd-party intel / consortium — Insurance (US &amp; Canada only, 40%)</c:v>
+                    <c:v>3rd-party intel / consortium — Insurance (44%)</c:v>
                   </c:pt>
                 </c:lvl>
               </c:multiLvlStrCache>
@@ -8947,7 +8947,7 @@
                   <c:v>3</c:v>
                 </c:pt>
                 <c:pt idx="1">
-                  <c:v>0</c:v>
+                  <c:v>4</c:v>
                 </c:pt>
                 <c:pt idx="2">
                   <c:v>3</c:v>
@@ -8959,7 +8959,7 @@
                   <c:v>4</c:v>
                 </c:pt>
                 <c:pt idx="5">
-                  <c:v>0</c:v>
+                  <c:v>4</c:v>
                 </c:pt>
                 <c:pt idx="6">
                   <c:v>7</c:v>
@@ -9027,25 +9027,25 @@
                     <c:v>Staff awareness &amp; training — Banking (49%)</c:v>
                   </c:pt>
                   <c:pt idx="1">
-                    <c:v>Staff awareness &amp; training — Insurance (US &amp; Canada only, 56%)</c:v>
+                    <c:v>Staff awareness &amp; training — Insurance (64%)</c:v>
                   </c:pt>
                   <c:pt idx="2">
                     <c:v>ID verification / prevention — Banking (51%)</c:v>
                   </c:pt>
                   <c:pt idx="3">
-                    <c:v>ID verification / prevention — Insurance (US &amp; Canada only, 44%)</c:v>
+                    <c:v>ID verification / prevention — Insurance (48%)</c:v>
                   </c:pt>
                   <c:pt idx="4">
                     <c:v>Fraud detection technology — Banking (48%)</c:v>
                   </c:pt>
                   <c:pt idx="5">
-                    <c:v>Fraud detection technology — Insurance (US &amp; Canada only, 36%)</c:v>
+                    <c:v>Fraud detection technology — Insurance (40%)</c:v>
                   </c:pt>
                   <c:pt idx="6">
                     <c:v>3rd-party intel / consortium — Banking (43%)</c:v>
                   </c:pt>
                   <c:pt idx="7">
-                    <c:v>3rd-party intel / consortium — Insurance (US &amp; Canada only, 40%)</c:v>
+                    <c:v>3rd-party intel / consortium — Insurance (44%)</c:v>
                   </c:pt>
                 </c:lvl>
               </c:multiLvlStrCache>
@@ -25814,7 +25814,7 @@
                 <a:ea typeface="Calibri" pitchFamily="34" charset="-122"/>
                 <a:cs typeface="Calibri" pitchFamily="34" charset="-120"/>
               </a:rPr>
-              <a:t>The % in each Banking category label is the full sector-level figure; stacked region segments are rounded to the nearest whole percent and may sum to within ±1pt of that total. Banking/Australia (n=7) and Banking/Singapore (n=4) are thin samples shown directionally. Insurance bars reflect only its United States and Canada respondents (n=22 of 25) — UK (n=2), Australia (n=1), and Singapore (n=0) are excluded here for insufficient individual sample size, so Insurance's stacked totals run below the full-sample figures shown on the previous slide (64%, 48%, 40%, 44%).</a:t>
+              <a:t>The % in each category label is the full sector-level figure; stacked region segments are rounded to the nearest whole percent and may sum to within ±1pt of that total. Banking/Australia (n=7) and Banking/Singapore (n=4) are thin samples shown directionally. Insurance/Europe (n=2, both United Kingdom) and Insurance/Australia (n=1) are extremely thin — each segment reflects just 1–2 respondents — and are shown for completeness, not as statistically reliable estimates. Insurance had zero Singapore respondents, so no segment appears there.</a:t>
             </a:r>
             <a:endParaRPr lang="en-US" sz="850" dirty="0"/>
           </a:p>

</xml_diff>

<commit_message>
Add Q8/Q9 sector x institution tier breakdowns
Two new stacked-bar slides right after the existing combined Q8/Q9
slide, one per question (current approach and 3-year focus), each
showing Banking vs. Insurance paired bars per scaling lever, stacked
by institution tier (Top 100/Top 50 vs. Large, using newS8/S9).

All sector-level totals verified to reconcile exactly with the
already-published overall Q8 (34/29/10/10/10/7) and Q9
(41/27/18/7/5/2) figures, and tier totals reconcile with the Q1
sector x tier slide's institution counts (Banking Top 100 n=40,
Insurance Large n=10, including the previously reclassified
respondents).

Co-Authored-By: Claude Sonnet 5 <noreply@anthropic.com>
Claude-Session: https://claude.ai/code/session_01F6YKjZtdH33RrHLpCiLALg
</commit_message>
<xml_diff>
--- a/Fraud in 2026 - Full Results.pptx
+++ b/Fraud in 2026 - Full Results.pptx
@@ -36,9 +36,11 @@
     <p:sldId id="284" r:id="rId30"/>
     <p:sldId id="285" r:id="rId31"/>
     <p:sldId id="286" r:id="rId32"/>
+    <p:sldId id="287" r:id="rId33"/>
+    <p:sldId id="288" r:id="rId34"/>
   </p:sldIdLst>
   <p:notesMasterIdLst>
-    <p:notesMasterId r:id="rId33"/>
+    <p:notesMasterId r:id="rId35"/>
   </p:notesMasterIdLst>
   <p:sldSz cx="12192000" cy="6858000"/>
   <p:notesSz cx="6858000" cy="12192000"/>
@@ -6989,6 +6991,876 @@
       <c:layout/>
       <c:barChart>
         <c:barDir val="bar"/>
+        <c:grouping val="stacked"/>
+        <c:varyColors val="0"/>
+        <c:ser>
+          <c:idx val="0"/>
+          <c:order val="0"/>
+          <c:tx>
+            <c:strRef>
+              <c:f>Sheet1!$B$1</c:f>
+              <c:strCache>
+                <c:ptCount val="1"/>
+                <c:pt idx="0">
+                  <c:v>Top tier (Top 100 Banking / Top 50 Insurance)</c:v>
+                </c:pt>
+              </c:strCache>
+            </c:strRef>
+          </c:tx>
+          <c:spPr>
+            <a:solidFill>
+              <a:srgbClr val="86BC25"/>
+            </a:solidFill>
+            <a:effectLst/>
+          </c:spPr>
+          <c:invertIfNegative val="0"/>
+          <c:dLbls>
+            <c:numFmt formatCode="0&quot;%&quot;;-0&quot;%&quot;;;@" sourceLinked="0"/>
+            <c:txPr>
+              <a:bodyPr/>
+              <a:lstStyle/>
+              <a:p>
+                <a:pPr>
+                  <a:defRPr b="0" i="0" strike="noStrike" sz="700" u="none">
+                    <a:solidFill>
+                      <a:srgbClr val="FFFFFF"/>
+                    </a:solidFill>
+                    <a:latin typeface="Arial"/>
+                  </a:defRPr>
+                </a:pPr>
+              </a:p>
+            </c:txPr>
+            <c:dLblPos val="ctr"/>
+            <c:showLegendKey val="0"/>
+            <c:showVal val="1"/>
+            <c:showCatName val="0"/>
+            <c:showSerName val="0"/>
+            <c:showPercent val="0"/>
+            <c:showBubbleSize val="0"/>
+            <c:showLeaderLines val="0"/>
+          </c:dLbls>
+          <c:cat>
+            <c:multiLvlStrRef>
+              <c:f>Sheet1!$A$2:$A$13</c:f>
+              <c:multiLvlStrCache>
+                <c:ptCount val="12"/>
+                <c:lvl>
+                  <c:pt idx="0">
+                    <c:v>AI-enabled tools augmentation — Banking (34%)</c:v>
+                  </c:pt>
+                  <c:pt idx="1">
+                    <c:v>AI-enabled tools augmentation — Insurance (32%)</c:v>
+                  </c:pt>
+                  <c:pt idx="2">
+                    <c:v>Automating workflows — Banking (29%)</c:v>
+                  </c:pt>
+                  <c:pt idx="3">
+                    <c:v>Automating workflows — Insurance (28%)</c:v>
+                  </c:pt>
+                  <c:pt idx="4">
+                    <c:v>Redesigning processes &amp; playbooks — Banking (10%)</c:v>
+                  </c:pt>
+                  <c:pt idx="5">
+                    <c:v>Redesigning processes &amp; playbooks — Insurance (12%)</c:v>
+                  </c:pt>
+                  <c:pt idx="6">
+                    <c:v>Outsourcing — Banking (10%)</c:v>
+                  </c:pt>
+                  <c:pt idx="7">
+                    <c:v>Outsourcing — Insurance (16%)</c:v>
+                  </c:pt>
+                  <c:pt idx="8">
+                    <c:v>Hiring / workforce expansion — Banking (10%)</c:v>
+                  </c:pt>
+                  <c:pt idx="9">
+                    <c:v>Hiring / workforce expansion — Insurance (12%)</c:v>
+                  </c:pt>
+                  <c:pt idx="10">
+                    <c:v>Combination of approaches — Banking (7%)</c:v>
+                  </c:pt>
+                  <c:pt idx="11">
+                    <c:v>Combination of approaches — Insurance (0%)</c:v>
+                  </c:pt>
+                </c:lvl>
+              </c:multiLvlStrCache>
+            </c:multiLvlStrRef>
+          </c:cat>
+          <c:val>
+            <c:numRef>
+              <c:f>Sheet1!$B$2:$B$13</c:f>
+              <c:numCache>
+                <c:formatCode>General</c:formatCode>
+                <c:ptCount val="12"/>
+                <c:pt idx="0">
+                  <c:v>19</c:v>
+                </c:pt>
+                <c:pt idx="1">
+                  <c:v>28</c:v>
+                </c:pt>
+                <c:pt idx="2">
+                  <c:v>17</c:v>
+                </c:pt>
+                <c:pt idx="3">
+                  <c:v>20</c:v>
+                </c:pt>
+                <c:pt idx="4">
+                  <c:v>4</c:v>
+                </c:pt>
+                <c:pt idx="5">
+                  <c:v>4</c:v>
+                </c:pt>
+                <c:pt idx="6">
+                  <c:v>3</c:v>
+                </c:pt>
+                <c:pt idx="7">
+                  <c:v>4</c:v>
+                </c:pt>
+                <c:pt idx="8">
+                  <c:v>3</c:v>
+                </c:pt>
+                <c:pt idx="9">
+                  <c:v>4</c:v>
+                </c:pt>
+                <c:pt idx="10">
+                  <c:v>8</c:v>
+                </c:pt>
+                <c:pt idx="11">
+                  <c:v>0</c:v>
+                </c:pt>
+              </c:numCache>
+            </c:numRef>
+          </c:val>
+        </c:ser>
+        <c:ser>
+          <c:idx val="1"/>
+          <c:order val="1"/>
+          <c:tx>
+            <c:strRef>
+              <c:f>Sheet1!$C$1</c:f>
+              <c:strCache>
+                <c:ptCount val="1"/>
+                <c:pt idx="0">
+                  <c:v>Large institution (outside Top 100 / Top 50)</c:v>
+                </c:pt>
+              </c:strCache>
+            </c:strRef>
+          </c:tx>
+          <c:spPr>
+            <a:solidFill>
+              <a:srgbClr val="046A38"/>
+            </a:solidFill>
+            <a:effectLst/>
+          </c:spPr>
+          <c:invertIfNegative val="0"/>
+          <c:dLbls>
+            <c:numFmt formatCode="0&quot;%&quot;;-0&quot;%&quot;;;@" sourceLinked="0"/>
+            <c:txPr>
+              <a:bodyPr/>
+              <a:lstStyle/>
+              <a:p>
+                <a:pPr>
+                  <a:defRPr b="0" i="0" strike="noStrike" sz="700" u="none">
+                    <a:solidFill>
+                      <a:srgbClr val="FFFFFF"/>
+                    </a:solidFill>
+                    <a:latin typeface="Arial"/>
+                  </a:defRPr>
+                </a:pPr>
+              </a:p>
+            </c:txPr>
+            <c:dLblPos val="ctr"/>
+            <c:showLegendKey val="0"/>
+            <c:showVal val="1"/>
+            <c:showCatName val="0"/>
+            <c:showSerName val="0"/>
+            <c:showPercent val="0"/>
+            <c:showBubbleSize val="0"/>
+            <c:showLeaderLines val="0"/>
+          </c:dLbls>
+          <c:cat>
+            <c:multiLvlStrRef>
+              <c:f>Sheet1!$A$2:$A$13</c:f>
+              <c:multiLvlStrCache>
+                <c:ptCount val="12"/>
+                <c:lvl>
+                  <c:pt idx="0">
+                    <c:v>AI-enabled tools augmentation — Banking (34%)</c:v>
+                  </c:pt>
+                  <c:pt idx="1">
+                    <c:v>AI-enabled tools augmentation — Insurance (32%)</c:v>
+                  </c:pt>
+                  <c:pt idx="2">
+                    <c:v>Automating workflows — Banking (29%)</c:v>
+                  </c:pt>
+                  <c:pt idx="3">
+                    <c:v>Automating workflows — Insurance (28%)</c:v>
+                  </c:pt>
+                  <c:pt idx="4">
+                    <c:v>Redesigning processes &amp; playbooks — Banking (10%)</c:v>
+                  </c:pt>
+                  <c:pt idx="5">
+                    <c:v>Redesigning processes &amp; playbooks — Insurance (12%)</c:v>
+                  </c:pt>
+                  <c:pt idx="6">
+                    <c:v>Outsourcing — Banking (10%)</c:v>
+                  </c:pt>
+                  <c:pt idx="7">
+                    <c:v>Outsourcing — Insurance (16%)</c:v>
+                  </c:pt>
+                  <c:pt idx="8">
+                    <c:v>Hiring / workforce expansion — Banking (10%)</c:v>
+                  </c:pt>
+                  <c:pt idx="9">
+                    <c:v>Hiring / workforce expansion — Insurance (12%)</c:v>
+                  </c:pt>
+                  <c:pt idx="10">
+                    <c:v>Combination of approaches — Banking (7%)</c:v>
+                  </c:pt>
+                  <c:pt idx="11">
+                    <c:v>Combination of approaches — Insurance (0%)</c:v>
+                  </c:pt>
+                </c:lvl>
+              </c:multiLvlStrCache>
+            </c:multiLvlStrRef>
+          </c:cat>
+          <c:val>
+            <c:numRef>
+              <c:f>Sheet1!$C$2:$C$13</c:f>
+              <c:numCache>
+                <c:formatCode>General</c:formatCode>
+                <c:ptCount val="12"/>
+                <c:pt idx="0">
+                  <c:v>16</c:v>
+                </c:pt>
+                <c:pt idx="1">
+                  <c:v>4</c:v>
+                </c:pt>
+                <c:pt idx="2">
+                  <c:v>12</c:v>
+                </c:pt>
+                <c:pt idx="3">
+                  <c:v>8</c:v>
+                </c:pt>
+                <c:pt idx="4">
+                  <c:v>5</c:v>
+                </c:pt>
+                <c:pt idx="5">
+                  <c:v>8</c:v>
+                </c:pt>
+                <c:pt idx="6">
+                  <c:v>5</c:v>
+                </c:pt>
+                <c:pt idx="7">
+                  <c:v>12</c:v>
+                </c:pt>
+                <c:pt idx="8">
+                  <c:v>7</c:v>
+                </c:pt>
+                <c:pt idx="9">
+                  <c:v>8</c:v>
+                </c:pt>
+                <c:pt idx="10">
+                  <c:v>1</c:v>
+                </c:pt>
+                <c:pt idx="11">
+                  <c:v>0</c:v>
+                </c:pt>
+              </c:numCache>
+            </c:numRef>
+          </c:val>
+        </c:ser>
+        <c:dLbls>
+          <c:numFmt formatCode="0&quot;%&quot;;-0&quot;%&quot;;;@" sourceLinked="0"/>
+          <c:txPr>
+            <a:bodyPr/>
+            <a:lstStyle/>
+            <a:p>
+              <a:pPr>
+                <a:defRPr b="0" i="0" strike="noStrike" sz="700" u="none">
+                  <a:solidFill>
+                    <a:srgbClr val="FFFFFF"/>
+                  </a:solidFill>
+                  <a:latin typeface="Arial"/>
+                </a:defRPr>
+              </a:pPr>
+            </a:p>
+          </c:txPr>
+          <c:dLblPos val="ctr"/>
+          <c:showLegendKey val="0"/>
+          <c:showVal val="1"/>
+          <c:showCatName val="0"/>
+          <c:showSerName val="0"/>
+          <c:showPercent val="0"/>
+          <c:showBubbleSize val="0"/>
+          <c:showLeaderLines val="0"/>
+        </c:dLbls>
+        <c:gapWidth val="40"/>
+        <c:overlap val="100"/>
+        <c:axId val="2094734554"/>
+        <c:axId val="2094734552"/>
+        <c:axId val="2094734556"/>
+      </c:barChart>
+      <c:catAx>
+        <c:axId val="2094734554"/>
+        <c:scaling>
+          <c:orientation val="minMax"/>
+        </c:scaling>
+        <c:delete val="0"/>
+        <c:axPos val="l"/>
+        <c:numFmt formatCode="General" sourceLinked="1"/>
+        <c:majorTickMark val="out"/>
+        <c:minorTickMark val="none"/>
+        <c:tickLblPos val="nextTo"/>
+        <c:spPr>
+          <a:ln w="12700" cap="flat">
+            <a:noFill/>
+            <a:prstDash val="solid"/>
+            <a:round/>
+          </a:ln>
+        </c:spPr>
+        <c:txPr>
+          <a:bodyPr/>
+          <a:lstStyle/>
+          <a:p>
+            <a:pPr>
+              <a:defRPr sz="750" b="0" i="0" u="none" strike="noStrike">
+                <a:solidFill>
+                  <a:srgbClr val="53565A"/>
+                </a:solidFill>
+                <a:latin typeface="Arial"/>
+              </a:defRPr>
+            </a:pPr>
+            <a:endParaRPr lang="en-US"/>
+          </a:p>
+        </c:txPr>
+        <c:crossAx val="2094734552"/>
+        <c:crosses val="autoZero"/>
+        <c:auto val="1"/>
+        <c:lblAlgn val="ctr"/>
+        <c:noMultiLvlLbl val="1"/>
+      </c:catAx>
+      <c:valAx>
+        <c:axId val="2094734552"/>
+        <c:scaling>
+          <c:orientation val="minMax"/>
+        </c:scaling>
+        <c:delete val="1"/>
+        <c:axPos val="b"/>
+        <c:numFmt formatCode="General" sourceLinked="0"/>
+        <c:majorTickMark val="out"/>
+        <c:minorTickMark val="none"/>
+        <c:tickLblPos val="low"/>
+        <c:spPr>
+          <a:ln w="12700" cap="flat">
+            <a:noFill/>
+            <a:prstDash val="solid"/>
+            <a:round/>
+          </a:ln>
+        </c:spPr>
+        <c:txPr>
+          <a:bodyPr/>
+          <a:lstStyle/>
+          <a:p>
+            <a:pPr>
+              <a:defRPr sz="1200" b="0" i="0" u="none" strike="noStrike">
+                <a:solidFill>
+                  <a:srgbClr val="000000"/>
+                </a:solidFill>
+                <a:latin typeface="Arial"/>
+              </a:defRPr>
+            </a:pPr>
+            <a:endParaRPr lang="en-US"/>
+          </a:p>
+        </c:txPr>
+        <c:crossAx val="2094734554"/>
+        <c:crosses val="autoZero"/>
+        <c:crossBetween val="between"/>
+      </c:valAx>
+      <c:spPr>
+        <a:solidFill>
+          <a:srgbClr val="FFFFFF"/>
+        </a:solidFill>
+        <a:ln>
+          <a:noFill/>
+        </a:ln>
+        <a:effectLst/>
+      </c:spPr>
+    </c:plotArea>
+    <c:legend>
+      <c:legendPos val="b"/>
+      <c:overlay val="0"/>
+      <c:txPr>
+        <a:bodyPr/>
+        <a:lstStyle/>
+        <a:p>
+          <a:pPr>
+            <a:defRPr sz="850">      </a:defRPr>
+          </a:pPr>
+          <a:endParaRPr lang="en-US"/>
+        </a:p>
+      </c:txPr>
+    </c:legend>
+    <c:plotVisOnly val="1"/>
+    <c:dispBlanksAs val="span"/>
+  </c:chart>
+  <c:spPr>
+    <a:noFill/>
+    <a:ln>
+      <a:noFill/>
+    </a:ln>
+    <a:effectLst/>
+  </c:spPr>
+  <c:externalData r:id="rId1">
+    <c:autoUpdate val="0"/>
+  </c:externalData>
+</c:chartSpace>
+</file>
+
+<file path=ppt/charts/chart24.xml><?xml version="1.0" encoding="utf-8"?>
+<c:chartSpace xmlns:c="http://schemas.openxmlformats.org/drawingml/2006/chart" xmlns:a="http://schemas.openxmlformats.org/drawingml/2006/main" xmlns:r="http://schemas.openxmlformats.org/officeDocument/2006/relationships">
+  <c:date1904 val="0"/>
+  <c:roundedCorners val="1"/>
+  <c:chart>
+    <c:autoTitleDeleted val="1"/>
+    <c:plotArea>
+      <c:layout/>
+      <c:barChart>
+        <c:barDir val="bar"/>
+        <c:grouping val="stacked"/>
+        <c:varyColors val="0"/>
+        <c:ser>
+          <c:idx val="0"/>
+          <c:order val="0"/>
+          <c:tx>
+            <c:strRef>
+              <c:f>Sheet1!$B$1</c:f>
+              <c:strCache>
+                <c:ptCount val="1"/>
+                <c:pt idx="0">
+                  <c:v>Top tier (Top 100 Banking / Top 50 Insurance)</c:v>
+                </c:pt>
+              </c:strCache>
+            </c:strRef>
+          </c:tx>
+          <c:spPr>
+            <a:solidFill>
+              <a:srgbClr val="86BC25"/>
+            </a:solidFill>
+            <a:effectLst/>
+          </c:spPr>
+          <c:invertIfNegative val="0"/>
+          <c:dLbls>
+            <c:numFmt formatCode="0&quot;%&quot;;-0&quot;%&quot;;;@" sourceLinked="0"/>
+            <c:txPr>
+              <a:bodyPr/>
+              <a:lstStyle/>
+              <a:p>
+                <a:pPr>
+                  <a:defRPr b="0" i="0" strike="noStrike" sz="700" u="none">
+                    <a:solidFill>
+                      <a:srgbClr val="FFFFFF"/>
+                    </a:solidFill>
+                    <a:latin typeface="Arial"/>
+                  </a:defRPr>
+                </a:pPr>
+              </a:p>
+            </c:txPr>
+            <c:dLblPos val="ctr"/>
+            <c:showLegendKey val="0"/>
+            <c:showVal val="1"/>
+            <c:showCatName val="0"/>
+            <c:showSerName val="0"/>
+            <c:showPercent val="0"/>
+            <c:showBubbleSize val="0"/>
+            <c:showLeaderLines val="0"/>
+          </c:dLbls>
+          <c:cat>
+            <c:multiLvlStrRef>
+              <c:f>Sheet1!$A$2:$A$13</c:f>
+              <c:multiLvlStrCache>
+                <c:ptCount val="12"/>
+                <c:lvl>
+                  <c:pt idx="0">
+                    <c:v>AI-enabled tools augmentation — Banking (41%)</c:v>
+                  </c:pt>
+                  <c:pt idx="1">
+                    <c:v>AI-enabled tools augmentation — Insurance (40%)</c:v>
+                  </c:pt>
+                  <c:pt idx="2">
+                    <c:v>Automating workflows — Banking (27%)</c:v>
+                  </c:pt>
+                  <c:pt idx="3">
+                    <c:v>Automating workflows — Insurance (28%)</c:v>
+                  </c:pt>
+                  <c:pt idx="4">
+                    <c:v>Redesigning processes &amp; playbooks — Banking (18%)</c:v>
+                  </c:pt>
+                  <c:pt idx="5">
+                    <c:v>Redesigning processes &amp; playbooks — Insurance (24%)</c:v>
+                  </c:pt>
+                  <c:pt idx="6">
+                    <c:v>Outsourcing — Banking (7%)</c:v>
+                  </c:pt>
+                  <c:pt idx="7">
+                    <c:v>Outsourcing — Insurance (4%)</c:v>
+                  </c:pt>
+                  <c:pt idx="8">
+                    <c:v>Hiring / workforce expansion — Banking (5%)</c:v>
+                  </c:pt>
+                  <c:pt idx="9">
+                    <c:v>Hiring / workforce expansion — Insurance (4%)</c:v>
+                  </c:pt>
+                  <c:pt idx="10">
+                    <c:v>Combination of approaches — Banking (2%)</c:v>
+                  </c:pt>
+                  <c:pt idx="11">
+                    <c:v>Combination of approaches — Insurance (0%)</c:v>
+                  </c:pt>
+                </c:lvl>
+              </c:multiLvlStrCache>
+            </c:multiLvlStrRef>
+          </c:cat>
+          <c:val>
+            <c:numRef>
+              <c:f>Sheet1!$B$2:$B$13</c:f>
+              <c:numCache>
+                <c:formatCode>General</c:formatCode>
+                <c:ptCount val="12"/>
+                <c:pt idx="0">
+                  <c:v>21</c:v>
+                </c:pt>
+                <c:pt idx="1">
+                  <c:v>24</c:v>
+                </c:pt>
+                <c:pt idx="2">
+                  <c:v>17</c:v>
+                </c:pt>
+                <c:pt idx="3">
+                  <c:v>16</c:v>
+                </c:pt>
+                <c:pt idx="4">
+                  <c:v>8</c:v>
+                </c:pt>
+                <c:pt idx="5">
+                  <c:v>16</c:v>
+                </c:pt>
+                <c:pt idx="6">
+                  <c:v>4</c:v>
+                </c:pt>
+                <c:pt idx="7">
+                  <c:v>4</c:v>
+                </c:pt>
+                <c:pt idx="8">
+                  <c:v>1</c:v>
+                </c:pt>
+                <c:pt idx="9">
+                  <c:v>0</c:v>
+                </c:pt>
+                <c:pt idx="10">
+                  <c:v>1</c:v>
+                </c:pt>
+                <c:pt idx="11">
+                  <c:v>0</c:v>
+                </c:pt>
+              </c:numCache>
+            </c:numRef>
+          </c:val>
+        </c:ser>
+        <c:ser>
+          <c:idx val="1"/>
+          <c:order val="1"/>
+          <c:tx>
+            <c:strRef>
+              <c:f>Sheet1!$C$1</c:f>
+              <c:strCache>
+                <c:ptCount val="1"/>
+                <c:pt idx="0">
+                  <c:v>Large institution (outside Top 100 / Top 50)</c:v>
+                </c:pt>
+              </c:strCache>
+            </c:strRef>
+          </c:tx>
+          <c:spPr>
+            <a:solidFill>
+              <a:srgbClr val="046A38"/>
+            </a:solidFill>
+            <a:effectLst/>
+          </c:spPr>
+          <c:invertIfNegative val="0"/>
+          <c:dLbls>
+            <c:numFmt formatCode="0&quot;%&quot;;-0&quot;%&quot;;;@" sourceLinked="0"/>
+            <c:txPr>
+              <a:bodyPr/>
+              <a:lstStyle/>
+              <a:p>
+                <a:pPr>
+                  <a:defRPr b="0" i="0" strike="noStrike" sz="700" u="none">
+                    <a:solidFill>
+                      <a:srgbClr val="FFFFFF"/>
+                    </a:solidFill>
+                    <a:latin typeface="Arial"/>
+                  </a:defRPr>
+                </a:pPr>
+              </a:p>
+            </c:txPr>
+            <c:dLblPos val="ctr"/>
+            <c:showLegendKey val="0"/>
+            <c:showVal val="1"/>
+            <c:showCatName val="0"/>
+            <c:showSerName val="0"/>
+            <c:showPercent val="0"/>
+            <c:showBubbleSize val="0"/>
+            <c:showLeaderLines val="0"/>
+          </c:dLbls>
+          <c:cat>
+            <c:multiLvlStrRef>
+              <c:f>Sheet1!$A$2:$A$13</c:f>
+              <c:multiLvlStrCache>
+                <c:ptCount val="12"/>
+                <c:lvl>
+                  <c:pt idx="0">
+                    <c:v>AI-enabled tools augmentation — Banking (41%)</c:v>
+                  </c:pt>
+                  <c:pt idx="1">
+                    <c:v>AI-enabled tools augmentation — Insurance (40%)</c:v>
+                  </c:pt>
+                  <c:pt idx="2">
+                    <c:v>Automating workflows — Banking (27%)</c:v>
+                  </c:pt>
+                  <c:pt idx="3">
+                    <c:v>Automating workflows — Insurance (28%)</c:v>
+                  </c:pt>
+                  <c:pt idx="4">
+                    <c:v>Redesigning processes &amp; playbooks — Banking (18%)</c:v>
+                  </c:pt>
+                  <c:pt idx="5">
+                    <c:v>Redesigning processes &amp; playbooks — Insurance (24%)</c:v>
+                  </c:pt>
+                  <c:pt idx="6">
+                    <c:v>Outsourcing — Banking (7%)</c:v>
+                  </c:pt>
+                  <c:pt idx="7">
+                    <c:v>Outsourcing — Insurance (4%)</c:v>
+                  </c:pt>
+                  <c:pt idx="8">
+                    <c:v>Hiring / workforce expansion — Banking (5%)</c:v>
+                  </c:pt>
+                  <c:pt idx="9">
+                    <c:v>Hiring / workforce expansion — Insurance (4%)</c:v>
+                  </c:pt>
+                  <c:pt idx="10">
+                    <c:v>Combination of approaches — Banking (2%)</c:v>
+                  </c:pt>
+                  <c:pt idx="11">
+                    <c:v>Combination of approaches — Insurance (0%)</c:v>
+                  </c:pt>
+                </c:lvl>
+              </c:multiLvlStrCache>
+            </c:multiLvlStrRef>
+          </c:cat>
+          <c:val>
+            <c:numRef>
+              <c:f>Sheet1!$C$2:$C$13</c:f>
+              <c:numCache>
+                <c:formatCode>General</c:formatCode>
+                <c:ptCount val="12"/>
+                <c:pt idx="0">
+                  <c:v>20</c:v>
+                </c:pt>
+                <c:pt idx="1">
+                  <c:v>16</c:v>
+                </c:pt>
+                <c:pt idx="2">
+                  <c:v>9</c:v>
+                </c:pt>
+                <c:pt idx="3">
+                  <c:v>12</c:v>
+                </c:pt>
+                <c:pt idx="4">
+                  <c:v>8</c:v>
+                </c:pt>
+                <c:pt idx="5">
+                  <c:v>8</c:v>
+                </c:pt>
+                <c:pt idx="6">
+                  <c:v>4</c:v>
+                </c:pt>
+                <c:pt idx="7">
+                  <c:v>0</c:v>
+                </c:pt>
+                <c:pt idx="8">
+                  <c:v>4</c:v>
+                </c:pt>
+                <c:pt idx="9">
+                  <c:v>4</c:v>
+                </c:pt>
+                <c:pt idx="10">
+                  <c:v>1</c:v>
+                </c:pt>
+                <c:pt idx="11">
+                  <c:v>0</c:v>
+                </c:pt>
+              </c:numCache>
+            </c:numRef>
+          </c:val>
+        </c:ser>
+        <c:dLbls>
+          <c:numFmt formatCode="0&quot;%&quot;;-0&quot;%&quot;;;@" sourceLinked="0"/>
+          <c:txPr>
+            <a:bodyPr/>
+            <a:lstStyle/>
+            <a:p>
+              <a:pPr>
+                <a:defRPr b="0" i="0" strike="noStrike" sz="700" u="none">
+                  <a:solidFill>
+                    <a:srgbClr val="FFFFFF"/>
+                  </a:solidFill>
+                  <a:latin typeface="Arial"/>
+                </a:defRPr>
+              </a:pPr>
+            </a:p>
+          </c:txPr>
+          <c:dLblPos val="ctr"/>
+          <c:showLegendKey val="0"/>
+          <c:showVal val="1"/>
+          <c:showCatName val="0"/>
+          <c:showSerName val="0"/>
+          <c:showPercent val="0"/>
+          <c:showBubbleSize val="0"/>
+          <c:showLeaderLines val="0"/>
+        </c:dLbls>
+        <c:gapWidth val="40"/>
+        <c:overlap val="100"/>
+        <c:axId val="2094734554"/>
+        <c:axId val="2094734552"/>
+        <c:axId val="2094734556"/>
+      </c:barChart>
+      <c:catAx>
+        <c:axId val="2094734554"/>
+        <c:scaling>
+          <c:orientation val="minMax"/>
+        </c:scaling>
+        <c:delete val="0"/>
+        <c:axPos val="l"/>
+        <c:numFmt formatCode="General" sourceLinked="1"/>
+        <c:majorTickMark val="out"/>
+        <c:minorTickMark val="none"/>
+        <c:tickLblPos val="nextTo"/>
+        <c:spPr>
+          <a:ln w="12700" cap="flat">
+            <a:noFill/>
+            <a:prstDash val="solid"/>
+            <a:round/>
+          </a:ln>
+        </c:spPr>
+        <c:txPr>
+          <a:bodyPr/>
+          <a:lstStyle/>
+          <a:p>
+            <a:pPr>
+              <a:defRPr sz="750" b="0" i="0" u="none" strike="noStrike">
+                <a:solidFill>
+                  <a:srgbClr val="53565A"/>
+                </a:solidFill>
+                <a:latin typeface="Arial"/>
+              </a:defRPr>
+            </a:pPr>
+            <a:endParaRPr lang="en-US"/>
+          </a:p>
+        </c:txPr>
+        <c:crossAx val="2094734552"/>
+        <c:crosses val="autoZero"/>
+        <c:auto val="1"/>
+        <c:lblAlgn val="ctr"/>
+        <c:noMultiLvlLbl val="1"/>
+      </c:catAx>
+      <c:valAx>
+        <c:axId val="2094734552"/>
+        <c:scaling>
+          <c:orientation val="minMax"/>
+        </c:scaling>
+        <c:delete val="1"/>
+        <c:axPos val="b"/>
+        <c:numFmt formatCode="General" sourceLinked="0"/>
+        <c:majorTickMark val="out"/>
+        <c:minorTickMark val="none"/>
+        <c:tickLblPos val="low"/>
+        <c:spPr>
+          <a:ln w="12700" cap="flat">
+            <a:noFill/>
+            <a:prstDash val="solid"/>
+            <a:round/>
+          </a:ln>
+        </c:spPr>
+        <c:txPr>
+          <a:bodyPr/>
+          <a:lstStyle/>
+          <a:p>
+            <a:pPr>
+              <a:defRPr sz="1200" b="0" i="0" u="none" strike="noStrike">
+                <a:solidFill>
+                  <a:srgbClr val="000000"/>
+                </a:solidFill>
+                <a:latin typeface="Arial"/>
+              </a:defRPr>
+            </a:pPr>
+            <a:endParaRPr lang="en-US"/>
+          </a:p>
+        </c:txPr>
+        <c:crossAx val="2094734554"/>
+        <c:crosses val="autoZero"/>
+        <c:crossBetween val="between"/>
+      </c:valAx>
+      <c:spPr>
+        <a:solidFill>
+          <a:srgbClr val="FFFFFF"/>
+        </a:solidFill>
+        <a:ln>
+          <a:noFill/>
+        </a:ln>
+        <a:effectLst/>
+      </c:spPr>
+    </c:plotArea>
+    <c:legend>
+      <c:legendPos val="b"/>
+      <c:overlay val="0"/>
+      <c:txPr>
+        <a:bodyPr/>
+        <a:lstStyle/>
+        <a:p>
+          <a:pPr>
+            <a:defRPr sz="850">      </a:defRPr>
+          </a:pPr>
+          <a:endParaRPr lang="en-US"/>
+        </a:p>
+      </c:txPr>
+    </c:legend>
+    <c:plotVisOnly val="1"/>
+    <c:dispBlanksAs val="span"/>
+  </c:chart>
+  <c:spPr>
+    <a:noFill/>
+    <a:ln>
+      <a:noFill/>
+    </a:ln>
+    <a:effectLst/>
+  </c:spPr>
+  <c:externalData r:id="rId1">
+    <c:autoUpdate val="0"/>
+  </c:externalData>
+</c:chartSpace>
+</file>
+
+<file path=ppt/charts/chart25.xml><?xml version="1.0" encoding="utf-8"?>
+<c:chartSpace xmlns:c="http://schemas.openxmlformats.org/drawingml/2006/chart" xmlns:a="http://schemas.openxmlformats.org/drawingml/2006/main" xmlns:r="http://schemas.openxmlformats.org/officeDocument/2006/relationships">
+  <c:date1904 val="0"/>
+  <c:roundedCorners val="1"/>
+  <c:chart>
+    <c:autoTitleDeleted val="1"/>
+    <c:plotArea>
+      <c:layout/>
+      <c:barChart>
+        <c:barDir val="bar"/>
         <c:grouping val="clustered"/>
         <c:varyColors val="0"/>
         <c:ser>
@@ -7206,7 +8078,7 @@
 </c:chartSpace>
 </file>
 
-<file path=ppt/charts/chart24.xml><?xml version="1.0" encoding="utf-8"?>
+<file path=ppt/charts/chart26.xml><?xml version="1.0" encoding="utf-8"?>
 <c:chartSpace xmlns:c="http://schemas.openxmlformats.org/drawingml/2006/chart" xmlns:a="http://schemas.openxmlformats.org/drawingml/2006/main" xmlns:r="http://schemas.openxmlformats.org/officeDocument/2006/relationships">
   <c:date1904 val="0"/>
   <c:roundedCorners val="1"/>
@@ -12260,6 +13132,182 @@
             <a:fld id="{F7021451-1387-4CA6-816F-3879F97B5CBC}" type="slidenum">
               <a:rPr lang="en-US"/>
               <a:t>31</a:t>
+            </a:fld>
+            <a:endParaRPr lang="en-US"/>
+          </a:p>
+        </p:txBody>
+      </p:sp>
+    </p:spTree>
+    <p:extLst>
+      <p:ext uri="{BB962C8B-B14F-4D97-AF65-F5344CB8AC3E}">
+        <p14:creationId xmlns:p14="http://schemas.microsoft.com/office/powerpoint/2010/main" val="1024086991"/>
+      </p:ext>
+    </p:extLst>
+  </p:cSld>
+  <p:clrMapOvr>
+    <a:masterClrMapping/>
+  </p:clrMapOvr>
+</p:notes>
+</file>
+
+<file path=ppt/notesSlides/notesSlide32.xml><?xml version="1.0" encoding="utf-8"?>
+<p:notes xmlns:a="http://schemas.openxmlformats.org/drawingml/2006/main" xmlns:r="http://schemas.openxmlformats.org/officeDocument/2006/relationships" xmlns:p="http://schemas.openxmlformats.org/presentationml/2006/main">
+  <p:cSld>
+    <p:spTree>
+      <p:nvGrpSpPr>
+        <p:cNvPr id="1" name=""/>
+        <p:cNvGrpSpPr/>
+        <p:nvPr/>
+      </p:nvGrpSpPr>
+      <p:grpSpPr>
+        <a:xfrm>
+          <a:off x="0" y="0"/>
+          <a:ext cx="0" cy="0"/>
+          <a:chOff x="0" y="0"/>
+          <a:chExt cx="0" cy="0"/>
+        </a:xfrm>
+      </p:grpSpPr>
+      <p:sp>
+        <p:nvSpPr>
+          <p:cNvPr id="2" name="Slide Image Placeholder 1"/>
+          <p:cNvSpPr>
+            <a:spLocks noGrp="1" noRot="1" noChangeAspect="1"/>
+          </p:cNvSpPr>
+          <p:nvPr>
+            <p:ph type="sldImg"/>
+          </p:nvPr>
+        </p:nvSpPr>
+        <p:spPr/>
+      </p:sp>
+      <p:sp>
+        <p:nvSpPr>
+          <p:cNvPr id="3" name="Notes Placeholder 2"/>
+          <p:cNvSpPr>
+            <a:spLocks noGrp="1"/>
+          </p:cNvSpPr>
+          <p:nvPr>
+            <p:ph type="body" idx="1"/>
+          </p:nvPr>
+        </p:nvSpPr>
+        <p:spPr/>
+        <p:txBody>
+          <a:bodyPr/>
+          <a:lstStyle/>
+          <a:p>
+            <a:r>
+              <a:rPr lang="en-US" dirty="0"/>
+              <a:t/>
+            </a:r>
+            <a:endParaRPr lang="en-US" dirty="0"/>
+          </a:p>
+        </p:txBody>
+      </p:sp>
+      <p:sp>
+        <p:nvSpPr>
+          <p:cNvPr id="4" name="Slide Number Placeholder 3"/>
+          <p:cNvSpPr>
+            <a:spLocks noGrp="1"/>
+          </p:cNvSpPr>
+          <p:nvPr>
+            <p:ph type="sldNum" sz="quarter" idx="10"/>
+          </p:nvPr>
+        </p:nvSpPr>
+        <p:spPr/>
+        <p:txBody>
+          <a:bodyPr/>
+          <a:lstStyle/>
+          <a:p>
+            <a:fld id="{F7021451-1387-4CA6-816F-3879F97B5CBC}" type="slidenum">
+              <a:rPr lang="en-US"/>
+              <a:t>32</a:t>
+            </a:fld>
+            <a:endParaRPr lang="en-US"/>
+          </a:p>
+        </p:txBody>
+      </p:sp>
+    </p:spTree>
+    <p:extLst>
+      <p:ext uri="{BB962C8B-B14F-4D97-AF65-F5344CB8AC3E}">
+        <p14:creationId xmlns:p14="http://schemas.microsoft.com/office/powerpoint/2010/main" val="1024086991"/>
+      </p:ext>
+    </p:extLst>
+  </p:cSld>
+  <p:clrMapOvr>
+    <a:masterClrMapping/>
+  </p:clrMapOvr>
+</p:notes>
+</file>
+
+<file path=ppt/notesSlides/notesSlide33.xml><?xml version="1.0" encoding="utf-8"?>
+<p:notes xmlns:a="http://schemas.openxmlformats.org/drawingml/2006/main" xmlns:r="http://schemas.openxmlformats.org/officeDocument/2006/relationships" xmlns:p="http://schemas.openxmlformats.org/presentationml/2006/main">
+  <p:cSld>
+    <p:spTree>
+      <p:nvGrpSpPr>
+        <p:cNvPr id="1" name=""/>
+        <p:cNvGrpSpPr/>
+        <p:nvPr/>
+      </p:nvGrpSpPr>
+      <p:grpSpPr>
+        <a:xfrm>
+          <a:off x="0" y="0"/>
+          <a:ext cx="0" cy="0"/>
+          <a:chOff x="0" y="0"/>
+          <a:chExt cx="0" cy="0"/>
+        </a:xfrm>
+      </p:grpSpPr>
+      <p:sp>
+        <p:nvSpPr>
+          <p:cNvPr id="2" name="Slide Image Placeholder 1"/>
+          <p:cNvSpPr>
+            <a:spLocks noGrp="1" noRot="1" noChangeAspect="1"/>
+          </p:cNvSpPr>
+          <p:nvPr>
+            <p:ph type="sldImg"/>
+          </p:nvPr>
+        </p:nvSpPr>
+        <p:spPr/>
+      </p:sp>
+      <p:sp>
+        <p:nvSpPr>
+          <p:cNvPr id="3" name="Notes Placeholder 2"/>
+          <p:cNvSpPr>
+            <a:spLocks noGrp="1"/>
+          </p:cNvSpPr>
+          <p:nvPr>
+            <p:ph type="body" idx="1"/>
+          </p:nvPr>
+        </p:nvSpPr>
+        <p:spPr/>
+        <p:txBody>
+          <a:bodyPr/>
+          <a:lstStyle/>
+          <a:p>
+            <a:r>
+              <a:rPr lang="en-US" dirty="0"/>
+              <a:t/>
+            </a:r>
+            <a:endParaRPr lang="en-US" dirty="0"/>
+          </a:p>
+        </p:txBody>
+      </p:sp>
+      <p:sp>
+        <p:nvSpPr>
+          <p:cNvPr id="4" name="Slide Number Placeholder 3"/>
+          <p:cNvSpPr>
+            <a:spLocks noGrp="1"/>
+          </p:cNvSpPr>
+          <p:nvPr>
+            <p:ph type="sldNum" sz="quarter" idx="10"/>
+          </p:nvPr>
+        </p:nvSpPr>
+        <p:spPr/>
+        <p:txBody>
+          <a:bodyPr/>
+          <a:lstStyle/>
+          <a:p>
+            <a:fld id="{F7021451-1387-4CA6-816F-3879F97B5CBC}" type="slidenum">
+              <a:rPr lang="en-US"/>
+              <a:t>33</a:t>
             </a:fld>
             <a:endParaRPr lang="en-US"/>
           </a:p>
@@ -20825,7 +21873,7 @@
     <p:bg>
       <p:bgPr>
         <a:solidFill>
-          <a:srgbClr val="86BC25"/>
+          <a:srgbClr val="FFFFFF"/>
         </a:solidFill>
       </p:bgPr>
     </p:bg>
@@ -20851,47 +21899,8 @@
         </p:nvSpPr>
         <p:spPr>
           <a:xfrm>
-            <a:off x="502920" y="1699870"/>
-            <a:ext cx="10415016" cy="1591970"/>
-          </a:xfrm>
-          <a:prstGeom prst="rect">
-            <a:avLst/>
-          </a:prstGeom>
-          <a:noFill/>
-          <a:ln/>
-        </p:spPr>
-        <p:txBody>
-          <a:bodyPr wrap="square" lIns="0" tIns="0" rIns="0" bIns="0" rtlCol="0" anchor="b"/>
-          <a:lstStyle/>
-          <a:p>
-            <a:pPr algn="l" indent="0" marL="0">
-              <a:buNone/>
-            </a:pPr>
-            <a:r>
-              <a:rPr lang="en-US" sz="3600" b="1" dirty="0">
-                <a:solidFill>
-                  <a:srgbClr val="FFFFFF"/>
-                </a:solidFill>
-                <a:latin typeface="Calibri" pitchFamily="34" charset="0"/>
-                <a:ea typeface="Calibri" pitchFamily="34" charset="-122"/>
-                <a:cs typeface="Calibri" pitchFamily="34" charset="-120"/>
-              </a:rPr>
-              <a:t>5. Regulatory &amp; Market Change</a:t>
-            </a:r>
-            <a:endParaRPr lang="en-US" sz="3600" dirty="0"/>
-          </a:p>
-        </p:txBody>
-      </p:sp>
-      <p:sp>
-        <p:nvSpPr>
-          <p:cNvPr id="3" name="Text 1"/>
-          <p:cNvSpPr txBox="1"/>
-          <p:nvPr/>
-        </p:nvSpPr>
-        <p:spPr>
-          <a:xfrm>
-            <a:off x="502920" y="3423514"/>
-            <a:ext cx="10415016" cy="1563624"/>
+            <a:off x="502006" y="256032"/>
+            <a:ext cx="11188598" cy="310896"/>
           </a:xfrm>
           <a:prstGeom prst="rect">
             <a:avLst/>
@@ -20904,29 +21913,150 @@
           <a:lstStyle/>
           <a:p>
             <a:pPr algn="l" indent="0" marL="0">
+              <a:buNone/>
+            </a:pPr>
+            <a:r>
+              <a:rPr lang="en-US" sz="1900" b="1" dirty="0">
+                <a:solidFill>
+                  <a:srgbClr val="000000"/>
+                </a:solidFill>
+                <a:latin typeface="Calibri" pitchFamily="34" charset="0"/>
+                <a:ea typeface="Calibri" pitchFamily="34" charset="-122"/>
+                <a:cs typeface="Calibri" pitchFamily="34" charset="-120"/>
+              </a:rPr>
+              <a:t>Current Scaling Approach — By Sector and Institution Tier</a:t>
+            </a:r>
+            <a:endParaRPr lang="en-US" sz="1900" dirty="0"/>
+          </a:p>
+        </p:txBody>
+      </p:sp>
+      <p:sp>
+        <p:nvSpPr>
+          <p:cNvPr id="3" name="Text 1"/>
+          <p:cNvSpPr txBox="1"/>
+          <p:nvPr/>
+        </p:nvSpPr>
+        <p:spPr>
+          <a:xfrm>
+            <a:off x="502006" y="585216"/>
+            <a:ext cx="11188598" cy="713232"/>
+          </a:xfrm>
+          <a:prstGeom prst="rect">
+            <a:avLst/>
+          </a:prstGeom>
+          <a:noFill/>
+          <a:ln/>
+        </p:spPr>
+        <p:txBody>
+          <a:bodyPr wrap="square" lIns="0" tIns="0" rIns="0" bIns="0" rtlCol="0" anchor="t"/>
+          <a:lstStyle/>
+          <a:p>
+            <a:pPr algn="l" indent="0" marL="0">
               <a:lnSpc>
-                <a:spcPct val="110000"/>
+                <a:spcPct val="105000"/>
               </a:lnSpc>
               <a:buNone/>
             </a:pPr>
             <a:r>
-              <a:rPr lang="en-US" sz="1600" dirty="0">
-                <a:solidFill>
-                  <a:srgbClr val="FFFFFF"/>
-                </a:solidFill>
-                <a:latin typeface="Calibri" pitchFamily="34" charset="0"/>
-                <a:ea typeface="Calibri" pitchFamily="34" charset="-122"/>
-                <a:cs typeface="Calibri" pitchFamily="34" charset="-120"/>
-              </a:rPr>
-              <a:t>Where fraud investment is really going, and the disruption leaders see coming next.</a:t>
-            </a:r>
-            <a:endParaRPr lang="en-US" sz="1600" dirty="0"/>
+              <a:rPr lang="en-US" sz="1350" b="1" dirty="0">
+                <a:solidFill>
+                  <a:srgbClr val="046A38"/>
+                </a:solidFill>
+                <a:latin typeface="Calibri" pitchFamily="34" charset="0"/>
+                <a:ea typeface="Calibri" pitchFamily="34" charset="-122"/>
+                <a:cs typeface="Calibri" pitchFamily="34" charset="-120"/>
+              </a:rPr>
+              <a:t>AI-enabled tools lead in both sectors, but Top-tier institutions lean on it more heavily than Large institutions.</a:t>
+            </a:r>
+            <a:endParaRPr lang="en-US" sz="1350" dirty="0"/>
           </a:p>
         </p:txBody>
       </p:sp>
       <p:sp>
         <p:nvSpPr>
-          <p:cNvPr id="4" name="Text 2"/>
+          <p:cNvPr id="4" name="Shape 2"/>
+          <p:cNvSpPr/>
+          <p:nvPr/>
+        </p:nvSpPr>
+        <p:spPr>
+          <a:xfrm>
+            <a:off x="502006" y="1335024"/>
+            <a:ext cx="0" cy="512064"/>
+          </a:xfrm>
+          <a:prstGeom prst="line">
+            <a:avLst/>
+          </a:prstGeom>
+          <a:noFill/>
+          <a:ln w="25400">
+            <a:solidFill>
+              <a:srgbClr val="D0D0CE"/>
+            </a:solidFill>
+            <a:prstDash val="solid"/>
+          </a:ln>
+        </p:spPr>
+      </p:sp>
+      <p:sp>
+        <p:nvSpPr>
+          <p:cNvPr id="5" name="Text 3"/>
+          <p:cNvSpPr txBox="1"/>
+          <p:nvPr/>
+        </p:nvSpPr>
+        <p:spPr>
+          <a:xfrm>
+            <a:off x="648310" y="1335024"/>
+            <a:ext cx="11042294" cy="512064"/>
+          </a:xfrm>
+          <a:prstGeom prst="rect">
+            <a:avLst/>
+          </a:prstGeom>
+          <a:noFill/>
+          <a:ln/>
+        </p:spPr>
+        <p:txBody>
+          <a:bodyPr wrap="square" lIns="0" tIns="0" rIns="0" bIns="0" rtlCol="0" anchor="t"/>
+          <a:lstStyle/>
+          <a:p>
+            <a:pPr algn="l" indent="0" marL="0">
+              <a:lnSpc>
+                <a:spcPct val="106000"/>
+              </a:lnSpc>
+              <a:buNone/>
+            </a:pPr>
+            <a:r>
+              <a:rPr lang="en-US" sz="900" b="1" dirty="0">
+                <a:solidFill>
+                  <a:srgbClr val="046A38"/>
+                </a:solidFill>
+                <a:latin typeface="IBM Plex Mono" pitchFamily="34" charset="0"/>
+                <a:ea typeface="IBM Plex Mono" pitchFamily="34" charset="-122"/>
+                <a:cs typeface="IBM Plex Mono" pitchFamily="34" charset="-120"/>
+              </a:rPr>
+              <a:t>Q8 / newS8 / S9  </a:t>
+            </a:r>
+            <a:pPr algn="l" indent="0" marL="0">
+              <a:lnSpc>
+                <a:spcPct val="106000"/>
+              </a:lnSpc>
+              <a:buNone/>
+            </a:pPr>
+            <a:r>
+              <a:rPr lang="en-US" sz="1000" i="1" dirty="0">
+                <a:solidFill>
+                  <a:srgbClr val="575757"/>
+                </a:solidFill>
+                <a:latin typeface="Calibri" pitchFamily="34" charset="0"/>
+                <a:ea typeface="Calibri" pitchFamily="34" charset="-122"/>
+                <a:cs typeface="Calibri" pitchFamily="34" charset="-120"/>
+              </a:rPr>
+              <a:t>“Which statement best describes your current approach to scaling fraud/investigations operations as fraud volume and complexity increases? (Banking vs. Insurance, further broken down by institution tier)”</a:t>
+            </a:r>
+            <a:endParaRPr lang="en-US" sz="1000" dirty="0"/>
+          </a:p>
+        </p:txBody>
+      </p:sp>
+      <p:sp>
+        <p:nvSpPr>
+          <p:cNvPr id="6" name="Text 4"/>
           <p:cNvSpPr txBox="1"/>
           <p:nvPr/>
         </p:nvSpPr>
@@ -20951,7 +22081,7 @@
             <a:r>
               <a:rPr lang="en-US" sz="900" dirty="0">
                 <a:solidFill>
-                  <a:srgbClr val="FFFFFF"/>
+                  <a:srgbClr val="53565A"/>
                 </a:solidFill>
                 <a:latin typeface="Calibri" pitchFamily="34" charset="0"/>
                 <a:ea typeface="Calibri" pitchFamily="34" charset="-122"/>
@@ -20960,6 +22090,163 @@
               <a:t>25</a:t>
             </a:r>
             <a:endParaRPr lang="en-US" sz="900" dirty="0"/>
+          </a:p>
+        </p:txBody>
+      </p:sp>
+      <p:graphicFrame>
+        <p:nvGraphicFramePr>
+          <p:cNvPr id="7" name="Chart 0" descr=""/>
+          <p:cNvGraphicFramePr/>
+          <p:nvPr/>
+        </p:nvGraphicFramePr>
+        <p:xfrm>
+          <a:off x="502006" y="2011680"/>
+          <a:ext cx="11188598" cy="3063240"/>
+        </p:xfrm>
+        <a:graphic xmlns:a="http://schemas.openxmlformats.org/drawingml/2006/main">
+          <a:graphicData uri="http://schemas.openxmlformats.org/drawingml/2006/chart">
+            <c:chart xmlns:c="http://schemas.openxmlformats.org/drawingml/2006/chart" r:id="rId1"/>
+          </a:graphicData>
+        </a:graphic>
+      </p:graphicFrame>
+      <p:sp>
+        <p:nvSpPr>
+          <p:cNvPr id="8" name="Shape 5"/>
+          <p:cNvSpPr/>
+          <p:nvPr/>
+        </p:nvSpPr>
+        <p:spPr>
+          <a:xfrm>
+            <a:off x="502006" y="5202936"/>
+            <a:ext cx="11188598" cy="0"/>
+          </a:xfrm>
+          <a:prstGeom prst="line">
+            <a:avLst/>
+          </a:prstGeom>
+          <a:noFill/>
+          <a:ln w="9525">
+            <a:solidFill>
+              <a:srgbClr val="D0D0CE"/>
+            </a:solidFill>
+            <a:prstDash val="solid"/>
+          </a:ln>
+        </p:spPr>
+      </p:sp>
+      <p:sp>
+        <p:nvSpPr>
+          <p:cNvPr id="9" name="Text 6"/>
+          <p:cNvSpPr txBox="1"/>
+          <p:nvPr/>
+        </p:nvSpPr>
+        <p:spPr>
+          <a:xfrm>
+            <a:off x="502006" y="5276088"/>
+            <a:ext cx="11188598" cy="548640"/>
+          </a:xfrm>
+          <a:prstGeom prst="rect">
+            <a:avLst/>
+          </a:prstGeom>
+          <a:noFill/>
+          <a:ln/>
+        </p:spPr>
+        <p:txBody>
+          <a:bodyPr wrap="square" lIns="0" tIns="0" rIns="0" bIns="0" rtlCol="0" anchor="t"/>
+          <a:lstStyle/>
+          <a:p>
+            <a:pPr algn="l" indent="0" marL="0">
+              <a:lnSpc>
+                <a:spcPct val="115000"/>
+              </a:lnSpc>
+              <a:buNone/>
+            </a:pPr>
+            <a:r>
+              <a:rPr lang="en-US" sz="850" b="1" dirty="0">
+                <a:solidFill>
+                  <a:srgbClr val="53565A"/>
+                </a:solidFill>
+                <a:latin typeface="Calibri" pitchFamily="34" charset="0"/>
+                <a:ea typeface="Calibri" pitchFamily="34" charset="-122"/>
+                <a:cs typeface="Calibri" pitchFamily="34" charset="-120"/>
+              </a:rPr>
+              <a:t>Single select. </a:t>
+            </a:r>
+            <a:pPr algn="l" indent="0" marL="0">
+              <a:lnSpc>
+                <a:spcPct val="115000"/>
+              </a:lnSpc>
+              <a:buNone/>
+            </a:pPr>
+            <a:r>
+              <a:rPr lang="en-US" sz="850" dirty="0">
+                <a:solidFill>
+                  <a:srgbClr val="53565A"/>
+                </a:solidFill>
+                <a:latin typeface="Calibri" pitchFamily="34" charset="0"/>
+                <a:ea typeface="Calibri" pitchFamily="34" charset="-122"/>
+                <a:cs typeface="Calibri" pitchFamily="34" charset="-120"/>
+              </a:rPr>
+              <a:t>The % in each category label is the full sector-level figure; tier segments are rounded to the nearest whole percent and may sum to within ±1pt of that total. Institution tier is based on newS8 (Banking) / S9 (Insurance), including respondents reclassified from their employer description elsewhere in the survey — Banking Top 100 is n=40, Insurance Large is n=10 (see the Q1 sector x tier slide for detail).</a:t>
+            </a:r>
+            <a:endParaRPr lang="en-US" sz="850" dirty="0"/>
+          </a:p>
+        </p:txBody>
+      </p:sp>
+      <p:sp>
+        <p:nvSpPr>
+          <p:cNvPr id="10" name="Text 7"/>
+          <p:cNvSpPr txBox="1"/>
+          <p:nvPr/>
+        </p:nvSpPr>
+        <p:spPr>
+          <a:xfrm>
+            <a:off x="502006" y="5843016"/>
+            <a:ext cx="11188598" cy="402336"/>
+          </a:xfrm>
+          <a:prstGeom prst="rect">
+            <a:avLst/>
+          </a:prstGeom>
+          <a:noFill/>
+          <a:ln/>
+        </p:spPr>
+        <p:txBody>
+          <a:bodyPr wrap="square" lIns="0" tIns="0" rIns="0" bIns="0" rtlCol="0" anchor="t"/>
+          <a:lstStyle/>
+          <a:p>
+            <a:pPr algn="l" indent="0" marL="0">
+              <a:lnSpc>
+                <a:spcPct val="110000"/>
+              </a:lnSpc>
+              <a:buNone/>
+            </a:pPr>
+            <a:r>
+              <a:rPr lang="en-US" sz="850" b="1" dirty="0">
+                <a:solidFill>
+                  <a:srgbClr val="53565A"/>
+                </a:solidFill>
+                <a:latin typeface="Calibri" pitchFamily="34" charset="0"/>
+                <a:ea typeface="Calibri" pitchFamily="34" charset="-122"/>
+                <a:cs typeface="Calibri" pitchFamily="34" charset="-120"/>
+              </a:rPr>
+              <a:t>Response options as fielded: </a:t>
+            </a:r>
+            <a:pPr algn="l" indent="0" marL="0">
+              <a:lnSpc>
+                <a:spcPct val="110000"/>
+              </a:lnSpc>
+              <a:buNone/>
+            </a:pPr>
+            <a:r>
+              <a:rPr lang="en-US" sz="800" i="1" dirty="0">
+                <a:solidFill>
+                  <a:srgbClr val="53565A"/>
+                </a:solidFill>
+                <a:latin typeface="Calibri" pitchFamily="34" charset="0"/>
+                <a:ea typeface="Calibri" pitchFamily="34" charset="-122"/>
+                <a:cs typeface="Calibri" pitchFamily="34" charset="-120"/>
+              </a:rPr>
+              <a:t>“Adding capacity through hiring full-time employees and workforce expansion” · “Adding capacity through outsourcing arrangements (e.g., contractors)” · “Automating workflows and minimizing manual activities” · “Augmenting existing capacity with AI-enabled tools” · “Redesigning operation processes and playbooks across the lifecycle” · “Pursuing a combination of the above approaches”</a:t>
+            </a:r>
+            <a:endParaRPr lang="en-US" sz="850" dirty="0"/>
           </a:p>
         </p:txBody>
       </p:sp>
@@ -21028,7 +22315,7 @@
                 <a:ea typeface="Calibri" pitchFamily="34" charset="-122"/>
                 <a:cs typeface="Calibri" pitchFamily="34" charset="-120"/>
               </a:rPr>
-              <a:t>Fraud Investment Relative to Regulatory Requirements</a:t>
+              <a:t>3-Year Scaling Focus — By Sector and Institution Tier</a:t>
             </a:r>
             <a:endParaRPr lang="en-US" sz="1900" dirty="0"/>
           </a:p>
@@ -21070,7 +22357,7 @@
                 <a:ea typeface="Calibri" pitchFamily="34" charset="-122"/>
                 <a:cs typeface="Calibri" pitchFamily="34" charset="-120"/>
               </a:rPr>
-              <a:t>Most fraud spending today is about fixing past problems, not getting ahead of new ones.</a:t>
+              <a:t>AI's lead grows in every tier — but Insurance's Top-tier carriers show the sharpest three-year pivot toward it.</a:t>
             </a:r>
             <a:endParaRPr lang="en-US" sz="1350" dirty="0"/>
           </a:p>
@@ -21135,7 +22422,7 @@
                 <a:ea typeface="IBM Plex Mono" pitchFamily="34" charset="-122"/>
                 <a:cs typeface="IBM Plex Mono" pitchFamily="34" charset="-120"/>
               </a:rPr>
-              <a:t>Q10  </a:t>
+              <a:t>Q9 / newS8 / S9  </a:t>
             </a:r>
             <a:pPr algn="l" indent="0" marL="0">
               <a:lnSpc>
@@ -21152,7 +22439,7 @@
                 <a:ea typeface="Calibri" pitchFamily="34" charset="-122"/>
                 <a:cs typeface="Calibri" pitchFamily="34" charset="-120"/>
               </a:rPr>
-              <a:t>“Which statement best reflects how your organization is allocating fraud-related investment in response to regulatory and compliance requirements?”</a:t>
+              <a:t>“Which area do you expect will receive the greatest focus for fraud/investigations operations transformation over the next three years? (Banking vs. Insurance, further broken down by institution tier)”</a:t>
             </a:r>
             <a:endParaRPr lang="en-US" sz="1000" dirty="0"/>
           </a:p>
@@ -21245,7 +22532,7 @@
         <p:spPr>
           <a:xfrm>
             <a:off x="502006" y="5276088"/>
-            <a:ext cx="11188598" cy="886968"/>
+            <a:ext cx="11188598" cy="548640"/>
           </a:xfrm>
           <a:prstGeom prst="rect">
             <a:avLst/>
@@ -21259,7 +22546,7 @@
           <a:p>
             <a:pPr algn="l" indent="0" marL="0">
               <a:lnSpc>
-                <a:spcPct val="118000"/>
+                <a:spcPct val="115000"/>
               </a:lnSpc>
               <a:buNone/>
             </a:pPr>
@@ -21272,15 +22559,57 @@
                 <a:ea typeface="Calibri" pitchFamily="34" charset="-122"/>
                 <a:cs typeface="Calibri" pitchFamily="34" charset="-120"/>
               </a:rPr>
-              <a:t>Single select.  </a:t>
+              <a:t>Single select. </a:t>
             </a:r>
             <a:pPr algn="l" indent="0" marL="0">
               <a:lnSpc>
-                <a:spcPct val="118000"/>
+                <a:spcPct val="115000"/>
               </a:lnSpc>
               <a:buNone/>
             </a:pPr>
             <a:r>
+              <a:rPr lang="en-US" sz="850" dirty="0">
+                <a:solidFill>
+                  <a:srgbClr val="53565A"/>
+                </a:solidFill>
+                <a:latin typeface="Calibri" pitchFamily="34" charset="0"/>
+                <a:ea typeface="Calibri" pitchFamily="34" charset="-122"/>
+                <a:cs typeface="Calibri" pitchFamily="34" charset="-120"/>
+              </a:rPr>
+              <a:t>The % in each category label is the full sector-level figure; tier segments are rounded to the nearest whole percent and may sum to within ±1pt of that total. Institution tier is based on newS8 (Banking) / S9 (Insurance), including respondents reclassified from their employer description elsewhere in the survey — Banking Top 100 is n=40, Insurance Large is n=10 (see the Q1 sector x tier slide for detail).</a:t>
+            </a:r>
+            <a:endParaRPr lang="en-US" sz="850" dirty="0"/>
+          </a:p>
+        </p:txBody>
+      </p:sp>
+      <p:sp>
+        <p:nvSpPr>
+          <p:cNvPr id="10" name="Text 7"/>
+          <p:cNvSpPr txBox="1"/>
+          <p:nvPr/>
+        </p:nvSpPr>
+        <p:spPr>
+          <a:xfrm>
+            <a:off x="502006" y="5843016"/>
+            <a:ext cx="11188598" cy="402336"/>
+          </a:xfrm>
+          <a:prstGeom prst="rect">
+            <a:avLst/>
+          </a:prstGeom>
+          <a:noFill/>
+          <a:ln/>
+        </p:spPr>
+        <p:txBody>
+          <a:bodyPr wrap="square" lIns="0" tIns="0" rIns="0" bIns="0" rtlCol="0" anchor="t"/>
+          <a:lstStyle/>
+          <a:p>
+            <a:pPr algn="l" indent="0" marL="0">
+              <a:lnSpc>
+                <a:spcPct val="110000"/>
+              </a:lnSpc>
+              <a:buNone/>
+            </a:pPr>
+            <a:r>
               <a:rPr lang="en-US" sz="850" b="1" dirty="0">
                 <a:solidFill>
                   <a:srgbClr val="53565A"/>
@@ -21293,12 +22622,12 @@
             </a:r>
             <a:pPr algn="l" indent="0" marL="0">
               <a:lnSpc>
-                <a:spcPct val="118000"/>
+                <a:spcPct val="110000"/>
               </a:lnSpc>
               <a:buNone/>
             </a:pPr>
             <a:r>
-              <a:rPr lang="en-US" sz="850" i="1" dirty="0">
+              <a:rPr lang="en-US" sz="800" i="1" dirty="0">
                 <a:solidFill>
                   <a:srgbClr val="53565A"/>
                 </a:solidFill>
@@ -21306,75 +22635,7 @@
                 <a:ea typeface="Calibri" pitchFamily="34" charset="-122"/>
                 <a:cs typeface="Calibri" pitchFamily="34" charset="-120"/>
               </a:rPr>
-              <a:t>“Primarily investing to meet upcoming and draft regulatory requirements”</a:t>
-            </a:r>
-            <a:pPr algn="l" indent="0" marL="0">
-              <a:lnSpc>
-                <a:spcPct val="118000"/>
-              </a:lnSpc>
-              <a:buNone/>
-            </a:pPr>
-            <a:r>
-              <a:rPr lang="en-US" sz="850" dirty="0">
-                <a:solidFill>
-                  <a:srgbClr val="D0D0CE"/>
-                </a:solidFill>
-                <a:latin typeface="Calibri" pitchFamily="34" charset="0"/>
-                <a:ea typeface="Calibri" pitchFamily="34" charset="-122"/>
-                <a:cs typeface="Calibri" pitchFamily="34" charset="-120"/>
-              </a:rPr>
-              <a:t>  ·  </a:t>
-            </a:r>
-            <a:pPr algn="l" indent="0" marL="0">
-              <a:lnSpc>
-                <a:spcPct val="118000"/>
-              </a:lnSpc>
-              <a:buNone/>
-            </a:pPr>
-            <a:r>
-              <a:rPr lang="en-US" sz="850" i="1" dirty="0">
-                <a:solidFill>
-                  <a:srgbClr val="53565A"/>
-                </a:solidFill>
-                <a:latin typeface="Calibri" pitchFamily="34" charset="0"/>
-                <a:ea typeface="Calibri" pitchFamily="34" charset="-122"/>
-                <a:cs typeface="Calibri" pitchFamily="34" charset="-120"/>
-              </a:rPr>
-              <a:t>“Primarily investing to remediate existing compliance and control gaps”</a:t>
-            </a:r>
-            <a:pPr algn="l" indent="0" marL="0">
-              <a:lnSpc>
-                <a:spcPct val="118000"/>
-              </a:lnSpc>
-              <a:buNone/>
-            </a:pPr>
-            <a:r>
-              <a:rPr lang="en-US" sz="850" dirty="0">
-                <a:solidFill>
-                  <a:srgbClr val="D0D0CE"/>
-                </a:solidFill>
-                <a:latin typeface="Calibri" pitchFamily="34" charset="0"/>
-                <a:ea typeface="Calibri" pitchFamily="34" charset="-122"/>
-                <a:cs typeface="Calibri" pitchFamily="34" charset="-120"/>
-              </a:rPr>
-              <a:t>  ·  </a:t>
-            </a:r>
-            <a:pPr algn="l" indent="0" marL="0">
-              <a:lnSpc>
-                <a:spcPct val="118000"/>
-              </a:lnSpc>
-              <a:buNone/>
-            </a:pPr>
-            <a:r>
-              <a:rPr lang="en-US" sz="850" i="1" dirty="0">
-                <a:solidFill>
-                  <a:srgbClr val="53565A"/>
-                </a:solidFill>
-                <a:latin typeface="Calibri" pitchFamily="34" charset="0"/>
-                <a:ea typeface="Calibri" pitchFamily="34" charset="-122"/>
-                <a:cs typeface="Calibri" pitchFamily="34" charset="-120"/>
-              </a:rPr>
-              <a:t>“Regulatory requirements are not a primary driver of fraud-related investment”</a:t>
+              <a:t>“Adding capacity through hiring full-time employees and workforce expansion” · “Adding capacity through outsourcing arrangements (e.g., contractors)” · “Automating workflows and minimizing manual activities” · “Augmenting existing capacity with AI-enabled tools” · “Redesigning operation processes and playbooks across the lifecycle” · “Pursuing a combination of the above approaches”</a:t>
             </a:r>
             <a:endParaRPr lang="en-US" sz="850" dirty="0"/>
           </a:p>
@@ -21391,6 +22652,158 @@
 <file path=ppt/slides/slide28.xml><?xml version="1.0" encoding="utf-8"?>
 <p:sld xmlns:a="http://schemas.openxmlformats.org/drawingml/2006/main" xmlns:r="http://schemas.openxmlformats.org/officeDocument/2006/relationships" xmlns:p="http://schemas.openxmlformats.org/presentationml/2006/main">
   <p:cSld name="Slide 28">
+    <p:bg>
+      <p:bgPr>
+        <a:solidFill>
+          <a:srgbClr val="86BC25"/>
+        </a:solidFill>
+      </p:bgPr>
+    </p:bg>
+    <p:spTree>
+      <p:nvGrpSpPr>
+        <p:cNvPr id="1" name=""/>
+        <p:cNvGrpSpPr/>
+        <p:nvPr/>
+      </p:nvGrpSpPr>
+      <p:grpSpPr>
+        <a:xfrm>
+          <a:off x="0" y="0"/>
+          <a:ext cx="0" cy="0"/>
+          <a:chOff x="0" y="0"/>
+          <a:chExt cx="0" cy="0"/>
+        </a:xfrm>
+      </p:grpSpPr>
+      <p:sp>
+        <p:nvSpPr>
+          <p:cNvPr id="2" name="Text 0"/>
+          <p:cNvSpPr txBox="1"/>
+          <p:nvPr/>
+        </p:nvSpPr>
+        <p:spPr>
+          <a:xfrm>
+            <a:off x="502920" y="1699870"/>
+            <a:ext cx="10415016" cy="1591970"/>
+          </a:xfrm>
+          <a:prstGeom prst="rect">
+            <a:avLst/>
+          </a:prstGeom>
+          <a:noFill/>
+          <a:ln/>
+        </p:spPr>
+        <p:txBody>
+          <a:bodyPr wrap="square" lIns="0" tIns="0" rIns="0" bIns="0" rtlCol="0" anchor="b"/>
+          <a:lstStyle/>
+          <a:p>
+            <a:pPr algn="l" indent="0" marL="0">
+              <a:buNone/>
+            </a:pPr>
+            <a:r>
+              <a:rPr lang="en-US" sz="3600" b="1" dirty="0">
+                <a:solidFill>
+                  <a:srgbClr val="FFFFFF"/>
+                </a:solidFill>
+                <a:latin typeface="Calibri" pitchFamily="34" charset="0"/>
+                <a:ea typeface="Calibri" pitchFamily="34" charset="-122"/>
+                <a:cs typeface="Calibri" pitchFamily="34" charset="-120"/>
+              </a:rPr>
+              <a:t>5. Regulatory &amp; Market Change</a:t>
+            </a:r>
+            <a:endParaRPr lang="en-US" sz="3600" dirty="0"/>
+          </a:p>
+        </p:txBody>
+      </p:sp>
+      <p:sp>
+        <p:nvSpPr>
+          <p:cNvPr id="3" name="Text 1"/>
+          <p:cNvSpPr txBox="1"/>
+          <p:nvPr/>
+        </p:nvSpPr>
+        <p:spPr>
+          <a:xfrm>
+            <a:off x="502920" y="3423514"/>
+            <a:ext cx="10415016" cy="1563624"/>
+          </a:xfrm>
+          <a:prstGeom prst="rect">
+            <a:avLst/>
+          </a:prstGeom>
+          <a:noFill/>
+          <a:ln/>
+        </p:spPr>
+        <p:txBody>
+          <a:bodyPr wrap="square" lIns="0" tIns="0" rIns="0" bIns="0" rtlCol="0" anchor="t"/>
+          <a:lstStyle/>
+          <a:p>
+            <a:pPr algn="l" indent="0" marL="0">
+              <a:lnSpc>
+                <a:spcPct val="110000"/>
+              </a:lnSpc>
+              <a:buNone/>
+            </a:pPr>
+            <a:r>
+              <a:rPr lang="en-US" sz="1600" dirty="0">
+                <a:solidFill>
+                  <a:srgbClr val="FFFFFF"/>
+                </a:solidFill>
+                <a:latin typeface="Calibri" pitchFamily="34" charset="0"/>
+                <a:ea typeface="Calibri" pitchFamily="34" charset="-122"/>
+                <a:cs typeface="Calibri" pitchFamily="34" charset="-120"/>
+              </a:rPr>
+              <a:t>Where fraud investment is really going, and the disruption leaders see coming next.</a:t>
+            </a:r>
+            <a:endParaRPr lang="en-US" sz="1600" dirty="0"/>
+          </a:p>
+        </p:txBody>
+      </p:sp>
+      <p:sp>
+        <p:nvSpPr>
+          <p:cNvPr id="4" name="Text 2"/>
+          <p:cNvSpPr txBox="1"/>
+          <p:nvPr/>
+        </p:nvSpPr>
+        <p:spPr>
+          <a:xfrm>
+            <a:off x="11346790" y="6537960"/>
+            <a:ext cx="343814" cy="182880"/>
+          </a:xfrm>
+          <a:prstGeom prst="rect">
+            <a:avLst/>
+          </a:prstGeom>
+          <a:noFill/>
+          <a:ln/>
+        </p:spPr>
+        <p:txBody>
+          <a:bodyPr wrap="square" rtlCol="0" anchor="ctr"/>
+          <a:lstStyle/>
+          <a:p>
+            <a:pPr algn="r" indent="0" marL="0">
+              <a:buNone/>
+            </a:pPr>
+            <a:r>
+              <a:rPr lang="en-US" sz="900" dirty="0">
+                <a:solidFill>
+                  <a:srgbClr val="FFFFFF"/>
+                </a:solidFill>
+                <a:latin typeface="Calibri" pitchFamily="34" charset="0"/>
+                <a:ea typeface="Calibri" pitchFamily="34" charset="-122"/>
+                <a:cs typeface="Calibri" pitchFamily="34" charset="-120"/>
+              </a:rPr>
+              <a:t>27</a:t>
+            </a:r>
+            <a:endParaRPr lang="en-US" sz="900" dirty="0"/>
+          </a:p>
+        </p:txBody>
+      </p:sp>
+    </p:spTree>
+  </p:cSld>
+  <p:clrMapOvr>
+    <a:masterClrMapping/>
+  </p:clrMapOvr>
+</p:sld>
+</file>
+
+<file path=ppt/slides/slide29.xml><?xml version="1.0" encoding="utf-8"?>
+<p:sld xmlns:a="http://schemas.openxmlformats.org/drawingml/2006/main" xmlns:r="http://schemas.openxmlformats.org/officeDocument/2006/relationships" xmlns:p="http://schemas.openxmlformats.org/presentationml/2006/main">
+  <p:cSld name="Slide 29">
     <p:bg>
       <p:bgPr>
         <a:solidFill>
@@ -21445,7 +22858,7 @@
                 <a:ea typeface="Calibri" pitchFamily="34" charset="-122"/>
                 <a:cs typeface="Calibri" pitchFamily="34" charset="-120"/>
               </a:rPr>
-              <a:t>Upcoming Regulatory / Market Change With Greatest Expected Impact</a:t>
+              <a:t>Fraud Investment Relative to Regulatory Requirements</a:t>
             </a:r>
             <a:endParaRPr lang="en-US" sz="1900" dirty="0"/>
           </a:p>
@@ -21487,7 +22900,7 @@
                 <a:ea typeface="Calibri" pitchFamily="34" charset="-122"/>
                 <a:cs typeface="Calibri" pitchFamily="34" charset="-120"/>
               </a:rPr>
-              <a:t>Identity and authentication tops a close three-way race for the next big disruption.</a:t>
+              <a:t>Most fraud spending today is about fixing past problems, not getting ahead of new ones.</a:t>
             </a:r>
             <a:endParaRPr lang="en-US" sz="1350" dirty="0"/>
           </a:p>
@@ -21552,7 +22965,7 @@
                 <a:ea typeface="IBM Plex Mono" pitchFamily="34" charset="-122"/>
                 <a:cs typeface="IBM Plex Mono" pitchFamily="34" charset="-120"/>
               </a:rPr>
-              <a:t>Q11  </a:t>
+              <a:t>Q10  </a:t>
             </a:r>
             <a:pPr algn="l" indent="0" marL="0">
               <a:lnSpc>
@@ -21569,7 +22982,7 @@
                 <a:ea typeface="Calibri" pitchFamily="34" charset="-122"/>
                 <a:cs typeface="Calibri" pitchFamily="34" charset="-120"/>
               </a:rPr>
-              <a:t>“Which upcoming regulatory or market changes is expected to have the greatest impact on your fraud program?”</a:t>
+              <a:t>“Which statement best reflects how your organization is allocating fraud-related investment in response to regulatory and compliance requirements?”</a:t>
             </a:r>
             <a:endParaRPr lang="en-US" sz="1000" dirty="0"/>
           </a:p>
@@ -21608,7 +23021,7 @@
                 <a:ea typeface="Calibri" pitchFamily="34" charset="-122"/>
                 <a:cs typeface="Calibri" pitchFamily="34" charset="-120"/>
               </a:rPr>
-              <a:t>27</a:t>
+              <a:t>28</a:t>
             </a:r>
             <a:endParaRPr lang="en-US" sz="900" dirty="0"/>
           </a:p>
@@ -21689,7 +23102,7 @@
                 <a:ea typeface="Calibri" pitchFamily="34" charset="-122"/>
                 <a:cs typeface="Calibri" pitchFamily="34" charset="-120"/>
               </a:rPr>
-              <a:t>Ranked top 3 — shown as % of respondents who placed the option anywhere in their top 3 (not mutually exclusive; bars don't sum to 100%).  </a:t>
+              <a:t>Single select.  </a:t>
             </a:r>
             <a:pPr algn="l" indent="0" marL="0">
               <a:lnSpc>
@@ -21723,7 +23136,7 @@
                 <a:ea typeface="Calibri" pitchFamily="34" charset="-122"/>
                 <a:cs typeface="Calibri" pitchFamily="34" charset="-120"/>
               </a:rPr>
-              <a:t>“Payment innovation and adoption (e.g., real-time payments, stable coins, agentic payments)”</a:t>
+              <a:t>“Primarily investing to meet upcoming and draft regulatory requirements”</a:t>
             </a:r>
             <a:pPr algn="l" indent="0" marL="0">
               <a:lnSpc>
@@ -21757,7 +23170,7 @@
                 <a:ea typeface="Calibri" pitchFamily="34" charset="-122"/>
                 <a:cs typeface="Calibri" pitchFamily="34" charset="-120"/>
               </a:rPr>
-              <a:t>“Liability and reimbursement changes”</a:t>
+              <a:t>“Primarily investing to remediate existing compliance and control gaps”</a:t>
             </a:r>
             <a:pPr algn="l" indent="0" marL="0">
               <a:lnSpc>
@@ -21791,221 +23204,9 @@
                 <a:ea typeface="Calibri" pitchFamily="34" charset="-122"/>
                 <a:cs typeface="Calibri" pitchFamily="34" charset="-120"/>
               </a:rPr>
-              <a:t>“Open Banking / Consumer-driven banking initiatives”</a:t>
-            </a:r>
-            <a:pPr algn="l" indent="0" marL="0">
-              <a:lnSpc>
-                <a:spcPct val="118000"/>
-              </a:lnSpc>
-              <a:buNone/>
-            </a:pPr>
-            <a:r>
-              <a:rPr lang="en-US" sz="850" dirty="0">
-                <a:solidFill>
-                  <a:srgbClr val="D0D0CE"/>
-                </a:solidFill>
-                <a:latin typeface="Calibri" pitchFamily="34" charset="0"/>
-                <a:ea typeface="Calibri" pitchFamily="34" charset="-122"/>
-                <a:cs typeface="Calibri" pitchFamily="34" charset="-120"/>
-              </a:rPr>
-              <a:t>  ·  </a:t>
-            </a:r>
-            <a:pPr algn="l" indent="0" marL="0">
-              <a:lnSpc>
-                <a:spcPct val="118000"/>
-              </a:lnSpc>
-              <a:buNone/>
-            </a:pPr>
-            <a:r>
-              <a:rPr lang="en-US" sz="850" i="1" dirty="0">
-                <a:solidFill>
-                  <a:srgbClr val="53565A"/>
-                </a:solidFill>
-                <a:latin typeface="Calibri" pitchFamily="34" charset="0"/>
-                <a:ea typeface="Calibri" pitchFamily="34" charset="-122"/>
-                <a:cs typeface="Calibri" pitchFamily="34" charset="-120"/>
-              </a:rPr>
-              <a:t>“AML related modernization initiatives”</a:t>
-            </a:r>
-            <a:pPr algn="l" indent="0" marL="0">
-              <a:lnSpc>
-                <a:spcPct val="118000"/>
-              </a:lnSpc>
-              <a:buNone/>
-            </a:pPr>
-            <a:r>
-              <a:rPr lang="en-US" sz="850" dirty="0">
-                <a:solidFill>
-                  <a:srgbClr val="D0D0CE"/>
-                </a:solidFill>
-                <a:latin typeface="Calibri" pitchFamily="34" charset="0"/>
-                <a:ea typeface="Calibri" pitchFamily="34" charset="-122"/>
-                <a:cs typeface="Calibri" pitchFamily="34" charset="-120"/>
-              </a:rPr>
-              <a:t>  ·  </a:t>
-            </a:r>
-            <a:pPr algn="l" indent="0" marL="0">
-              <a:lnSpc>
-                <a:spcPct val="118000"/>
-              </a:lnSpc>
-              <a:buNone/>
-            </a:pPr>
-            <a:r>
-              <a:rPr lang="en-US" sz="850" i="1" dirty="0">
-                <a:solidFill>
-                  <a:srgbClr val="53565A"/>
-                </a:solidFill>
-                <a:latin typeface="Calibri" pitchFamily="34" charset="0"/>
-                <a:ea typeface="Calibri" pitchFamily="34" charset="-122"/>
-                <a:cs typeface="Calibri" pitchFamily="34" charset="-120"/>
-              </a:rPr>
-              <a:t>“Privacy, data-sharing requirements, and AI governance requirements”</a:t>
-            </a:r>
-            <a:pPr algn="l" indent="0" marL="0">
-              <a:lnSpc>
-                <a:spcPct val="118000"/>
-              </a:lnSpc>
-              <a:buNone/>
-            </a:pPr>
-            <a:r>
-              <a:rPr lang="en-US" sz="850" dirty="0">
-                <a:solidFill>
-                  <a:srgbClr val="D0D0CE"/>
-                </a:solidFill>
-                <a:latin typeface="Calibri" pitchFamily="34" charset="0"/>
-                <a:ea typeface="Calibri" pitchFamily="34" charset="-122"/>
-                <a:cs typeface="Calibri" pitchFamily="34" charset="-120"/>
-              </a:rPr>
-              <a:t>  ·  </a:t>
-            </a:r>
-            <a:pPr algn="l" indent="0" marL="0">
-              <a:lnSpc>
-                <a:spcPct val="118000"/>
-              </a:lnSpc>
-              <a:buNone/>
-            </a:pPr>
-            <a:r>
-              <a:rPr lang="en-US" sz="850" i="1" dirty="0">
-                <a:solidFill>
-                  <a:srgbClr val="53565A"/>
-                </a:solidFill>
-                <a:latin typeface="Calibri" pitchFamily="34" charset="0"/>
-                <a:ea typeface="Calibri" pitchFamily="34" charset="-122"/>
-                <a:cs typeface="Calibri" pitchFamily="34" charset="-120"/>
-              </a:rPr>
-              <a:t>“Customer identity, authentication, and digital trust expectations”</a:t>
+              <a:t>“Regulatory requirements are not a primary driver of fraud-related investment”</a:t>
             </a:r>
             <a:endParaRPr lang="en-US" sz="850" dirty="0"/>
-          </a:p>
-        </p:txBody>
-      </p:sp>
-    </p:spTree>
-  </p:cSld>
-  <p:clrMapOvr>
-    <a:masterClrMapping/>
-  </p:clrMapOvr>
-</p:sld>
-</file>
-
-<file path=ppt/slides/slide29.xml><?xml version="1.0" encoding="utf-8"?>
-<p:sld xmlns:a="http://schemas.openxmlformats.org/drawingml/2006/main" xmlns:r="http://schemas.openxmlformats.org/officeDocument/2006/relationships" xmlns:p="http://schemas.openxmlformats.org/presentationml/2006/main">
-  <p:cSld name="Slide 29">
-    <p:bg>
-      <p:bgPr>
-        <a:solidFill>
-          <a:srgbClr val="86BC25"/>
-        </a:solidFill>
-      </p:bgPr>
-    </p:bg>
-    <p:spTree>
-      <p:nvGrpSpPr>
-        <p:cNvPr id="1" name=""/>
-        <p:cNvGrpSpPr/>
-        <p:nvPr/>
-      </p:nvGrpSpPr>
-      <p:grpSpPr>
-        <a:xfrm>
-          <a:off x="0" y="0"/>
-          <a:ext cx="0" cy="0"/>
-          <a:chOff x="0" y="0"/>
-          <a:chExt cx="0" cy="0"/>
-        </a:xfrm>
-      </p:grpSpPr>
-      <p:sp>
-        <p:nvSpPr>
-          <p:cNvPr id="2" name="Text 0"/>
-          <p:cNvSpPr txBox="1"/>
-          <p:nvPr/>
-        </p:nvSpPr>
-        <p:spPr>
-          <a:xfrm>
-            <a:off x="502920" y="1699870"/>
-            <a:ext cx="10415016" cy="1591970"/>
-          </a:xfrm>
-          <a:prstGeom prst="rect">
-            <a:avLst/>
-          </a:prstGeom>
-          <a:noFill/>
-          <a:ln/>
-        </p:spPr>
-        <p:txBody>
-          <a:bodyPr wrap="square" lIns="0" tIns="0" rIns="0" bIns="0" rtlCol="0" anchor="b"/>
-          <a:lstStyle/>
-          <a:p>
-            <a:pPr algn="l" indent="0" marL="0">
-              <a:buNone/>
-            </a:pPr>
-            <a:r>
-              <a:rPr lang="en-US" sz="3600" b="1" dirty="0">
-                <a:solidFill>
-                  <a:srgbClr val="FFFFFF"/>
-                </a:solidFill>
-                <a:latin typeface="Calibri" pitchFamily="34" charset="0"/>
-                <a:ea typeface="Calibri" pitchFamily="34" charset="-122"/>
-                <a:cs typeface="Calibri" pitchFamily="34" charset="-120"/>
-              </a:rPr>
-              <a:t>6. Looking Ahead Three Years</a:t>
-            </a:r>
-            <a:endParaRPr lang="en-US" sz="3600" dirty="0"/>
-          </a:p>
-        </p:txBody>
-      </p:sp>
-      <p:sp>
-        <p:nvSpPr>
-          <p:cNvPr id="3" name="Text 1"/>
-          <p:cNvSpPr txBox="1"/>
-          <p:nvPr/>
-        </p:nvSpPr>
-        <p:spPr>
-          <a:xfrm>
-            <a:off x="11346790" y="6537960"/>
-            <a:ext cx="343814" cy="182880"/>
-          </a:xfrm>
-          <a:prstGeom prst="rect">
-            <a:avLst/>
-          </a:prstGeom>
-          <a:noFill/>
-          <a:ln/>
-        </p:spPr>
-        <p:txBody>
-          <a:bodyPr wrap="square" rtlCol="0" anchor="ctr"/>
-          <a:lstStyle/>
-          <a:p>
-            <a:pPr algn="r" indent="0" marL="0">
-              <a:buNone/>
-            </a:pPr>
-            <a:r>
-              <a:rPr lang="en-US" sz="900" dirty="0">
-                <a:solidFill>
-                  <a:srgbClr val="FFFFFF"/>
-                </a:solidFill>
-                <a:latin typeface="Calibri" pitchFamily="34" charset="0"/>
-                <a:ea typeface="Calibri" pitchFamily="34" charset="-122"/>
-                <a:cs typeface="Calibri" pitchFamily="34" charset="-120"/>
-              </a:rPr>
-              <a:t>28</a:t>
-            </a:r>
-            <a:endParaRPr lang="en-US" sz="900" dirty="0"/>
           </a:p>
         </p:txBody>
       </p:sp>
@@ -22756,7 +23957,7 @@
                 <a:ea typeface="Calibri" pitchFamily="34" charset="-122"/>
                 <a:cs typeface="Calibri" pitchFamily="34" charset="-120"/>
               </a:rPr>
-              <a:t>What Leaders Say, Unprompted</a:t>
+              <a:t>Upcoming Regulatory / Market Change With Greatest Expected Impact</a:t>
             </a:r>
             <a:endParaRPr lang="en-US" sz="1900" dirty="0"/>
           </a:p>
@@ -22798,7 +23999,7 @@
                 <a:ea typeface="Calibri" pitchFamily="34" charset="-122"/>
                 <a:cs typeface="Calibri" pitchFamily="34" charset="-120"/>
               </a:rPr>
-              <a:t>Left to answer in their own words, leaders converge on the same trend.</a:t>
+              <a:t>Identity and authentication tops a close three-way race for the next big disruption.</a:t>
             </a:r>
             <a:endParaRPr lang="en-US" sz="1350" dirty="0"/>
           </a:p>
@@ -22863,7 +24064,7 @@
                 <a:ea typeface="IBM Plex Mono" pitchFamily="34" charset="-122"/>
                 <a:cs typeface="IBM Plex Mono" pitchFamily="34" charset="-120"/>
               </a:rPr>
-              <a:t>Q12  </a:t>
+              <a:t>Q11  </a:t>
             </a:r>
             <a:pPr algn="l" indent="0" marL="0">
               <a:lnSpc>
@@ -22880,7 +24081,7 @@
                 <a:ea typeface="Calibri" pitchFamily="34" charset="-122"/>
                 <a:cs typeface="Calibri" pitchFamily="34" charset="-120"/>
               </a:rPr>
-              <a:t>“Looking ahead three years, what development do you believe will have the greatest impact on fraud risk management, and why? (open-ended)”</a:t>
+              <a:t>“Which upcoming regulatory or market changes is expected to have the greatest impact on your fraud program?”</a:t>
             </a:r>
             <a:endParaRPr lang="en-US" sz="1000" dirty="0"/>
           </a:p>
@@ -22920,6 +24121,635 @@
                 <a:cs typeface="Calibri" pitchFamily="34" charset="-120"/>
               </a:rPr>
               <a:t>29</a:t>
+            </a:r>
+            <a:endParaRPr lang="en-US" sz="900" dirty="0"/>
+          </a:p>
+        </p:txBody>
+      </p:sp>
+      <p:graphicFrame>
+        <p:nvGraphicFramePr>
+          <p:cNvPr id="7" name="Chart 0" descr=""/>
+          <p:cNvGraphicFramePr/>
+          <p:nvPr/>
+        </p:nvGraphicFramePr>
+        <p:xfrm>
+          <a:off x="502006" y="2011680"/>
+          <a:ext cx="11188598" cy="3063240"/>
+        </p:xfrm>
+        <a:graphic xmlns:a="http://schemas.openxmlformats.org/drawingml/2006/main">
+          <a:graphicData uri="http://schemas.openxmlformats.org/drawingml/2006/chart">
+            <c:chart xmlns:c="http://schemas.openxmlformats.org/drawingml/2006/chart" r:id="rId1"/>
+          </a:graphicData>
+        </a:graphic>
+      </p:graphicFrame>
+      <p:sp>
+        <p:nvSpPr>
+          <p:cNvPr id="8" name="Shape 5"/>
+          <p:cNvSpPr/>
+          <p:nvPr/>
+        </p:nvSpPr>
+        <p:spPr>
+          <a:xfrm>
+            <a:off x="502006" y="5202936"/>
+            <a:ext cx="11188598" cy="0"/>
+          </a:xfrm>
+          <a:prstGeom prst="line">
+            <a:avLst/>
+          </a:prstGeom>
+          <a:noFill/>
+          <a:ln w="9525">
+            <a:solidFill>
+              <a:srgbClr val="D0D0CE"/>
+            </a:solidFill>
+            <a:prstDash val="solid"/>
+          </a:ln>
+        </p:spPr>
+      </p:sp>
+      <p:sp>
+        <p:nvSpPr>
+          <p:cNvPr id="9" name="Text 6"/>
+          <p:cNvSpPr txBox="1"/>
+          <p:nvPr/>
+        </p:nvSpPr>
+        <p:spPr>
+          <a:xfrm>
+            <a:off x="502006" y="5276088"/>
+            <a:ext cx="11188598" cy="886968"/>
+          </a:xfrm>
+          <a:prstGeom prst="rect">
+            <a:avLst/>
+          </a:prstGeom>
+          <a:noFill/>
+          <a:ln/>
+        </p:spPr>
+        <p:txBody>
+          <a:bodyPr wrap="square" lIns="0" tIns="0" rIns="0" bIns="0" rtlCol="0" anchor="t"/>
+          <a:lstStyle/>
+          <a:p>
+            <a:pPr algn="l" indent="0" marL="0">
+              <a:lnSpc>
+                <a:spcPct val="118000"/>
+              </a:lnSpc>
+              <a:buNone/>
+            </a:pPr>
+            <a:r>
+              <a:rPr lang="en-US" sz="850" b="1" dirty="0">
+                <a:solidFill>
+                  <a:srgbClr val="53565A"/>
+                </a:solidFill>
+                <a:latin typeface="Calibri" pitchFamily="34" charset="0"/>
+                <a:ea typeface="Calibri" pitchFamily="34" charset="-122"/>
+                <a:cs typeface="Calibri" pitchFamily="34" charset="-120"/>
+              </a:rPr>
+              <a:t>Ranked top 3 — shown as % of respondents who placed the option anywhere in their top 3 (not mutually exclusive; bars don't sum to 100%).  </a:t>
+            </a:r>
+            <a:pPr algn="l" indent="0" marL="0">
+              <a:lnSpc>
+                <a:spcPct val="118000"/>
+              </a:lnSpc>
+              <a:buNone/>
+            </a:pPr>
+            <a:r>
+              <a:rPr lang="en-US" sz="850" b="1" dirty="0">
+                <a:solidFill>
+                  <a:srgbClr val="53565A"/>
+                </a:solidFill>
+                <a:latin typeface="Calibri" pitchFamily="34" charset="0"/>
+                <a:ea typeface="Calibri" pitchFamily="34" charset="-122"/>
+                <a:cs typeface="Calibri" pitchFamily="34" charset="-120"/>
+              </a:rPr>
+              <a:t>Response options as fielded: </a:t>
+            </a:r>
+            <a:pPr algn="l" indent="0" marL="0">
+              <a:lnSpc>
+                <a:spcPct val="118000"/>
+              </a:lnSpc>
+              <a:buNone/>
+            </a:pPr>
+            <a:r>
+              <a:rPr lang="en-US" sz="850" i="1" dirty="0">
+                <a:solidFill>
+                  <a:srgbClr val="53565A"/>
+                </a:solidFill>
+                <a:latin typeface="Calibri" pitchFamily="34" charset="0"/>
+                <a:ea typeface="Calibri" pitchFamily="34" charset="-122"/>
+                <a:cs typeface="Calibri" pitchFamily="34" charset="-120"/>
+              </a:rPr>
+              <a:t>“Payment innovation and adoption (e.g., real-time payments, stable coins, agentic payments)”</a:t>
+            </a:r>
+            <a:pPr algn="l" indent="0" marL="0">
+              <a:lnSpc>
+                <a:spcPct val="118000"/>
+              </a:lnSpc>
+              <a:buNone/>
+            </a:pPr>
+            <a:r>
+              <a:rPr lang="en-US" sz="850" dirty="0">
+                <a:solidFill>
+                  <a:srgbClr val="D0D0CE"/>
+                </a:solidFill>
+                <a:latin typeface="Calibri" pitchFamily="34" charset="0"/>
+                <a:ea typeface="Calibri" pitchFamily="34" charset="-122"/>
+                <a:cs typeface="Calibri" pitchFamily="34" charset="-120"/>
+              </a:rPr>
+              <a:t>  ·  </a:t>
+            </a:r>
+            <a:pPr algn="l" indent="0" marL="0">
+              <a:lnSpc>
+                <a:spcPct val="118000"/>
+              </a:lnSpc>
+              <a:buNone/>
+            </a:pPr>
+            <a:r>
+              <a:rPr lang="en-US" sz="850" i="1" dirty="0">
+                <a:solidFill>
+                  <a:srgbClr val="53565A"/>
+                </a:solidFill>
+                <a:latin typeface="Calibri" pitchFamily="34" charset="0"/>
+                <a:ea typeface="Calibri" pitchFamily="34" charset="-122"/>
+                <a:cs typeface="Calibri" pitchFamily="34" charset="-120"/>
+              </a:rPr>
+              <a:t>“Liability and reimbursement changes”</a:t>
+            </a:r>
+            <a:pPr algn="l" indent="0" marL="0">
+              <a:lnSpc>
+                <a:spcPct val="118000"/>
+              </a:lnSpc>
+              <a:buNone/>
+            </a:pPr>
+            <a:r>
+              <a:rPr lang="en-US" sz="850" dirty="0">
+                <a:solidFill>
+                  <a:srgbClr val="D0D0CE"/>
+                </a:solidFill>
+                <a:latin typeface="Calibri" pitchFamily="34" charset="0"/>
+                <a:ea typeface="Calibri" pitchFamily="34" charset="-122"/>
+                <a:cs typeface="Calibri" pitchFamily="34" charset="-120"/>
+              </a:rPr>
+              <a:t>  ·  </a:t>
+            </a:r>
+            <a:pPr algn="l" indent="0" marL="0">
+              <a:lnSpc>
+                <a:spcPct val="118000"/>
+              </a:lnSpc>
+              <a:buNone/>
+            </a:pPr>
+            <a:r>
+              <a:rPr lang="en-US" sz="850" i="1" dirty="0">
+                <a:solidFill>
+                  <a:srgbClr val="53565A"/>
+                </a:solidFill>
+                <a:latin typeface="Calibri" pitchFamily="34" charset="0"/>
+                <a:ea typeface="Calibri" pitchFamily="34" charset="-122"/>
+                <a:cs typeface="Calibri" pitchFamily="34" charset="-120"/>
+              </a:rPr>
+              <a:t>“Open Banking / Consumer-driven banking initiatives”</a:t>
+            </a:r>
+            <a:pPr algn="l" indent="0" marL="0">
+              <a:lnSpc>
+                <a:spcPct val="118000"/>
+              </a:lnSpc>
+              <a:buNone/>
+            </a:pPr>
+            <a:r>
+              <a:rPr lang="en-US" sz="850" dirty="0">
+                <a:solidFill>
+                  <a:srgbClr val="D0D0CE"/>
+                </a:solidFill>
+                <a:latin typeface="Calibri" pitchFamily="34" charset="0"/>
+                <a:ea typeface="Calibri" pitchFamily="34" charset="-122"/>
+                <a:cs typeface="Calibri" pitchFamily="34" charset="-120"/>
+              </a:rPr>
+              <a:t>  ·  </a:t>
+            </a:r>
+            <a:pPr algn="l" indent="0" marL="0">
+              <a:lnSpc>
+                <a:spcPct val="118000"/>
+              </a:lnSpc>
+              <a:buNone/>
+            </a:pPr>
+            <a:r>
+              <a:rPr lang="en-US" sz="850" i="1" dirty="0">
+                <a:solidFill>
+                  <a:srgbClr val="53565A"/>
+                </a:solidFill>
+                <a:latin typeface="Calibri" pitchFamily="34" charset="0"/>
+                <a:ea typeface="Calibri" pitchFamily="34" charset="-122"/>
+                <a:cs typeface="Calibri" pitchFamily="34" charset="-120"/>
+              </a:rPr>
+              <a:t>“AML related modernization initiatives”</a:t>
+            </a:r>
+            <a:pPr algn="l" indent="0" marL="0">
+              <a:lnSpc>
+                <a:spcPct val="118000"/>
+              </a:lnSpc>
+              <a:buNone/>
+            </a:pPr>
+            <a:r>
+              <a:rPr lang="en-US" sz="850" dirty="0">
+                <a:solidFill>
+                  <a:srgbClr val="D0D0CE"/>
+                </a:solidFill>
+                <a:latin typeface="Calibri" pitchFamily="34" charset="0"/>
+                <a:ea typeface="Calibri" pitchFamily="34" charset="-122"/>
+                <a:cs typeface="Calibri" pitchFamily="34" charset="-120"/>
+              </a:rPr>
+              <a:t>  ·  </a:t>
+            </a:r>
+            <a:pPr algn="l" indent="0" marL="0">
+              <a:lnSpc>
+                <a:spcPct val="118000"/>
+              </a:lnSpc>
+              <a:buNone/>
+            </a:pPr>
+            <a:r>
+              <a:rPr lang="en-US" sz="850" i="1" dirty="0">
+                <a:solidFill>
+                  <a:srgbClr val="53565A"/>
+                </a:solidFill>
+                <a:latin typeface="Calibri" pitchFamily="34" charset="0"/>
+                <a:ea typeface="Calibri" pitchFamily="34" charset="-122"/>
+                <a:cs typeface="Calibri" pitchFamily="34" charset="-120"/>
+              </a:rPr>
+              <a:t>“Privacy, data-sharing requirements, and AI governance requirements”</a:t>
+            </a:r>
+            <a:pPr algn="l" indent="0" marL="0">
+              <a:lnSpc>
+                <a:spcPct val="118000"/>
+              </a:lnSpc>
+              <a:buNone/>
+            </a:pPr>
+            <a:r>
+              <a:rPr lang="en-US" sz="850" dirty="0">
+                <a:solidFill>
+                  <a:srgbClr val="D0D0CE"/>
+                </a:solidFill>
+                <a:latin typeface="Calibri" pitchFamily="34" charset="0"/>
+                <a:ea typeface="Calibri" pitchFamily="34" charset="-122"/>
+                <a:cs typeface="Calibri" pitchFamily="34" charset="-120"/>
+              </a:rPr>
+              <a:t>  ·  </a:t>
+            </a:r>
+            <a:pPr algn="l" indent="0" marL="0">
+              <a:lnSpc>
+                <a:spcPct val="118000"/>
+              </a:lnSpc>
+              <a:buNone/>
+            </a:pPr>
+            <a:r>
+              <a:rPr lang="en-US" sz="850" i="1" dirty="0">
+                <a:solidFill>
+                  <a:srgbClr val="53565A"/>
+                </a:solidFill>
+                <a:latin typeface="Calibri" pitchFamily="34" charset="0"/>
+                <a:ea typeface="Calibri" pitchFamily="34" charset="-122"/>
+                <a:cs typeface="Calibri" pitchFamily="34" charset="-120"/>
+              </a:rPr>
+              <a:t>“Customer identity, authentication, and digital trust expectations”</a:t>
+            </a:r>
+            <a:endParaRPr lang="en-US" sz="850" dirty="0"/>
+          </a:p>
+        </p:txBody>
+      </p:sp>
+    </p:spTree>
+  </p:cSld>
+  <p:clrMapOvr>
+    <a:masterClrMapping/>
+  </p:clrMapOvr>
+</p:sld>
+</file>
+
+<file path=ppt/slides/slide31.xml><?xml version="1.0" encoding="utf-8"?>
+<p:sld xmlns:a="http://schemas.openxmlformats.org/drawingml/2006/main" xmlns:r="http://schemas.openxmlformats.org/officeDocument/2006/relationships" xmlns:p="http://schemas.openxmlformats.org/presentationml/2006/main">
+  <p:cSld name="Slide 31">
+    <p:bg>
+      <p:bgPr>
+        <a:solidFill>
+          <a:srgbClr val="86BC25"/>
+        </a:solidFill>
+      </p:bgPr>
+    </p:bg>
+    <p:spTree>
+      <p:nvGrpSpPr>
+        <p:cNvPr id="1" name=""/>
+        <p:cNvGrpSpPr/>
+        <p:nvPr/>
+      </p:nvGrpSpPr>
+      <p:grpSpPr>
+        <a:xfrm>
+          <a:off x="0" y="0"/>
+          <a:ext cx="0" cy="0"/>
+          <a:chOff x="0" y="0"/>
+          <a:chExt cx="0" cy="0"/>
+        </a:xfrm>
+      </p:grpSpPr>
+      <p:sp>
+        <p:nvSpPr>
+          <p:cNvPr id="2" name="Text 0"/>
+          <p:cNvSpPr txBox="1"/>
+          <p:nvPr/>
+        </p:nvSpPr>
+        <p:spPr>
+          <a:xfrm>
+            <a:off x="502920" y="1699870"/>
+            <a:ext cx="10415016" cy="1591970"/>
+          </a:xfrm>
+          <a:prstGeom prst="rect">
+            <a:avLst/>
+          </a:prstGeom>
+          <a:noFill/>
+          <a:ln/>
+        </p:spPr>
+        <p:txBody>
+          <a:bodyPr wrap="square" lIns="0" tIns="0" rIns="0" bIns="0" rtlCol="0" anchor="b"/>
+          <a:lstStyle/>
+          <a:p>
+            <a:pPr algn="l" indent="0" marL="0">
+              <a:buNone/>
+            </a:pPr>
+            <a:r>
+              <a:rPr lang="en-US" sz="3600" b="1" dirty="0">
+                <a:solidFill>
+                  <a:srgbClr val="FFFFFF"/>
+                </a:solidFill>
+                <a:latin typeface="Calibri" pitchFamily="34" charset="0"/>
+                <a:ea typeface="Calibri" pitchFamily="34" charset="-122"/>
+                <a:cs typeface="Calibri" pitchFamily="34" charset="-120"/>
+              </a:rPr>
+              <a:t>6. Looking Ahead Three Years</a:t>
+            </a:r>
+            <a:endParaRPr lang="en-US" sz="3600" dirty="0"/>
+          </a:p>
+        </p:txBody>
+      </p:sp>
+      <p:sp>
+        <p:nvSpPr>
+          <p:cNvPr id="3" name="Text 1"/>
+          <p:cNvSpPr txBox="1"/>
+          <p:nvPr/>
+        </p:nvSpPr>
+        <p:spPr>
+          <a:xfrm>
+            <a:off x="11346790" y="6537960"/>
+            <a:ext cx="343814" cy="182880"/>
+          </a:xfrm>
+          <a:prstGeom prst="rect">
+            <a:avLst/>
+          </a:prstGeom>
+          <a:noFill/>
+          <a:ln/>
+        </p:spPr>
+        <p:txBody>
+          <a:bodyPr wrap="square" rtlCol="0" anchor="ctr"/>
+          <a:lstStyle/>
+          <a:p>
+            <a:pPr algn="r" indent="0" marL="0">
+              <a:buNone/>
+            </a:pPr>
+            <a:r>
+              <a:rPr lang="en-US" sz="900" dirty="0">
+                <a:solidFill>
+                  <a:srgbClr val="FFFFFF"/>
+                </a:solidFill>
+                <a:latin typeface="Calibri" pitchFamily="34" charset="0"/>
+                <a:ea typeface="Calibri" pitchFamily="34" charset="-122"/>
+                <a:cs typeface="Calibri" pitchFamily="34" charset="-120"/>
+              </a:rPr>
+              <a:t>30</a:t>
+            </a:r>
+            <a:endParaRPr lang="en-US" sz="900" dirty="0"/>
+          </a:p>
+        </p:txBody>
+      </p:sp>
+    </p:spTree>
+  </p:cSld>
+  <p:clrMapOvr>
+    <a:masterClrMapping/>
+  </p:clrMapOvr>
+</p:sld>
+</file>
+
+<file path=ppt/slides/slide32.xml><?xml version="1.0" encoding="utf-8"?>
+<p:sld xmlns:a="http://schemas.openxmlformats.org/drawingml/2006/main" xmlns:r="http://schemas.openxmlformats.org/officeDocument/2006/relationships" xmlns:p="http://schemas.openxmlformats.org/presentationml/2006/main">
+  <p:cSld name="Slide 32">
+    <p:bg>
+      <p:bgPr>
+        <a:solidFill>
+          <a:srgbClr val="FFFFFF"/>
+        </a:solidFill>
+      </p:bgPr>
+    </p:bg>
+    <p:spTree>
+      <p:nvGrpSpPr>
+        <p:cNvPr id="1" name=""/>
+        <p:cNvGrpSpPr/>
+        <p:nvPr/>
+      </p:nvGrpSpPr>
+      <p:grpSpPr>
+        <a:xfrm>
+          <a:off x="0" y="0"/>
+          <a:ext cx="0" cy="0"/>
+          <a:chOff x="0" y="0"/>
+          <a:chExt cx="0" cy="0"/>
+        </a:xfrm>
+      </p:grpSpPr>
+      <p:sp>
+        <p:nvSpPr>
+          <p:cNvPr id="2" name="Text 0"/>
+          <p:cNvSpPr txBox="1"/>
+          <p:nvPr/>
+        </p:nvSpPr>
+        <p:spPr>
+          <a:xfrm>
+            <a:off x="502006" y="256032"/>
+            <a:ext cx="11188598" cy="310896"/>
+          </a:xfrm>
+          <a:prstGeom prst="rect">
+            <a:avLst/>
+          </a:prstGeom>
+          <a:noFill/>
+          <a:ln/>
+        </p:spPr>
+        <p:txBody>
+          <a:bodyPr wrap="square" lIns="0" tIns="0" rIns="0" bIns="0" rtlCol="0" anchor="t"/>
+          <a:lstStyle/>
+          <a:p>
+            <a:pPr algn="l" indent="0" marL="0">
+              <a:buNone/>
+            </a:pPr>
+            <a:r>
+              <a:rPr lang="en-US" sz="1900" b="1" dirty="0">
+                <a:solidFill>
+                  <a:srgbClr val="000000"/>
+                </a:solidFill>
+                <a:latin typeface="Calibri" pitchFamily="34" charset="0"/>
+                <a:ea typeface="Calibri" pitchFamily="34" charset="-122"/>
+                <a:cs typeface="Calibri" pitchFamily="34" charset="-120"/>
+              </a:rPr>
+              <a:t>What Leaders Say, Unprompted</a:t>
+            </a:r>
+            <a:endParaRPr lang="en-US" sz="1900" dirty="0"/>
+          </a:p>
+        </p:txBody>
+      </p:sp>
+      <p:sp>
+        <p:nvSpPr>
+          <p:cNvPr id="3" name="Text 1"/>
+          <p:cNvSpPr txBox="1"/>
+          <p:nvPr/>
+        </p:nvSpPr>
+        <p:spPr>
+          <a:xfrm>
+            <a:off x="502006" y="585216"/>
+            <a:ext cx="11188598" cy="713232"/>
+          </a:xfrm>
+          <a:prstGeom prst="rect">
+            <a:avLst/>
+          </a:prstGeom>
+          <a:noFill/>
+          <a:ln/>
+        </p:spPr>
+        <p:txBody>
+          <a:bodyPr wrap="square" lIns="0" tIns="0" rIns="0" bIns="0" rtlCol="0" anchor="t"/>
+          <a:lstStyle/>
+          <a:p>
+            <a:pPr algn="l" indent="0" marL="0">
+              <a:lnSpc>
+                <a:spcPct val="105000"/>
+              </a:lnSpc>
+              <a:buNone/>
+            </a:pPr>
+            <a:r>
+              <a:rPr lang="en-US" sz="1350" b="1" dirty="0">
+                <a:solidFill>
+                  <a:srgbClr val="046A38"/>
+                </a:solidFill>
+                <a:latin typeface="Calibri" pitchFamily="34" charset="0"/>
+                <a:ea typeface="Calibri" pitchFamily="34" charset="-122"/>
+                <a:cs typeface="Calibri" pitchFamily="34" charset="-120"/>
+              </a:rPr>
+              <a:t>Left to answer in their own words, leaders converge on the same trend.</a:t>
+            </a:r>
+            <a:endParaRPr lang="en-US" sz="1350" dirty="0"/>
+          </a:p>
+        </p:txBody>
+      </p:sp>
+      <p:sp>
+        <p:nvSpPr>
+          <p:cNvPr id="4" name="Shape 2"/>
+          <p:cNvSpPr/>
+          <p:nvPr/>
+        </p:nvSpPr>
+        <p:spPr>
+          <a:xfrm>
+            <a:off x="502006" y="1335024"/>
+            <a:ext cx="0" cy="512064"/>
+          </a:xfrm>
+          <a:prstGeom prst="line">
+            <a:avLst/>
+          </a:prstGeom>
+          <a:noFill/>
+          <a:ln w="25400">
+            <a:solidFill>
+              <a:srgbClr val="D0D0CE"/>
+            </a:solidFill>
+            <a:prstDash val="solid"/>
+          </a:ln>
+        </p:spPr>
+      </p:sp>
+      <p:sp>
+        <p:nvSpPr>
+          <p:cNvPr id="5" name="Text 3"/>
+          <p:cNvSpPr txBox="1"/>
+          <p:nvPr/>
+        </p:nvSpPr>
+        <p:spPr>
+          <a:xfrm>
+            <a:off x="648310" y="1335024"/>
+            <a:ext cx="11042294" cy="512064"/>
+          </a:xfrm>
+          <a:prstGeom prst="rect">
+            <a:avLst/>
+          </a:prstGeom>
+          <a:noFill/>
+          <a:ln/>
+        </p:spPr>
+        <p:txBody>
+          <a:bodyPr wrap="square" lIns="0" tIns="0" rIns="0" bIns="0" rtlCol="0" anchor="t"/>
+          <a:lstStyle/>
+          <a:p>
+            <a:pPr algn="l" indent="0" marL="0">
+              <a:lnSpc>
+                <a:spcPct val="106000"/>
+              </a:lnSpc>
+              <a:buNone/>
+            </a:pPr>
+            <a:r>
+              <a:rPr lang="en-US" sz="900" b="1" dirty="0">
+                <a:solidFill>
+                  <a:srgbClr val="046A38"/>
+                </a:solidFill>
+                <a:latin typeface="IBM Plex Mono" pitchFamily="34" charset="0"/>
+                <a:ea typeface="IBM Plex Mono" pitchFamily="34" charset="-122"/>
+                <a:cs typeface="IBM Plex Mono" pitchFamily="34" charset="-120"/>
+              </a:rPr>
+              <a:t>Q12  </a:t>
+            </a:r>
+            <a:pPr algn="l" indent="0" marL="0">
+              <a:lnSpc>
+                <a:spcPct val="106000"/>
+              </a:lnSpc>
+              <a:buNone/>
+            </a:pPr>
+            <a:r>
+              <a:rPr lang="en-US" sz="1000" i="1" dirty="0">
+                <a:solidFill>
+                  <a:srgbClr val="575757"/>
+                </a:solidFill>
+                <a:latin typeface="Calibri" pitchFamily="34" charset="0"/>
+                <a:ea typeface="Calibri" pitchFamily="34" charset="-122"/>
+                <a:cs typeface="Calibri" pitchFamily="34" charset="-120"/>
+              </a:rPr>
+              <a:t>“Looking ahead three years, what development do you believe will have the greatest impact on fraud risk management, and why? (open-ended)”</a:t>
+            </a:r>
+            <a:endParaRPr lang="en-US" sz="1000" dirty="0"/>
+          </a:p>
+        </p:txBody>
+      </p:sp>
+      <p:sp>
+        <p:nvSpPr>
+          <p:cNvPr id="6" name="Text 4"/>
+          <p:cNvSpPr txBox="1"/>
+          <p:nvPr/>
+        </p:nvSpPr>
+        <p:spPr>
+          <a:xfrm>
+            <a:off x="11346790" y="6537960"/>
+            <a:ext cx="343814" cy="182880"/>
+          </a:xfrm>
+          <a:prstGeom prst="rect">
+            <a:avLst/>
+          </a:prstGeom>
+          <a:noFill/>
+          <a:ln/>
+        </p:spPr>
+        <p:txBody>
+          <a:bodyPr wrap="square" rtlCol="0" anchor="ctr"/>
+          <a:lstStyle/>
+          <a:p>
+            <a:pPr algn="r" indent="0" marL="0">
+              <a:buNone/>
+            </a:pPr>
+            <a:r>
+              <a:rPr lang="en-US" sz="900" dirty="0">
+                <a:solidFill>
+                  <a:srgbClr val="53565A"/>
+                </a:solidFill>
+                <a:latin typeface="Calibri" pitchFamily="34" charset="0"/>
+                <a:ea typeface="Calibri" pitchFamily="34" charset="-122"/>
+                <a:cs typeface="Calibri" pitchFamily="34" charset="-120"/>
+              </a:rPr>
+              <a:t>31</a:t>
             </a:r>
             <a:endParaRPr lang="en-US" sz="900" dirty="0"/>
           </a:p>
@@ -23468,9 +25298,9 @@
 </p:sld>
 </file>
 
-<file path=ppt/slides/slide31.xml><?xml version="1.0" encoding="utf-8"?>
+<file path=ppt/slides/slide33.xml><?xml version="1.0" encoding="utf-8"?>
 <p:sld xmlns:a="http://schemas.openxmlformats.org/drawingml/2006/main" xmlns:r="http://schemas.openxmlformats.org/officeDocument/2006/relationships" xmlns:p="http://schemas.openxmlformats.org/presentationml/2006/main">
-  <p:cSld name="Slide 31">
+  <p:cSld name="Slide 33">
     <p:bg>
       <p:bgPr>
         <a:solidFill>

</xml_diff>

<commit_message>
Add Q10 breakdowns: by region, and by institution tier for each sector
Adds three slides after the existing Q10 overall slide: a region-only
stacked bar (matching the Q4 pattern), an Insurance-only tier view
(Top 50 vs. Large Insurance Carrier), and a Banking-only tier view
(Top 100 vs. Large Financial Institution).

Co-Authored-By: Claude Sonnet 5 <noreply@anthropic.com>
Claude-Session: https://claude.ai/code/session_01F6YKjZtdH33RrHLpCiLALg
</commit_message>
<xml_diff>
--- a/Fraud in 2026 - Full Results.pptx
+++ b/Fraud in 2026 - Full Results.pptx
@@ -42,9 +42,12 @@
     <p:sldId id="290" r:id="rId36"/>
     <p:sldId id="291" r:id="rId37"/>
     <p:sldId id="292" r:id="rId38"/>
+    <p:sldId id="293" r:id="rId39"/>
+    <p:sldId id="294" r:id="rId40"/>
+    <p:sldId id="295" r:id="rId41"/>
   </p:sldIdLst>
   <p:notesMasterIdLst>
-    <p:notesMasterId r:id="rId39"/>
+    <p:notesMasterId r:id="rId42"/>
   </p:notesMasterIdLst>
   <p:sldSz cx="12192000" cy="6858000"/>
   <p:notesSz cx="6858000" cy="12192000"/>
@@ -12027,6 +12030,1233 @@
       <c:layout/>
       <c:barChart>
         <c:barDir val="bar"/>
+        <c:grouping val="stacked"/>
+        <c:varyColors val="0"/>
+        <c:ser>
+          <c:idx val="0"/>
+          <c:order val="0"/>
+          <c:tx>
+            <c:strRef>
+              <c:f>Sheet1!$B$1</c:f>
+              <c:strCache>
+                <c:ptCount val="1"/>
+                <c:pt idx="0">
+                  <c:v>United States (n=44)</c:v>
+                </c:pt>
+              </c:strCache>
+            </c:strRef>
+          </c:tx>
+          <c:spPr>
+            <a:solidFill>
+              <a:srgbClr val="86BC25"/>
+            </a:solidFill>
+            <a:effectLst/>
+          </c:spPr>
+          <c:invertIfNegative val="0"/>
+          <c:dLbls>
+            <c:numFmt formatCode="0&quot;%&quot;;-0&quot;%&quot;;;@" sourceLinked="0"/>
+            <c:txPr>
+              <a:bodyPr/>
+              <a:lstStyle/>
+              <a:p>
+                <a:pPr>
+                  <a:defRPr b="0" i="0" strike="noStrike" sz="650" u="none">
+                    <a:solidFill>
+                      <a:srgbClr val="FFFFFF"/>
+                    </a:solidFill>
+                    <a:latin typeface="Arial"/>
+                  </a:defRPr>
+                </a:pPr>
+              </a:p>
+            </c:txPr>
+            <c:dLblPos val="ctr"/>
+            <c:showLegendKey val="0"/>
+            <c:showVal val="1"/>
+            <c:showCatName val="0"/>
+            <c:showSerName val="0"/>
+            <c:showPercent val="0"/>
+            <c:showBubbleSize val="0"/>
+            <c:showLeaderLines val="0"/>
+          </c:dLbls>
+          <c:cat>
+            <c:multiLvlStrRef>
+              <c:f>Sheet1!$A$2:$A$4</c:f>
+              <c:multiLvlStrCache>
+                <c:ptCount val="3"/>
+                <c:lvl>
+                  <c:pt idx="0">
+                    <c:v>Investing to remediate existing compliance gaps (48%)</c:v>
+                  </c:pt>
+                  <c:pt idx="1">
+                    <c:v>Investing to meet upcoming / draft regulations (39%)</c:v>
+                  </c:pt>
+                  <c:pt idx="2">
+                    <c:v>Regulation not a primary driver (13%)</c:v>
+                  </c:pt>
+                </c:lvl>
+              </c:multiLvlStrCache>
+            </c:multiLvlStrRef>
+          </c:cat>
+          <c:val>
+            <c:numRef>
+              <c:f>Sheet1!$B$2:$B$4</c:f>
+              <c:numCache>
+                <c:formatCode>General</c:formatCode>
+                <c:ptCount val="3"/>
+                <c:pt idx="0">
+                  <c:v>18</c:v>
+                </c:pt>
+                <c:pt idx="1">
+                  <c:v>19</c:v>
+                </c:pt>
+                <c:pt idx="2">
+                  <c:v>7</c:v>
+                </c:pt>
+              </c:numCache>
+            </c:numRef>
+          </c:val>
+        </c:ser>
+        <c:ser>
+          <c:idx val="1"/>
+          <c:order val="1"/>
+          <c:tx>
+            <c:strRef>
+              <c:f>Sheet1!$C$1</c:f>
+              <c:strCache>
+                <c:ptCount val="1"/>
+                <c:pt idx="0">
+                  <c:v>Canada (n=30)</c:v>
+                </c:pt>
+              </c:strCache>
+            </c:strRef>
+          </c:tx>
+          <c:spPr>
+            <a:solidFill>
+              <a:srgbClr val="43B02A"/>
+            </a:solidFill>
+            <a:effectLst/>
+          </c:spPr>
+          <c:invertIfNegative val="0"/>
+          <c:dLbls>
+            <c:numFmt formatCode="0&quot;%&quot;;-0&quot;%&quot;;;@" sourceLinked="0"/>
+            <c:txPr>
+              <a:bodyPr/>
+              <a:lstStyle/>
+              <a:p>
+                <a:pPr>
+                  <a:defRPr b="0" i="0" strike="noStrike" sz="650" u="none">
+                    <a:solidFill>
+                      <a:srgbClr val="FFFFFF"/>
+                    </a:solidFill>
+                    <a:latin typeface="Arial"/>
+                  </a:defRPr>
+                </a:pPr>
+              </a:p>
+            </c:txPr>
+            <c:dLblPos val="ctr"/>
+            <c:showLegendKey val="0"/>
+            <c:showVal val="1"/>
+            <c:showCatName val="0"/>
+            <c:showSerName val="0"/>
+            <c:showPercent val="0"/>
+            <c:showBubbleSize val="0"/>
+            <c:showLeaderLines val="0"/>
+          </c:dLbls>
+          <c:cat>
+            <c:multiLvlStrRef>
+              <c:f>Sheet1!$A$2:$A$4</c:f>
+              <c:multiLvlStrCache>
+                <c:ptCount val="3"/>
+                <c:lvl>
+                  <c:pt idx="0">
+                    <c:v>Investing to remediate existing compliance gaps (48%)</c:v>
+                  </c:pt>
+                  <c:pt idx="1">
+                    <c:v>Investing to meet upcoming / draft regulations (39%)</c:v>
+                  </c:pt>
+                  <c:pt idx="2">
+                    <c:v>Regulation not a primary driver (13%)</c:v>
+                  </c:pt>
+                </c:lvl>
+              </c:multiLvlStrCache>
+            </c:multiLvlStrRef>
+          </c:cat>
+          <c:val>
+            <c:numRef>
+              <c:f>Sheet1!$C$2:$C$4</c:f>
+              <c:numCache>
+                <c:formatCode>General</c:formatCode>
+                <c:ptCount val="3"/>
+                <c:pt idx="0">
+                  <c:v>19</c:v>
+                </c:pt>
+                <c:pt idx="1">
+                  <c:v>9</c:v>
+                </c:pt>
+                <c:pt idx="2">
+                  <c:v>2</c:v>
+                </c:pt>
+              </c:numCache>
+            </c:numRef>
+          </c:val>
+        </c:ser>
+        <c:ser>
+          <c:idx val="2"/>
+          <c:order val="2"/>
+          <c:tx>
+            <c:strRef>
+              <c:f>Sheet1!$D$1</c:f>
+              <c:strCache>
+                <c:ptCount val="1"/>
+                <c:pt idx="0">
+                  <c:v>Europe — EU+UK (n=14)</c:v>
+                </c:pt>
+              </c:strCache>
+            </c:strRef>
+          </c:tx>
+          <c:spPr>
+            <a:solidFill>
+              <a:srgbClr val="046A38"/>
+            </a:solidFill>
+            <a:effectLst/>
+          </c:spPr>
+          <c:invertIfNegative val="0"/>
+          <c:dLbls>
+            <c:numFmt formatCode="0&quot;%&quot;;-0&quot;%&quot;;;@" sourceLinked="0"/>
+            <c:txPr>
+              <a:bodyPr/>
+              <a:lstStyle/>
+              <a:p>
+                <a:pPr>
+                  <a:defRPr b="0" i="0" strike="noStrike" sz="650" u="none">
+                    <a:solidFill>
+                      <a:srgbClr val="FFFFFF"/>
+                    </a:solidFill>
+                    <a:latin typeface="Arial"/>
+                  </a:defRPr>
+                </a:pPr>
+              </a:p>
+            </c:txPr>
+            <c:dLblPos val="ctr"/>
+            <c:showLegendKey val="0"/>
+            <c:showVal val="1"/>
+            <c:showCatName val="0"/>
+            <c:showSerName val="0"/>
+            <c:showPercent val="0"/>
+            <c:showBubbleSize val="0"/>
+            <c:showLeaderLines val="0"/>
+          </c:dLbls>
+          <c:cat>
+            <c:multiLvlStrRef>
+              <c:f>Sheet1!$A$2:$A$4</c:f>
+              <c:multiLvlStrCache>
+                <c:ptCount val="3"/>
+                <c:lvl>
+                  <c:pt idx="0">
+                    <c:v>Investing to remediate existing compliance gaps (48%)</c:v>
+                  </c:pt>
+                  <c:pt idx="1">
+                    <c:v>Investing to meet upcoming / draft regulations (39%)</c:v>
+                  </c:pt>
+                  <c:pt idx="2">
+                    <c:v>Regulation not a primary driver (13%)</c:v>
+                  </c:pt>
+                </c:lvl>
+              </c:multiLvlStrCache>
+            </c:multiLvlStrRef>
+          </c:cat>
+          <c:val>
+            <c:numRef>
+              <c:f>Sheet1!$D$2:$D$4</c:f>
+              <c:numCache>
+                <c:formatCode>General</c:formatCode>
+                <c:ptCount val="3"/>
+                <c:pt idx="0">
+                  <c:v>5</c:v>
+                </c:pt>
+                <c:pt idx="1">
+                  <c:v>7</c:v>
+                </c:pt>
+                <c:pt idx="2">
+                  <c:v>2</c:v>
+                </c:pt>
+              </c:numCache>
+            </c:numRef>
+          </c:val>
+        </c:ser>
+        <c:ser>
+          <c:idx val="3"/>
+          <c:order val="3"/>
+          <c:tx>
+            <c:strRef>
+              <c:f>Sheet1!$E$1</c:f>
+              <c:strCache>
+                <c:ptCount val="1"/>
+                <c:pt idx="0">
+                  <c:v>Australia (n=8)</c:v>
+                </c:pt>
+              </c:strCache>
+            </c:strRef>
+          </c:tx>
+          <c:spPr>
+            <a:solidFill>
+              <a:srgbClr val="0D8390"/>
+            </a:solidFill>
+            <a:effectLst/>
+          </c:spPr>
+          <c:invertIfNegative val="0"/>
+          <c:dLbls>
+            <c:numFmt formatCode="0&quot;%&quot;;-0&quot;%&quot;;;@" sourceLinked="0"/>
+            <c:txPr>
+              <a:bodyPr/>
+              <a:lstStyle/>
+              <a:p>
+                <a:pPr>
+                  <a:defRPr b="0" i="0" strike="noStrike" sz="650" u="none">
+                    <a:solidFill>
+                      <a:srgbClr val="FFFFFF"/>
+                    </a:solidFill>
+                    <a:latin typeface="Arial"/>
+                  </a:defRPr>
+                </a:pPr>
+              </a:p>
+            </c:txPr>
+            <c:dLblPos val="ctr"/>
+            <c:showLegendKey val="0"/>
+            <c:showVal val="1"/>
+            <c:showCatName val="0"/>
+            <c:showSerName val="0"/>
+            <c:showPercent val="0"/>
+            <c:showBubbleSize val="0"/>
+            <c:showLeaderLines val="0"/>
+          </c:dLbls>
+          <c:cat>
+            <c:multiLvlStrRef>
+              <c:f>Sheet1!$A$2:$A$4</c:f>
+              <c:multiLvlStrCache>
+                <c:ptCount val="3"/>
+                <c:lvl>
+                  <c:pt idx="0">
+                    <c:v>Investing to remediate existing compliance gaps (48%)</c:v>
+                  </c:pt>
+                  <c:pt idx="1">
+                    <c:v>Investing to meet upcoming / draft regulations (39%)</c:v>
+                  </c:pt>
+                  <c:pt idx="2">
+                    <c:v>Regulation not a primary driver (13%)</c:v>
+                  </c:pt>
+                </c:lvl>
+              </c:multiLvlStrCache>
+            </c:multiLvlStrRef>
+          </c:cat>
+          <c:val>
+            <c:numRef>
+              <c:f>Sheet1!$E$2:$E$4</c:f>
+              <c:numCache>
+                <c:formatCode>General</c:formatCode>
+                <c:ptCount val="3"/>
+                <c:pt idx="0">
+                  <c:v>5</c:v>
+                </c:pt>
+                <c:pt idx="1">
+                  <c:v>2</c:v>
+                </c:pt>
+                <c:pt idx="2">
+                  <c:v>1</c:v>
+                </c:pt>
+              </c:numCache>
+            </c:numRef>
+          </c:val>
+        </c:ser>
+        <c:ser>
+          <c:idx val="4"/>
+          <c:order val="4"/>
+          <c:tx>
+            <c:strRef>
+              <c:f>Sheet1!$F$1</c:f>
+              <c:strCache>
+                <c:ptCount val="1"/>
+                <c:pt idx="0">
+                  <c:v>Singapore (n=4)</c:v>
+                </c:pt>
+              </c:strCache>
+            </c:strRef>
+          </c:tx>
+          <c:spPr>
+            <a:solidFill>
+              <a:srgbClr val="53565A"/>
+            </a:solidFill>
+            <a:effectLst/>
+          </c:spPr>
+          <c:invertIfNegative val="0"/>
+          <c:dLbls>
+            <c:numFmt formatCode="0&quot;%&quot;;-0&quot;%&quot;;;@" sourceLinked="0"/>
+            <c:txPr>
+              <a:bodyPr/>
+              <a:lstStyle/>
+              <a:p>
+                <a:pPr>
+                  <a:defRPr b="0" i="0" strike="noStrike" sz="650" u="none">
+                    <a:solidFill>
+                      <a:srgbClr val="FFFFFF"/>
+                    </a:solidFill>
+                    <a:latin typeface="Arial"/>
+                  </a:defRPr>
+                </a:pPr>
+              </a:p>
+            </c:txPr>
+            <c:dLblPos val="ctr"/>
+            <c:showLegendKey val="0"/>
+            <c:showVal val="1"/>
+            <c:showCatName val="0"/>
+            <c:showSerName val="0"/>
+            <c:showPercent val="0"/>
+            <c:showBubbleSize val="0"/>
+            <c:showLeaderLines val="0"/>
+          </c:dLbls>
+          <c:cat>
+            <c:multiLvlStrRef>
+              <c:f>Sheet1!$A$2:$A$4</c:f>
+              <c:multiLvlStrCache>
+                <c:ptCount val="3"/>
+                <c:lvl>
+                  <c:pt idx="0">
+                    <c:v>Investing to remediate existing compliance gaps (48%)</c:v>
+                  </c:pt>
+                  <c:pt idx="1">
+                    <c:v>Investing to meet upcoming / draft regulations (39%)</c:v>
+                  </c:pt>
+                  <c:pt idx="2">
+                    <c:v>Regulation not a primary driver (13%)</c:v>
+                  </c:pt>
+                </c:lvl>
+              </c:multiLvlStrCache>
+            </c:multiLvlStrRef>
+          </c:cat>
+          <c:val>
+            <c:numRef>
+              <c:f>Sheet1!$F$2:$F$4</c:f>
+              <c:numCache>
+                <c:formatCode>General</c:formatCode>
+                <c:ptCount val="3"/>
+                <c:pt idx="0">
+                  <c:v>1</c:v>
+                </c:pt>
+                <c:pt idx="1">
+                  <c:v>2</c:v>
+                </c:pt>
+                <c:pt idx="2">
+                  <c:v>1</c:v>
+                </c:pt>
+              </c:numCache>
+            </c:numRef>
+          </c:val>
+        </c:ser>
+        <c:dLbls>
+          <c:numFmt formatCode="0&quot;%&quot;;-0&quot;%&quot;;;@" sourceLinked="0"/>
+          <c:txPr>
+            <a:bodyPr/>
+            <a:lstStyle/>
+            <a:p>
+              <a:pPr>
+                <a:defRPr b="0" i="0" strike="noStrike" sz="650" u="none">
+                  <a:solidFill>
+                    <a:srgbClr val="FFFFFF"/>
+                  </a:solidFill>
+                  <a:latin typeface="Arial"/>
+                </a:defRPr>
+              </a:pPr>
+            </a:p>
+          </c:txPr>
+          <c:dLblPos val="ctr"/>
+          <c:showLegendKey val="0"/>
+          <c:showVal val="1"/>
+          <c:showCatName val="0"/>
+          <c:showSerName val="0"/>
+          <c:showPercent val="0"/>
+          <c:showBubbleSize val="0"/>
+          <c:showLeaderLines val="0"/>
+        </c:dLbls>
+        <c:gapWidth val="40"/>
+        <c:overlap val="100"/>
+        <c:axId val="2094734554"/>
+        <c:axId val="2094734552"/>
+        <c:axId val="2094734556"/>
+      </c:barChart>
+      <c:catAx>
+        <c:axId val="2094734554"/>
+        <c:scaling>
+          <c:orientation val="minMax"/>
+        </c:scaling>
+        <c:delete val="0"/>
+        <c:axPos val="l"/>
+        <c:numFmt formatCode="General" sourceLinked="1"/>
+        <c:majorTickMark val="out"/>
+        <c:minorTickMark val="none"/>
+        <c:tickLblPos val="nextTo"/>
+        <c:spPr>
+          <a:ln w="12700" cap="flat">
+            <a:noFill/>
+            <a:prstDash val="solid"/>
+            <a:round/>
+          </a:ln>
+        </c:spPr>
+        <c:txPr>
+          <a:bodyPr/>
+          <a:lstStyle/>
+          <a:p>
+            <a:pPr>
+              <a:defRPr sz="900" b="0" i="0" u="none" strike="noStrike">
+                <a:solidFill>
+                  <a:srgbClr val="53565A"/>
+                </a:solidFill>
+                <a:latin typeface="Arial"/>
+              </a:defRPr>
+            </a:pPr>
+            <a:endParaRPr lang="en-US"/>
+          </a:p>
+        </c:txPr>
+        <c:crossAx val="2094734552"/>
+        <c:crosses val="autoZero"/>
+        <c:auto val="1"/>
+        <c:lblAlgn val="ctr"/>
+        <c:noMultiLvlLbl val="1"/>
+      </c:catAx>
+      <c:valAx>
+        <c:axId val="2094734552"/>
+        <c:scaling>
+          <c:orientation val="minMax"/>
+        </c:scaling>
+        <c:delete val="1"/>
+        <c:axPos val="b"/>
+        <c:numFmt formatCode="General" sourceLinked="0"/>
+        <c:majorTickMark val="out"/>
+        <c:minorTickMark val="none"/>
+        <c:tickLblPos val="low"/>
+        <c:spPr>
+          <a:ln w="12700" cap="flat">
+            <a:noFill/>
+            <a:prstDash val="solid"/>
+            <a:round/>
+          </a:ln>
+        </c:spPr>
+        <c:txPr>
+          <a:bodyPr/>
+          <a:lstStyle/>
+          <a:p>
+            <a:pPr>
+              <a:defRPr sz="1200" b="0" i="0" u="none" strike="noStrike">
+                <a:solidFill>
+                  <a:srgbClr val="000000"/>
+                </a:solidFill>
+                <a:latin typeface="Arial"/>
+              </a:defRPr>
+            </a:pPr>
+            <a:endParaRPr lang="en-US"/>
+          </a:p>
+        </c:txPr>
+        <c:crossAx val="2094734554"/>
+        <c:crosses val="autoZero"/>
+        <c:crossBetween val="between"/>
+      </c:valAx>
+      <c:spPr>
+        <a:solidFill>
+          <a:srgbClr val="FFFFFF"/>
+        </a:solidFill>
+        <a:ln>
+          <a:noFill/>
+        </a:ln>
+        <a:effectLst/>
+      </c:spPr>
+    </c:plotArea>
+    <c:legend>
+      <c:legendPos val="b"/>
+      <c:overlay val="0"/>
+      <c:txPr>
+        <a:bodyPr/>
+        <a:lstStyle/>
+        <a:p>
+          <a:pPr>
+            <a:defRPr sz="800">      </a:defRPr>
+          </a:pPr>
+          <a:endParaRPr lang="en-US"/>
+        </a:p>
+      </c:txPr>
+    </c:legend>
+    <c:plotVisOnly val="1"/>
+    <c:dispBlanksAs val="span"/>
+  </c:chart>
+  <c:spPr>
+    <a:noFill/>
+    <a:ln>
+      <a:noFill/>
+    </a:ln>
+    <a:effectLst/>
+  </c:spPr>
+  <c:externalData r:id="rId1">
+    <c:autoUpdate val="0"/>
+  </c:externalData>
+</c:chartSpace>
+</file>
+
+<file path=ppt/charts/chart33.xml><?xml version="1.0" encoding="utf-8"?>
+<c:chartSpace xmlns:c="http://schemas.openxmlformats.org/drawingml/2006/chart" xmlns:a="http://schemas.openxmlformats.org/drawingml/2006/main" xmlns:r="http://schemas.openxmlformats.org/officeDocument/2006/relationships">
+  <c:date1904 val="0"/>
+  <c:roundedCorners val="1"/>
+  <c:chart>
+    <c:autoTitleDeleted val="1"/>
+    <c:plotArea>
+      <c:layout/>
+      <c:barChart>
+        <c:barDir val="bar"/>
+        <c:grouping val="clustered"/>
+        <c:varyColors val="0"/>
+        <c:ser>
+          <c:idx val="0"/>
+          <c:order val="0"/>
+          <c:tx>
+            <c:strRef>
+              <c:f>Sheet1!$B$1</c:f>
+              <c:strCache>
+                <c:ptCount val="1"/>
+                <c:pt idx="0">
+                  <c:v>Top 50 Global Insurance Carrier (n=15)</c:v>
+                </c:pt>
+              </c:strCache>
+            </c:strRef>
+          </c:tx>
+          <c:spPr>
+            <a:solidFill>
+              <a:srgbClr val="86BC25"/>
+            </a:solidFill>
+            <a:effectLst/>
+          </c:spPr>
+          <c:invertIfNegative val="0"/>
+          <c:dLbls>
+            <c:numFmt formatCode="0&quot;%&quot;" sourceLinked="0"/>
+            <c:txPr>
+              <a:bodyPr/>
+              <a:lstStyle/>
+              <a:p>
+                <a:pPr>
+                  <a:defRPr b="0" i="0" strike="noStrike" sz="1000" u="none">
+                    <a:solidFill>
+                      <a:srgbClr val="000000"/>
+                    </a:solidFill>
+                    <a:latin typeface="Arial"/>
+                  </a:defRPr>
+                </a:pPr>
+              </a:p>
+            </c:txPr>
+            <c:showLegendKey val="0"/>
+            <c:showVal val="1"/>
+            <c:showCatName val="0"/>
+            <c:showSerName val="0"/>
+            <c:showPercent val="0"/>
+            <c:showBubbleSize val="0"/>
+            <c:showLeaderLines val="0"/>
+          </c:dLbls>
+          <c:cat>
+            <c:multiLvlStrRef>
+              <c:f>Sheet1!$A$2:$A$4</c:f>
+              <c:multiLvlStrCache>
+                <c:ptCount val="3"/>
+                <c:lvl>
+                  <c:pt idx="0">
+                    <c:v>Investing to remediate existing compliance gaps</c:v>
+                  </c:pt>
+                  <c:pt idx="1">
+                    <c:v>Investing to meet upcoming / draft regulations</c:v>
+                  </c:pt>
+                  <c:pt idx="2">
+                    <c:v>Regulation not a primary driver</c:v>
+                  </c:pt>
+                </c:lvl>
+              </c:multiLvlStrCache>
+            </c:multiLvlStrRef>
+          </c:cat>
+          <c:val>
+            <c:numRef>
+              <c:f>Sheet1!$B$2:$B$4</c:f>
+              <c:numCache>
+                <c:formatCode>General</c:formatCode>
+                <c:ptCount val="3"/>
+                <c:pt idx="0">
+                  <c:v>33</c:v>
+                </c:pt>
+                <c:pt idx="1">
+                  <c:v>47</c:v>
+                </c:pt>
+                <c:pt idx="2">
+                  <c:v>20</c:v>
+                </c:pt>
+              </c:numCache>
+            </c:numRef>
+          </c:val>
+        </c:ser>
+        <c:ser>
+          <c:idx val="1"/>
+          <c:order val="1"/>
+          <c:tx>
+            <c:strRef>
+              <c:f>Sheet1!$C$1</c:f>
+              <c:strCache>
+                <c:ptCount val="1"/>
+                <c:pt idx="0">
+                  <c:v>Large Insurance Carrier (n=10)</c:v>
+                </c:pt>
+              </c:strCache>
+            </c:strRef>
+          </c:tx>
+          <c:spPr>
+            <a:solidFill>
+              <a:srgbClr val="046A38"/>
+            </a:solidFill>
+            <a:effectLst/>
+          </c:spPr>
+          <c:invertIfNegative val="0"/>
+          <c:dLbls>
+            <c:numFmt formatCode="0&quot;%&quot;" sourceLinked="0"/>
+            <c:txPr>
+              <a:bodyPr/>
+              <a:lstStyle/>
+              <a:p>
+                <a:pPr>
+                  <a:defRPr b="0" i="0" strike="noStrike" sz="1000" u="none">
+                    <a:solidFill>
+                      <a:srgbClr val="000000"/>
+                    </a:solidFill>
+                    <a:latin typeface="Arial"/>
+                  </a:defRPr>
+                </a:pPr>
+              </a:p>
+            </c:txPr>
+            <c:showLegendKey val="0"/>
+            <c:showVal val="1"/>
+            <c:showCatName val="0"/>
+            <c:showSerName val="0"/>
+            <c:showPercent val="0"/>
+            <c:showBubbleSize val="0"/>
+            <c:showLeaderLines val="0"/>
+          </c:dLbls>
+          <c:cat>
+            <c:multiLvlStrRef>
+              <c:f>Sheet1!$A$2:$A$4</c:f>
+              <c:multiLvlStrCache>
+                <c:ptCount val="3"/>
+                <c:lvl>
+                  <c:pt idx="0">
+                    <c:v>Investing to remediate existing compliance gaps</c:v>
+                  </c:pt>
+                  <c:pt idx="1">
+                    <c:v>Investing to meet upcoming / draft regulations</c:v>
+                  </c:pt>
+                  <c:pt idx="2">
+                    <c:v>Regulation not a primary driver</c:v>
+                  </c:pt>
+                </c:lvl>
+              </c:multiLvlStrCache>
+            </c:multiLvlStrRef>
+          </c:cat>
+          <c:val>
+            <c:numRef>
+              <c:f>Sheet1!$C$2:$C$4</c:f>
+              <c:numCache>
+                <c:formatCode>General</c:formatCode>
+                <c:ptCount val="3"/>
+                <c:pt idx="0">
+                  <c:v>70</c:v>
+                </c:pt>
+                <c:pt idx="1">
+                  <c:v>30</c:v>
+                </c:pt>
+                <c:pt idx="2">
+                  <c:v>0</c:v>
+                </c:pt>
+              </c:numCache>
+            </c:numRef>
+          </c:val>
+        </c:ser>
+        <c:dLbls>
+          <c:numFmt formatCode="0&quot;%&quot;" sourceLinked="0"/>
+          <c:txPr>
+            <a:bodyPr/>
+            <a:lstStyle/>
+            <a:p>
+              <a:pPr>
+                <a:defRPr b="0" i="0" strike="noStrike" sz="1000" u="none">
+                  <a:solidFill>
+                    <a:srgbClr val="000000"/>
+                  </a:solidFill>
+                  <a:latin typeface="Arial"/>
+                </a:defRPr>
+              </a:pPr>
+            </a:p>
+          </c:txPr>
+          <c:showLegendKey val="0"/>
+          <c:showVal val="1"/>
+          <c:showCatName val="0"/>
+          <c:showSerName val="0"/>
+          <c:showPercent val="0"/>
+          <c:showBubbleSize val="0"/>
+          <c:showLeaderLines val="0"/>
+        </c:dLbls>
+        <c:gapWidth val="40"/>
+        <c:overlap val="0"/>
+        <c:axId val="2094734554"/>
+        <c:axId val="2094734552"/>
+        <c:axId val="2094734556"/>
+      </c:barChart>
+      <c:catAx>
+        <c:axId val="2094734554"/>
+        <c:scaling>
+          <c:orientation val="minMax"/>
+        </c:scaling>
+        <c:delete val="0"/>
+        <c:axPos val="l"/>
+        <c:numFmt formatCode="General" sourceLinked="1"/>
+        <c:majorTickMark val="out"/>
+        <c:minorTickMark val="none"/>
+        <c:tickLblPos val="nextTo"/>
+        <c:spPr>
+          <a:ln w="12700" cap="flat">
+            <a:noFill/>
+            <a:prstDash val="solid"/>
+            <a:round/>
+          </a:ln>
+        </c:spPr>
+        <c:txPr>
+          <a:bodyPr/>
+          <a:lstStyle/>
+          <a:p>
+            <a:pPr>
+              <a:defRPr sz="1000" b="0" i="0" u="none" strike="noStrike">
+                <a:solidFill>
+                  <a:srgbClr val="53565A"/>
+                </a:solidFill>
+                <a:latin typeface="Arial"/>
+              </a:defRPr>
+            </a:pPr>
+            <a:endParaRPr lang="en-US"/>
+          </a:p>
+        </c:txPr>
+        <c:crossAx val="2094734552"/>
+        <c:crosses val="autoZero"/>
+        <c:auto val="1"/>
+        <c:lblAlgn val="ctr"/>
+        <c:noMultiLvlLbl val="1"/>
+      </c:catAx>
+      <c:valAx>
+        <c:axId val="2094734552"/>
+        <c:scaling>
+          <c:orientation val="minMax"/>
+        </c:scaling>
+        <c:delete val="1"/>
+        <c:axPos val="b"/>
+        <c:numFmt formatCode="General" sourceLinked="0"/>
+        <c:majorTickMark val="out"/>
+        <c:minorTickMark val="none"/>
+        <c:tickLblPos val="low"/>
+        <c:spPr>
+          <a:ln w="12700" cap="flat">
+            <a:noFill/>
+            <a:prstDash val="solid"/>
+            <a:round/>
+          </a:ln>
+        </c:spPr>
+        <c:txPr>
+          <a:bodyPr/>
+          <a:lstStyle/>
+          <a:p>
+            <a:pPr>
+              <a:defRPr sz="1200" b="0" i="0" u="none" strike="noStrike">
+                <a:solidFill>
+                  <a:srgbClr val="000000"/>
+                </a:solidFill>
+                <a:latin typeface="Arial"/>
+              </a:defRPr>
+            </a:pPr>
+            <a:endParaRPr lang="en-US"/>
+          </a:p>
+        </c:txPr>
+        <c:crossAx val="2094734554"/>
+        <c:crosses val="autoZero"/>
+        <c:crossBetween val="between"/>
+      </c:valAx>
+      <c:spPr>
+        <a:solidFill>
+          <a:srgbClr val="FFFFFF"/>
+        </a:solidFill>
+        <a:ln>
+          <a:noFill/>
+        </a:ln>
+        <a:effectLst/>
+      </c:spPr>
+    </c:plotArea>
+    <c:legend>
+      <c:legendPos val="b"/>
+      <c:overlay val="0"/>
+      <c:txPr>
+        <a:bodyPr/>
+        <a:lstStyle/>
+        <a:p>
+          <a:pPr>
+            <a:defRPr sz="950">      </a:defRPr>
+          </a:pPr>
+          <a:endParaRPr lang="en-US"/>
+        </a:p>
+      </c:txPr>
+    </c:legend>
+    <c:plotVisOnly val="1"/>
+    <c:dispBlanksAs val="span"/>
+  </c:chart>
+  <c:spPr>
+    <a:noFill/>
+    <a:ln>
+      <a:noFill/>
+    </a:ln>
+    <a:effectLst/>
+  </c:spPr>
+  <c:externalData r:id="rId1">
+    <c:autoUpdate val="0"/>
+  </c:externalData>
+</c:chartSpace>
+</file>
+
+<file path=ppt/charts/chart34.xml><?xml version="1.0" encoding="utf-8"?>
+<c:chartSpace xmlns:c="http://schemas.openxmlformats.org/drawingml/2006/chart" xmlns:a="http://schemas.openxmlformats.org/drawingml/2006/main" xmlns:r="http://schemas.openxmlformats.org/officeDocument/2006/relationships">
+  <c:date1904 val="0"/>
+  <c:roundedCorners val="1"/>
+  <c:chart>
+    <c:autoTitleDeleted val="1"/>
+    <c:plotArea>
+      <c:layout/>
+      <c:barChart>
+        <c:barDir val="bar"/>
+        <c:grouping val="clustered"/>
+        <c:varyColors val="0"/>
+        <c:ser>
+          <c:idx val="0"/>
+          <c:order val="0"/>
+          <c:tx>
+            <c:strRef>
+              <c:f>Sheet1!$B$1</c:f>
+              <c:strCache>
+                <c:ptCount val="1"/>
+                <c:pt idx="0">
+                  <c:v>Top 100 Financial Institution (n=40)</c:v>
+                </c:pt>
+              </c:strCache>
+            </c:strRef>
+          </c:tx>
+          <c:spPr>
+            <a:solidFill>
+              <a:srgbClr val="86BC25"/>
+            </a:solidFill>
+            <a:effectLst/>
+          </c:spPr>
+          <c:invertIfNegative val="0"/>
+          <c:dLbls>
+            <c:numFmt formatCode="0&quot;%&quot;" sourceLinked="0"/>
+            <c:txPr>
+              <a:bodyPr/>
+              <a:lstStyle/>
+              <a:p>
+                <a:pPr>
+                  <a:defRPr b="0" i="0" strike="noStrike" sz="1000" u="none">
+                    <a:solidFill>
+                      <a:srgbClr val="000000"/>
+                    </a:solidFill>
+                    <a:latin typeface="Arial"/>
+                  </a:defRPr>
+                </a:pPr>
+              </a:p>
+            </c:txPr>
+            <c:showLegendKey val="0"/>
+            <c:showVal val="1"/>
+            <c:showCatName val="0"/>
+            <c:showSerName val="0"/>
+            <c:showPercent val="0"/>
+            <c:showBubbleSize val="0"/>
+            <c:showLeaderLines val="0"/>
+          </c:dLbls>
+          <c:cat>
+            <c:multiLvlStrRef>
+              <c:f>Sheet1!$A$2:$A$4</c:f>
+              <c:multiLvlStrCache>
+                <c:ptCount val="3"/>
+                <c:lvl>
+                  <c:pt idx="0">
+                    <c:v>Investing to remediate existing compliance gaps</c:v>
+                  </c:pt>
+                  <c:pt idx="1">
+                    <c:v>Investing to meet upcoming / draft regulations</c:v>
+                  </c:pt>
+                  <c:pt idx="2">
+                    <c:v>Regulation not a primary driver</c:v>
+                  </c:pt>
+                </c:lvl>
+              </c:multiLvlStrCache>
+            </c:multiLvlStrRef>
+          </c:cat>
+          <c:val>
+            <c:numRef>
+              <c:f>Sheet1!$B$2:$B$4</c:f>
+              <c:numCache>
+                <c:formatCode>General</c:formatCode>
+                <c:ptCount val="3"/>
+                <c:pt idx="0">
+                  <c:v>42</c:v>
+                </c:pt>
+                <c:pt idx="1">
+                  <c:v>48</c:v>
+                </c:pt>
+                <c:pt idx="2">
+                  <c:v>10</c:v>
+                </c:pt>
+              </c:numCache>
+            </c:numRef>
+          </c:val>
+        </c:ser>
+        <c:ser>
+          <c:idx val="1"/>
+          <c:order val="1"/>
+          <c:tx>
+            <c:strRef>
+              <c:f>Sheet1!$C$1</c:f>
+              <c:strCache>
+                <c:ptCount val="1"/>
+                <c:pt idx="0">
+                  <c:v>Large Financial Institution (n=35)</c:v>
+                </c:pt>
+              </c:strCache>
+            </c:strRef>
+          </c:tx>
+          <c:spPr>
+            <a:solidFill>
+              <a:srgbClr val="046A38"/>
+            </a:solidFill>
+            <a:effectLst/>
+          </c:spPr>
+          <c:invertIfNegative val="0"/>
+          <c:dLbls>
+            <c:numFmt formatCode="0&quot;%&quot;" sourceLinked="0"/>
+            <c:txPr>
+              <a:bodyPr/>
+              <a:lstStyle/>
+              <a:p>
+                <a:pPr>
+                  <a:defRPr b="0" i="0" strike="noStrike" sz="1000" u="none">
+                    <a:solidFill>
+                      <a:srgbClr val="000000"/>
+                    </a:solidFill>
+                    <a:latin typeface="Arial"/>
+                  </a:defRPr>
+                </a:pPr>
+              </a:p>
+            </c:txPr>
+            <c:showLegendKey val="0"/>
+            <c:showVal val="1"/>
+            <c:showCatName val="0"/>
+            <c:showSerName val="0"/>
+            <c:showPercent val="0"/>
+            <c:showBubbleSize val="0"/>
+            <c:showLeaderLines val="0"/>
+          </c:dLbls>
+          <c:cat>
+            <c:multiLvlStrRef>
+              <c:f>Sheet1!$A$2:$A$4</c:f>
+              <c:multiLvlStrCache>
+                <c:ptCount val="3"/>
+                <c:lvl>
+                  <c:pt idx="0">
+                    <c:v>Investing to remediate existing compliance gaps</c:v>
+                  </c:pt>
+                  <c:pt idx="1">
+                    <c:v>Investing to meet upcoming / draft regulations</c:v>
+                  </c:pt>
+                  <c:pt idx="2">
+                    <c:v>Regulation not a primary driver</c:v>
+                  </c:pt>
+                </c:lvl>
+              </c:multiLvlStrCache>
+            </c:multiLvlStrRef>
+          </c:cat>
+          <c:val>
+            <c:numRef>
+              <c:f>Sheet1!$C$2:$C$4</c:f>
+              <c:numCache>
+                <c:formatCode>General</c:formatCode>
+                <c:ptCount val="3"/>
+                <c:pt idx="0">
+                  <c:v>54</c:v>
+                </c:pt>
+                <c:pt idx="1">
+                  <c:v>29</c:v>
+                </c:pt>
+                <c:pt idx="2">
+                  <c:v>17</c:v>
+                </c:pt>
+              </c:numCache>
+            </c:numRef>
+          </c:val>
+        </c:ser>
+        <c:dLbls>
+          <c:numFmt formatCode="0&quot;%&quot;" sourceLinked="0"/>
+          <c:txPr>
+            <a:bodyPr/>
+            <a:lstStyle/>
+            <a:p>
+              <a:pPr>
+                <a:defRPr b="0" i="0" strike="noStrike" sz="1000" u="none">
+                  <a:solidFill>
+                    <a:srgbClr val="000000"/>
+                  </a:solidFill>
+                  <a:latin typeface="Arial"/>
+                </a:defRPr>
+              </a:pPr>
+            </a:p>
+          </c:txPr>
+          <c:showLegendKey val="0"/>
+          <c:showVal val="1"/>
+          <c:showCatName val="0"/>
+          <c:showSerName val="0"/>
+          <c:showPercent val="0"/>
+          <c:showBubbleSize val="0"/>
+          <c:showLeaderLines val="0"/>
+        </c:dLbls>
+        <c:gapWidth val="40"/>
+        <c:overlap val="0"/>
+        <c:axId val="2094734554"/>
+        <c:axId val="2094734552"/>
+        <c:axId val="2094734556"/>
+      </c:barChart>
+      <c:catAx>
+        <c:axId val="2094734554"/>
+        <c:scaling>
+          <c:orientation val="minMax"/>
+        </c:scaling>
+        <c:delete val="0"/>
+        <c:axPos val="l"/>
+        <c:numFmt formatCode="General" sourceLinked="1"/>
+        <c:majorTickMark val="out"/>
+        <c:minorTickMark val="none"/>
+        <c:tickLblPos val="nextTo"/>
+        <c:spPr>
+          <a:ln w="12700" cap="flat">
+            <a:noFill/>
+            <a:prstDash val="solid"/>
+            <a:round/>
+          </a:ln>
+        </c:spPr>
+        <c:txPr>
+          <a:bodyPr/>
+          <a:lstStyle/>
+          <a:p>
+            <a:pPr>
+              <a:defRPr sz="1000" b="0" i="0" u="none" strike="noStrike">
+                <a:solidFill>
+                  <a:srgbClr val="53565A"/>
+                </a:solidFill>
+                <a:latin typeface="Arial"/>
+              </a:defRPr>
+            </a:pPr>
+            <a:endParaRPr lang="en-US"/>
+          </a:p>
+        </c:txPr>
+        <c:crossAx val="2094734552"/>
+        <c:crosses val="autoZero"/>
+        <c:auto val="1"/>
+        <c:lblAlgn val="ctr"/>
+        <c:noMultiLvlLbl val="1"/>
+      </c:catAx>
+      <c:valAx>
+        <c:axId val="2094734552"/>
+        <c:scaling>
+          <c:orientation val="minMax"/>
+        </c:scaling>
+        <c:delete val="1"/>
+        <c:axPos val="b"/>
+        <c:numFmt formatCode="General" sourceLinked="0"/>
+        <c:majorTickMark val="out"/>
+        <c:minorTickMark val="none"/>
+        <c:tickLblPos val="low"/>
+        <c:spPr>
+          <a:ln w="12700" cap="flat">
+            <a:noFill/>
+            <a:prstDash val="solid"/>
+            <a:round/>
+          </a:ln>
+        </c:spPr>
+        <c:txPr>
+          <a:bodyPr/>
+          <a:lstStyle/>
+          <a:p>
+            <a:pPr>
+              <a:defRPr sz="1200" b="0" i="0" u="none" strike="noStrike">
+                <a:solidFill>
+                  <a:srgbClr val="000000"/>
+                </a:solidFill>
+                <a:latin typeface="Arial"/>
+              </a:defRPr>
+            </a:pPr>
+            <a:endParaRPr lang="en-US"/>
+          </a:p>
+        </c:txPr>
+        <c:crossAx val="2094734554"/>
+        <c:crosses val="autoZero"/>
+        <c:crossBetween val="between"/>
+      </c:valAx>
+      <c:spPr>
+        <a:solidFill>
+          <a:srgbClr val="FFFFFF"/>
+        </a:solidFill>
+        <a:ln>
+          <a:noFill/>
+        </a:ln>
+        <a:effectLst/>
+      </c:spPr>
+    </c:plotArea>
+    <c:legend>
+      <c:legendPos val="b"/>
+      <c:overlay val="0"/>
+      <c:txPr>
+        <a:bodyPr/>
+        <a:lstStyle/>
+        <a:p>
+          <a:pPr>
+            <a:defRPr sz="950">      </a:defRPr>
+          </a:pPr>
+          <a:endParaRPr lang="en-US"/>
+        </a:p>
+      </c:txPr>
+    </c:legend>
+    <c:plotVisOnly val="1"/>
+    <c:dispBlanksAs val="span"/>
+  </c:chart>
+  <c:spPr>
+    <a:noFill/>
+    <a:ln>
+      <a:noFill/>
+    </a:ln>
+    <a:effectLst/>
+  </c:spPr>
+  <c:externalData r:id="rId1">
+    <c:autoUpdate val="0"/>
+  </c:externalData>
+</c:chartSpace>
+</file>
+
+<file path=ppt/charts/chart35.xml><?xml version="1.0" encoding="utf-8"?>
+<c:chartSpace xmlns:c="http://schemas.openxmlformats.org/drawingml/2006/chart" xmlns:a="http://schemas.openxmlformats.org/drawingml/2006/main" xmlns:r="http://schemas.openxmlformats.org/officeDocument/2006/relationships">
+  <c:date1904 val="0"/>
+  <c:roundedCorners val="1"/>
+  <c:chart>
+    <c:autoTitleDeleted val="1"/>
+    <c:plotArea>
+      <c:layout/>
+      <c:barChart>
+        <c:barDir val="bar"/>
         <c:grouping val="clustered"/>
         <c:varyColors val="0"/>
         <c:ser>
@@ -17372,6 +18602,182 @@
 </p:notes>
 </file>
 
+<file path=ppt/notesSlides/notesSlide38.xml><?xml version="1.0" encoding="utf-8"?>
+<p:notes xmlns:a="http://schemas.openxmlformats.org/drawingml/2006/main" xmlns:r="http://schemas.openxmlformats.org/officeDocument/2006/relationships" xmlns:p="http://schemas.openxmlformats.org/presentationml/2006/main">
+  <p:cSld>
+    <p:spTree>
+      <p:nvGrpSpPr>
+        <p:cNvPr id="1" name=""/>
+        <p:cNvGrpSpPr/>
+        <p:nvPr/>
+      </p:nvGrpSpPr>
+      <p:grpSpPr>
+        <a:xfrm>
+          <a:off x="0" y="0"/>
+          <a:ext cx="0" cy="0"/>
+          <a:chOff x="0" y="0"/>
+          <a:chExt cx="0" cy="0"/>
+        </a:xfrm>
+      </p:grpSpPr>
+      <p:sp>
+        <p:nvSpPr>
+          <p:cNvPr id="2" name="Slide Image Placeholder 1"/>
+          <p:cNvSpPr>
+            <a:spLocks noGrp="1" noRot="1" noChangeAspect="1"/>
+          </p:cNvSpPr>
+          <p:nvPr>
+            <p:ph type="sldImg"/>
+          </p:nvPr>
+        </p:nvSpPr>
+        <p:spPr/>
+      </p:sp>
+      <p:sp>
+        <p:nvSpPr>
+          <p:cNvPr id="3" name="Notes Placeholder 2"/>
+          <p:cNvSpPr>
+            <a:spLocks noGrp="1"/>
+          </p:cNvSpPr>
+          <p:nvPr>
+            <p:ph type="body" idx="1"/>
+          </p:nvPr>
+        </p:nvSpPr>
+        <p:spPr/>
+        <p:txBody>
+          <a:bodyPr/>
+          <a:lstStyle/>
+          <a:p>
+            <a:r>
+              <a:rPr lang="en-US" dirty="0"/>
+              <a:t/>
+            </a:r>
+            <a:endParaRPr lang="en-US" dirty="0"/>
+          </a:p>
+        </p:txBody>
+      </p:sp>
+      <p:sp>
+        <p:nvSpPr>
+          <p:cNvPr id="4" name="Slide Number Placeholder 3"/>
+          <p:cNvSpPr>
+            <a:spLocks noGrp="1"/>
+          </p:cNvSpPr>
+          <p:nvPr>
+            <p:ph type="sldNum" sz="quarter" idx="10"/>
+          </p:nvPr>
+        </p:nvSpPr>
+        <p:spPr/>
+        <p:txBody>
+          <a:bodyPr/>
+          <a:lstStyle/>
+          <a:p>
+            <a:fld id="{F7021451-1387-4CA6-816F-3879F97B5CBC}" type="slidenum">
+              <a:rPr lang="en-US"/>
+              <a:t>38</a:t>
+            </a:fld>
+            <a:endParaRPr lang="en-US"/>
+          </a:p>
+        </p:txBody>
+      </p:sp>
+    </p:spTree>
+    <p:extLst>
+      <p:ext uri="{BB962C8B-B14F-4D97-AF65-F5344CB8AC3E}">
+        <p14:creationId xmlns:p14="http://schemas.microsoft.com/office/powerpoint/2010/main" val="1024086991"/>
+      </p:ext>
+    </p:extLst>
+  </p:cSld>
+  <p:clrMapOvr>
+    <a:masterClrMapping/>
+  </p:clrMapOvr>
+</p:notes>
+</file>
+
+<file path=ppt/notesSlides/notesSlide39.xml><?xml version="1.0" encoding="utf-8"?>
+<p:notes xmlns:a="http://schemas.openxmlformats.org/drawingml/2006/main" xmlns:r="http://schemas.openxmlformats.org/officeDocument/2006/relationships" xmlns:p="http://schemas.openxmlformats.org/presentationml/2006/main">
+  <p:cSld>
+    <p:spTree>
+      <p:nvGrpSpPr>
+        <p:cNvPr id="1" name=""/>
+        <p:cNvGrpSpPr/>
+        <p:nvPr/>
+      </p:nvGrpSpPr>
+      <p:grpSpPr>
+        <a:xfrm>
+          <a:off x="0" y="0"/>
+          <a:ext cx="0" cy="0"/>
+          <a:chOff x="0" y="0"/>
+          <a:chExt cx="0" cy="0"/>
+        </a:xfrm>
+      </p:grpSpPr>
+      <p:sp>
+        <p:nvSpPr>
+          <p:cNvPr id="2" name="Slide Image Placeholder 1"/>
+          <p:cNvSpPr>
+            <a:spLocks noGrp="1" noRot="1" noChangeAspect="1"/>
+          </p:cNvSpPr>
+          <p:nvPr>
+            <p:ph type="sldImg"/>
+          </p:nvPr>
+        </p:nvSpPr>
+        <p:spPr/>
+      </p:sp>
+      <p:sp>
+        <p:nvSpPr>
+          <p:cNvPr id="3" name="Notes Placeholder 2"/>
+          <p:cNvSpPr>
+            <a:spLocks noGrp="1"/>
+          </p:cNvSpPr>
+          <p:nvPr>
+            <p:ph type="body" idx="1"/>
+          </p:nvPr>
+        </p:nvSpPr>
+        <p:spPr/>
+        <p:txBody>
+          <a:bodyPr/>
+          <a:lstStyle/>
+          <a:p>
+            <a:r>
+              <a:rPr lang="en-US" dirty="0"/>
+              <a:t/>
+            </a:r>
+            <a:endParaRPr lang="en-US" dirty="0"/>
+          </a:p>
+        </p:txBody>
+      </p:sp>
+      <p:sp>
+        <p:nvSpPr>
+          <p:cNvPr id="4" name="Slide Number Placeholder 3"/>
+          <p:cNvSpPr>
+            <a:spLocks noGrp="1"/>
+          </p:cNvSpPr>
+          <p:nvPr>
+            <p:ph type="sldNum" sz="quarter" idx="10"/>
+          </p:nvPr>
+        </p:nvSpPr>
+        <p:spPr/>
+        <p:txBody>
+          <a:bodyPr/>
+          <a:lstStyle/>
+          <a:p>
+            <a:fld id="{F7021451-1387-4CA6-816F-3879F97B5CBC}" type="slidenum">
+              <a:rPr lang="en-US"/>
+              <a:t>39</a:t>
+            </a:fld>
+            <a:endParaRPr lang="en-US"/>
+          </a:p>
+        </p:txBody>
+      </p:sp>
+    </p:spTree>
+    <p:extLst>
+      <p:ext uri="{BB962C8B-B14F-4D97-AF65-F5344CB8AC3E}">
+        <p14:creationId xmlns:p14="http://schemas.microsoft.com/office/powerpoint/2010/main" val="1024086991"/>
+      </p:ext>
+    </p:extLst>
+  </p:cSld>
+  <p:clrMapOvr>
+    <a:masterClrMapping/>
+  </p:clrMapOvr>
+</p:notes>
+</file>
+
 <file path=ppt/notesSlides/notesSlide4.xml><?xml version="1.0" encoding="utf-8"?>
 <p:notes xmlns:a="http://schemas.openxmlformats.org/drawingml/2006/main" xmlns:r="http://schemas.openxmlformats.org/officeDocument/2006/relationships" xmlns:p="http://schemas.openxmlformats.org/presentationml/2006/main">
   <p:cSld>
@@ -17442,6 +18848,94 @@
             <a:fld id="{F7021451-1387-4CA6-816F-3879F97B5CBC}" type="slidenum">
               <a:rPr lang="en-US"/>
               <a:t>4</a:t>
+            </a:fld>
+            <a:endParaRPr lang="en-US"/>
+          </a:p>
+        </p:txBody>
+      </p:sp>
+    </p:spTree>
+    <p:extLst>
+      <p:ext uri="{BB962C8B-B14F-4D97-AF65-F5344CB8AC3E}">
+        <p14:creationId xmlns:p14="http://schemas.microsoft.com/office/powerpoint/2010/main" val="1024086991"/>
+      </p:ext>
+    </p:extLst>
+  </p:cSld>
+  <p:clrMapOvr>
+    <a:masterClrMapping/>
+  </p:clrMapOvr>
+</p:notes>
+</file>
+
+<file path=ppt/notesSlides/notesSlide40.xml><?xml version="1.0" encoding="utf-8"?>
+<p:notes xmlns:a="http://schemas.openxmlformats.org/drawingml/2006/main" xmlns:r="http://schemas.openxmlformats.org/officeDocument/2006/relationships" xmlns:p="http://schemas.openxmlformats.org/presentationml/2006/main">
+  <p:cSld>
+    <p:spTree>
+      <p:nvGrpSpPr>
+        <p:cNvPr id="1" name=""/>
+        <p:cNvGrpSpPr/>
+        <p:nvPr/>
+      </p:nvGrpSpPr>
+      <p:grpSpPr>
+        <a:xfrm>
+          <a:off x="0" y="0"/>
+          <a:ext cx="0" cy="0"/>
+          <a:chOff x="0" y="0"/>
+          <a:chExt cx="0" cy="0"/>
+        </a:xfrm>
+      </p:grpSpPr>
+      <p:sp>
+        <p:nvSpPr>
+          <p:cNvPr id="2" name="Slide Image Placeholder 1"/>
+          <p:cNvSpPr>
+            <a:spLocks noGrp="1" noRot="1" noChangeAspect="1"/>
+          </p:cNvSpPr>
+          <p:nvPr>
+            <p:ph type="sldImg"/>
+          </p:nvPr>
+        </p:nvSpPr>
+        <p:spPr/>
+      </p:sp>
+      <p:sp>
+        <p:nvSpPr>
+          <p:cNvPr id="3" name="Notes Placeholder 2"/>
+          <p:cNvSpPr>
+            <a:spLocks noGrp="1"/>
+          </p:cNvSpPr>
+          <p:nvPr>
+            <p:ph type="body" idx="1"/>
+          </p:nvPr>
+        </p:nvSpPr>
+        <p:spPr/>
+        <p:txBody>
+          <a:bodyPr/>
+          <a:lstStyle/>
+          <a:p>
+            <a:r>
+              <a:rPr lang="en-US" dirty="0"/>
+              <a:t/>
+            </a:r>
+            <a:endParaRPr lang="en-US" dirty="0"/>
+          </a:p>
+        </p:txBody>
+      </p:sp>
+      <p:sp>
+        <p:nvSpPr>
+          <p:cNvPr id="4" name="Slide Number Placeholder 3"/>
+          <p:cNvSpPr>
+            <a:spLocks noGrp="1"/>
+          </p:cNvSpPr>
+          <p:nvPr>
+            <p:ph type="sldNum" sz="quarter" idx="10"/>
+          </p:nvPr>
+        </p:nvSpPr>
+        <p:spPr/>
+        <p:txBody>
+          <a:bodyPr/>
+          <a:lstStyle/>
+          <a:p>
+            <a:fld id="{F7021451-1387-4CA6-816F-3879F97B5CBC}" type="slidenum">
+              <a:rPr lang="en-US"/>
+              <a:t>40</a:t>
             </a:fld>
             <a:endParaRPr lang="en-US"/>
           </a:p>
@@ -29671,7 +31165,7 @@
                 <a:ea typeface="Calibri" pitchFamily="34" charset="-122"/>
                 <a:cs typeface="Calibri" pitchFamily="34" charset="-120"/>
               </a:rPr>
-              <a:t>Upcoming Regulatory / Market Change With Greatest Expected Impact</a:t>
+              <a:t>Fraud Investment Relative to Regulatory Requirements — By Region</a:t>
             </a:r>
             <a:endParaRPr lang="en-US" sz="1900" dirty="0"/>
           </a:p>
@@ -29713,7 +31207,7 @@
                 <a:ea typeface="Calibri" pitchFamily="34" charset="-122"/>
                 <a:cs typeface="Calibri" pitchFamily="34" charset="-120"/>
               </a:rPr>
-              <a:t>Identity and authentication tops a close three-way race for the next big disruption.</a:t>
+              <a:t>The remediation-first pattern holds broadly across markets, though Canada leans even more toward fixing existing gaps.</a:t>
             </a:r>
             <a:endParaRPr lang="en-US" sz="1350" dirty="0"/>
           </a:p>
@@ -29778,7 +31272,7 @@
                 <a:ea typeface="IBM Plex Mono" pitchFamily="34" charset="-122"/>
                 <a:cs typeface="IBM Plex Mono" pitchFamily="34" charset="-120"/>
               </a:rPr>
-              <a:t>Q11  </a:t>
+              <a:t>Q10  </a:t>
             </a:r>
             <a:pPr algn="l" indent="0" marL="0">
               <a:lnSpc>
@@ -29795,7 +31289,7 @@
                 <a:ea typeface="Calibri" pitchFamily="34" charset="-122"/>
                 <a:cs typeface="Calibri" pitchFamily="34" charset="-120"/>
               </a:rPr>
-              <a:t>“Which upcoming regulatory or market changes is expected to have the greatest impact on your fraud program?”</a:t>
+              <a:t>“Which statement best reflects how your organization is allocating fraud-related investment in response to regulatory and compliance requirements? (by region, all respondents)”</a:t>
             </a:r>
             <a:endParaRPr lang="en-US" sz="1000" dirty="0"/>
           </a:p>
@@ -29915,7 +31409,7 @@
                 <a:ea typeface="Calibri" pitchFamily="34" charset="-122"/>
                 <a:cs typeface="Calibri" pitchFamily="34" charset="-120"/>
               </a:rPr>
-              <a:t>Ranked top 3 — shown as % of respondents who placed the option anywhere in their top 3 (not mutually exclusive; bars don't sum to 100%).  </a:t>
+              <a:t>Single select — % shown is each region's share of the full 100-respondent sample, so segments sum to the overall figure in each category label. Australia (n=8) and Singapore (n=4) are thin samples, shown directionally.  </a:t>
             </a:r>
             <a:pPr algn="l" indent="0" marL="0">
               <a:lnSpc>
@@ -29949,7 +31443,7 @@
                 <a:ea typeface="Calibri" pitchFamily="34" charset="-122"/>
                 <a:cs typeface="Calibri" pitchFamily="34" charset="-120"/>
               </a:rPr>
-              <a:t>“Payment innovation and adoption (e.g., real-time payments, stable coins, agentic payments)”</a:t>
+              <a:t>“Primarily investing to meet upcoming and draft regulatory requirements”</a:t>
             </a:r>
             <a:pPr algn="l" indent="0" marL="0">
               <a:lnSpc>
@@ -29983,7 +31477,7 @@
                 <a:ea typeface="Calibri" pitchFamily="34" charset="-122"/>
                 <a:cs typeface="Calibri" pitchFamily="34" charset="-120"/>
               </a:rPr>
-              <a:t>“Liability and reimbursement changes”</a:t>
+              <a:t>“Primarily investing to remediate existing compliance and control gaps”</a:t>
             </a:r>
             <a:pPr algn="l" indent="0" marL="0">
               <a:lnSpc>
@@ -30017,109 +31511,7 @@
                 <a:ea typeface="Calibri" pitchFamily="34" charset="-122"/>
                 <a:cs typeface="Calibri" pitchFamily="34" charset="-120"/>
               </a:rPr>
-              <a:t>“Open Banking / Consumer-driven banking initiatives”</a:t>
-            </a:r>
-            <a:pPr algn="l" indent="0" marL="0">
-              <a:lnSpc>
-                <a:spcPct val="118000"/>
-              </a:lnSpc>
-              <a:buNone/>
-            </a:pPr>
-            <a:r>
-              <a:rPr lang="en-US" sz="850" dirty="0">
-                <a:solidFill>
-                  <a:srgbClr val="D0D0CE"/>
-                </a:solidFill>
-                <a:latin typeface="Calibri" pitchFamily="34" charset="0"/>
-                <a:ea typeface="Calibri" pitchFamily="34" charset="-122"/>
-                <a:cs typeface="Calibri" pitchFamily="34" charset="-120"/>
-              </a:rPr>
-              <a:t>  ·  </a:t>
-            </a:r>
-            <a:pPr algn="l" indent="0" marL="0">
-              <a:lnSpc>
-                <a:spcPct val="118000"/>
-              </a:lnSpc>
-              <a:buNone/>
-            </a:pPr>
-            <a:r>
-              <a:rPr lang="en-US" sz="850" i="1" dirty="0">
-                <a:solidFill>
-                  <a:srgbClr val="53565A"/>
-                </a:solidFill>
-                <a:latin typeface="Calibri" pitchFamily="34" charset="0"/>
-                <a:ea typeface="Calibri" pitchFamily="34" charset="-122"/>
-                <a:cs typeface="Calibri" pitchFamily="34" charset="-120"/>
-              </a:rPr>
-              <a:t>“AML related modernization initiatives”</a:t>
-            </a:r>
-            <a:pPr algn="l" indent="0" marL="0">
-              <a:lnSpc>
-                <a:spcPct val="118000"/>
-              </a:lnSpc>
-              <a:buNone/>
-            </a:pPr>
-            <a:r>
-              <a:rPr lang="en-US" sz="850" dirty="0">
-                <a:solidFill>
-                  <a:srgbClr val="D0D0CE"/>
-                </a:solidFill>
-                <a:latin typeface="Calibri" pitchFamily="34" charset="0"/>
-                <a:ea typeface="Calibri" pitchFamily="34" charset="-122"/>
-                <a:cs typeface="Calibri" pitchFamily="34" charset="-120"/>
-              </a:rPr>
-              <a:t>  ·  </a:t>
-            </a:r>
-            <a:pPr algn="l" indent="0" marL="0">
-              <a:lnSpc>
-                <a:spcPct val="118000"/>
-              </a:lnSpc>
-              <a:buNone/>
-            </a:pPr>
-            <a:r>
-              <a:rPr lang="en-US" sz="850" i="1" dirty="0">
-                <a:solidFill>
-                  <a:srgbClr val="53565A"/>
-                </a:solidFill>
-                <a:latin typeface="Calibri" pitchFamily="34" charset="0"/>
-                <a:ea typeface="Calibri" pitchFamily="34" charset="-122"/>
-                <a:cs typeface="Calibri" pitchFamily="34" charset="-120"/>
-              </a:rPr>
-              <a:t>“Privacy, data-sharing requirements, and AI governance requirements”</a:t>
-            </a:r>
-            <a:pPr algn="l" indent="0" marL="0">
-              <a:lnSpc>
-                <a:spcPct val="118000"/>
-              </a:lnSpc>
-              <a:buNone/>
-            </a:pPr>
-            <a:r>
-              <a:rPr lang="en-US" sz="850" dirty="0">
-                <a:solidFill>
-                  <a:srgbClr val="D0D0CE"/>
-                </a:solidFill>
-                <a:latin typeface="Calibri" pitchFamily="34" charset="0"/>
-                <a:ea typeface="Calibri" pitchFamily="34" charset="-122"/>
-                <a:cs typeface="Calibri" pitchFamily="34" charset="-120"/>
-              </a:rPr>
-              <a:t>  ·  </a:t>
-            </a:r>
-            <a:pPr algn="l" indent="0" marL="0">
-              <a:lnSpc>
-                <a:spcPct val="118000"/>
-              </a:lnSpc>
-              <a:buNone/>
-            </a:pPr>
-            <a:r>
-              <a:rPr lang="en-US" sz="850" i="1" dirty="0">
-                <a:solidFill>
-                  <a:srgbClr val="53565A"/>
-                </a:solidFill>
-                <a:latin typeface="Calibri" pitchFamily="34" charset="0"/>
-                <a:ea typeface="Calibri" pitchFamily="34" charset="-122"/>
-                <a:cs typeface="Calibri" pitchFamily="34" charset="-120"/>
-              </a:rPr>
-              <a:t>“Customer identity, authentication, and digital trust expectations”</a:t>
+              <a:t>“Regulatory requirements are not a primary driver of fraud-related investment”</a:t>
             </a:r>
             <a:endParaRPr lang="en-US" sz="850" dirty="0"/>
           </a:p>
@@ -30139,7 +31531,7 @@
     <p:bg>
       <p:bgPr>
         <a:solidFill>
-          <a:srgbClr val="86BC25"/>
+          <a:srgbClr val="FFFFFF"/>
         </a:solidFill>
       </p:bgPr>
     </p:bg>
@@ -30165,8 +31557,8 @@
         </p:nvSpPr>
         <p:spPr>
           <a:xfrm>
-            <a:off x="502920" y="1699870"/>
-            <a:ext cx="10415016" cy="1591970"/>
+            <a:off x="502006" y="256032"/>
+            <a:ext cx="11188598" cy="310896"/>
           </a:xfrm>
           <a:prstGeom prst="rect">
             <a:avLst/>
@@ -30175,30 +31567,154 @@
           <a:ln/>
         </p:spPr>
         <p:txBody>
-          <a:bodyPr wrap="square" lIns="0" tIns="0" rIns="0" bIns="0" rtlCol="0" anchor="b"/>
+          <a:bodyPr wrap="square" lIns="0" tIns="0" rIns="0" bIns="0" rtlCol="0" anchor="t"/>
           <a:lstStyle/>
           <a:p>
             <a:pPr algn="l" indent="0" marL="0">
               <a:buNone/>
             </a:pPr>
             <a:r>
-              <a:rPr lang="en-US" sz="3600" b="1" dirty="0">
-                <a:solidFill>
-                  <a:srgbClr val="FFFFFF"/>
-                </a:solidFill>
-                <a:latin typeface="Calibri" pitchFamily="34" charset="0"/>
-                <a:ea typeface="Calibri" pitchFamily="34" charset="-122"/>
-                <a:cs typeface="Calibri" pitchFamily="34" charset="-120"/>
-              </a:rPr>
-              <a:t>6. Looking Ahead Three Years</a:t>
-            </a:r>
-            <a:endParaRPr lang="en-US" sz="3600" dirty="0"/>
+              <a:rPr lang="en-US" sz="1900" b="1" dirty="0">
+                <a:solidFill>
+                  <a:srgbClr val="000000"/>
+                </a:solidFill>
+                <a:latin typeface="Calibri" pitchFamily="34" charset="0"/>
+                <a:ea typeface="Calibri" pitchFamily="34" charset="-122"/>
+                <a:cs typeface="Calibri" pitchFamily="34" charset="-120"/>
+              </a:rPr>
+              <a:t>Regulatory Investment Focus — Insurance, by Institution Tier</a:t>
+            </a:r>
+            <a:endParaRPr lang="en-US" sz="1900" dirty="0"/>
           </a:p>
         </p:txBody>
       </p:sp>
       <p:sp>
         <p:nvSpPr>
           <p:cNvPr id="3" name="Text 1"/>
+          <p:cNvSpPr txBox="1"/>
+          <p:nvPr/>
+        </p:nvSpPr>
+        <p:spPr>
+          <a:xfrm>
+            <a:off x="502006" y="585216"/>
+            <a:ext cx="11188598" cy="713232"/>
+          </a:xfrm>
+          <a:prstGeom prst="rect">
+            <a:avLst/>
+          </a:prstGeom>
+          <a:noFill/>
+          <a:ln/>
+        </p:spPr>
+        <p:txBody>
+          <a:bodyPr wrap="square" lIns="0" tIns="0" rIns="0" bIns="0" rtlCol="0" anchor="t"/>
+          <a:lstStyle/>
+          <a:p>
+            <a:pPr algn="l" indent="0" marL="0">
+              <a:lnSpc>
+                <a:spcPct val="105000"/>
+              </a:lnSpc>
+              <a:buNone/>
+            </a:pPr>
+            <a:r>
+              <a:rPr lang="en-US" sz="1350" b="1" dirty="0">
+                <a:solidFill>
+                  <a:srgbClr val="046A38"/>
+                </a:solidFill>
+                <a:latin typeface="Calibri" pitchFamily="34" charset="0"/>
+                <a:ea typeface="Calibri" pitchFamily="34" charset="-122"/>
+                <a:cs typeface="Calibri" pitchFamily="34" charset="-120"/>
+              </a:rPr>
+              <a:t>Large Insurance Carriers lean hardest into remediation; Top 50 carriers split more evenly toward getting ahead of upcoming rules.</a:t>
+            </a:r>
+            <a:endParaRPr lang="en-US" sz="1350" dirty="0"/>
+          </a:p>
+        </p:txBody>
+      </p:sp>
+      <p:sp>
+        <p:nvSpPr>
+          <p:cNvPr id="4" name="Shape 2"/>
+          <p:cNvSpPr/>
+          <p:nvPr/>
+        </p:nvSpPr>
+        <p:spPr>
+          <a:xfrm>
+            <a:off x="502006" y="1335024"/>
+            <a:ext cx="0" cy="512064"/>
+          </a:xfrm>
+          <a:prstGeom prst="line">
+            <a:avLst/>
+          </a:prstGeom>
+          <a:noFill/>
+          <a:ln w="25400">
+            <a:solidFill>
+              <a:srgbClr val="D0D0CE"/>
+            </a:solidFill>
+            <a:prstDash val="solid"/>
+          </a:ln>
+        </p:spPr>
+      </p:sp>
+      <p:sp>
+        <p:nvSpPr>
+          <p:cNvPr id="5" name="Text 3"/>
+          <p:cNvSpPr txBox="1"/>
+          <p:nvPr/>
+        </p:nvSpPr>
+        <p:spPr>
+          <a:xfrm>
+            <a:off x="648310" y="1335024"/>
+            <a:ext cx="11042294" cy="512064"/>
+          </a:xfrm>
+          <a:prstGeom prst="rect">
+            <a:avLst/>
+          </a:prstGeom>
+          <a:noFill/>
+          <a:ln/>
+        </p:spPr>
+        <p:txBody>
+          <a:bodyPr wrap="square" lIns="0" tIns="0" rIns="0" bIns="0" rtlCol="0" anchor="t"/>
+          <a:lstStyle/>
+          <a:p>
+            <a:pPr algn="l" indent="0" marL="0">
+              <a:lnSpc>
+                <a:spcPct val="106000"/>
+              </a:lnSpc>
+              <a:buNone/>
+            </a:pPr>
+            <a:r>
+              <a:rPr lang="en-US" sz="900" b="1" dirty="0">
+                <a:solidFill>
+                  <a:srgbClr val="046A38"/>
+                </a:solidFill>
+                <a:latin typeface="IBM Plex Mono" pitchFamily="34" charset="0"/>
+                <a:ea typeface="IBM Plex Mono" pitchFamily="34" charset="-122"/>
+                <a:cs typeface="IBM Plex Mono" pitchFamily="34" charset="-120"/>
+              </a:rPr>
+              <a:t>Q10 / S9  </a:t>
+            </a:r>
+            <a:pPr algn="l" indent="0" marL="0">
+              <a:lnSpc>
+                <a:spcPct val="106000"/>
+              </a:lnSpc>
+              <a:buNone/>
+            </a:pPr>
+            <a:r>
+              <a:rPr lang="en-US" sz="1000" i="1" dirty="0">
+                <a:solidFill>
+                  <a:srgbClr val="575757"/>
+                </a:solidFill>
+                <a:latin typeface="Calibri" pitchFamily="34" charset="0"/>
+                <a:ea typeface="Calibri" pitchFamily="34" charset="-122"/>
+                <a:cs typeface="Calibri" pitchFamily="34" charset="-120"/>
+              </a:rPr>
+              <a:t>“Which statement best reflects how your organization is allocating fraud-related investment in response to regulatory and compliance requirements? (Insurance only, by institution tier)”</a:t>
+            </a:r>
+            <a:endParaRPr lang="en-US" sz="1000" dirty="0"/>
+          </a:p>
+        </p:txBody>
+      </p:sp>
+      <p:sp>
+        <p:nvSpPr>
+          <p:cNvPr id="6" name="Text 4"/>
           <p:cNvSpPr txBox="1"/>
           <p:nvPr/>
         </p:nvSpPr>
@@ -30223,7 +31739,7 @@
             <a:r>
               <a:rPr lang="en-US" sz="900" dirty="0">
                 <a:solidFill>
-                  <a:srgbClr val="FFFFFF"/>
+                  <a:srgbClr val="53565A"/>
                 </a:solidFill>
                 <a:latin typeface="Calibri" pitchFamily="34" charset="0"/>
                 <a:ea typeface="Calibri" pitchFamily="34" charset="-122"/>
@@ -30232,6 +31748,189 @@
               <a:t>34</a:t>
             </a:r>
             <a:endParaRPr lang="en-US" sz="900" dirty="0"/>
+          </a:p>
+        </p:txBody>
+      </p:sp>
+      <p:graphicFrame>
+        <p:nvGraphicFramePr>
+          <p:cNvPr id="7" name="Chart 0" descr=""/>
+          <p:cNvGraphicFramePr/>
+          <p:nvPr/>
+        </p:nvGraphicFramePr>
+        <p:xfrm>
+          <a:off x="502006" y="2011680"/>
+          <a:ext cx="11188598" cy="3063240"/>
+        </p:xfrm>
+        <a:graphic xmlns:a="http://schemas.openxmlformats.org/drawingml/2006/main">
+          <a:graphicData uri="http://schemas.openxmlformats.org/drawingml/2006/chart">
+            <c:chart xmlns:c="http://schemas.openxmlformats.org/drawingml/2006/chart" r:id="rId1"/>
+          </a:graphicData>
+        </a:graphic>
+      </p:graphicFrame>
+      <p:sp>
+        <p:nvSpPr>
+          <p:cNvPr id="8" name="Shape 5"/>
+          <p:cNvSpPr/>
+          <p:nvPr/>
+        </p:nvSpPr>
+        <p:spPr>
+          <a:xfrm>
+            <a:off x="502006" y="5202936"/>
+            <a:ext cx="11188598" cy="0"/>
+          </a:xfrm>
+          <a:prstGeom prst="line">
+            <a:avLst/>
+          </a:prstGeom>
+          <a:noFill/>
+          <a:ln w="9525">
+            <a:solidFill>
+              <a:srgbClr val="D0D0CE"/>
+            </a:solidFill>
+            <a:prstDash val="solid"/>
+          </a:ln>
+        </p:spPr>
+      </p:sp>
+      <p:sp>
+        <p:nvSpPr>
+          <p:cNvPr id="9" name="Text 6"/>
+          <p:cNvSpPr txBox="1"/>
+          <p:nvPr/>
+        </p:nvSpPr>
+        <p:spPr>
+          <a:xfrm>
+            <a:off x="502006" y="5276088"/>
+            <a:ext cx="11188598" cy="886968"/>
+          </a:xfrm>
+          <a:prstGeom prst="rect">
+            <a:avLst/>
+          </a:prstGeom>
+          <a:noFill/>
+          <a:ln/>
+        </p:spPr>
+        <p:txBody>
+          <a:bodyPr wrap="square" lIns="0" tIns="0" rIns="0" bIns="0" rtlCol="0" anchor="t"/>
+          <a:lstStyle/>
+          <a:p>
+            <a:pPr algn="l" indent="0" marL="0">
+              <a:lnSpc>
+                <a:spcPct val="118000"/>
+              </a:lnSpc>
+              <a:buNone/>
+            </a:pPr>
+            <a:r>
+              <a:rPr lang="en-US" sz="850" b="1" dirty="0">
+                <a:solidFill>
+                  <a:srgbClr val="53565A"/>
+                </a:solidFill>
+                <a:latin typeface="Calibri" pitchFamily="34" charset="0"/>
+                <a:ea typeface="Calibri" pitchFamily="34" charset="-122"/>
+                <a:cs typeface="Calibri" pitchFamily="34" charset="-120"/>
+              </a:rPr>
+              <a:t>Single select. Institution tier based on S9; 1 respondent who did not directly answer was classified as Large Insurance Carrier from their employer description elsewhere in the survey (Large is n=10 = 9 direct + 1 reclassified).  </a:t>
+            </a:r>
+            <a:pPr algn="l" indent="0" marL="0">
+              <a:lnSpc>
+                <a:spcPct val="118000"/>
+              </a:lnSpc>
+              <a:buNone/>
+            </a:pPr>
+            <a:r>
+              <a:rPr lang="en-US" sz="850" b="1" dirty="0">
+                <a:solidFill>
+                  <a:srgbClr val="53565A"/>
+                </a:solidFill>
+                <a:latin typeface="Calibri" pitchFamily="34" charset="0"/>
+                <a:ea typeface="Calibri" pitchFamily="34" charset="-122"/>
+                <a:cs typeface="Calibri" pitchFamily="34" charset="-120"/>
+              </a:rPr>
+              <a:t>Response options as fielded: </a:t>
+            </a:r>
+            <a:pPr algn="l" indent="0" marL="0">
+              <a:lnSpc>
+                <a:spcPct val="118000"/>
+              </a:lnSpc>
+              <a:buNone/>
+            </a:pPr>
+            <a:r>
+              <a:rPr lang="en-US" sz="850" i="1" dirty="0">
+                <a:solidFill>
+                  <a:srgbClr val="53565A"/>
+                </a:solidFill>
+                <a:latin typeface="Calibri" pitchFamily="34" charset="0"/>
+                <a:ea typeface="Calibri" pitchFamily="34" charset="-122"/>
+                <a:cs typeface="Calibri" pitchFamily="34" charset="-120"/>
+              </a:rPr>
+              <a:t>“Primarily investing to meet upcoming and draft regulatory requirements”</a:t>
+            </a:r>
+            <a:pPr algn="l" indent="0" marL="0">
+              <a:lnSpc>
+                <a:spcPct val="118000"/>
+              </a:lnSpc>
+              <a:buNone/>
+            </a:pPr>
+            <a:r>
+              <a:rPr lang="en-US" sz="850" dirty="0">
+                <a:solidFill>
+                  <a:srgbClr val="D0D0CE"/>
+                </a:solidFill>
+                <a:latin typeface="Calibri" pitchFamily="34" charset="0"/>
+                <a:ea typeface="Calibri" pitchFamily="34" charset="-122"/>
+                <a:cs typeface="Calibri" pitchFamily="34" charset="-120"/>
+              </a:rPr>
+              <a:t>  ·  </a:t>
+            </a:r>
+            <a:pPr algn="l" indent="0" marL="0">
+              <a:lnSpc>
+                <a:spcPct val="118000"/>
+              </a:lnSpc>
+              <a:buNone/>
+            </a:pPr>
+            <a:r>
+              <a:rPr lang="en-US" sz="850" i="1" dirty="0">
+                <a:solidFill>
+                  <a:srgbClr val="53565A"/>
+                </a:solidFill>
+                <a:latin typeface="Calibri" pitchFamily="34" charset="0"/>
+                <a:ea typeface="Calibri" pitchFamily="34" charset="-122"/>
+                <a:cs typeface="Calibri" pitchFamily="34" charset="-120"/>
+              </a:rPr>
+              <a:t>“Primarily investing to remediate existing compliance and control gaps”</a:t>
+            </a:r>
+            <a:pPr algn="l" indent="0" marL="0">
+              <a:lnSpc>
+                <a:spcPct val="118000"/>
+              </a:lnSpc>
+              <a:buNone/>
+            </a:pPr>
+            <a:r>
+              <a:rPr lang="en-US" sz="850" dirty="0">
+                <a:solidFill>
+                  <a:srgbClr val="D0D0CE"/>
+                </a:solidFill>
+                <a:latin typeface="Calibri" pitchFamily="34" charset="0"/>
+                <a:ea typeface="Calibri" pitchFamily="34" charset="-122"/>
+                <a:cs typeface="Calibri" pitchFamily="34" charset="-120"/>
+              </a:rPr>
+              <a:t>  ·  </a:t>
+            </a:r>
+            <a:pPr algn="l" indent="0" marL="0">
+              <a:lnSpc>
+                <a:spcPct val="118000"/>
+              </a:lnSpc>
+              <a:buNone/>
+            </a:pPr>
+            <a:r>
+              <a:rPr lang="en-US" sz="850" i="1" dirty="0">
+                <a:solidFill>
+                  <a:srgbClr val="53565A"/>
+                </a:solidFill>
+                <a:latin typeface="Calibri" pitchFamily="34" charset="0"/>
+                <a:ea typeface="Calibri" pitchFamily="34" charset="-122"/>
+                <a:cs typeface="Calibri" pitchFamily="34" charset="-120"/>
+              </a:rPr>
+              <a:t>“Regulatory requirements are not a primary driver of fraud-related investment”</a:t>
+            </a:r>
+            <a:endParaRPr lang="en-US" sz="850" dirty="0"/>
           </a:p>
         </p:txBody>
       </p:sp>
@@ -30300,7 +31999,7 @@
                 <a:ea typeface="Calibri" pitchFamily="34" charset="-122"/>
                 <a:cs typeface="Calibri" pitchFamily="34" charset="-120"/>
               </a:rPr>
-              <a:t>What Leaders Say, Unprompted</a:t>
+              <a:t>Regulatory Investment Focus — Banking, by Institution Tier</a:t>
             </a:r>
             <a:endParaRPr lang="en-US" sz="1900" dirty="0"/>
           </a:p>
@@ -30342,7 +32041,7 @@
                 <a:ea typeface="Calibri" pitchFamily="34" charset="-122"/>
                 <a:cs typeface="Calibri" pitchFamily="34" charset="-120"/>
               </a:rPr>
-              <a:t>Left to answer in their own words, leaders converge on the same trend.</a:t>
+              <a:t>Large Financial Institutions skew further toward remediation than Top 100 banks, who are closer to an even split.</a:t>
             </a:r>
             <a:endParaRPr lang="en-US" sz="1350" dirty="0"/>
           </a:p>
@@ -30407,7 +32106,7 @@
                 <a:ea typeface="IBM Plex Mono" pitchFamily="34" charset="-122"/>
                 <a:cs typeface="IBM Plex Mono" pitchFamily="34" charset="-120"/>
               </a:rPr>
-              <a:t>Q12  </a:t>
+              <a:t>Q10 / newS8  </a:t>
             </a:r>
             <a:pPr algn="l" indent="0" marL="0">
               <a:lnSpc>
@@ -30424,7 +32123,7 @@
                 <a:ea typeface="Calibri" pitchFamily="34" charset="-122"/>
                 <a:cs typeface="Calibri" pitchFamily="34" charset="-120"/>
               </a:rPr>
-              <a:t>“Looking ahead three years, what development do you believe will have the greatest impact on fraud risk management, and why? (open-ended)”</a:t>
+              <a:t>“Which statement best reflects how your organization is allocating fraud-related investment in response to regulatory and compliance requirements? (Banking only, by institution tier)”</a:t>
             </a:r>
             <a:endParaRPr lang="en-US" sz="1000" dirty="0"/>
           </a:p>
@@ -30464,6 +32163,1052 @@
                 <a:cs typeface="Calibri" pitchFamily="34" charset="-120"/>
               </a:rPr>
               <a:t>35</a:t>
+            </a:r>
+            <a:endParaRPr lang="en-US" sz="900" dirty="0"/>
+          </a:p>
+        </p:txBody>
+      </p:sp>
+      <p:graphicFrame>
+        <p:nvGraphicFramePr>
+          <p:cNvPr id="7" name="Chart 0" descr=""/>
+          <p:cNvGraphicFramePr/>
+          <p:nvPr/>
+        </p:nvGraphicFramePr>
+        <p:xfrm>
+          <a:off x="502006" y="2011680"/>
+          <a:ext cx="11188598" cy="3063240"/>
+        </p:xfrm>
+        <a:graphic xmlns:a="http://schemas.openxmlformats.org/drawingml/2006/main">
+          <a:graphicData uri="http://schemas.openxmlformats.org/drawingml/2006/chart">
+            <c:chart xmlns:c="http://schemas.openxmlformats.org/drawingml/2006/chart" r:id="rId1"/>
+          </a:graphicData>
+        </a:graphic>
+      </p:graphicFrame>
+      <p:sp>
+        <p:nvSpPr>
+          <p:cNvPr id="8" name="Shape 5"/>
+          <p:cNvSpPr/>
+          <p:nvPr/>
+        </p:nvSpPr>
+        <p:spPr>
+          <a:xfrm>
+            <a:off x="502006" y="5202936"/>
+            <a:ext cx="11188598" cy="0"/>
+          </a:xfrm>
+          <a:prstGeom prst="line">
+            <a:avLst/>
+          </a:prstGeom>
+          <a:noFill/>
+          <a:ln w="9525">
+            <a:solidFill>
+              <a:srgbClr val="D0D0CE"/>
+            </a:solidFill>
+            <a:prstDash val="solid"/>
+          </a:ln>
+        </p:spPr>
+      </p:sp>
+      <p:sp>
+        <p:nvSpPr>
+          <p:cNvPr id="9" name="Text 6"/>
+          <p:cNvSpPr txBox="1"/>
+          <p:nvPr/>
+        </p:nvSpPr>
+        <p:spPr>
+          <a:xfrm>
+            <a:off x="502006" y="5276088"/>
+            <a:ext cx="11188598" cy="886968"/>
+          </a:xfrm>
+          <a:prstGeom prst="rect">
+            <a:avLst/>
+          </a:prstGeom>
+          <a:noFill/>
+          <a:ln/>
+        </p:spPr>
+        <p:txBody>
+          <a:bodyPr wrap="square" lIns="0" tIns="0" rIns="0" bIns="0" rtlCol="0" anchor="t"/>
+          <a:lstStyle/>
+          <a:p>
+            <a:pPr algn="l" indent="0" marL="0">
+              <a:lnSpc>
+                <a:spcPct val="118000"/>
+              </a:lnSpc>
+              <a:buNone/>
+            </a:pPr>
+            <a:r>
+              <a:rPr lang="en-US" sz="850" b="1" dirty="0">
+                <a:solidFill>
+                  <a:srgbClr val="53565A"/>
+                </a:solidFill>
+                <a:latin typeface="Calibri" pitchFamily="34" charset="0"/>
+                <a:ea typeface="Calibri" pitchFamily="34" charset="-122"/>
+                <a:cs typeface="Calibri" pitchFamily="34" charset="-120"/>
+              </a:rPr>
+              <a:t>Single select. Institution tier based on newS8; 5 respondents who did not directly answer were classified as Top 100 from their employer description elsewhere in the survey (Top 100 is n=40 = 35 direct + 5 reclassified).  </a:t>
+            </a:r>
+            <a:pPr algn="l" indent="0" marL="0">
+              <a:lnSpc>
+                <a:spcPct val="118000"/>
+              </a:lnSpc>
+              <a:buNone/>
+            </a:pPr>
+            <a:r>
+              <a:rPr lang="en-US" sz="850" b="1" dirty="0">
+                <a:solidFill>
+                  <a:srgbClr val="53565A"/>
+                </a:solidFill>
+                <a:latin typeface="Calibri" pitchFamily="34" charset="0"/>
+                <a:ea typeface="Calibri" pitchFamily="34" charset="-122"/>
+                <a:cs typeface="Calibri" pitchFamily="34" charset="-120"/>
+              </a:rPr>
+              <a:t>Response options as fielded: </a:t>
+            </a:r>
+            <a:pPr algn="l" indent="0" marL="0">
+              <a:lnSpc>
+                <a:spcPct val="118000"/>
+              </a:lnSpc>
+              <a:buNone/>
+            </a:pPr>
+            <a:r>
+              <a:rPr lang="en-US" sz="850" i="1" dirty="0">
+                <a:solidFill>
+                  <a:srgbClr val="53565A"/>
+                </a:solidFill>
+                <a:latin typeface="Calibri" pitchFamily="34" charset="0"/>
+                <a:ea typeface="Calibri" pitchFamily="34" charset="-122"/>
+                <a:cs typeface="Calibri" pitchFamily="34" charset="-120"/>
+              </a:rPr>
+              <a:t>“Primarily investing to meet upcoming and draft regulatory requirements”</a:t>
+            </a:r>
+            <a:pPr algn="l" indent="0" marL="0">
+              <a:lnSpc>
+                <a:spcPct val="118000"/>
+              </a:lnSpc>
+              <a:buNone/>
+            </a:pPr>
+            <a:r>
+              <a:rPr lang="en-US" sz="850" dirty="0">
+                <a:solidFill>
+                  <a:srgbClr val="D0D0CE"/>
+                </a:solidFill>
+                <a:latin typeface="Calibri" pitchFamily="34" charset="0"/>
+                <a:ea typeface="Calibri" pitchFamily="34" charset="-122"/>
+                <a:cs typeface="Calibri" pitchFamily="34" charset="-120"/>
+              </a:rPr>
+              <a:t>  ·  </a:t>
+            </a:r>
+            <a:pPr algn="l" indent="0" marL="0">
+              <a:lnSpc>
+                <a:spcPct val="118000"/>
+              </a:lnSpc>
+              <a:buNone/>
+            </a:pPr>
+            <a:r>
+              <a:rPr lang="en-US" sz="850" i="1" dirty="0">
+                <a:solidFill>
+                  <a:srgbClr val="53565A"/>
+                </a:solidFill>
+                <a:latin typeface="Calibri" pitchFamily="34" charset="0"/>
+                <a:ea typeface="Calibri" pitchFamily="34" charset="-122"/>
+                <a:cs typeface="Calibri" pitchFamily="34" charset="-120"/>
+              </a:rPr>
+              <a:t>“Primarily investing to remediate existing compliance and control gaps”</a:t>
+            </a:r>
+            <a:pPr algn="l" indent="0" marL="0">
+              <a:lnSpc>
+                <a:spcPct val="118000"/>
+              </a:lnSpc>
+              <a:buNone/>
+            </a:pPr>
+            <a:r>
+              <a:rPr lang="en-US" sz="850" dirty="0">
+                <a:solidFill>
+                  <a:srgbClr val="D0D0CE"/>
+                </a:solidFill>
+                <a:latin typeface="Calibri" pitchFamily="34" charset="0"/>
+                <a:ea typeface="Calibri" pitchFamily="34" charset="-122"/>
+                <a:cs typeface="Calibri" pitchFamily="34" charset="-120"/>
+              </a:rPr>
+              <a:t>  ·  </a:t>
+            </a:r>
+            <a:pPr algn="l" indent="0" marL="0">
+              <a:lnSpc>
+                <a:spcPct val="118000"/>
+              </a:lnSpc>
+              <a:buNone/>
+            </a:pPr>
+            <a:r>
+              <a:rPr lang="en-US" sz="850" i="1" dirty="0">
+                <a:solidFill>
+                  <a:srgbClr val="53565A"/>
+                </a:solidFill>
+                <a:latin typeface="Calibri" pitchFamily="34" charset="0"/>
+                <a:ea typeface="Calibri" pitchFamily="34" charset="-122"/>
+                <a:cs typeface="Calibri" pitchFamily="34" charset="-120"/>
+              </a:rPr>
+              <a:t>“Regulatory requirements are not a primary driver of fraud-related investment”</a:t>
+            </a:r>
+            <a:endParaRPr lang="en-US" sz="850" dirty="0"/>
+          </a:p>
+        </p:txBody>
+      </p:sp>
+    </p:spTree>
+  </p:cSld>
+  <p:clrMapOvr>
+    <a:masterClrMapping/>
+  </p:clrMapOvr>
+</p:sld>
+</file>
+
+<file path=ppt/slides/slide37.xml><?xml version="1.0" encoding="utf-8"?>
+<p:sld xmlns:a="http://schemas.openxmlformats.org/drawingml/2006/main" xmlns:r="http://schemas.openxmlformats.org/officeDocument/2006/relationships" xmlns:p="http://schemas.openxmlformats.org/presentationml/2006/main">
+  <p:cSld name="Slide 37">
+    <p:bg>
+      <p:bgPr>
+        <a:solidFill>
+          <a:srgbClr val="FFFFFF"/>
+        </a:solidFill>
+      </p:bgPr>
+    </p:bg>
+    <p:spTree>
+      <p:nvGrpSpPr>
+        <p:cNvPr id="1" name=""/>
+        <p:cNvGrpSpPr/>
+        <p:nvPr/>
+      </p:nvGrpSpPr>
+      <p:grpSpPr>
+        <a:xfrm>
+          <a:off x="0" y="0"/>
+          <a:ext cx="0" cy="0"/>
+          <a:chOff x="0" y="0"/>
+          <a:chExt cx="0" cy="0"/>
+        </a:xfrm>
+      </p:grpSpPr>
+      <p:sp>
+        <p:nvSpPr>
+          <p:cNvPr id="2" name="Text 0"/>
+          <p:cNvSpPr txBox="1"/>
+          <p:nvPr/>
+        </p:nvSpPr>
+        <p:spPr>
+          <a:xfrm>
+            <a:off x="502006" y="256032"/>
+            <a:ext cx="11188598" cy="310896"/>
+          </a:xfrm>
+          <a:prstGeom prst="rect">
+            <a:avLst/>
+          </a:prstGeom>
+          <a:noFill/>
+          <a:ln/>
+        </p:spPr>
+        <p:txBody>
+          <a:bodyPr wrap="square" lIns="0" tIns="0" rIns="0" bIns="0" rtlCol="0" anchor="t"/>
+          <a:lstStyle/>
+          <a:p>
+            <a:pPr algn="l" indent="0" marL="0">
+              <a:buNone/>
+            </a:pPr>
+            <a:r>
+              <a:rPr lang="en-US" sz="1900" b="1" dirty="0">
+                <a:solidFill>
+                  <a:srgbClr val="000000"/>
+                </a:solidFill>
+                <a:latin typeface="Calibri" pitchFamily="34" charset="0"/>
+                <a:ea typeface="Calibri" pitchFamily="34" charset="-122"/>
+                <a:cs typeface="Calibri" pitchFamily="34" charset="-120"/>
+              </a:rPr>
+              <a:t>Upcoming Regulatory / Market Change With Greatest Expected Impact</a:t>
+            </a:r>
+            <a:endParaRPr lang="en-US" sz="1900" dirty="0"/>
+          </a:p>
+        </p:txBody>
+      </p:sp>
+      <p:sp>
+        <p:nvSpPr>
+          <p:cNvPr id="3" name="Text 1"/>
+          <p:cNvSpPr txBox="1"/>
+          <p:nvPr/>
+        </p:nvSpPr>
+        <p:spPr>
+          <a:xfrm>
+            <a:off x="502006" y="585216"/>
+            <a:ext cx="11188598" cy="713232"/>
+          </a:xfrm>
+          <a:prstGeom prst="rect">
+            <a:avLst/>
+          </a:prstGeom>
+          <a:noFill/>
+          <a:ln/>
+        </p:spPr>
+        <p:txBody>
+          <a:bodyPr wrap="square" lIns="0" tIns="0" rIns="0" bIns="0" rtlCol="0" anchor="t"/>
+          <a:lstStyle/>
+          <a:p>
+            <a:pPr algn="l" indent="0" marL="0">
+              <a:lnSpc>
+                <a:spcPct val="105000"/>
+              </a:lnSpc>
+              <a:buNone/>
+            </a:pPr>
+            <a:r>
+              <a:rPr lang="en-US" sz="1350" b="1" dirty="0">
+                <a:solidFill>
+                  <a:srgbClr val="046A38"/>
+                </a:solidFill>
+                <a:latin typeface="Calibri" pitchFamily="34" charset="0"/>
+                <a:ea typeface="Calibri" pitchFamily="34" charset="-122"/>
+                <a:cs typeface="Calibri" pitchFamily="34" charset="-120"/>
+              </a:rPr>
+              <a:t>Identity and authentication tops a close three-way race for the next big disruption.</a:t>
+            </a:r>
+            <a:endParaRPr lang="en-US" sz="1350" dirty="0"/>
+          </a:p>
+        </p:txBody>
+      </p:sp>
+      <p:sp>
+        <p:nvSpPr>
+          <p:cNvPr id="4" name="Shape 2"/>
+          <p:cNvSpPr/>
+          <p:nvPr/>
+        </p:nvSpPr>
+        <p:spPr>
+          <a:xfrm>
+            <a:off x="502006" y="1335024"/>
+            <a:ext cx="0" cy="512064"/>
+          </a:xfrm>
+          <a:prstGeom prst="line">
+            <a:avLst/>
+          </a:prstGeom>
+          <a:noFill/>
+          <a:ln w="25400">
+            <a:solidFill>
+              <a:srgbClr val="D0D0CE"/>
+            </a:solidFill>
+            <a:prstDash val="solid"/>
+          </a:ln>
+        </p:spPr>
+      </p:sp>
+      <p:sp>
+        <p:nvSpPr>
+          <p:cNvPr id="5" name="Text 3"/>
+          <p:cNvSpPr txBox="1"/>
+          <p:nvPr/>
+        </p:nvSpPr>
+        <p:spPr>
+          <a:xfrm>
+            <a:off x="648310" y="1335024"/>
+            <a:ext cx="11042294" cy="512064"/>
+          </a:xfrm>
+          <a:prstGeom prst="rect">
+            <a:avLst/>
+          </a:prstGeom>
+          <a:noFill/>
+          <a:ln/>
+        </p:spPr>
+        <p:txBody>
+          <a:bodyPr wrap="square" lIns="0" tIns="0" rIns="0" bIns="0" rtlCol="0" anchor="t"/>
+          <a:lstStyle/>
+          <a:p>
+            <a:pPr algn="l" indent="0" marL="0">
+              <a:lnSpc>
+                <a:spcPct val="106000"/>
+              </a:lnSpc>
+              <a:buNone/>
+            </a:pPr>
+            <a:r>
+              <a:rPr lang="en-US" sz="900" b="1" dirty="0">
+                <a:solidFill>
+                  <a:srgbClr val="046A38"/>
+                </a:solidFill>
+                <a:latin typeface="IBM Plex Mono" pitchFamily="34" charset="0"/>
+                <a:ea typeface="IBM Plex Mono" pitchFamily="34" charset="-122"/>
+                <a:cs typeface="IBM Plex Mono" pitchFamily="34" charset="-120"/>
+              </a:rPr>
+              <a:t>Q11  </a:t>
+            </a:r>
+            <a:pPr algn="l" indent="0" marL="0">
+              <a:lnSpc>
+                <a:spcPct val="106000"/>
+              </a:lnSpc>
+              <a:buNone/>
+            </a:pPr>
+            <a:r>
+              <a:rPr lang="en-US" sz="1000" i="1" dirty="0">
+                <a:solidFill>
+                  <a:srgbClr val="575757"/>
+                </a:solidFill>
+                <a:latin typeface="Calibri" pitchFamily="34" charset="0"/>
+                <a:ea typeface="Calibri" pitchFamily="34" charset="-122"/>
+                <a:cs typeface="Calibri" pitchFamily="34" charset="-120"/>
+              </a:rPr>
+              <a:t>“Which upcoming regulatory or market changes is expected to have the greatest impact on your fraud program?”</a:t>
+            </a:r>
+            <a:endParaRPr lang="en-US" sz="1000" dirty="0"/>
+          </a:p>
+        </p:txBody>
+      </p:sp>
+      <p:sp>
+        <p:nvSpPr>
+          <p:cNvPr id="6" name="Text 4"/>
+          <p:cNvSpPr txBox="1"/>
+          <p:nvPr/>
+        </p:nvSpPr>
+        <p:spPr>
+          <a:xfrm>
+            <a:off x="11346790" y="6537960"/>
+            <a:ext cx="343814" cy="182880"/>
+          </a:xfrm>
+          <a:prstGeom prst="rect">
+            <a:avLst/>
+          </a:prstGeom>
+          <a:noFill/>
+          <a:ln/>
+        </p:spPr>
+        <p:txBody>
+          <a:bodyPr wrap="square" rtlCol="0" anchor="ctr"/>
+          <a:lstStyle/>
+          <a:p>
+            <a:pPr algn="r" indent="0" marL="0">
+              <a:buNone/>
+            </a:pPr>
+            <a:r>
+              <a:rPr lang="en-US" sz="900" dirty="0">
+                <a:solidFill>
+                  <a:srgbClr val="53565A"/>
+                </a:solidFill>
+                <a:latin typeface="Calibri" pitchFamily="34" charset="0"/>
+                <a:ea typeface="Calibri" pitchFamily="34" charset="-122"/>
+                <a:cs typeface="Calibri" pitchFamily="34" charset="-120"/>
+              </a:rPr>
+              <a:t>36</a:t>
+            </a:r>
+            <a:endParaRPr lang="en-US" sz="900" dirty="0"/>
+          </a:p>
+        </p:txBody>
+      </p:sp>
+      <p:graphicFrame>
+        <p:nvGraphicFramePr>
+          <p:cNvPr id="7" name="Chart 0" descr=""/>
+          <p:cNvGraphicFramePr/>
+          <p:nvPr/>
+        </p:nvGraphicFramePr>
+        <p:xfrm>
+          <a:off x="502006" y="2011680"/>
+          <a:ext cx="11188598" cy="3063240"/>
+        </p:xfrm>
+        <a:graphic xmlns:a="http://schemas.openxmlformats.org/drawingml/2006/main">
+          <a:graphicData uri="http://schemas.openxmlformats.org/drawingml/2006/chart">
+            <c:chart xmlns:c="http://schemas.openxmlformats.org/drawingml/2006/chart" r:id="rId1"/>
+          </a:graphicData>
+        </a:graphic>
+      </p:graphicFrame>
+      <p:sp>
+        <p:nvSpPr>
+          <p:cNvPr id="8" name="Shape 5"/>
+          <p:cNvSpPr/>
+          <p:nvPr/>
+        </p:nvSpPr>
+        <p:spPr>
+          <a:xfrm>
+            <a:off x="502006" y="5202936"/>
+            <a:ext cx="11188598" cy="0"/>
+          </a:xfrm>
+          <a:prstGeom prst="line">
+            <a:avLst/>
+          </a:prstGeom>
+          <a:noFill/>
+          <a:ln w="9525">
+            <a:solidFill>
+              <a:srgbClr val="D0D0CE"/>
+            </a:solidFill>
+            <a:prstDash val="solid"/>
+          </a:ln>
+        </p:spPr>
+      </p:sp>
+      <p:sp>
+        <p:nvSpPr>
+          <p:cNvPr id="9" name="Text 6"/>
+          <p:cNvSpPr txBox="1"/>
+          <p:nvPr/>
+        </p:nvSpPr>
+        <p:spPr>
+          <a:xfrm>
+            <a:off x="502006" y="5276088"/>
+            <a:ext cx="11188598" cy="886968"/>
+          </a:xfrm>
+          <a:prstGeom prst="rect">
+            <a:avLst/>
+          </a:prstGeom>
+          <a:noFill/>
+          <a:ln/>
+        </p:spPr>
+        <p:txBody>
+          <a:bodyPr wrap="square" lIns="0" tIns="0" rIns="0" bIns="0" rtlCol="0" anchor="t"/>
+          <a:lstStyle/>
+          <a:p>
+            <a:pPr algn="l" indent="0" marL="0">
+              <a:lnSpc>
+                <a:spcPct val="118000"/>
+              </a:lnSpc>
+              <a:buNone/>
+            </a:pPr>
+            <a:r>
+              <a:rPr lang="en-US" sz="850" b="1" dirty="0">
+                <a:solidFill>
+                  <a:srgbClr val="53565A"/>
+                </a:solidFill>
+                <a:latin typeface="Calibri" pitchFamily="34" charset="0"/>
+                <a:ea typeface="Calibri" pitchFamily="34" charset="-122"/>
+                <a:cs typeface="Calibri" pitchFamily="34" charset="-120"/>
+              </a:rPr>
+              <a:t>Ranked top 3 — shown as % of respondents who placed the option anywhere in their top 3 (not mutually exclusive; bars don't sum to 100%).  </a:t>
+            </a:r>
+            <a:pPr algn="l" indent="0" marL="0">
+              <a:lnSpc>
+                <a:spcPct val="118000"/>
+              </a:lnSpc>
+              <a:buNone/>
+            </a:pPr>
+            <a:r>
+              <a:rPr lang="en-US" sz="850" b="1" dirty="0">
+                <a:solidFill>
+                  <a:srgbClr val="53565A"/>
+                </a:solidFill>
+                <a:latin typeface="Calibri" pitchFamily="34" charset="0"/>
+                <a:ea typeface="Calibri" pitchFamily="34" charset="-122"/>
+                <a:cs typeface="Calibri" pitchFamily="34" charset="-120"/>
+              </a:rPr>
+              <a:t>Response options as fielded: </a:t>
+            </a:r>
+            <a:pPr algn="l" indent="0" marL="0">
+              <a:lnSpc>
+                <a:spcPct val="118000"/>
+              </a:lnSpc>
+              <a:buNone/>
+            </a:pPr>
+            <a:r>
+              <a:rPr lang="en-US" sz="850" i="1" dirty="0">
+                <a:solidFill>
+                  <a:srgbClr val="53565A"/>
+                </a:solidFill>
+                <a:latin typeface="Calibri" pitchFamily="34" charset="0"/>
+                <a:ea typeface="Calibri" pitchFamily="34" charset="-122"/>
+                <a:cs typeface="Calibri" pitchFamily="34" charset="-120"/>
+              </a:rPr>
+              <a:t>“Payment innovation and adoption (e.g., real-time payments, stable coins, agentic payments)”</a:t>
+            </a:r>
+            <a:pPr algn="l" indent="0" marL="0">
+              <a:lnSpc>
+                <a:spcPct val="118000"/>
+              </a:lnSpc>
+              <a:buNone/>
+            </a:pPr>
+            <a:r>
+              <a:rPr lang="en-US" sz="850" dirty="0">
+                <a:solidFill>
+                  <a:srgbClr val="D0D0CE"/>
+                </a:solidFill>
+                <a:latin typeface="Calibri" pitchFamily="34" charset="0"/>
+                <a:ea typeface="Calibri" pitchFamily="34" charset="-122"/>
+                <a:cs typeface="Calibri" pitchFamily="34" charset="-120"/>
+              </a:rPr>
+              <a:t>  ·  </a:t>
+            </a:r>
+            <a:pPr algn="l" indent="0" marL="0">
+              <a:lnSpc>
+                <a:spcPct val="118000"/>
+              </a:lnSpc>
+              <a:buNone/>
+            </a:pPr>
+            <a:r>
+              <a:rPr lang="en-US" sz="850" i="1" dirty="0">
+                <a:solidFill>
+                  <a:srgbClr val="53565A"/>
+                </a:solidFill>
+                <a:latin typeface="Calibri" pitchFamily="34" charset="0"/>
+                <a:ea typeface="Calibri" pitchFamily="34" charset="-122"/>
+                <a:cs typeface="Calibri" pitchFamily="34" charset="-120"/>
+              </a:rPr>
+              <a:t>“Liability and reimbursement changes”</a:t>
+            </a:r>
+            <a:pPr algn="l" indent="0" marL="0">
+              <a:lnSpc>
+                <a:spcPct val="118000"/>
+              </a:lnSpc>
+              <a:buNone/>
+            </a:pPr>
+            <a:r>
+              <a:rPr lang="en-US" sz="850" dirty="0">
+                <a:solidFill>
+                  <a:srgbClr val="D0D0CE"/>
+                </a:solidFill>
+                <a:latin typeface="Calibri" pitchFamily="34" charset="0"/>
+                <a:ea typeface="Calibri" pitchFamily="34" charset="-122"/>
+                <a:cs typeface="Calibri" pitchFamily="34" charset="-120"/>
+              </a:rPr>
+              <a:t>  ·  </a:t>
+            </a:r>
+            <a:pPr algn="l" indent="0" marL="0">
+              <a:lnSpc>
+                <a:spcPct val="118000"/>
+              </a:lnSpc>
+              <a:buNone/>
+            </a:pPr>
+            <a:r>
+              <a:rPr lang="en-US" sz="850" i="1" dirty="0">
+                <a:solidFill>
+                  <a:srgbClr val="53565A"/>
+                </a:solidFill>
+                <a:latin typeface="Calibri" pitchFamily="34" charset="0"/>
+                <a:ea typeface="Calibri" pitchFamily="34" charset="-122"/>
+                <a:cs typeface="Calibri" pitchFamily="34" charset="-120"/>
+              </a:rPr>
+              <a:t>“Open Banking / Consumer-driven banking initiatives”</a:t>
+            </a:r>
+            <a:pPr algn="l" indent="0" marL="0">
+              <a:lnSpc>
+                <a:spcPct val="118000"/>
+              </a:lnSpc>
+              <a:buNone/>
+            </a:pPr>
+            <a:r>
+              <a:rPr lang="en-US" sz="850" dirty="0">
+                <a:solidFill>
+                  <a:srgbClr val="D0D0CE"/>
+                </a:solidFill>
+                <a:latin typeface="Calibri" pitchFamily="34" charset="0"/>
+                <a:ea typeface="Calibri" pitchFamily="34" charset="-122"/>
+                <a:cs typeface="Calibri" pitchFamily="34" charset="-120"/>
+              </a:rPr>
+              <a:t>  ·  </a:t>
+            </a:r>
+            <a:pPr algn="l" indent="0" marL="0">
+              <a:lnSpc>
+                <a:spcPct val="118000"/>
+              </a:lnSpc>
+              <a:buNone/>
+            </a:pPr>
+            <a:r>
+              <a:rPr lang="en-US" sz="850" i="1" dirty="0">
+                <a:solidFill>
+                  <a:srgbClr val="53565A"/>
+                </a:solidFill>
+                <a:latin typeface="Calibri" pitchFamily="34" charset="0"/>
+                <a:ea typeface="Calibri" pitchFamily="34" charset="-122"/>
+                <a:cs typeface="Calibri" pitchFamily="34" charset="-120"/>
+              </a:rPr>
+              <a:t>“AML related modernization initiatives”</a:t>
+            </a:r>
+            <a:pPr algn="l" indent="0" marL="0">
+              <a:lnSpc>
+                <a:spcPct val="118000"/>
+              </a:lnSpc>
+              <a:buNone/>
+            </a:pPr>
+            <a:r>
+              <a:rPr lang="en-US" sz="850" dirty="0">
+                <a:solidFill>
+                  <a:srgbClr val="D0D0CE"/>
+                </a:solidFill>
+                <a:latin typeface="Calibri" pitchFamily="34" charset="0"/>
+                <a:ea typeface="Calibri" pitchFamily="34" charset="-122"/>
+                <a:cs typeface="Calibri" pitchFamily="34" charset="-120"/>
+              </a:rPr>
+              <a:t>  ·  </a:t>
+            </a:r>
+            <a:pPr algn="l" indent="0" marL="0">
+              <a:lnSpc>
+                <a:spcPct val="118000"/>
+              </a:lnSpc>
+              <a:buNone/>
+            </a:pPr>
+            <a:r>
+              <a:rPr lang="en-US" sz="850" i="1" dirty="0">
+                <a:solidFill>
+                  <a:srgbClr val="53565A"/>
+                </a:solidFill>
+                <a:latin typeface="Calibri" pitchFamily="34" charset="0"/>
+                <a:ea typeface="Calibri" pitchFamily="34" charset="-122"/>
+                <a:cs typeface="Calibri" pitchFamily="34" charset="-120"/>
+              </a:rPr>
+              <a:t>“Privacy, data-sharing requirements, and AI governance requirements”</a:t>
+            </a:r>
+            <a:pPr algn="l" indent="0" marL="0">
+              <a:lnSpc>
+                <a:spcPct val="118000"/>
+              </a:lnSpc>
+              <a:buNone/>
+            </a:pPr>
+            <a:r>
+              <a:rPr lang="en-US" sz="850" dirty="0">
+                <a:solidFill>
+                  <a:srgbClr val="D0D0CE"/>
+                </a:solidFill>
+                <a:latin typeface="Calibri" pitchFamily="34" charset="0"/>
+                <a:ea typeface="Calibri" pitchFamily="34" charset="-122"/>
+                <a:cs typeface="Calibri" pitchFamily="34" charset="-120"/>
+              </a:rPr>
+              <a:t>  ·  </a:t>
+            </a:r>
+            <a:pPr algn="l" indent="0" marL="0">
+              <a:lnSpc>
+                <a:spcPct val="118000"/>
+              </a:lnSpc>
+              <a:buNone/>
+            </a:pPr>
+            <a:r>
+              <a:rPr lang="en-US" sz="850" i="1" dirty="0">
+                <a:solidFill>
+                  <a:srgbClr val="53565A"/>
+                </a:solidFill>
+                <a:latin typeface="Calibri" pitchFamily="34" charset="0"/>
+                <a:ea typeface="Calibri" pitchFamily="34" charset="-122"/>
+                <a:cs typeface="Calibri" pitchFamily="34" charset="-120"/>
+              </a:rPr>
+              <a:t>“Customer identity, authentication, and digital trust expectations”</a:t>
+            </a:r>
+            <a:endParaRPr lang="en-US" sz="850" dirty="0"/>
+          </a:p>
+        </p:txBody>
+      </p:sp>
+    </p:spTree>
+  </p:cSld>
+  <p:clrMapOvr>
+    <a:masterClrMapping/>
+  </p:clrMapOvr>
+</p:sld>
+</file>
+
+<file path=ppt/slides/slide38.xml><?xml version="1.0" encoding="utf-8"?>
+<p:sld xmlns:a="http://schemas.openxmlformats.org/drawingml/2006/main" xmlns:r="http://schemas.openxmlformats.org/officeDocument/2006/relationships" xmlns:p="http://schemas.openxmlformats.org/presentationml/2006/main">
+  <p:cSld name="Slide 38">
+    <p:bg>
+      <p:bgPr>
+        <a:solidFill>
+          <a:srgbClr val="86BC25"/>
+        </a:solidFill>
+      </p:bgPr>
+    </p:bg>
+    <p:spTree>
+      <p:nvGrpSpPr>
+        <p:cNvPr id="1" name=""/>
+        <p:cNvGrpSpPr/>
+        <p:nvPr/>
+      </p:nvGrpSpPr>
+      <p:grpSpPr>
+        <a:xfrm>
+          <a:off x="0" y="0"/>
+          <a:ext cx="0" cy="0"/>
+          <a:chOff x="0" y="0"/>
+          <a:chExt cx="0" cy="0"/>
+        </a:xfrm>
+      </p:grpSpPr>
+      <p:sp>
+        <p:nvSpPr>
+          <p:cNvPr id="2" name="Text 0"/>
+          <p:cNvSpPr txBox="1"/>
+          <p:nvPr/>
+        </p:nvSpPr>
+        <p:spPr>
+          <a:xfrm>
+            <a:off x="502920" y="1699870"/>
+            <a:ext cx="10415016" cy="1591970"/>
+          </a:xfrm>
+          <a:prstGeom prst="rect">
+            <a:avLst/>
+          </a:prstGeom>
+          <a:noFill/>
+          <a:ln/>
+        </p:spPr>
+        <p:txBody>
+          <a:bodyPr wrap="square" lIns="0" tIns="0" rIns="0" bIns="0" rtlCol="0" anchor="b"/>
+          <a:lstStyle/>
+          <a:p>
+            <a:pPr algn="l" indent="0" marL="0">
+              <a:buNone/>
+            </a:pPr>
+            <a:r>
+              <a:rPr lang="en-US" sz="3600" b="1" dirty="0">
+                <a:solidFill>
+                  <a:srgbClr val="FFFFFF"/>
+                </a:solidFill>
+                <a:latin typeface="Calibri" pitchFamily="34" charset="0"/>
+                <a:ea typeface="Calibri" pitchFamily="34" charset="-122"/>
+                <a:cs typeface="Calibri" pitchFamily="34" charset="-120"/>
+              </a:rPr>
+              <a:t>6. Looking Ahead Three Years</a:t>
+            </a:r>
+            <a:endParaRPr lang="en-US" sz="3600" dirty="0"/>
+          </a:p>
+        </p:txBody>
+      </p:sp>
+      <p:sp>
+        <p:nvSpPr>
+          <p:cNvPr id="3" name="Text 1"/>
+          <p:cNvSpPr txBox="1"/>
+          <p:nvPr/>
+        </p:nvSpPr>
+        <p:spPr>
+          <a:xfrm>
+            <a:off x="11346790" y="6537960"/>
+            <a:ext cx="343814" cy="182880"/>
+          </a:xfrm>
+          <a:prstGeom prst="rect">
+            <a:avLst/>
+          </a:prstGeom>
+          <a:noFill/>
+          <a:ln/>
+        </p:spPr>
+        <p:txBody>
+          <a:bodyPr wrap="square" rtlCol="0" anchor="ctr"/>
+          <a:lstStyle/>
+          <a:p>
+            <a:pPr algn="r" indent="0" marL="0">
+              <a:buNone/>
+            </a:pPr>
+            <a:r>
+              <a:rPr lang="en-US" sz="900" dirty="0">
+                <a:solidFill>
+                  <a:srgbClr val="FFFFFF"/>
+                </a:solidFill>
+                <a:latin typeface="Calibri" pitchFamily="34" charset="0"/>
+                <a:ea typeface="Calibri" pitchFamily="34" charset="-122"/>
+                <a:cs typeface="Calibri" pitchFamily="34" charset="-120"/>
+              </a:rPr>
+              <a:t>37</a:t>
+            </a:r>
+            <a:endParaRPr lang="en-US" sz="900" dirty="0"/>
+          </a:p>
+        </p:txBody>
+      </p:sp>
+    </p:spTree>
+  </p:cSld>
+  <p:clrMapOvr>
+    <a:masterClrMapping/>
+  </p:clrMapOvr>
+</p:sld>
+</file>
+
+<file path=ppt/slides/slide39.xml><?xml version="1.0" encoding="utf-8"?>
+<p:sld xmlns:a="http://schemas.openxmlformats.org/drawingml/2006/main" xmlns:r="http://schemas.openxmlformats.org/officeDocument/2006/relationships" xmlns:p="http://schemas.openxmlformats.org/presentationml/2006/main">
+  <p:cSld name="Slide 39">
+    <p:bg>
+      <p:bgPr>
+        <a:solidFill>
+          <a:srgbClr val="FFFFFF"/>
+        </a:solidFill>
+      </p:bgPr>
+    </p:bg>
+    <p:spTree>
+      <p:nvGrpSpPr>
+        <p:cNvPr id="1" name=""/>
+        <p:cNvGrpSpPr/>
+        <p:nvPr/>
+      </p:nvGrpSpPr>
+      <p:grpSpPr>
+        <a:xfrm>
+          <a:off x="0" y="0"/>
+          <a:ext cx="0" cy="0"/>
+          <a:chOff x="0" y="0"/>
+          <a:chExt cx="0" cy="0"/>
+        </a:xfrm>
+      </p:grpSpPr>
+      <p:sp>
+        <p:nvSpPr>
+          <p:cNvPr id="2" name="Text 0"/>
+          <p:cNvSpPr txBox="1"/>
+          <p:nvPr/>
+        </p:nvSpPr>
+        <p:spPr>
+          <a:xfrm>
+            <a:off x="502006" y="256032"/>
+            <a:ext cx="11188598" cy="310896"/>
+          </a:xfrm>
+          <a:prstGeom prst="rect">
+            <a:avLst/>
+          </a:prstGeom>
+          <a:noFill/>
+          <a:ln/>
+        </p:spPr>
+        <p:txBody>
+          <a:bodyPr wrap="square" lIns="0" tIns="0" rIns="0" bIns="0" rtlCol="0" anchor="t"/>
+          <a:lstStyle/>
+          <a:p>
+            <a:pPr algn="l" indent="0" marL="0">
+              <a:buNone/>
+            </a:pPr>
+            <a:r>
+              <a:rPr lang="en-US" sz="1900" b="1" dirty="0">
+                <a:solidFill>
+                  <a:srgbClr val="000000"/>
+                </a:solidFill>
+                <a:latin typeface="Calibri" pitchFamily="34" charset="0"/>
+                <a:ea typeface="Calibri" pitchFamily="34" charset="-122"/>
+                <a:cs typeface="Calibri" pitchFamily="34" charset="-120"/>
+              </a:rPr>
+              <a:t>What Leaders Say, Unprompted</a:t>
+            </a:r>
+            <a:endParaRPr lang="en-US" sz="1900" dirty="0"/>
+          </a:p>
+        </p:txBody>
+      </p:sp>
+      <p:sp>
+        <p:nvSpPr>
+          <p:cNvPr id="3" name="Text 1"/>
+          <p:cNvSpPr txBox="1"/>
+          <p:nvPr/>
+        </p:nvSpPr>
+        <p:spPr>
+          <a:xfrm>
+            <a:off x="502006" y="585216"/>
+            <a:ext cx="11188598" cy="713232"/>
+          </a:xfrm>
+          <a:prstGeom prst="rect">
+            <a:avLst/>
+          </a:prstGeom>
+          <a:noFill/>
+          <a:ln/>
+        </p:spPr>
+        <p:txBody>
+          <a:bodyPr wrap="square" lIns="0" tIns="0" rIns="0" bIns="0" rtlCol="0" anchor="t"/>
+          <a:lstStyle/>
+          <a:p>
+            <a:pPr algn="l" indent="0" marL="0">
+              <a:lnSpc>
+                <a:spcPct val="105000"/>
+              </a:lnSpc>
+              <a:buNone/>
+            </a:pPr>
+            <a:r>
+              <a:rPr lang="en-US" sz="1350" b="1" dirty="0">
+                <a:solidFill>
+                  <a:srgbClr val="046A38"/>
+                </a:solidFill>
+                <a:latin typeface="Calibri" pitchFamily="34" charset="0"/>
+                <a:ea typeface="Calibri" pitchFamily="34" charset="-122"/>
+                <a:cs typeface="Calibri" pitchFamily="34" charset="-120"/>
+              </a:rPr>
+              <a:t>Left to answer in their own words, leaders converge on the same trend.</a:t>
+            </a:r>
+            <a:endParaRPr lang="en-US" sz="1350" dirty="0"/>
+          </a:p>
+        </p:txBody>
+      </p:sp>
+      <p:sp>
+        <p:nvSpPr>
+          <p:cNvPr id="4" name="Shape 2"/>
+          <p:cNvSpPr/>
+          <p:nvPr/>
+        </p:nvSpPr>
+        <p:spPr>
+          <a:xfrm>
+            <a:off x="502006" y="1335024"/>
+            <a:ext cx="0" cy="512064"/>
+          </a:xfrm>
+          <a:prstGeom prst="line">
+            <a:avLst/>
+          </a:prstGeom>
+          <a:noFill/>
+          <a:ln w="25400">
+            <a:solidFill>
+              <a:srgbClr val="D0D0CE"/>
+            </a:solidFill>
+            <a:prstDash val="solid"/>
+          </a:ln>
+        </p:spPr>
+      </p:sp>
+      <p:sp>
+        <p:nvSpPr>
+          <p:cNvPr id="5" name="Text 3"/>
+          <p:cNvSpPr txBox="1"/>
+          <p:nvPr/>
+        </p:nvSpPr>
+        <p:spPr>
+          <a:xfrm>
+            <a:off x="648310" y="1335024"/>
+            <a:ext cx="11042294" cy="512064"/>
+          </a:xfrm>
+          <a:prstGeom prst="rect">
+            <a:avLst/>
+          </a:prstGeom>
+          <a:noFill/>
+          <a:ln/>
+        </p:spPr>
+        <p:txBody>
+          <a:bodyPr wrap="square" lIns="0" tIns="0" rIns="0" bIns="0" rtlCol="0" anchor="t"/>
+          <a:lstStyle/>
+          <a:p>
+            <a:pPr algn="l" indent="0" marL="0">
+              <a:lnSpc>
+                <a:spcPct val="106000"/>
+              </a:lnSpc>
+              <a:buNone/>
+            </a:pPr>
+            <a:r>
+              <a:rPr lang="en-US" sz="900" b="1" dirty="0">
+                <a:solidFill>
+                  <a:srgbClr val="046A38"/>
+                </a:solidFill>
+                <a:latin typeface="IBM Plex Mono" pitchFamily="34" charset="0"/>
+                <a:ea typeface="IBM Plex Mono" pitchFamily="34" charset="-122"/>
+                <a:cs typeface="IBM Plex Mono" pitchFamily="34" charset="-120"/>
+              </a:rPr>
+              <a:t>Q12  </a:t>
+            </a:r>
+            <a:pPr algn="l" indent="0" marL="0">
+              <a:lnSpc>
+                <a:spcPct val="106000"/>
+              </a:lnSpc>
+              <a:buNone/>
+            </a:pPr>
+            <a:r>
+              <a:rPr lang="en-US" sz="1000" i="1" dirty="0">
+                <a:solidFill>
+                  <a:srgbClr val="575757"/>
+                </a:solidFill>
+                <a:latin typeface="Calibri" pitchFamily="34" charset="0"/>
+                <a:ea typeface="Calibri" pitchFamily="34" charset="-122"/>
+                <a:cs typeface="Calibri" pitchFamily="34" charset="-120"/>
+              </a:rPr>
+              <a:t>“Looking ahead three years, what development do you believe will have the greatest impact on fraud risk management, and why? (open-ended)”</a:t>
+            </a:r>
+            <a:endParaRPr lang="en-US" sz="1000" dirty="0"/>
+          </a:p>
+        </p:txBody>
+      </p:sp>
+      <p:sp>
+        <p:nvSpPr>
+          <p:cNvPr id="6" name="Text 4"/>
+          <p:cNvSpPr txBox="1"/>
+          <p:nvPr/>
+        </p:nvSpPr>
+        <p:spPr>
+          <a:xfrm>
+            <a:off x="11346790" y="6537960"/>
+            <a:ext cx="343814" cy="182880"/>
+          </a:xfrm>
+          <a:prstGeom prst="rect">
+            <a:avLst/>
+          </a:prstGeom>
+          <a:noFill/>
+          <a:ln/>
+        </p:spPr>
+        <p:txBody>
+          <a:bodyPr wrap="square" rtlCol="0" anchor="ctr"/>
+          <a:lstStyle/>
+          <a:p>
+            <a:pPr algn="r" indent="0" marL="0">
+              <a:buNone/>
+            </a:pPr>
+            <a:r>
+              <a:rPr lang="en-US" sz="900" dirty="0">
+                <a:solidFill>
+                  <a:srgbClr val="53565A"/>
+                </a:solidFill>
+                <a:latin typeface="Calibri" pitchFamily="34" charset="0"/>
+                <a:ea typeface="Calibri" pitchFamily="34" charset="-122"/>
+                <a:cs typeface="Calibri" pitchFamily="34" charset="-120"/>
+              </a:rPr>
+              <a:t>38</a:t>
             </a:r>
             <a:endParaRPr lang="en-US" sz="900" dirty="0"/>
           </a:p>
@@ -31001,305 +33746,6 @@
               <a:t>VP · Banking</a:t>
             </a:r>
             <a:endParaRPr lang="en-US" sz="900" dirty="0"/>
-          </a:p>
-        </p:txBody>
-      </p:sp>
-    </p:spTree>
-  </p:cSld>
-  <p:clrMapOvr>
-    <a:masterClrMapping/>
-  </p:clrMapOvr>
-</p:sld>
-</file>
-
-<file path=ppt/slides/slide37.xml><?xml version="1.0" encoding="utf-8"?>
-<p:sld xmlns:a="http://schemas.openxmlformats.org/drawingml/2006/main" xmlns:r="http://schemas.openxmlformats.org/officeDocument/2006/relationships" xmlns:p="http://schemas.openxmlformats.org/presentationml/2006/main">
-  <p:cSld name="Slide 37">
-    <p:bg>
-      <p:bgPr>
-        <a:solidFill>
-          <a:srgbClr val="050607"/>
-        </a:solidFill>
-      </p:bgPr>
-    </p:bg>
-    <p:spTree>
-      <p:nvGrpSpPr>
-        <p:cNvPr id="1" name=""/>
-        <p:cNvGrpSpPr/>
-        <p:nvPr/>
-      </p:nvGrpSpPr>
-      <p:grpSpPr>
-        <a:xfrm>
-          <a:off x="0" y="0"/>
-          <a:ext cx="0" cy="0"/>
-          <a:chOff x="0" y="0"/>
-          <a:chExt cx="0" cy="0"/>
-        </a:xfrm>
-      </p:grpSpPr>
-      <p:sp>
-        <p:nvSpPr>
-          <p:cNvPr id="2" name="Text 0"/>
-          <p:cNvSpPr txBox="1"/>
-          <p:nvPr/>
-        </p:nvSpPr>
-        <p:spPr>
-          <a:xfrm>
-            <a:off x="502006" y="457200"/>
-            <a:ext cx="1417320" cy="274320"/>
-          </a:xfrm>
-          <a:prstGeom prst="rect">
-            <a:avLst/>
-          </a:prstGeom>
-          <a:noFill/>
-          <a:ln/>
-        </p:spPr>
-        <p:txBody>
-          <a:bodyPr wrap="square" lIns="0" tIns="0" rIns="0" bIns="0" rtlCol="0" anchor="ctr"/>
-          <a:lstStyle/>
-          <a:p>
-            <a:pPr algn="l" indent="0" marL="0">
-              <a:buNone/>
-            </a:pPr>
-            <a:r>
-              <a:rPr lang="en-US" sz="1600" b="1" dirty="0">
-                <a:solidFill>
-                  <a:srgbClr val="FFFFFF"/>
-                </a:solidFill>
-                <a:latin typeface="Calibri" pitchFamily="34" charset="0"/>
-                <a:ea typeface="Calibri" pitchFamily="34" charset="-122"/>
-                <a:cs typeface="Calibri" pitchFamily="34" charset="-120"/>
-              </a:rPr>
-              <a:t>Deloitte</a:t>
-            </a:r>
-            <a:endParaRPr lang="en-US" sz="1600" dirty="0"/>
-          </a:p>
-        </p:txBody>
-      </p:sp>
-      <p:sp>
-        <p:nvSpPr>
-          <p:cNvPr id="3" name="Shape 1"/>
-          <p:cNvSpPr/>
-          <p:nvPr/>
-        </p:nvSpPr>
-        <p:spPr>
-          <a:xfrm>
-            <a:off x="1800454" y="598932"/>
-            <a:ext cx="82296" cy="82296"/>
-          </a:xfrm>
-          <a:prstGeom prst="ellipse">
-            <a:avLst/>
-          </a:prstGeom>
-          <a:solidFill>
-            <a:srgbClr val="86BC25"/>
-          </a:solidFill>
-          <a:ln/>
-        </p:spPr>
-      </p:sp>
-      <p:sp>
-        <p:nvSpPr>
-          <p:cNvPr id="4" name="Text 2"/>
-          <p:cNvSpPr txBox="1"/>
-          <p:nvPr/>
-        </p:nvSpPr>
-        <p:spPr>
-          <a:xfrm>
-            <a:off x="502006" y="4215384"/>
-            <a:ext cx="8531352" cy="2167128"/>
-          </a:xfrm>
-          <a:prstGeom prst="rect">
-            <a:avLst/>
-          </a:prstGeom>
-          <a:noFill/>
-          <a:ln/>
-        </p:spPr>
-        <p:txBody>
-          <a:bodyPr wrap="square" lIns="0" tIns="0" rIns="0" bIns="0" rtlCol="0" anchor="t"/>
-          <a:lstStyle/>
-          <a:p>
-            <a:pPr algn="l" indent="0" marL="0">
-              <a:lnSpc>
-                <a:spcPct val="120000"/>
-              </a:lnSpc>
-              <a:buNone/>
-            </a:pPr>
-            <a:r>
-              <a:rPr lang="en-US" sz="2800" b="1" dirty="0">
-                <a:solidFill>
-                  <a:srgbClr val="FFFFFF"/>
-                </a:solidFill>
-                <a:latin typeface="Calibri" pitchFamily="34" charset="0"/>
-                <a:ea typeface="Calibri" pitchFamily="34" charset="-122"/>
-                <a:cs typeface="Calibri" pitchFamily="34" charset="-120"/>
-              </a:rPr>
-              <a:t>Thank you
-</a:t>
-            </a:r>
-            <a:endParaRPr lang="en-US" sz="2800" dirty="0"/>
-          </a:p>
-          <a:p>
-            <a:pPr algn="l" indent="0" marL="0">
-              <a:lnSpc>
-                <a:spcPct val="120000"/>
-              </a:lnSpc>
-              <a:buNone/>
-            </a:pPr>
-            <a:r>
-              <a:rPr lang="en-US" sz="1600" b="1" dirty="0">
-                <a:solidFill>
-                  <a:srgbClr val="86BC25"/>
-                </a:solidFill>
-                <a:latin typeface="Calibri" pitchFamily="34" charset="0"/>
-                <a:ea typeface="Calibri" pitchFamily="34" charset="-122"/>
-                <a:cs typeface="Calibri" pitchFamily="34" charset="-120"/>
-              </a:rPr>
-              <a:t>[Presenter Name]
-</a:t>
-            </a:r>
-            <a:endParaRPr lang="en-US" sz="2800" dirty="0"/>
-          </a:p>
-          <a:p>
-            <a:pPr algn="l" indent="0" marL="0">
-              <a:lnSpc>
-                <a:spcPct val="120000"/>
-              </a:lnSpc>
-              <a:buNone/>
-            </a:pPr>
-            <a:r>
-              <a:rPr lang="en-US" sz="1300" dirty="0">
-                <a:solidFill>
-                  <a:srgbClr val="FFFFFF"/>
-                </a:solidFill>
-                <a:latin typeface="Calibri" pitchFamily="34" charset="0"/>
-                <a:ea typeface="Calibri" pitchFamily="34" charset="-122"/>
-                <a:cs typeface="Calibri" pitchFamily="34" charset="-120"/>
-              </a:rPr>
-              <a:t>[Title | Practice]
-</a:t>
-            </a:r>
-            <a:endParaRPr lang="en-US" sz="2800" dirty="0"/>
-          </a:p>
-          <a:p>
-            <a:pPr algn="l" indent="0" marL="0">
-              <a:lnSpc>
-                <a:spcPct val="120000"/>
-              </a:lnSpc>
-              <a:buNone/>
-            </a:pPr>
-            <a:r>
-              <a:rPr lang="en-US" sz="1300" dirty="0">
-                <a:solidFill>
-                  <a:srgbClr val="D0D0CE"/>
-                </a:solidFill>
-                <a:latin typeface="Calibri" pitchFamily="34" charset="0"/>
-                <a:ea typeface="Calibri" pitchFamily="34" charset="-122"/>
-                <a:cs typeface="Calibri" pitchFamily="34" charset="-120"/>
-              </a:rPr>
-              <a:t>[email@deloitte.com]</a:t>
-            </a:r>
-            <a:endParaRPr lang="en-US" sz="2800" dirty="0"/>
-          </a:p>
-        </p:txBody>
-      </p:sp>
-      <p:sp>
-        <p:nvSpPr>
-          <p:cNvPr id="5" name="Shape 3"/>
-          <p:cNvSpPr/>
-          <p:nvPr/>
-        </p:nvSpPr>
-        <p:spPr>
-          <a:xfrm>
-            <a:off x="9372600" y="4215384"/>
-            <a:ext cx="2322576" cy="1728216"/>
-          </a:xfrm>
-          <a:prstGeom prst="rect">
-            <a:avLst/>
-          </a:prstGeom>
-          <a:solidFill>
-            <a:srgbClr val="0B1C14"/>
-          </a:solidFill>
-          <a:ln w="9525">
-            <a:solidFill>
-              <a:srgbClr val="86BC25"/>
-            </a:solidFill>
-            <a:prstDash val="solid"/>
-          </a:ln>
-        </p:spPr>
-      </p:sp>
-      <p:sp>
-        <p:nvSpPr>
-          <p:cNvPr id="6" name="Text 4"/>
-          <p:cNvSpPr txBox="1"/>
-          <p:nvPr/>
-        </p:nvSpPr>
-        <p:spPr>
-          <a:xfrm>
-            <a:off x="9372600" y="4892040"/>
-            <a:ext cx="2322576" cy="365760"/>
-          </a:xfrm>
-          <a:prstGeom prst="rect">
-            <a:avLst/>
-          </a:prstGeom>
-          <a:noFill/>
-          <a:ln/>
-        </p:spPr>
-        <p:txBody>
-          <a:bodyPr wrap="square" rtlCol="0" anchor="ctr"/>
-          <a:lstStyle/>
-          <a:p>
-            <a:pPr algn="ctr" indent="0" marL="0">
-              <a:buNone/>
-            </a:pPr>
-            <a:r>
-              <a:rPr lang="en-US" sz="1600" b="1" dirty="0">
-                <a:solidFill>
-                  <a:srgbClr val="86BC25"/>
-                </a:solidFill>
-                <a:latin typeface="Calibri" pitchFamily="34" charset="0"/>
-                <a:ea typeface="Calibri" pitchFamily="34" charset="-122"/>
-                <a:cs typeface="Calibri" pitchFamily="34" charset="-120"/>
-              </a:rPr>
-              <a:t>D.FEND</a:t>
-            </a:r>
-            <a:endParaRPr lang="en-US" sz="1600" dirty="0"/>
-          </a:p>
-        </p:txBody>
-      </p:sp>
-      <p:sp>
-        <p:nvSpPr>
-          <p:cNvPr id="7" name="Text 5"/>
-          <p:cNvSpPr txBox="1"/>
-          <p:nvPr/>
-        </p:nvSpPr>
-        <p:spPr>
-          <a:xfrm>
-            <a:off x="9370771" y="6016752"/>
-            <a:ext cx="2322576" cy="365760"/>
-          </a:xfrm>
-          <a:prstGeom prst="rect">
-            <a:avLst/>
-          </a:prstGeom>
-          <a:noFill/>
-          <a:ln/>
-        </p:spPr>
-        <p:txBody>
-          <a:bodyPr wrap="square" rtlCol="0" anchor="ctr"/>
-          <a:lstStyle/>
-          <a:p>
-            <a:pPr algn="ctr" indent="0" marL="0">
-              <a:buNone/>
-            </a:pPr>
-            <a:r>
-              <a:rPr lang="en-US" sz="1000" i="1" dirty="0">
-                <a:solidFill>
-                  <a:srgbClr val="D0D0CE"/>
-                </a:solidFill>
-                <a:latin typeface="Calibri" pitchFamily="34" charset="0"/>
-                <a:ea typeface="Calibri" pitchFamily="34" charset="-122"/>
-                <a:cs typeface="Calibri" pitchFamily="34" charset="-120"/>
-              </a:rPr>
-              <a:t>Fin Crime Forum</a:t>
-            </a:r>
-            <a:endParaRPr lang="en-US" sz="1000" dirty="0"/>
           </a:p>
         </p:txBody>
       </p:sp>
@@ -31452,6 +33898,305 @@
               <a:t>3</a:t>
             </a:r>
             <a:endParaRPr lang="en-US" sz="900" dirty="0"/>
+          </a:p>
+        </p:txBody>
+      </p:sp>
+    </p:spTree>
+  </p:cSld>
+  <p:clrMapOvr>
+    <a:masterClrMapping/>
+  </p:clrMapOvr>
+</p:sld>
+</file>
+
+<file path=ppt/slides/slide40.xml><?xml version="1.0" encoding="utf-8"?>
+<p:sld xmlns:a="http://schemas.openxmlformats.org/drawingml/2006/main" xmlns:r="http://schemas.openxmlformats.org/officeDocument/2006/relationships" xmlns:p="http://schemas.openxmlformats.org/presentationml/2006/main">
+  <p:cSld name="Slide 40">
+    <p:bg>
+      <p:bgPr>
+        <a:solidFill>
+          <a:srgbClr val="050607"/>
+        </a:solidFill>
+      </p:bgPr>
+    </p:bg>
+    <p:spTree>
+      <p:nvGrpSpPr>
+        <p:cNvPr id="1" name=""/>
+        <p:cNvGrpSpPr/>
+        <p:nvPr/>
+      </p:nvGrpSpPr>
+      <p:grpSpPr>
+        <a:xfrm>
+          <a:off x="0" y="0"/>
+          <a:ext cx="0" cy="0"/>
+          <a:chOff x="0" y="0"/>
+          <a:chExt cx="0" cy="0"/>
+        </a:xfrm>
+      </p:grpSpPr>
+      <p:sp>
+        <p:nvSpPr>
+          <p:cNvPr id="2" name="Text 0"/>
+          <p:cNvSpPr txBox="1"/>
+          <p:nvPr/>
+        </p:nvSpPr>
+        <p:spPr>
+          <a:xfrm>
+            <a:off x="502006" y="457200"/>
+            <a:ext cx="1417320" cy="274320"/>
+          </a:xfrm>
+          <a:prstGeom prst="rect">
+            <a:avLst/>
+          </a:prstGeom>
+          <a:noFill/>
+          <a:ln/>
+        </p:spPr>
+        <p:txBody>
+          <a:bodyPr wrap="square" lIns="0" tIns="0" rIns="0" bIns="0" rtlCol="0" anchor="ctr"/>
+          <a:lstStyle/>
+          <a:p>
+            <a:pPr algn="l" indent="0" marL="0">
+              <a:buNone/>
+            </a:pPr>
+            <a:r>
+              <a:rPr lang="en-US" sz="1600" b="1" dirty="0">
+                <a:solidFill>
+                  <a:srgbClr val="FFFFFF"/>
+                </a:solidFill>
+                <a:latin typeface="Calibri" pitchFamily="34" charset="0"/>
+                <a:ea typeface="Calibri" pitchFamily="34" charset="-122"/>
+                <a:cs typeface="Calibri" pitchFamily="34" charset="-120"/>
+              </a:rPr>
+              <a:t>Deloitte</a:t>
+            </a:r>
+            <a:endParaRPr lang="en-US" sz="1600" dirty="0"/>
+          </a:p>
+        </p:txBody>
+      </p:sp>
+      <p:sp>
+        <p:nvSpPr>
+          <p:cNvPr id="3" name="Shape 1"/>
+          <p:cNvSpPr/>
+          <p:nvPr/>
+        </p:nvSpPr>
+        <p:spPr>
+          <a:xfrm>
+            <a:off x="1800454" y="598932"/>
+            <a:ext cx="82296" cy="82296"/>
+          </a:xfrm>
+          <a:prstGeom prst="ellipse">
+            <a:avLst/>
+          </a:prstGeom>
+          <a:solidFill>
+            <a:srgbClr val="86BC25"/>
+          </a:solidFill>
+          <a:ln/>
+        </p:spPr>
+      </p:sp>
+      <p:sp>
+        <p:nvSpPr>
+          <p:cNvPr id="4" name="Text 2"/>
+          <p:cNvSpPr txBox="1"/>
+          <p:nvPr/>
+        </p:nvSpPr>
+        <p:spPr>
+          <a:xfrm>
+            <a:off x="502006" y="4215384"/>
+            <a:ext cx="8531352" cy="2167128"/>
+          </a:xfrm>
+          <a:prstGeom prst="rect">
+            <a:avLst/>
+          </a:prstGeom>
+          <a:noFill/>
+          <a:ln/>
+        </p:spPr>
+        <p:txBody>
+          <a:bodyPr wrap="square" lIns="0" tIns="0" rIns="0" bIns="0" rtlCol="0" anchor="t"/>
+          <a:lstStyle/>
+          <a:p>
+            <a:pPr algn="l" indent="0" marL="0">
+              <a:lnSpc>
+                <a:spcPct val="120000"/>
+              </a:lnSpc>
+              <a:buNone/>
+            </a:pPr>
+            <a:r>
+              <a:rPr lang="en-US" sz="2800" b="1" dirty="0">
+                <a:solidFill>
+                  <a:srgbClr val="FFFFFF"/>
+                </a:solidFill>
+                <a:latin typeface="Calibri" pitchFamily="34" charset="0"/>
+                <a:ea typeface="Calibri" pitchFamily="34" charset="-122"/>
+                <a:cs typeface="Calibri" pitchFamily="34" charset="-120"/>
+              </a:rPr>
+              <a:t>Thank you
+</a:t>
+            </a:r>
+            <a:endParaRPr lang="en-US" sz="2800" dirty="0"/>
+          </a:p>
+          <a:p>
+            <a:pPr algn="l" indent="0" marL="0">
+              <a:lnSpc>
+                <a:spcPct val="120000"/>
+              </a:lnSpc>
+              <a:buNone/>
+            </a:pPr>
+            <a:r>
+              <a:rPr lang="en-US" sz="1600" b="1" dirty="0">
+                <a:solidFill>
+                  <a:srgbClr val="86BC25"/>
+                </a:solidFill>
+                <a:latin typeface="Calibri" pitchFamily="34" charset="0"/>
+                <a:ea typeface="Calibri" pitchFamily="34" charset="-122"/>
+                <a:cs typeface="Calibri" pitchFamily="34" charset="-120"/>
+              </a:rPr>
+              <a:t>[Presenter Name]
+</a:t>
+            </a:r>
+            <a:endParaRPr lang="en-US" sz="2800" dirty="0"/>
+          </a:p>
+          <a:p>
+            <a:pPr algn="l" indent="0" marL="0">
+              <a:lnSpc>
+                <a:spcPct val="120000"/>
+              </a:lnSpc>
+              <a:buNone/>
+            </a:pPr>
+            <a:r>
+              <a:rPr lang="en-US" sz="1300" dirty="0">
+                <a:solidFill>
+                  <a:srgbClr val="FFFFFF"/>
+                </a:solidFill>
+                <a:latin typeface="Calibri" pitchFamily="34" charset="0"/>
+                <a:ea typeface="Calibri" pitchFamily="34" charset="-122"/>
+                <a:cs typeface="Calibri" pitchFamily="34" charset="-120"/>
+              </a:rPr>
+              <a:t>[Title | Practice]
+</a:t>
+            </a:r>
+            <a:endParaRPr lang="en-US" sz="2800" dirty="0"/>
+          </a:p>
+          <a:p>
+            <a:pPr algn="l" indent="0" marL="0">
+              <a:lnSpc>
+                <a:spcPct val="120000"/>
+              </a:lnSpc>
+              <a:buNone/>
+            </a:pPr>
+            <a:r>
+              <a:rPr lang="en-US" sz="1300" dirty="0">
+                <a:solidFill>
+                  <a:srgbClr val="D0D0CE"/>
+                </a:solidFill>
+                <a:latin typeface="Calibri" pitchFamily="34" charset="0"/>
+                <a:ea typeface="Calibri" pitchFamily="34" charset="-122"/>
+                <a:cs typeface="Calibri" pitchFamily="34" charset="-120"/>
+              </a:rPr>
+              <a:t>[email@deloitte.com]</a:t>
+            </a:r>
+            <a:endParaRPr lang="en-US" sz="2800" dirty="0"/>
+          </a:p>
+        </p:txBody>
+      </p:sp>
+      <p:sp>
+        <p:nvSpPr>
+          <p:cNvPr id="5" name="Shape 3"/>
+          <p:cNvSpPr/>
+          <p:nvPr/>
+        </p:nvSpPr>
+        <p:spPr>
+          <a:xfrm>
+            <a:off x="9372600" y="4215384"/>
+            <a:ext cx="2322576" cy="1728216"/>
+          </a:xfrm>
+          <a:prstGeom prst="rect">
+            <a:avLst/>
+          </a:prstGeom>
+          <a:solidFill>
+            <a:srgbClr val="0B1C14"/>
+          </a:solidFill>
+          <a:ln w="9525">
+            <a:solidFill>
+              <a:srgbClr val="86BC25"/>
+            </a:solidFill>
+            <a:prstDash val="solid"/>
+          </a:ln>
+        </p:spPr>
+      </p:sp>
+      <p:sp>
+        <p:nvSpPr>
+          <p:cNvPr id="6" name="Text 4"/>
+          <p:cNvSpPr txBox="1"/>
+          <p:nvPr/>
+        </p:nvSpPr>
+        <p:spPr>
+          <a:xfrm>
+            <a:off x="9372600" y="4892040"/>
+            <a:ext cx="2322576" cy="365760"/>
+          </a:xfrm>
+          <a:prstGeom prst="rect">
+            <a:avLst/>
+          </a:prstGeom>
+          <a:noFill/>
+          <a:ln/>
+        </p:spPr>
+        <p:txBody>
+          <a:bodyPr wrap="square" rtlCol="0" anchor="ctr"/>
+          <a:lstStyle/>
+          <a:p>
+            <a:pPr algn="ctr" indent="0" marL="0">
+              <a:buNone/>
+            </a:pPr>
+            <a:r>
+              <a:rPr lang="en-US" sz="1600" b="1" dirty="0">
+                <a:solidFill>
+                  <a:srgbClr val="86BC25"/>
+                </a:solidFill>
+                <a:latin typeface="Calibri" pitchFamily="34" charset="0"/>
+                <a:ea typeface="Calibri" pitchFamily="34" charset="-122"/>
+                <a:cs typeface="Calibri" pitchFamily="34" charset="-120"/>
+              </a:rPr>
+              <a:t>D.FEND</a:t>
+            </a:r>
+            <a:endParaRPr lang="en-US" sz="1600" dirty="0"/>
+          </a:p>
+        </p:txBody>
+      </p:sp>
+      <p:sp>
+        <p:nvSpPr>
+          <p:cNvPr id="7" name="Text 5"/>
+          <p:cNvSpPr txBox="1"/>
+          <p:nvPr/>
+        </p:nvSpPr>
+        <p:spPr>
+          <a:xfrm>
+            <a:off x="9370771" y="6016752"/>
+            <a:ext cx="2322576" cy="365760"/>
+          </a:xfrm>
+          <a:prstGeom prst="rect">
+            <a:avLst/>
+          </a:prstGeom>
+          <a:noFill/>
+          <a:ln/>
+        </p:spPr>
+        <p:txBody>
+          <a:bodyPr wrap="square" rtlCol="0" anchor="ctr"/>
+          <a:lstStyle/>
+          <a:p>
+            <a:pPr algn="ctr" indent="0" marL="0">
+              <a:buNone/>
+            </a:pPr>
+            <a:r>
+              <a:rPr lang="en-US" sz="1000" i="1" dirty="0">
+                <a:solidFill>
+                  <a:srgbClr val="D0D0CE"/>
+                </a:solidFill>
+                <a:latin typeface="Calibri" pitchFamily="34" charset="0"/>
+                <a:ea typeface="Calibri" pitchFamily="34" charset="-122"/>
+                <a:cs typeface="Calibri" pitchFamily="34" charset="-120"/>
+              </a:rPr>
+              <a:t>Fin Crime Forum</a:t>
+            </a:r>
+            <a:endParaRPr lang="en-US" sz="1000" dirty="0"/>
           </a:p>
         </p:txBody>
       </p:sp>

</xml_diff>

<commit_message>
Add Q11 geographic breakdown slide
Adds a region-only stacked bar after the existing Q11 slide, decomposing
each of the six upcoming-change options into its regional share of the
100-respondent sample (top-3 ranked, not mutually exclusive).

Co-Authored-By: Claude Sonnet 5 <noreply@anthropic.com>
Claude-Session: https://claude.ai/code/session_01F6YKjZtdH33RrHLpCiLALg
</commit_message>
<xml_diff>
--- a/Fraud in 2026 - Full Results.pptx
+++ b/Fraud in 2026 - Full Results.pptx
@@ -45,9 +45,10 @@
     <p:sldId id="293" r:id="rId39"/>
     <p:sldId id="294" r:id="rId40"/>
     <p:sldId id="295" r:id="rId41"/>
+    <p:sldId id="296" r:id="rId42"/>
   </p:sldIdLst>
   <p:notesMasterIdLst>
-    <p:notesMasterId r:id="rId42"/>
+    <p:notesMasterId r:id="rId43"/>
   </p:notesMasterIdLst>
   <p:sldSz cx="12192000" cy="6858000"/>
   <p:notesSz cx="6858000" cy="12192000"/>
@@ -13492,6 +13493,675 @@
 </c:chartSpace>
 </file>
 
+<file path=ppt/charts/chart36.xml><?xml version="1.0" encoding="utf-8"?>
+<c:chartSpace xmlns:c="http://schemas.openxmlformats.org/drawingml/2006/chart" xmlns:a="http://schemas.openxmlformats.org/drawingml/2006/main" xmlns:r="http://schemas.openxmlformats.org/officeDocument/2006/relationships">
+  <c:date1904 val="0"/>
+  <c:roundedCorners val="1"/>
+  <c:chart>
+    <c:autoTitleDeleted val="1"/>
+    <c:plotArea>
+      <c:layout/>
+      <c:barChart>
+        <c:barDir val="bar"/>
+        <c:grouping val="stacked"/>
+        <c:varyColors val="0"/>
+        <c:ser>
+          <c:idx val="0"/>
+          <c:order val="0"/>
+          <c:tx>
+            <c:strRef>
+              <c:f>Sheet1!$B$1</c:f>
+              <c:strCache>
+                <c:ptCount val="1"/>
+                <c:pt idx="0">
+                  <c:v>United States (n=44)</c:v>
+                </c:pt>
+              </c:strCache>
+            </c:strRef>
+          </c:tx>
+          <c:spPr>
+            <a:solidFill>
+              <a:srgbClr val="86BC25"/>
+            </a:solidFill>
+            <a:effectLst/>
+          </c:spPr>
+          <c:invertIfNegative val="0"/>
+          <c:dLbls>
+            <c:numFmt formatCode="0&quot;%&quot;;-0&quot;%&quot;;;@" sourceLinked="0"/>
+            <c:txPr>
+              <a:bodyPr/>
+              <a:lstStyle/>
+              <a:p>
+                <a:pPr>
+                  <a:defRPr b="0" i="0" strike="noStrike" sz="650" u="none">
+                    <a:solidFill>
+                      <a:srgbClr val="FFFFFF"/>
+                    </a:solidFill>
+                    <a:latin typeface="Arial"/>
+                  </a:defRPr>
+                </a:pPr>
+              </a:p>
+            </c:txPr>
+            <c:dLblPos val="ctr"/>
+            <c:showLegendKey val="0"/>
+            <c:showVal val="1"/>
+            <c:showCatName val="0"/>
+            <c:showSerName val="0"/>
+            <c:showPercent val="0"/>
+            <c:showBubbleSize val="0"/>
+            <c:showLeaderLines val="0"/>
+          </c:dLbls>
+          <c:cat>
+            <c:multiLvlStrRef>
+              <c:f>Sheet1!$A$2:$A$7</c:f>
+              <c:multiLvlStrCache>
+                <c:ptCount val="6"/>
+                <c:lvl>
+                  <c:pt idx="0">
+                    <c:v>Customer identity, authentication &amp; digital trust (71%)</c:v>
+                  </c:pt>
+                  <c:pt idx="1">
+                    <c:v>Privacy, data-sharing &amp; AI governance requirements (66%)</c:v>
+                  </c:pt>
+                  <c:pt idx="2">
+                    <c:v>Payment innovation (RTP, stablecoins, agentic payments) (65%)</c:v>
+                  </c:pt>
+                  <c:pt idx="3">
+                    <c:v>Liability &amp; reimbursement changes (36%)</c:v>
+                  </c:pt>
+                  <c:pt idx="4">
+                    <c:v>AML modernization initiatives (33%)</c:v>
+                  </c:pt>
+                  <c:pt idx="5">
+                    <c:v>Open Banking / consumer-driven initiatives (29%)</c:v>
+                  </c:pt>
+                </c:lvl>
+              </c:multiLvlStrCache>
+            </c:multiLvlStrRef>
+          </c:cat>
+          <c:val>
+            <c:numRef>
+              <c:f>Sheet1!$B$2:$B$7</c:f>
+              <c:numCache>
+                <c:formatCode>General</c:formatCode>
+                <c:ptCount val="6"/>
+                <c:pt idx="0">
+                  <c:v>33</c:v>
+                </c:pt>
+                <c:pt idx="1">
+                  <c:v>32</c:v>
+                </c:pt>
+                <c:pt idx="2">
+                  <c:v>25</c:v>
+                </c:pt>
+                <c:pt idx="3">
+                  <c:v>18</c:v>
+                </c:pt>
+                <c:pt idx="4">
+                  <c:v>16</c:v>
+                </c:pt>
+                <c:pt idx="5">
+                  <c:v>8</c:v>
+                </c:pt>
+              </c:numCache>
+            </c:numRef>
+          </c:val>
+        </c:ser>
+        <c:ser>
+          <c:idx val="1"/>
+          <c:order val="1"/>
+          <c:tx>
+            <c:strRef>
+              <c:f>Sheet1!$C$1</c:f>
+              <c:strCache>
+                <c:ptCount val="1"/>
+                <c:pt idx="0">
+                  <c:v>Canada (n=30)</c:v>
+                </c:pt>
+              </c:strCache>
+            </c:strRef>
+          </c:tx>
+          <c:spPr>
+            <a:solidFill>
+              <a:srgbClr val="43B02A"/>
+            </a:solidFill>
+            <a:effectLst/>
+          </c:spPr>
+          <c:invertIfNegative val="0"/>
+          <c:dLbls>
+            <c:numFmt formatCode="0&quot;%&quot;;-0&quot;%&quot;;;@" sourceLinked="0"/>
+            <c:txPr>
+              <a:bodyPr/>
+              <a:lstStyle/>
+              <a:p>
+                <a:pPr>
+                  <a:defRPr b="0" i="0" strike="noStrike" sz="650" u="none">
+                    <a:solidFill>
+                      <a:srgbClr val="FFFFFF"/>
+                    </a:solidFill>
+                    <a:latin typeface="Arial"/>
+                  </a:defRPr>
+                </a:pPr>
+              </a:p>
+            </c:txPr>
+            <c:dLblPos val="ctr"/>
+            <c:showLegendKey val="0"/>
+            <c:showVal val="1"/>
+            <c:showCatName val="0"/>
+            <c:showSerName val="0"/>
+            <c:showPercent val="0"/>
+            <c:showBubbleSize val="0"/>
+            <c:showLeaderLines val="0"/>
+          </c:dLbls>
+          <c:cat>
+            <c:multiLvlStrRef>
+              <c:f>Sheet1!$A$2:$A$7</c:f>
+              <c:multiLvlStrCache>
+                <c:ptCount val="6"/>
+                <c:lvl>
+                  <c:pt idx="0">
+                    <c:v>Customer identity, authentication &amp; digital trust (71%)</c:v>
+                  </c:pt>
+                  <c:pt idx="1">
+                    <c:v>Privacy, data-sharing &amp; AI governance requirements (66%)</c:v>
+                  </c:pt>
+                  <c:pt idx="2">
+                    <c:v>Payment innovation (RTP, stablecoins, agentic payments) (65%)</c:v>
+                  </c:pt>
+                  <c:pt idx="3">
+                    <c:v>Liability &amp; reimbursement changes (36%)</c:v>
+                  </c:pt>
+                  <c:pt idx="4">
+                    <c:v>AML modernization initiatives (33%)</c:v>
+                  </c:pt>
+                  <c:pt idx="5">
+                    <c:v>Open Banking / consumer-driven initiatives (29%)</c:v>
+                  </c:pt>
+                </c:lvl>
+              </c:multiLvlStrCache>
+            </c:multiLvlStrRef>
+          </c:cat>
+          <c:val>
+            <c:numRef>
+              <c:f>Sheet1!$C$2:$C$7</c:f>
+              <c:numCache>
+                <c:formatCode>General</c:formatCode>
+                <c:ptCount val="6"/>
+                <c:pt idx="0">
+                  <c:v>21</c:v>
+                </c:pt>
+                <c:pt idx="1">
+                  <c:v>19</c:v>
+                </c:pt>
+                <c:pt idx="2">
+                  <c:v>22</c:v>
+                </c:pt>
+                <c:pt idx="3">
+                  <c:v>6</c:v>
+                </c:pt>
+                <c:pt idx="4">
+                  <c:v>8</c:v>
+                </c:pt>
+                <c:pt idx="5">
+                  <c:v>14</c:v>
+                </c:pt>
+              </c:numCache>
+            </c:numRef>
+          </c:val>
+        </c:ser>
+        <c:ser>
+          <c:idx val="2"/>
+          <c:order val="2"/>
+          <c:tx>
+            <c:strRef>
+              <c:f>Sheet1!$D$1</c:f>
+              <c:strCache>
+                <c:ptCount val="1"/>
+                <c:pt idx="0">
+                  <c:v>Europe — EU+UK (n=14)</c:v>
+                </c:pt>
+              </c:strCache>
+            </c:strRef>
+          </c:tx>
+          <c:spPr>
+            <a:solidFill>
+              <a:srgbClr val="046A38"/>
+            </a:solidFill>
+            <a:effectLst/>
+          </c:spPr>
+          <c:invertIfNegative val="0"/>
+          <c:dLbls>
+            <c:numFmt formatCode="0&quot;%&quot;;-0&quot;%&quot;;;@" sourceLinked="0"/>
+            <c:txPr>
+              <a:bodyPr/>
+              <a:lstStyle/>
+              <a:p>
+                <a:pPr>
+                  <a:defRPr b="0" i="0" strike="noStrike" sz="650" u="none">
+                    <a:solidFill>
+                      <a:srgbClr val="FFFFFF"/>
+                    </a:solidFill>
+                    <a:latin typeface="Arial"/>
+                  </a:defRPr>
+                </a:pPr>
+              </a:p>
+            </c:txPr>
+            <c:dLblPos val="ctr"/>
+            <c:showLegendKey val="0"/>
+            <c:showVal val="1"/>
+            <c:showCatName val="0"/>
+            <c:showSerName val="0"/>
+            <c:showPercent val="0"/>
+            <c:showBubbleSize val="0"/>
+            <c:showLeaderLines val="0"/>
+          </c:dLbls>
+          <c:cat>
+            <c:multiLvlStrRef>
+              <c:f>Sheet1!$A$2:$A$7</c:f>
+              <c:multiLvlStrCache>
+                <c:ptCount val="6"/>
+                <c:lvl>
+                  <c:pt idx="0">
+                    <c:v>Customer identity, authentication &amp; digital trust (71%)</c:v>
+                  </c:pt>
+                  <c:pt idx="1">
+                    <c:v>Privacy, data-sharing &amp; AI governance requirements (66%)</c:v>
+                  </c:pt>
+                  <c:pt idx="2">
+                    <c:v>Payment innovation (RTP, stablecoins, agentic payments) (65%)</c:v>
+                  </c:pt>
+                  <c:pt idx="3">
+                    <c:v>Liability &amp; reimbursement changes (36%)</c:v>
+                  </c:pt>
+                  <c:pt idx="4">
+                    <c:v>AML modernization initiatives (33%)</c:v>
+                  </c:pt>
+                  <c:pt idx="5">
+                    <c:v>Open Banking / consumer-driven initiatives (29%)</c:v>
+                  </c:pt>
+                </c:lvl>
+              </c:multiLvlStrCache>
+            </c:multiLvlStrRef>
+          </c:cat>
+          <c:val>
+            <c:numRef>
+              <c:f>Sheet1!$D$2:$D$7</c:f>
+              <c:numCache>
+                <c:formatCode>General</c:formatCode>
+                <c:ptCount val="6"/>
+                <c:pt idx="0">
+                  <c:v>8</c:v>
+                </c:pt>
+                <c:pt idx="1">
+                  <c:v>9</c:v>
+                </c:pt>
+                <c:pt idx="2">
+                  <c:v>9</c:v>
+                </c:pt>
+                <c:pt idx="3">
+                  <c:v>7</c:v>
+                </c:pt>
+                <c:pt idx="4">
+                  <c:v>5</c:v>
+                </c:pt>
+                <c:pt idx="5">
+                  <c:v>4</c:v>
+                </c:pt>
+              </c:numCache>
+            </c:numRef>
+          </c:val>
+        </c:ser>
+        <c:ser>
+          <c:idx val="3"/>
+          <c:order val="3"/>
+          <c:tx>
+            <c:strRef>
+              <c:f>Sheet1!$E$1</c:f>
+              <c:strCache>
+                <c:ptCount val="1"/>
+                <c:pt idx="0">
+                  <c:v>Australia (n=8)</c:v>
+                </c:pt>
+              </c:strCache>
+            </c:strRef>
+          </c:tx>
+          <c:spPr>
+            <a:solidFill>
+              <a:srgbClr val="0D8390"/>
+            </a:solidFill>
+            <a:effectLst/>
+          </c:spPr>
+          <c:invertIfNegative val="0"/>
+          <c:dLbls>
+            <c:numFmt formatCode="0&quot;%&quot;;-0&quot;%&quot;;;@" sourceLinked="0"/>
+            <c:txPr>
+              <a:bodyPr/>
+              <a:lstStyle/>
+              <a:p>
+                <a:pPr>
+                  <a:defRPr b="0" i="0" strike="noStrike" sz="650" u="none">
+                    <a:solidFill>
+                      <a:srgbClr val="FFFFFF"/>
+                    </a:solidFill>
+                    <a:latin typeface="Arial"/>
+                  </a:defRPr>
+                </a:pPr>
+              </a:p>
+            </c:txPr>
+            <c:dLblPos val="ctr"/>
+            <c:showLegendKey val="0"/>
+            <c:showVal val="1"/>
+            <c:showCatName val="0"/>
+            <c:showSerName val="0"/>
+            <c:showPercent val="0"/>
+            <c:showBubbleSize val="0"/>
+            <c:showLeaderLines val="0"/>
+          </c:dLbls>
+          <c:cat>
+            <c:multiLvlStrRef>
+              <c:f>Sheet1!$A$2:$A$7</c:f>
+              <c:multiLvlStrCache>
+                <c:ptCount val="6"/>
+                <c:lvl>
+                  <c:pt idx="0">
+                    <c:v>Customer identity, authentication &amp; digital trust (71%)</c:v>
+                  </c:pt>
+                  <c:pt idx="1">
+                    <c:v>Privacy, data-sharing &amp; AI governance requirements (66%)</c:v>
+                  </c:pt>
+                  <c:pt idx="2">
+                    <c:v>Payment innovation (RTP, stablecoins, agentic payments) (65%)</c:v>
+                  </c:pt>
+                  <c:pt idx="3">
+                    <c:v>Liability &amp; reimbursement changes (36%)</c:v>
+                  </c:pt>
+                  <c:pt idx="4">
+                    <c:v>AML modernization initiatives (33%)</c:v>
+                  </c:pt>
+                  <c:pt idx="5">
+                    <c:v>Open Banking / consumer-driven initiatives (29%)</c:v>
+                  </c:pt>
+                </c:lvl>
+              </c:multiLvlStrCache>
+            </c:multiLvlStrRef>
+          </c:cat>
+          <c:val>
+            <c:numRef>
+              <c:f>Sheet1!$E$2:$E$7</c:f>
+              <c:numCache>
+                <c:formatCode>General</c:formatCode>
+                <c:ptCount val="6"/>
+                <c:pt idx="0">
+                  <c:v>6</c:v>
+                </c:pt>
+                <c:pt idx="1">
+                  <c:v>4</c:v>
+                </c:pt>
+                <c:pt idx="2">
+                  <c:v>5</c:v>
+                </c:pt>
+                <c:pt idx="3">
+                  <c:v>3</c:v>
+                </c:pt>
+                <c:pt idx="4">
+                  <c:v>3</c:v>
+                </c:pt>
+                <c:pt idx="5">
+                  <c:v>3</c:v>
+                </c:pt>
+              </c:numCache>
+            </c:numRef>
+          </c:val>
+        </c:ser>
+        <c:ser>
+          <c:idx val="4"/>
+          <c:order val="4"/>
+          <c:tx>
+            <c:strRef>
+              <c:f>Sheet1!$F$1</c:f>
+              <c:strCache>
+                <c:ptCount val="1"/>
+                <c:pt idx="0">
+                  <c:v>Singapore (n=4)</c:v>
+                </c:pt>
+              </c:strCache>
+            </c:strRef>
+          </c:tx>
+          <c:spPr>
+            <a:solidFill>
+              <a:srgbClr val="53565A"/>
+            </a:solidFill>
+            <a:effectLst/>
+          </c:spPr>
+          <c:invertIfNegative val="0"/>
+          <c:dLbls>
+            <c:numFmt formatCode="0&quot;%&quot;;-0&quot;%&quot;;;@" sourceLinked="0"/>
+            <c:txPr>
+              <a:bodyPr/>
+              <a:lstStyle/>
+              <a:p>
+                <a:pPr>
+                  <a:defRPr b="0" i="0" strike="noStrike" sz="650" u="none">
+                    <a:solidFill>
+                      <a:srgbClr val="FFFFFF"/>
+                    </a:solidFill>
+                    <a:latin typeface="Arial"/>
+                  </a:defRPr>
+                </a:pPr>
+              </a:p>
+            </c:txPr>
+            <c:dLblPos val="ctr"/>
+            <c:showLegendKey val="0"/>
+            <c:showVal val="1"/>
+            <c:showCatName val="0"/>
+            <c:showSerName val="0"/>
+            <c:showPercent val="0"/>
+            <c:showBubbleSize val="0"/>
+            <c:showLeaderLines val="0"/>
+          </c:dLbls>
+          <c:cat>
+            <c:multiLvlStrRef>
+              <c:f>Sheet1!$A$2:$A$7</c:f>
+              <c:multiLvlStrCache>
+                <c:ptCount val="6"/>
+                <c:lvl>
+                  <c:pt idx="0">
+                    <c:v>Customer identity, authentication &amp; digital trust (71%)</c:v>
+                  </c:pt>
+                  <c:pt idx="1">
+                    <c:v>Privacy, data-sharing &amp; AI governance requirements (66%)</c:v>
+                  </c:pt>
+                  <c:pt idx="2">
+                    <c:v>Payment innovation (RTP, stablecoins, agentic payments) (65%)</c:v>
+                  </c:pt>
+                  <c:pt idx="3">
+                    <c:v>Liability &amp; reimbursement changes (36%)</c:v>
+                  </c:pt>
+                  <c:pt idx="4">
+                    <c:v>AML modernization initiatives (33%)</c:v>
+                  </c:pt>
+                  <c:pt idx="5">
+                    <c:v>Open Banking / consumer-driven initiatives (29%)</c:v>
+                  </c:pt>
+                </c:lvl>
+              </c:multiLvlStrCache>
+            </c:multiLvlStrRef>
+          </c:cat>
+          <c:val>
+            <c:numRef>
+              <c:f>Sheet1!$F$2:$F$7</c:f>
+              <c:numCache>
+                <c:formatCode>General</c:formatCode>
+                <c:ptCount val="6"/>
+                <c:pt idx="0">
+                  <c:v>3</c:v>
+                </c:pt>
+                <c:pt idx="1">
+                  <c:v>2</c:v>
+                </c:pt>
+                <c:pt idx="2">
+                  <c:v>4</c:v>
+                </c:pt>
+                <c:pt idx="3">
+                  <c:v>2</c:v>
+                </c:pt>
+                <c:pt idx="4">
+                  <c:v>1</c:v>
+                </c:pt>
+                <c:pt idx="5">
+                  <c:v>0</c:v>
+                </c:pt>
+              </c:numCache>
+            </c:numRef>
+          </c:val>
+        </c:ser>
+        <c:dLbls>
+          <c:numFmt formatCode="0&quot;%&quot;;-0&quot;%&quot;;;@" sourceLinked="0"/>
+          <c:txPr>
+            <a:bodyPr/>
+            <a:lstStyle/>
+            <a:p>
+              <a:pPr>
+                <a:defRPr b="0" i="0" strike="noStrike" sz="650" u="none">
+                  <a:solidFill>
+                    <a:srgbClr val="FFFFFF"/>
+                  </a:solidFill>
+                  <a:latin typeface="Arial"/>
+                </a:defRPr>
+              </a:pPr>
+            </a:p>
+          </c:txPr>
+          <c:dLblPos val="ctr"/>
+          <c:showLegendKey val="0"/>
+          <c:showVal val="1"/>
+          <c:showCatName val="0"/>
+          <c:showSerName val="0"/>
+          <c:showPercent val="0"/>
+          <c:showBubbleSize val="0"/>
+          <c:showLeaderLines val="0"/>
+        </c:dLbls>
+        <c:gapWidth val="40"/>
+        <c:overlap val="100"/>
+        <c:axId val="2094734554"/>
+        <c:axId val="2094734552"/>
+        <c:axId val="2094734556"/>
+      </c:barChart>
+      <c:catAx>
+        <c:axId val="2094734554"/>
+        <c:scaling>
+          <c:orientation val="minMax"/>
+        </c:scaling>
+        <c:delete val="0"/>
+        <c:axPos val="l"/>
+        <c:numFmt formatCode="General" sourceLinked="1"/>
+        <c:majorTickMark val="out"/>
+        <c:minorTickMark val="none"/>
+        <c:tickLblPos val="nextTo"/>
+        <c:spPr>
+          <a:ln w="12700" cap="flat">
+            <a:noFill/>
+            <a:prstDash val="solid"/>
+            <a:round/>
+          </a:ln>
+        </c:spPr>
+        <c:txPr>
+          <a:bodyPr/>
+          <a:lstStyle/>
+          <a:p>
+            <a:pPr>
+              <a:defRPr sz="800" b="0" i="0" u="none" strike="noStrike">
+                <a:solidFill>
+                  <a:srgbClr val="53565A"/>
+                </a:solidFill>
+                <a:latin typeface="Arial"/>
+              </a:defRPr>
+            </a:pPr>
+            <a:endParaRPr lang="en-US"/>
+          </a:p>
+        </c:txPr>
+        <c:crossAx val="2094734552"/>
+        <c:crosses val="autoZero"/>
+        <c:auto val="1"/>
+        <c:lblAlgn val="ctr"/>
+        <c:noMultiLvlLbl val="1"/>
+      </c:catAx>
+      <c:valAx>
+        <c:axId val="2094734552"/>
+        <c:scaling>
+          <c:orientation val="minMax"/>
+        </c:scaling>
+        <c:delete val="1"/>
+        <c:axPos val="b"/>
+        <c:numFmt formatCode="General" sourceLinked="0"/>
+        <c:majorTickMark val="out"/>
+        <c:minorTickMark val="none"/>
+        <c:tickLblPos val="low"/>
+        <c:spPr>
+          <a:ln w="12700" cap="flat">
+            <a:noFill/>
+            <a:prstDash val="solid"/>
+            <a:round/>
+          </a:ln>
+        </c:spPr>
+        <c:txPr>
+          <a:bodyPr/>
+          <a:lstStyle/>
+          <a:p>
+            <a:pPr>
+              <a:defRPr sz="1200" b="0" i="0" u="none" strike="noStrike">
+                <a:solidFill>
+                  <a:srgbClr val="000000"/>
+                </a:solidFill>
+                <a:latin typeface="Arial"/>
+              </a:defRPr>
+            </a:pPr>
+            <a:endParaRPr lang="en-US"/>
+          </a:p>
+        </c:txPr>
+        <c:crossAx val="2094734554"/>
+        <c:crosses val="autoZero"/>
+        <c:crossBetween val="between"/>
+      </c:valAx>
+      <c:spPr>
+        <a:solidFill>
+          <a:srgbClr val="FFFFFF"/>
+        </a:solidFill>
+        <a:ln>
+          <a:noFill/>
+        </a:ln>
+        <a:effectLst/>
+      </c:spPr>
+    </c:plotArea>
+    <c:legend>
+      <c:legendPos val="b"/>
+      <c:overlay val="0"/>
+      <c:txPr>
+        <a:bodyPr/>
+        <a:lstStyle/>
+        <a:p>
+          <a:pPr>
+            <a:defRPr sz="800">      </a:defRPr>
+          </a:pPr>
+          <a:endParaRPr lang="en-US"/>
+        </a:p>
+      </c:txPr>
+    </c:legend>
+    <c:plotVisOnly val="1"/>
+    <c:dispBlanksAs val="span"/>
+  </c:chart>
+  <c:spPr>
+    <a:noFill/>
+    <a:ln>
+      <a:noFill/>
+    </a:ln>
+    <a:effectLst/>
+  </c:spPr>
+  <c:externalData r:id="rId1">
+    <c:autoUpdate val="0"/>
+  </c:externalData>
+</c:chartSpace>
+</file>
+
 <file path=ppt/charts/chart4.xml><?xml version="1.0" encoding="utf-8"?>
 <c:chartSpace xmlns:c="http://schemas.openxmlformats.org/drawingml/2006/chart" xmlns:a="http://schemas.openxmlformats.org/drawingml/2006/main" xmlns:r="http://schemas.openxmlformats.org/officeDocument/2006/relationships">
   <c:date1904 val="0"/>
@@ -18936,6 +19606,94 @@
             <a:fld id="{F7021451-1387-4CA6-816F-3879F97B5CBC}" type="slidenum">
               <a:rPr lang="en-US"/>
               <a:t>40</a:t>
+            </a:fld>
+            <a:endParaRPr lang="en-US"/>
+          </a:p>
+        </p:txBody>
+      </p:sp>
+    </p:spTree>
+    <p:extLst>
+      <p:ext uri="{BB962C8B-B14F-4D97-AF65-F5344CB8AC3E}">
+        <p14:creationId xmlns:p14="http://schemas.microsoft.com/office/powerpoint/2010/main" val="1024086991"/>
+      </p:ext>
+    </p:extLst>
+  </p:cSld>
+  <p:clrMapOvr>
+    <a:masterClrMapping/>
+  </p:clrMapOvr>
+</p:notes>
+</file>
+
+<file path=ppt/notesSlides/notesSlide41.xml><?xml version="1.0" encoding="utf-8"?>
+<p:notes xmlns:a="http://schemas.openxmlformats.org/drawingml/2006/main" xmlns:r="http://schemas.openxmlformats.org/officeDocument/2006/relationships" xmlns:p="http://schemas.openxmlformats.org/presentationml/2006/main">
+  <p:cSld>
+    <p:spTree>
+      <p:nvGrpSpPr>
+        <p:cNvPr id="1" name=""/>
+        <p:cNvGrpSpPr/>
+        <p:nvPr/>
+      </p:nvGrpSpPr>
+      <p:grpSpPr>
+        <a:xfrm>
+          <a:off x="0" y="0"/>
+          <a:ext cx="0" cy="0"/>
+          <a:chOff x="0" y="0"/>
+          <a:chExt cx="0" cy="0"/>
+        </a:xfrm>
+      </p:grpSpPr>
+      <p:sp>
+        <p:nvSpPr>
+          <p:cNvPr id="2" name="Slide Image Placeholder 1"/>
+          <p:cNvSpPr>
+            <a:spLocks noGrp="1" noRot="1" noChangeAspect="1"/>
+          </p:cNvSpPr>
+          <p:nvPr>
+            <p:ph type="sldImg"/>
+          </p:nvPr>
+        </p:nvSpPr>
+        <p:spPr/>
+      </p:sp>
+      <p:sp>
+        <p:nvSpPr>
+          <p:cNvPr id="3" name="Notes Placeholder 2"/>
+          <p:cNvSpPr>
+            <a:spLocks noGrp="1"/>
+          </p:cNvSpPr>
+          <p:nvPr>
+            <p:ph type="body" idx="1"/>
+          </p:nvPr>
+        </p:nvSpPr>
+        <p:spPr/>
+        <p:txBody>
+          <a:bodyPr/>
+          <a:lstStyle/>
+          <a:p>
+            <a:r>
+              <a:rPr lang="en-US" dirty="0"/>
+              <a:t/>
+            </a:r>
+            <a:endParaRPr lang="en-US" dirty="0"/>
+          </a:p>
+        </p:txBody>
+      </p:sp>
+      <p:sp>
+        <p:nvSpPr>
+          <p:cNvPr id="4" name="Slide Number Placeholder 3"/>
+          <p:cNvSpPr>
+            <a:spLocks noGrp="1"/>
+          </p:cNvSpPr>
+          <p:nvPr>
+            <p:ph type="sldNum" sz="quarter" idx="10"/>
+          </p:nvPr>
+        </p:nvSpPr>
+        <p:spPr/>
+        <p:txBody>
+          <a:bodyPr/>
+          <a:lstStyle/>
+          <a:p>
+            <a:fld id="{F7021451-1387-4CA6-816F-3879F97B5CBC}" type="slidenum">
+              <a:rPr lang="en-US"/>
+              <a:t>41</a:t>
             </a:fld>
             <a:endParaRPr lang="en-US"/>
           </a:p>
@@ -32884,6 +33642,525 @@
     <p:bg>
       <p:bgPr>
         <a:solidFill>
+          <a:srgbClr val="FFFFFF"/>
+        </a:solidFill>
+      </p:bgPr>
+    </p:bg>
+    <p:spTree>
+      <p:nvGrpSpPr>
+        <p:cNvPr id="1" name=""/>
+        <p:cNvGrpSpPr/>
+        <p:nvPr/>
+      </p:nvGrpSpPr>
+      <p:grpSpPr>
+        <a:xfrm>
+          <a:off x="0" y="0"/>
+          <a:ext cx="0" cy="0"/>
+          <a:chOff x="0" y="0"/>
+          <a:chExt cx="0" cy="0"/>
+        </a:xfrm>
+      </p:grpSpPr>
+      <p:sp>
+        <p:nvSpPr>
+          <p:cNvPr id="2" name="Text 0"/>
+          <p:cNvSpPr txBox="1"/>
+          <p:nvPr/>
+        </p:nvSpPr>
+        <p:spPr>
+          <a:xfrm>
+            <a:off x="502006" y="256032"/>
+            <a:ext cx="11188598" cy="310896"/>
+          </a:xfrm>
+          <a:prstGeom prst="rect">
+            <a:avLst/>
+          </a:prstGeom>
+          <a:noFill/>
+          <a:ln/>
+        </p:spPr>
+        <p:txBody>
+          <a:bodyPr wrap="square" lIns="0" tIns="0" rIns="0" bIns="0" rtlCol="0" anchor="t"/>
+          <a:lstStyle/>
+          <a:p>
+            <a:pPr algn="l" indent="0" marL="0">
+              <a:buNone/>
+            </a:pPr>
+            <a:r>
+              <a:rPr lang="en-US" sz="1900" b="1" dirty="0">
+                <a:solidFill>
+                  <a:srgbClr val="000000"/>
+                </a:solidFill>
+                <a:latin typeface="Calibri" pitchFamily="34" charset="0"/>
+                <a:ea typeface="Calibri" pitchFamily="34" charset="-122"/>
+                <a:cs typeface="Calibri" pitchFamily="34" charset="-120"/>
+              </a:rPr>
+              <a:t>Upcoming Regulatory / Market Change — By Region</a:t>
+            </a:r>
+            <a:endParaRPr lang="en-US" sz="1900" dirty="0"/>
+          </a:p>
+        </p:txBody>
+      </p:sp>
+      <p:sp>
+        <p:nvSpPr>
+          <p:cNvPr id="3" name="Text 1"/>
+          <p:cNvSpPr txBox="1"/>
+          <p:nvPr/>
+        </p:nvSpPr>
+        <p:spPr>
+          <a:xfrm>
+            <a:off x="502006" y="585216"/>
+            <a:ext cx="11188598" cy="713232"/>
+          </a:xfrm>
+          <a:prstGeom prst="rect">
+            <a:avLst/>
+          </a:prstGeom>
+          <a:noFill/>
+          <a:ln/>
+        </p:spPr>
+        <p:txBody>
+          <a:bodyPr wrap="square" lIns="0" tIns="0" rIns="0" bIns="0" rtlCol="0" anchor="t"/>
+          <a:lstStyle/>
+          <a:p>
+            <a:pPr algn="l" indent="0" marL="0">
+              <a:lnSpc>
+                <a:spcPct val="105000"/>
+              </a:lnSpc>
+              <a:buNone/>
+            </a:pPr>
+            <a:r>
+              <a:rPr lang="en-US" sz="1350" b="1" dirty="0">
+                <a:solidFill>
+                  <a:srgbClr val="046A38"/>
+                </a:solidFill>
+                <a:latin typeface="Calibri" pitchFamily="34" charset="0"/>
+                <a:ea typeface="Calibri" pitchFamily="34" charset="-122"/>
+                <a:cs typeface="Calibri" pitchFamily="34" charset="-120"/>
+              </a:rPr>
+              <a:t>Identity and privacy concerns dominate across every market; Canada stands out for prioritizing Open Banking well above its peers.</a:t>
+            </a:r>
+            <a:endParaRPr lang="en-US" sz="1350" dirty="0"/>
+          </a:p>
+        </p:txBody>
+      </p:sp>
+      <p:sp>
+        <p:nvSpPr>
+          <p:cNvPr id="4" name="Shape 2"/>
+          <p:cNvSpPr/>
+          <p:nvPr/>
+        </p:nvSpPr>
+        <p:spPr>
+          <a:xfrm>
+            <a:off x="502006" y="1335024"/>
+            <a:ext cx="0" cy="512064"/>
+          </a:xfrm>
+          <a:prstGeom prst="line">
+            <a:avLst/>
+          </a:prstGeom>
+          <a:noFill/>
+          <a:ln w="25400">
+            <a:solidFill>
+              <a:srgbClr val="D0D0CE"/>
+            </a:solidFill>
+            <a:prstDash val="solid"/>
+          </a:ln>
+        </p:spPr>
+      </p:sp>
+      <p:sp>
+        <p:nvSpPr>
+          <p:cNvPr id="5" name="Text 3"/>
+          <p:cNvSpPr txBox="1"/>
+          <p:nvPr/>
+        </p:nvSpPr>
+        <p:spPr>
+          <a:xfrm>
+            <a:off x="648310" y="1335024"/>
+            <a:ext cx="11042294" cy="512064"/>
+          </a:xfrm>
+          <a:prstGeom prst="rect">
+            <a:avLst/>
+          </a:prstGeom>
+          <a:noFill/>
+          <a:ln/>
+        </p:spPr>
+        <p:txBody>
+          <a:bodyPr wrap="square" lIns="0" tIns="0" rIns="0" bIns="0" rtlCol="0" anchor="t"/>
+          <a:lstStyle/>
+          <a:p>
+            <a:pPr algn="l" indent="0" marL="0">
+              <a:lnSpc>
+                <a:spcPct val="106000"/>
+              </a:lnSpc>
+              <a:buNone/>
+            </a:pPr>
+            <a:r>
+              <a:rPr lang="en-US" sz="900" b="1" dirty="0">
+                <a:solidFill>
+                  <a:srgbClr val="046A38"/>
+                </a:solidFill>
+                <a:latin typeface="IBM Plex Mono" pitchFamily="34" charset="0"/>
+                <a:ea typeface="IBM Plex Mono" pitchFamily="34" charset="-122"/>
+                <a:cs typeface="IBM Plex Mono" pitchFamily="34" charset="-120"/>
+              </a:rPr>
+              <a:t>Q11  </a:t>
+            </a:r>
+            <a:pPr algn="l" indent="0" marL="0">
+              <a:lnSpc>
+                <a:spcPct val="106000"/>
+              </a:lnSpc>
+              <a:buNone/>
+            </a:pPr>
+            <a:r>
+              <a:rPr lang="en-US" sz="1000" i="1" dirty="0">
+                <a:solidFill>
+                  <a:srgbClr val="575757"/>
+                </a:solidFill>
+                <a:latin typeface="Calibri" pitchFamily="34" charset="0"/>
+                <a:ea typeface="Calibri" pitchFamily="34" charset="-122"/>
+                <a:cs typeface="Calibri" pitchFamily="34" charset="-120"/>
+              </a:rPr>
+              <a:t>“Which upcoming regulatory or market changes is expected to have the greatest impact on your fraud program? (by region, all respondents)”</a:t>
+            </a:r>
+            <a:endParaRPr lang="en-US" sz="1000" dirty="0"/>
+          </a:p>
+        </p:txBody>
+      </p:sp>
+      <p:sp>
+        <p:nvSpPr>
+          <p:cNvPr id="6" name="Text 4"/>
+          <p:cNvSpPr txBox="1"/>
+          <p:nvPr/>
+        </p:nvSpPr>
+        <p:spPr>
+          <a:xfrm>
+            <a:off x="11346790" y="6537960"/>
+            <a:ext cx="343814" cy="182880"/>
+          </a:xfrm>
+          <a:prstGeom prst="rect">
+            <a:avLst/>
+          </a:prstGeom>
+          <a:noFill/>
+          <a:ln/>
+        </p:spPr>
+        <p:txBody>
+          <a:bodyPr wrap="square" rtlCol="0" anchor="ctr"/>
+          <a:lstStyle/>
+          <a:p>
+            <a:pPr algn="r" indent="0" marL="0">
+              <a:buNone/>
+            </a:pPr>
+            <a:r>
+              <a:rPr lang="en-US" sz="900" dirty="0">
+                <a:solidFill>
+                  <a:srgbClr val="53565A"/>
+                </a:solidFill>
+                <a:latin typeface="Calibri" pitchFamily="34" charset="0"/>
+                <a:ea typeface="Calibri" pitchFamily="34" charset="-122"/>
+                <a:cs typeface="Calibri" pitchFamily="34" charset="-120"/>
+              </a:rPr>
+              <a:t>37</a:t>
+            </a:r>
+            <a:endParaRPr lang="en-US" sz="900" dirty="0"/>
+          </a:p>
+        </p:txBody>
+      </p:sp>
+      <p:graphicFrame>
+        <p:nvGraphicFramePr>
+          <p:cNvPr id="7" name="Chart 0" descr=""/>
+          <p:cNvGraphicFramePr/>
+          <p:nvPr/>
+        </p:nvGraphicFramePr>
+        <p:xfrm>
+          <a:off x="502006" y="2011680"/>
+          <a:ext cx="11188598" cy="3063240"/>
+        </p:xfrm>
+        <a:graphic xmlns:a="http://schemas.openxmlformats.org/drawingml/2006/main">
+          <a:graphicData uri="http://schemas.openxmlformats.org/drawingml/2006/chart">
+            <c:chart xmlns:c="http://schemas.openxmlformats.org/drawingml/2006/chart" r:id="rId1"/>
+          </a:graphicData>
+        </a:graphic>
+      </p:graphicFrame>
+      <p:sp>
+        <p:nvSpPr>
+          <p:cNvPr id="8" name="Shape 5"/>
+          <p:cNvSpPr/>
+          <p:nvPr/>
+        </p:nvSpPr>
+        <p:spPr>
+          <a:xfrm>
+            <a:off x="502006" y="5202936"/>
+            <a:ext cx="11188598" cy="0"/>
+          </a:xfrm>
+          <a:prstGeom prst="line">
+            <a:avLst/>
+          </a:prstGeom>
+          <a:noFill/>
+          <a:ln w="9525">
+            <a:solidFill>
+              <a:srgbClr val="D0D0CE"/>
+            </a:solidFill>
+            <a:prstDash val="solid"/>
+          </a:ln>
+        </p:spPr>
+      </p:sp>
+      <p:sp>
+        <p:nvSpPr>
+          <p:cNvPr id="9" name="Text 6"/>
+          <p:cNvSpPr txBox="1"/>
+          <p:nvPr/>
+        </p:nvSpPr>
+        <p:spPr>
+          <a:xfrm>
+            <a:off x="502006" y="5276088"/>
+            <a:ext cx="11188598" cy="886968"/>
+          </a:xfrm>
+          <a:prstGeom prst="rect">
+            <a:avLst/>
+          </a:prstGeom>
+          <a:noFill/>
+          <a:ln/>
+        </p:spPr>
+        <p:txBody>
+          <a:bodyPr wrap="square" lIns="0" tIns="0" rIns="0" bIns="0" rtlCol="0" anchor="t"/>
+          <a:lstStyle/>
+          <a:p>
+            <a:pPr algn="l" indent="0" marL="0">
+              <a:lnSpc>
+                <a:spcPct val="118000"/>
+              </a:lnSpc>
+              <a:buNone/>
+            </a:pPr>
+            <a:r>
+              <a:rPr lang="en-US" sz="850" b="1" dirty="0">
+                <a:solidFill>
+                  <a:srgbClr val="53565A"/>
+                </a:solidFill>
+                <a:latin typeface="Calibri" pitchFamily="34" charset="0"/>
+                <a:ea typeface="Calibri" pitchFamily="34" charset="-122"/>
+                <a:cs typeface="Calibri" pitchFamily="34" charset="-120"/>
+              </a:rPr>
+              <a:t>Ranked top 3 — % shown is each region's share of the full 100-respondent sample who placed the option anywhere in their top 3, so segments sum to the overall figure in each category label (bars don't sum to 100%). Australia (n=8) and Singapore (n=4) are thin samples, shown directionally.  </a:t>
+            </a:r>
+            <a:pPr algn="l" indent="0" marL="0">
+              <a:lnSpc>
+                <a:spcPct val="118000"/>
+              </a:lnSpc>
+              <a:buNone/>
+            </a:pPr>
+            <a:r>
+              <a:rPr lang="en-US" sz="850" b="1" dirty="0">
+                <a:solidFill>
+                  <a:srgbClr val="53565A"/>
+                </a:solidFill>
+                <a:latin typeface="Calibri" pitchFamily="34" charset="0"/>
+                <a:ea typeface="Calibri" pitchFamily="34" charset="-122"/>
+                <a:cs typeface="Calibri" pitchFamily="34" charset="-120"/>
+              </a:rPr>
+              <a:t>Response options as fielded: </a:t>
+            </a:r>
+            <a:pPr algn="l" indent="0" marL="0">
+              <a:lnSpc>
+                <a:spcPct val="118000"/>
+              </a:lnSpc>
+              <a:buNone/>
+            </a:pPr>
+            <a:r>
+              <a:rPr lang="en-US" sz="850" i="1" dirty="0">
+                <a:solidFill>
+                  <a:srgbClr val="53565A"/>
+                </a:solidFill>
+                <a:latin typeface="Calibri" pitchFamily="34" charset="0"/>
+                <a:ea typeface="Calibri" pitchFamily="34" charset="-122"/>
+                <a:cs typeface="Calibri" pitchFamily="34" charset="-120"/>
+              </a:rPr>
+              <a:t>“Payment innovation and adoption (e.g., real-time payments, stable coins, agentic payments)”</a:t>
+            </a:r>
+            <a:pPr algn="l" indent="0" marL="0">
+              <a:lnSpc>
+                <a:spcPct val="118000"/>
+              </a:lnSpc>
+              <a:buNone/>
+            </a:pPr>
+            <a:r>
+              <a:rPr lang="en-US" sz="850" dirty="0">
+                <a:solidFill>
+                  <a:srgbClr val="D0D0CE"/>
+                </a:solidFill>
+                <a:latin typeface="Calibri" pitchFamily="34" charset="0"/>
+                <a:ea typeface="Calibri" pitchFamily="34" charset="-122"/>
+                <a:cs typeface="Calibri" pitchFamily="34" charset="-120"/>
+              </a:rPr>
+              <a:t>  ·  </a:t>
+            </a:r>
+            <a:pPr algn="l" indent="0" marL="0">
+              <a:lnSpc>
+                <a:spcPct val="118000"/>
+              </a:lnSpc>
+              <a:buNone/>
+            </a:pPr>
+            <a:r>
+              <a:rPr lang="en-US" sz="850" i="1" dirty="0">
+                <a:solidFill>
+                  <a:srgbClr val="53565A"/>
+                </a:solidFill>
+                <a:latin typeface="Calibri" pitchFamily="34" charset="0"/>
+                <a:ea typeface="Calibri" pitchFamily="34" charset="-122"/>
+                <a:cs typeface="Calibri" pitchFamily="34" charset="-120"/>
+              </a:rPr>
+              <a:t>“Liability and reimbursement changes”</a:t>
+            </a:r>
+            <a:pPr algn="l" indent="0" marL="0">
+              <a:lnSpc>
+                <a:spcPct val="118000"/>
+              </a:lnSpc>
+              <a:buNone/>
+            </a:pPr>
+            <a:r>
+              <a:rPr lang="en-US" sz="850" dirty="0">
+                <a:solidFill>
+                  <a:srgbClr val="D0D0CE"/>
+                </a:solidFill>
+                <a:latin typeface="Calibri" pitchFamily="34" charset="0"/>
+                <a:ea typeface="Calibri" pitchFamily="34" charset="-122"/>
+                <a:cs typeface="Calibri" pitchFamily="34" charset="-120"/>
+              </a:rPr>
+              <a:t>  ·  </a:t>
+            </a:r>
+            <a:pPr algn="l" indent="0" marL="0">
+              <a:lnSpc>
+                <a:spcPct val="118000"/>
+              </a:lnSpc>
+              <a:buNone/>
+            </a:pPr>
+            <a:r>
+              <a:rPr lang="en-US" sz="850" i="1" dirty="0">
+                <a:solidFill>
+                  <a:srgbClr val="53565A"/>
+                </a:solidFill>
+                <a:latin typeface="Calibri" pitchFamily="34" charset="0"/>
+                <a:ea typeface="Calibri" pitchFamily="34" charset="-122"/>
+                <a:cs typeface="Calibri" pitchFamily="34" charset="-120"/>
+              </a:rPr>
+              <a:t>“Open Banking / Consumer-driven banking initiatives”</a:t>
+            </a:r>
+            <a:pPr algn="l" indent="0" marL="0">
+              <a:lnSpc>
+                <a:spcPct val="118000"/>
+              </a:lnSpc>
+              <a:buNone/>
+            </a:pPr>
+            <a:r>
+              <a:rPr lang="en-US" sz="850" dirty="0">
+                <a:solidFill>
+                  <a:srgbClr val="D0D0CE"/>
+                </a:solidFill>
+                <a:latin typeface="Calibri" pitchFamily="34" charset="0"/>
+                <a:ea typeface="Calibri" pitchFamily="34" charset="-122"/>
+                <a:cs typeface="Calibri" pitchFamily="34" charset="-120"/>
+              </a:rPr>
+              <a:t>  ·  </a:t>
+            </a:r>
+            <a:pPr algn="l" indent="0" marL="0">
+              <a:lnSpc>
+                <a:spcPct val="118000"/>
+              </a:lnSpc>
+              <a:buNone/>
+            </a:pPr>
+            <a:r>
+              <a:rPr lang="en-US" sz="850" i="1" dirty="0">
+                <a:solidFill>
+                  <a:srgbClr val="53565A"/>
+                </a:solidFill>
+                <a:latin typeface="Calibri" pitchFamily="34" charset="0"/>
+                <a:ea typeface="Calibri" pitchFamily="34" charset="-122"/>
+                <a:cs typeface="Calibri" pitchFamily="34" charset="-120"/>
+              </a:rPr>
+              <a:t>“AML related modernization initiatives”</a:t>
+            </a:r>
+            <a:pPr algn="l" indent="0" marL="0">
+              <a:lnSpc>
+                <a:spcPct val="118000"/>
+              </a:lnSpc>
+              <a:buNone/>
+            </a:pPr>
+            <a:r>
+              <a:rPr lang="en-US" sz="850" dirty="0">
+                <a:solidFill>
+                  <a:srgbClr val="D0D0CE"/>
+                </a:solidFill>
+                <a:latin typeface="Calibri" pitchFamily="34" charset="0"/>
+                <a:ea typeface="Calibri" pitchFamily="34" charset="-122"/>
+                <a:cs typeface="Calibri" pitchFamily="34" charset="-120"/>
+              </a:rPr>
+              <a:t>  ·  </a:t>
+            </a:r>
+            <a:pPr algn="l" indent="0" marL="0">
+              <a:lnSpc>
+                <a:spcPct val="118000"/>
+              </a:lnSpc>
+              <a:buNone/>
+            </a:pPr>
+            <a:r>
+              <a:rPr lang="en-US" sz="850" i="1" dirty="0">
+                <a:solidFill>
+                  <a:srgbClr val="53565A"/>
+                </a:solidFill>
+                <a:latin typeface="Calibri" pitchFamily="34" charset="0"/>
+                <a:ea typeface="Calibri" pitchFamily="34" charset="-122"/>
+                <a:cs typeface="Calibri" pitchFamily="34" charset="-120"/>
+              </a:rPr>
+              <a:t>“Privacy, data-sharing requirements, and AI governance requirements”</a:t>
+            </a:r>
+            <a:pPr algn="l" indent="0" marL="0">
+              <a:lnSpc>
+                <a:spcPct val="118000"/>
+              </a:lnSpc>
+              <a:buNone/>
+            </a:pPr>
+            <a:r>
+              <a:rPr lang="en-US" sz="850" dirty="0">
+                <a:solidFill>
+                  <a:srgbClr val="D0D0CE"/>
+                </a:solidFill>
+                <a:latin typeface="Calibri" pitchFamily="34" charset="0"/>
+                <a:ea typeface="Calibri" pitchFamily="34" charset="-122"/>
+                <a:cs typeface="Calibri" pitchFamily="34" charset="-120"/>
+              </a:rPr>
+              <a:t>  ·  </a:t>
+            </a:r>
+            <a:pPr algn="l" indent="0" marL="0">
+              <a:lnSpc>
+                <a:spcPct val="118000"/>
+              </a:lnSpc>
+              <a:buNone/>
+            </a:pPr>
+            <a:r>
+              <a:rPr lang="en-US" sz="850" i="1" dirty="0">
+                <a:solidFill>
+                  <a:srgbClr val="53565A"/>
+                </a:solidFill>
+                <a:latin typeface="Calibri" pitchFamily="34" charset="0"/>
+                <a:ea typeface="Calibri" pitchFamily="34" charset="-122"/>
+                <a:cs typeface="Calibri" pitchFamily="34" charset="-120"/>
+              </a:rPr>
+              <a:t>“Customer identity, authentication, and digital trust expectations”</a:t>
+            </a:r>
+            <a:endParaRPr lang="en-US" sz="850" dirty="0"/>
+          </a:p>
+        </p:txBody>
+      </p:sp>
+    </p:spTree>
+  </p:cSld>
+  <p:clrMapOvr>
+    <a:masterClrMapping/>
+  </p:clrMapOvr>
+</p:sld>
+</file>
+
+<file path=ppt/slides/slide39.xml><?xml version="1.0" encoding="utf-8"?>
+<p:sld xmlns:a="http://schemas.openxmlformats.org/drawingml/2006/main" xmlns:r="http://schemas.openxmlformats.org/officeDocument/2006/relationships" xmlns:p="http://schemas.openxmlformats.org/presentationml/2006/main">
+  <p:cSld name="Slide 39">
+    <p:bg>
+      <p:bgPr>
+        <a:solidFill>
           <a:srgbClr val="86BC25"/>
         </a:solidFill>
       </p:bgPr>
@@ -32974,776 +34251,7 @@
                 <a:ea typeface="Calibri" pitchFamily="34" charset="-122"/>
                 <a:cs typeface="Calibri" pitchFamily="34" charset="-120"/>
               </a:rPr>
-              <a:t>37</a:t>
-            </a:r>
-            <a:endParaRPr lang="en-US" sz="900" dirty="0"/>
-          </a:p>
-        </p:txBody>
-      </p:sp>
-    </p:spTree>
-  </p:cSld>
-  <p:clrMapOvr>
-    <a:masterClrMapping/>
-  </p:clrMapOvr>
-</p:sld>
-</file>
-
-<file path=ppt/slides/slide39.xml><?xml version="1.0" encoding="utf-8"?>
-<p:sld xmlns:a="http://schemas.openxmlformats.org/drawingml/2006/main" xmlns:r="http://schemas.openxmlformats.org/officeDocument/2006/relationships" xmlns:p="http://schemas.openxmlformats.org/presentationml/2006/main">
-  <p:cSld name="Slide 39">
-    <p:bg>
-      <p:bgPr>
-        <a:solidFill>
-          <a:srgbClr val="FFFFFF"/>
-        </a:solidFill>
-      </p:bgPr>
-    </p:bg>
-    <p:spTree>
-      <p:nvGrpSpPr>
-        <p:cNvPr id="1" name=""/>
-        <p:cNvGrpSpPr/>
-        <p:nvPr/>
-      </p:nvGrpSpPr>
-      <p:grpSpPr>
-        <a:xfrm>
-          <a:off x="0" y="0"/>
-          <a:ext cx="0" cy="0"/>
-          <a:chOff x="0" y="0"/>
-          <a:chExt cx="0" cy="0"/>
-        </a:xfrm>
-      </p:grpSpPr>
-      <p:sp>
-        <p:nvSpPr>
-          <p:cNvPr id="2" name="Text 0"/>
-          <p:cNvSpPr txBox="1"/>
-          <p:nvPr/>
-        </p:nvSpPr>
-        <p:spPr>
-          <a:xfrm>
-            <a:off x="502006" y="256032"/>
-            <a:ext cx="11188598" cy="310896"/>
-          </a:xfrm>
-          <a:prstGeom prst="rect">
-            <a:avLst/>
-          </a:prstGeom>
-          <a:noFill/>
-          <a:ln/>
-        </p:spPr>
-        <p:txBody>
-          <a:bodyPr wrap="square" lIns="0" tIns="0" rIns="0" bIns="0" rtlCol="0" anchor="t"/>
-          <a:lstStyle/>
-          <a:p>
-            <a:pPr algn="l" indent="0" marL="0">
-              <a:buNone/>
-            </a:pPr>
-            <a:r>
-              <a:rPr lang="en-US" sz="1900" b="1" dirty="0">
-                <a:solidFill>
-                  <a:srgbClr val="000000"/>
-                </a:solidFill>
-                <a:latin typeface="Calibri" pitchFamily="34" charset="0"/>
-                <a:ea typeface="Calibri" pitchFamily="34" charset="-122"/>
-                <a:cs typeface="Calibri" pitchFamily="34" charset="-120"/>
-              </a:rPr>
-              <a:t>What Leaders Say, Unprompted</a:t>
-            </a:r>
-            <a:endParaRPr lang="en-US" sz="1900" dirty="0"/>
-          </a:p>
-        </p:txBody>
-      </p:sp>
-      <p:sp>
-        <p:nvSpPr>
-          <p:cNvPr id="3" name="Text 1"/>
-          <p:cNvSpPr txBox="1"/>
-          <p:nvPr/>
-        </p:nvSpPr>
-        <p:spPr>
-          <a:xfrm>
-            <a:off x="502006" y="585216"/>
-            <a:ext cx="11188598" cy="713232"/>
-          </a:xfrm>
-          <a:prstGeom prst="rect">
-            <a:avLst/>
-          </a:prstGeom>
-          <a:noFill/>
-          <a:ln/>
-        </p:spPr>
-        <p:txBody>
-          <a:bodyPr wrap="square" lIns="0" tIns="0" rIns="0" bIns="0" rtlCol="0" anchor="t"/>
-          <a:lstStyle/>
-          <a:p>
-            <a:pPr algn="l" indent="0" marL="0">
-              <a:lnSpc>
-                <a:spcPct val="105000"/>
-              </a:lnSpc>
-              <a:buNone/>
-            </a:pPr>
-            <a:r>
-              <a:rPr lang="en-US" sz="1350" b="1" dirty="0">
-                <a:solidFill>
-                  <a:srgbClr val="046A38"/>
-                </a:solidFill>
-                <a:latin typeface="Calibri" pitchFamily="34" charset="0"/>
-                <a:ea typeface="Calibri" pitchFamily="34" charset="-122"/>
-                <a:cs typeface="Calibri" pitchFamily="34" charset="-120"/>
-              </a:rPr>
-              <a:t>Left to answer in their own words, leaders converge on the same trend.</a:t>
-            </a:r>
-            <a:endParaRPr lang="en-US" sz="1350" dirty="0"/>
-          </a:p>
-        </p:txBody>
-      </p:sp>
-      <p:sp>
-        <p:nvSpPr>
-          <p:cNvPr id="4" name="Shape 2"/>
-          <p:cNvSpPr/>
-          <p:nvPr/>
-        </p:nvSpPr>
-        <p:spPr>
-          <a:xfrm>
-            <a:off x="502006" y="1335024"/>
-            <a:ext cx="0" cy="512064"/>
-          </a:xfrm>
-          <a:prstGeom prst="line">
-            <a:avLst/>
-          </a:prstGeom>
-          <a:noFill/>
-          <a:ln w="25400">
-            <a:solidFill>
-              <a:srgbClr val="D0D0CE"/>
-            </a:solidFill>
-            <a:prstDash val="solid"/>
-          </a:ln>
-        </p:spPr>
-      </p:sp>
-      <p:sp>
-        <p:nvSpPr>
-          <p:cNvPr id="5" name="Text 3"/>
-          <p:cNvSpPr txBox="1"/>
-          <p:nvPr/>
-        </p:nvSpPr>
-        <p:spPr>
-          <a:xfrm>
-            <a:off x="648310" y="1335024"/>
-            <a:ext cx="11042294" cy="512064"/>
-          </a:xfrm>
-          <a:prstGeom prst="rect">
-            <a:avLst/>
-          </a:prstGeom>
-          <a:noFill/>
-          <a:ln/>
-        </p:spPr>
-        <p:txBody>
-          <a:bodyPr wrap="square" lIns="0" tIns="0" rIns="0" bIns="0" rtlCol="0" anchor="t"/>
-          <a:lstStyle/>
-          <a:p>
-            <a:pPr algn="l" indent="0" marL="0">
-              <a:lnSpc>
-                <a:spcPct val="106000"/>
-              </a:lnSpc>
-              <a:buNone/>
-            </a:pPr>
-            <a:r>
-              <a:rPr lang="en-US" sz="900" b="1" dirty="0">
-                <a:solidFill>
-                  <a:srgbClr val="046A38"/>
-                </a:solidFill>
-                <a:latin typeface="IBM Plex Mono" pitchFamily="34" charset="0"/>
-                <a:ea typeface="IBM Plex Mono" pitchFamily="34" charset="-122"/>
-                <a:cs typeface="IBM Plex Mono" pitchFamily="34" charset="-120"/>
-              </a:rPr>
-              <a:t>Q12  </a:t>
-            </a:r>
-            <a:pPr algn="l" indent="0" marL="0">
-              <a:lnSpc>
-                <a:spcPct val="106000"/>
-              </a:lnSpc>
-              <a:buNone/>
-            </a:pPr>
-            <a:r>
-              <a:rPr lang="en-US" sz="1000" i="1" dirty="0">
-                <a:solidFill>
-                  <a:srgbClr val="575757"/>
-                </a:solidFill>
-                <a:latin typeface="Calibri" pitchFamily="34" charset="0"/>
-                <a:ea typeface="Calibri" pitchFamily="34" charset="-122"/>
-                <a:cs typeface="Calibri" pitchFamily="34" charset="-120"/>
-              </a:rPr>
-              <a:t>“Looking ahead three years, what development do you believe will have the greatest impact on fraud risk management, and why? (open-ended)”</a:t>
-            </a:r>
-            <a:endParaRPr lang="en-US" sz="1000" dirty="0"/>
-          </a:p>
-        </p:txBody>
-      </p:sp>
-      <p:sp>
-        <p:nvSpPr>
-          <p:cNvPr id="6" name="Text 4"/>
-          <p:cNvSpPr txBox="1"/>
-          <p:nvPr/>
-        </p:nvSpPr>
-        <p:spPr>
-          <a:xfrm>
-            <a:off x="11346790" y="6537960"/>
-            <a:ext cx="343814" cy="182880"/>
-          </a:xfrm>
-          <a:prstGeom prst="rect">
-            <a:avLst/>
-          </a:prstGeom>
-          <a:noFill/>
-          <a:ln/>
-        </p:spPr>
-        <p:txBody>
-          <a:bodyPr wrap="square" rtlCol="0" anchor="ctr"/>
-          <a:lstStyle/>
-          <a:p>
-            <a:pPr algn="r" indent="0" marL="0">
-              <a:buNone/>
-            </a:pPr>
-            <a:r>
-              <a:rPr lang="en-US" sz="900" dirty="0">
-                <a:solidFill>
-                  <a:srgbClr val="53565A"/>
-                </a:solidFill>
-                <a:latin typeface="Calibri" pitchFamily="34" charset="0"/>
-                <a:ea typeface="Calibri" pitchFamily="34" charset="-122"/>
-                <a:cs typeface="Calibri" pitchFamily="34" charset="-120"/>
-              </a:rPr>
               <a:t>38</a:t>
-            </a:r>
-            <a:endParaRPr lang="en-US" sz="900" dirty="0"/>
-          </a:p>
-        </p:txBody>
-      </p:sp>
-      <p:sp>
-        <p:nvSpPr>
-          <p:cNvPr id="7" name="Shape 5"/>
-          <p:cNvSpPr/>
-          <p:nvPr/>
-        </p:nvSpPr>
-        <p:spPr>
-          <a:xfrm>
-            <a:off x="502006" y="2011680"/>
-            <a:ext cx="11188598" cy="914400"/>
-          </a:xfrm>
-          <a:prstGeom prst="roundRect">
-            <a:avLst>
-              <a:gd name="adj" fmla="val 6000"/>
-            </a:avLst>
-          </a:prstGeom>
-          <a:solidFill>
-            <a:srgbClr val="F2F2F2"/>
-          </a:solidFill>
-          <a:ln/>
-        </p:spPr>
-      </p:sp>
-      <p:sp>
-        <p:nvSpPr>
-          <p:cNvPr id="8" name="Text 6"/>
-          <p:cNvSpPr txBox="1"/>
-          <p:nvPr/>
-        </p:nvSpPr>
-        <p:spPr>
-          <a:xfrm>
-            <a:off x="776326" y="2011680"/>
-            <a:ext cx="2011680" cy="914400"/>
-          </a:xfrm>
-          <a:prstGeom prst="rect">
-            <a:avLst/>
-          </a:prstGeom>
-          <a:noFill/>
-          <a:ln/>
-        </p:spPr>
-        <p:txBody>
-          <a:bodyPr wrap="square" rtlCol="0" anchor="ctr"/>
-          <a:lstStyle/>
-          <a:p>
-            <a:pPr indent="0" marL="0">
-              <a:buNone/>
-            </a:pPr>
-            <a:r>
-              <a:rPr lang="en-US" sz="3000" b="1" dirty="0">
-                <a:solidFill>
-                  <a:srgbClr val="046A38"/>
-                </a:solidFill>
-                <a:latin typeface="Calibri" pitchFamily="34" charset="0"/>
-                <a:ea typeface="Calibri" pitchFamily="34" charset="-122"/>
-                <a:cs typeface="Calibri" pitchFamily="34" charset="-120"/>
-              </a:rPr>
-              <a:t>100/100</a:t>
-            </a:r>
-            <a:endParaRPr lang="en-US" sz="3000" dirty="0"/>
-          </a:p>
-        </p:txBody>
-      </p:sp>
-      <p:sp>
-        <p:nvSpPr>
-          <p:cNvPr id="9" name="Text 7"/>
-          <p:cNvSpPr txBox="1"/>
-          <p:nvPr/>
-        </p:nvSpPr>
-        <p:spPr>
-          <a:xfrm>
-            <a:off x="2970886" y="2057400"/>
-            <a:ext cx="8445398" cy="822960"/>
-          </a:xfrm>
-          <a:prstGeom prst="rect">
-            <a:avLst/>
-          </a:prstGeom>
-          <a:noFill/>
-          <a:ln/>
-        </p:spPr>
-        <p:txBody>
-          <a:bodyPr wrap="square" rtlCol="0" anchor="ctr"/>
-          <a:lstStyle/>
-          <a:p>
-            <a:pPr indent="0" marL="0">
-              <a:lnSpc>
-                <a:spcPct val="110000"/>
-              </a:lnSpc>
-              <a:buNone/>
-            </a:pPr>
-            <a:r>
-              <a:rPr lang="en-US" sz="1150" dirty="0">
-                <a:solidFill>
-                  <a:srgbClr val="53565A"/>
-                </a:solidFill>
-                <a:latin typeface="Calibri" pitchFamily="34" charset="0"/>
-                <a:ea typeface="Calibri" pitchFamily="34" charset="-122"/>
-                <a:cs typeface="Calibri" pitchFamily="34" charset="-120"/>
-              </a:rPr>
-              <a:t>respondents answered in their own words — a full response rate on an open text field. The dominant unprompted theme: the convergence of GenAI, synthetic identity, and real-time payments — the same thread running through every closed-ended question above.</a:t>
-            </a:r>
-            <a:endParaRPr lang="en-US" sz="1150" dirty="0"/>
-          </a:p>
-        </p:txBody>
-      </p:sp>
-      <p:sp>
-        <p:nvSpPr>
-          <p:cNvPr id="10" name="Shape 8"/>
-          <p:cNvSpPr/>
-          <p:nvPr/>
-        </p:nvSpPr>
-        <p:spPr>
-          <a:xfrm>
-            <a:off x="502006" y="3154680"/>
-            <a:ext cx="5457139" cy="1600200"/>
-          </a:xfrm>
-          <a:prstGeom prst="roundRect">
-            <a:avLst>
-              <a:gd name="adj" fmla="val 2857"/>
-            </a:avLst>
-          </a:prstGeom>
-          <a:solidFill>
-            <a:srgbClr val="FFFFFF"/>
-          </a:solidFill>
-          <a:ln w="9525">
-            <a:solidFill>
-              <a:srgbClr val="D0D0CE"/>
-            </a:solidFill>
-            <a:prstDash val="solid"/>
-          </a:ln>
-        </p:spPr>
-      </p:sp>
-      <p:sp>
-        <p:nvSpPr>
-          <p:cNvPr id="11" name="Text 9"/>
-          <p:cNvSpPr txBox="1"/>
-          <p:nvPr/>
-        </p:nvSpPr>
-        <p:spPr>
-          <a:xfrm>
-            <a:off x="684886" y="3282696"/>
-            <a:ext cx="5091379" cy="1143000"/>
-          </a:xfrm>
-          <a:prstGeom prst="rect">
-            <a:avLst/>
-          </a:prstGeom>
-          <a:noFill/>
-          <a:ln/>
-        </p:spPr>
-        <p:txBody>
-          <a:bodyPr wrap="square" rtlCol="0" anchor="t"/>
-          <a:lstStyle/>
-          <a:p>
-            <a:pPr indent="0" marL="0">
-              <a:lnSpc>
-                <a:spcPct val="112000"/>
-              </a:lnSpc>
-              <a:buNone/>
-            </a:pPr>
-            <a:r>
-              <a:rPr lang="en-US" sz="1000" i="1" dirty="0">
-                <a:solidFill>
-                  <a:srgbClr val="000000"/>
-                </a:solidFill>
-                <a:latin typeface="Calibri" pitchFamily="34" charset="0"/>
-                <a:ea typeface="Calibri" pitchFamily="34" charset="-122"/>
-                <a:cs typeface="Calibri" pitchFamily="34" charset="-120"/>
-              </a:rPr>
-              <a:t>“The convergence of genAI, synthetic identities and real time digital identity verification. This will matter significantly because fraudsters will become AI-native, identity becomes the new battleground, fraud prevention will replace fraud detection, and the winners will use AI against AI.”</a:t>
-            </a:r>
-            <a:endParaRPr lang="en-US" sz="1000" dirty="0"/>
-          </a:p>
-        </p:txBody>
-      </p:sp>
-      <p:sp>
-        <p:nvSpPr>
-          <p:cNvPr id="12" name="Text 10"/>
-          <p:cNvSpPr txBox="1"/>
-          <p:nvPr/>
-        </p:nvSpPr>
-        <p:spPr>
-          <a:xfrm>
-            <a:off x="684886" y="4443984"/>
-            <a:ext cx="5091379" cy="256032"/>
-          </a:xfrm>
-          <a:prstGeom prst="rect">
-            <a:avLst/>
-          </a:prstGeom>
-          <a:noFill/>
-          <a:ln/>
-        </p:spPr>
-        <p:txBody>
-          <a:bodyPr wrap="square" rtlCol="0" anchor="ctr"/>
-          <a:lstStyle/>
-          <a:p>
-            <a:pPr indent="0" marL="0">
-              <a:buNone/>
-            </a:pPr>
-            <a:r>
-              <a:rPr lang="en-US" sz="900" dirty="0">
-                <a:solidFill>
-                  <a:srgbClr val="53565A"/>
-                </a:solidFill>
-                <a:latin typeface="IBM Plex Mono" pitchFamily="34" charset="0"/>
-                <a:ea typeface="IBM Plex Mono" pitchFamily="34" charset="-122"/>
-                <a:cs typeface="IBM Plex Mono" pitchFamily="34" charset="-120"/>
-              </a:rPr>
-              <a:t>Director · Insurance</a:t>
-            </a:r>
-            <a:endParaRPr lang="en-US" sz="900" dirty="0"/>
-          </a:p>
-        </p:txBody>
-      </p:sp>
-      <p:sp>
-        <p:nvSpPr>
-          <p:cNvPr id="13" name="Shape 11"/>
-          <p:cNvSpPr/>
-          <p:nvPr/>
-        </p:nvSpPr>
-        <p:spPr>
-          <a:xfrm>
-            <a:off x="6233465" y="3154680"/>
-            <a:ext cx="5457139" cy="1600200"/>
-          </a:xfrm>
-          <a:prstGeom prst="roundRect">
-            <a:avLst>
-              <a:gd name="adj" fmla="val 2857"/>
-            </a:avLst>
-          </a:prstGeom>
-          <a:solidFill>
-            <a:srgbClr val="FFFFFF"/>
-          </a:solidFill>
-          <a:ln w="9525">
-            <a:solidFill>
-              <a:srgbClr val="D0D0CE"/>
-            </a:solidFill>
-            <a:prstDash val="solid"/>
-          </a:ln>
-        </p:spPr>
-      </p:sp>
-      <p:sp>
-        <p:nvSpPr>
-          <p:cNvPr id="14" name="Text 12"/>
-          <p:cNvSpPr txBox="1"/>
-          <p:nvPr/>
-        </p:nvSpPr>
-        <p:spPr>
-          <a:xfrm>
-            <a:off x="6416345" y="3282696"/>
-            <a:ext cx="5091379" cy="1143000"/>
-          </a:xfrm>
-          <a:prstGeom prst="rect">
-            <a:avLst/>
-          </a:prstGeom>
-          <a:noFill/>
-          <a:ln/>
-        </p:spPr>
-        <p:txBody>
-          <a:bodyPr wrap="square" rtlCol="0" anchor="t"/>
-          <a:lstStyle/>
-          <a:p>
-            <a:pPr indent="0" marL="0">
-              <a:lnSpc>
-                <a:spcPct val="112000"/>
-              </a:lnSpc>
-              <a:buNone/>
-            </a:pPr>
-            <a:r>
-              <a:rPr lang="en-US" sz="1000" i="1" dirty="0">
-                <a:solidFill>
-                  <a:srgbClr val="000000"/>
-                </a:solidFill>
-                <a:latin typeface="Calibri" pitchFamily="34" charset="0"/>
-                <a:ea typeface="Calibri" pitchFamily="34" charset="-122"/>
-                <a:cs typeface="Calibri" pitchFamily="34" charset="-120"/>
-              </a:rPr>
-              <a:t>“The biggest development will be the convergence of GenAI, synthetic identity, and real-time payments. Fraud will become faster, more personalized, and harder to distinguish from legitimate customer behaviour.”</a:t>
-            </a:r>
-            <a:endParaRPr lang="en-US" sz="1000" dirty="0"/>
-          </a:p>
-        </p:txBody>
-      </p:sp>
-      <p:sp>
-        <p:nvSpPr>
-          <p:cNvPr id="15" name="Text 13"/>
-          <p:cNvSpPr txBox="1"/>
-          <p:nvPr/>
-        </p:nvSpPr>
-        <p:spPr>
-          <a:xfrm>
-            <a:off x="6416345" y="4443984"/>
-            <a:ext cx="5091379" cy="256032"/>
-          </a:xfrm>
-          <a:prstGeom prst="rect">
-            <a:avLst/>
-          </a:prstGeom>
-          <a:noFill/>
-          <a:ln/>
-        </p:spPr>
-        <p:txBody>
-          <a:bodyPr wrap="square" rtlCol="0" anchor="ctr"/>
-          <a:lstStyle/>
-          <a:p>
-            <a:pPr indent="0" marL="0">
-              <a:buNone/>
-            </a:pPr>
-            <a:r>
-              <a:rPr lang="en-US" sz="900" dirty="0">
-                <a:solidFill>
-                  <a:srgbClr val="53565A"/>
-                </a:solidFill>
-                <a:latin typeface="IBM Plex Mono" pitchFamily="34" charset="0"/>
-                <a:ea typeface="IBM Plex Mono" pitchFamily="34" charset="-122"/>
-                <a:cs typeface="IBM Plex Mono" pitchFamily="34" charset="-120"/>
-              </a:rPr>
-              <a:t>C-level · Banking</a:t>
-            </a:r>
-            <a:endParaRPr lang="en-US" sz="900" dirty="0"/>
-          </a:p>
-        </p:txBody>
-      </p:sp>
-      <p:sp>
-        <p:nvSpPr>
-          <p:cNvPr id="16" name="Shape 14"/>
-          <p:cNvSpPr/>
-          <p:nvPr/>
-        </p:nvSpPr>
-        <p:spPr>
-          <a:xfrm>
-            <a:off x="502006" y="4937760"/>
-            <a:ext cx="5457139" cy="1600200"/>
-          </a:xfrm>
-          <a:prstGeom prst="roundRect">
-            <a:avLst>
-              <a:gd name="adj" fmla="val 2857"/>
-            </a:avLst>
-          </a:prstGeom>
-          <a:solidFill>
-            <a:srgbClr val="FFFFFF"/>
-          </a:solidFill>
-          <a:ln w="9525">
-            <a:solidFill>
-              <a:srgbClr val="D0D0CE"/>
-            </a:solidFill>
-            <a:prstDash val="solid"/>
-          </a:ln>
-        </p:spPr>
-      </p:sp>
-      <p:sp>
-        <p:nvSpPr>
-          <p:cNvPr id="17" name="Text 15"/>
-          <p:cNvSpPr txBox="1"/>
-          <p:nvPr/>
-        </p:nvSpPr>
-        <p:spPr>
-          <a:xfrm>
-            <a:off x="684886" y="5065776"/>
-            <a:ext cx="5091379" cy="1143000"/>
-          </a:xfrm>
-          <a:prstGeom prst="rect">
-            <a:avLst/>
-          </a:prstGeom>
-          <a:noFill/>
-          <a:ln/>
-        </p:spPr>
-        <p:txBody>
-          <a:bodyPr wrap="square" rtlCol="0" anchor="t"/>
-          <a:lstStyle/>
-          <a:p>
-            <a:pPr indent="0" marL="0">
-              <a:lnSpc>
-                <a:spcPct val="112000"/>
-              </a:lnSpc>
-              <a:buNone/>
-            </a:pPr>
-            <a:r>
-              <a:rPr lang="en-US" sz="1000" i="1" dirty="0">
-                <a:solidFill>
-                  <a:srgbClr val="000000"/>
-                </a:solidFill>
-                <a:latin typeface="Calibri" pitchFamily="34" charset="0"/>
-                <a:ea typeface="Calibri" pitchFamily="34" charset="-122"/>
-                <a:cs typeface="Calibri" pitchFamily="34" charset="-120"/>
-              </a:rPr>
-              <a:t>“Companies are moving away from regular passwords towards decentralized digital credentials and biometric passkeys, as this would minimize phishing and account hacking.”</a:t>
-            </a:r>
-            <a:endParaRPr lang="en-US" sz="1000" dirty="0"/>
-          </a:p>
-        </p:txBody>
-      </p:sp>
-      <p:sp>
-        <p:nvSpPr>
-          <p:cNvPr id="18" name="Text 16"/>
-          <p:cNvSpPr txBox="1"/>
-          <p:nvPr/>
-        </p:nvSpPr>
-        <p:spPr>
-          <a:xfrm>
-            <a:off x="684886" y="6227064"/>
-            <a:ext cx="5091379" cy="256032"/>
-          </a:xfrm>
-          <a:prstGeom prst="rect">
-            <a:avLst/>
-          </a:prstGeom>
-          <a:noFill/>
-          <a:ln/>
-        </p:spPr>
-        <p:txBody>
-          <a:bodyPr wrap="square" rtlCol="0" anchor="ctr"/>
-          <a:lstStyle/>
-          <a:p>
-            <a:pPr indent="0" marL="0">
-              <a:buNone/>
-            </a:pPr>
-            <a:r>
-              <a:rPr lang="en-US" sz="900" dirty="0">
-                <a:solidFill>
-                  <a:srgbClr val="53565A"/>
-                </a:solidFill>
-                <a:latin typeface="IBM Plex Mono" pitchFamily="34" charset="0"/>
-                <a:ea typeface="IBM Plex Mono" pitchFamily="34" charset="-122"/>
-                <a:cs typeface="IBM Plex Mono" pitchFamily="34" charset="-120"/>
-              </a:rPr>
-              <a:t>Senior Manager · Banking</a:t>
-            </a:r>
-            <a:endParaRPr lang="en-US" sz="900" dirty="0"/>
-          </a:p>
-        </p:txBody>
-      </p:sp>
-      <p:sp>
-        <p:nvSpPr>
-          <p:cNvPr id="19" name="Shape 17"/>
-          <p:cNvSpPr/>
-          <p:nvPr/>
-        </p:nvSpPr>
-        <p:spPr>
-          <a:xfrm>
-            <a:off x="6233465" y="4937760"/>
-            <a:ext cx="5457139" cy="1600200"/>
-          </a:xfrm>
-          <a:prstGeom prst="roundRect">
-            <a:avLst>
-              <a:gd name="adj" fmla="val 2857"/>
-            </a:avLst>
-          </a:prstGeom>
-          <a:solidFill>
-            <a:srgbClr val="FFFFFF"/>
-          </a:solidFill>
-          <a:ln w="9525">
-            <a:solidFill>
-              <a:srgbClr val="D0D0CE"/>
-            </a:solidFill>
-            <a:prstDash val="solid"/>
-          </a:ln>
-        </p:spPr>
-      </p:sp>
-      <p:sp>
-        <p:nvSpPr>
-          <p:cNvPr id="20" name="Text 18"/>
-          <p:cNvSpPr txBox="1"/>
-          <p:nvPr/>
-        </p:nvSpPr>
-        <p:spPr>
-          <a:xfrm>
-            <a:off x="6416345" y="5065776"/>
-            <a:ext cx="5091379" cy="1143000"/>
-          </a:xfrm>
-          <a:prstGeom prst="rect">
-            <a:avLst/>
-          </a:prstGeom>
-          <a:noFill/>
-          <a:ln/>
-        </p:spPr>
-        <p:txBody>
-          <a:bodyPr wrap="square" rtlCol="0" anchor="t"/>
-          <a:lstStyle/>
-          <a:p>
-            <a:pPr indent="0" marL="0">
-              <a:lnSpc>
-                <a:spcPct val="112000"/>
-              </a:lnSpc>
-              <a:buNone/>
-            </a:pPr>
-            <a:r>
-              <a:rPr lang="en-US" sz="1000" i="1" dirty="0">
-                <a:solidFill>
-                  <a:srgbClr val="000000"/>
-                </a:solidFill>
-                <a:latin typeface="Calibri" pitchFamily="34" charset="0"/>
-                <a:ea typeface="Calibri" pitchFamily="34" charset="-122"/>
-                <a:cs typeface="Calibri" pitchFamily="34" charset="-120"/>
-              </a:rPr>
-              <a:t>“AI will shift fraud management from reactive investigation toward more predictive prevention, which should help us identify risks before losses occur.”</a:t>
-            </a:r>
-            <a:endParaRPr lang="en-US" sz="1000" dirty="0"/>
-          </a:p>
-        </p:txBody>
-      </p:sp>
-      <p:sp>
-        <p:nvSpPr>
-          <p:cNvPr id="21" name="Text 19"/>
-          <p:cNvSpPr txBox="1"/>
-          <p:nvPr/>
-        </p:nvSpPr>
-        <p:spPr>
-          <a:xfrm>
-            <a:off x="6416345" y="6227064"/>
-            <a:ext cx="5091379" cy="256032"/>
-          </a:xfrm>
-          <a:prstGeom prst="rect">
-            <a:avLst/>
-          </a:prstGeom>
-          <a:noFill/>
-          <a:ln/>
-        </p:spPr>
-        <p:txBody>
-          <a:bodyPr wrap="square" rtlCol="0" anchor="ctr"/>
-          <a:lstStyle/>
-          <a:p>
-            <a:pPr indent="0" marL="0">
-              <a:buNone/>
-            </a:pPr>
-            <a:r>
-              <a:rPr lang="en-US" sz="900" dirty="0">
-                <a:solidFill>
-                  <a:srgbClr val="53565A"/>
-                </a:solidFill>
-                <a:latin typeface="IBM Plex Mono" pitchFamily="34" charset="0"/>
-                <a:ea typeface="IBM Plex Mono" pitchFamily="34" charset="-122"/>
-                <a:cs typeface="IBM Plex Mono" pitchFamily="34" charset="-120"/>
-              </a:rPr>
-              <a:t>VP · Banking</a:t>
             </a:r>
             <a:endParaRPr lang="en-US" sz="900" dirty="0"/>
           </a:p>
@@ -33912,6 +34420,775 @@
 <file path=ppt/slides/slide40.xml><?xml version="1.0" encoding="utf-8"?>
 <p:sld xmlns:a="http://schemas.openxmlformats.org/drawingml/2006/main" xmlns:r="http://schemas.openxmlformats.org/officeDocument/2006/relationships" xmlns:p="http://schemas.openxmlformats.org/presentationml/2006/main">
   <p:cSld name="Slide 40">
+    <p:bg>
+      <p:bgPr>
+        <a:solidFill>
+          <a:srgbClr val="FFFFFF"/>
+        </a:solidFill>
+      </p:bgPr>
+    </p:bg>
+    <p:spTree>
+      <p:nvGrpSpPr>
+        <p:cNvPr id="1" name=""/>
+        <p:cNvGrpSpPr/>
+        <p:nvPr/>
+      </p:nvGrpSpPr>
+      <p:grpSpPr>
+        <a:xfrm>
+          <a:off x="0" y="0"/>
+          <a:ext cx="0" cy="0"/>
+          <a:chOff x="0" y="0"/>
+          <a:chExt cx="0" cy="0"/>
+        </a:xfrm>
+      </p:grpSpPr>
+      <p:sp>
+        <p:nvSpPr>
+          <p:cNvPr id="2" name="Text 0"/>
+          <p:cNvSpPr txBox="1"/>
+          <p:nvPr/>
+        </p:nvSpPr>
+        <p:spPr>
+          <a:xfrm>
+            <a:off x="502006" y="256032"/>
+            <a:ext cx="11188598" cy="310896"/>
+          </a:xfrm>
+          <a:prstGeom prst="rect">
+            <a:avLst/>
+          </a:prstGeom>
+          <a:noFill/>
+          <a:ln/>
+        </p:spPr>
+        <p:txBody>
+          <a:bodyPr wrap="square" lIns="0" tIns="0" rIns="0" bIns="0" rtlCol="0" anchor="t"/>
+          <a:lstStyle/>
+          <a:p>
+            <a:pPr algn="l" indent="0" marL="0">
+              <a:buNone/>
+            </a:pPr>
+            <a:r>
+              <a:rPr lang="en-US" sz="1900" b="1" dirty="0">
+                <a:solidFill>
+                  <a:srgbClr val="000000"/>
+                </a:solidFill>
+                <a:latin typeface="Calibri" pitchFamily="34" charset="0"/>
+                <a:ea typeface="Calibri" pitchFamily="34" charset="-122"/>
+                <a:cs typeface="Calibri" pitchFamily="34" charset="-120"/>
+              </a:rPr>
+              <a:t>What Leaders Say, Unprompted</a:t>
+            </a:r>
+            <a:endParaRPr lang="en-US" sz="1900" dirty="0"/>
+          </a:p>
+        </p:txBody>
+      </p:sp>
+      <p:sp>
+        <p:nvSpPr>
+          <p:cNvPr id="3" name="Text 1"/>
+          <p:cNvSpPr txBox="1"/>
+          <p:nvPr/>
+        </p:nvSpPr>
+        <p:spPr>
+          <a:xfrm>
+            <a:off x="502006" y="585216"/>
+            <a:ext cx="11188598" cy="713232"/>
+          </a:xfrm>
+          <a:prstGeom prst="rect">
+            <a:avLst/>
+          </a:prstGeom>
+          <a:noFill/>
+          <a:ln/>
+        </p:spPr>
+        <p:txBody>
+          <a:bodyPr wrap="square" lIns="0" tIns="0" rIns="0" bIns="0" rtlCol="0" anchor="t"/>
+          <a:lstStyle/>
+          <a:p>
+            <a:pPr algn="l" indent="0" marL="0">
+              <a:lnSpc>
+                <a:spcPct val="105000"/>
+              </a:lnSpc>
+              <a:buNone/>
+            </a:pPr>
+            <a:r>
+              <a:rPr lang="en-US" sz="1350" b="1" dirty="0">
+                <a:solidFill>
+                  <a:srgbClr val="046A38"/>
+                </a:solidFill>
+                <a:latin typeface="Calibri" pitchFamily="34" charset="0"/>
+                <a:ea typeface="Calibri" pitchFamily="34" charset="-122"/>
+                <a:cs typeface="Calibri" pitchFamily="34" charset="-120"/>
+              </a:rPr>
+              <a:t>Left to answer in their own words, leaders converge on the same trend.</a:t>
+            </a:r>
+            <a:endParaRPr lang="en-US" sz="1350" dirty="0"/>
+          </a:p>
+        </p:txBody>
+      </p:sp>
+      <p:sp>
+        <p:nvSpPr>
+          <p:cNvPr id="4" name="Shape 2"/>
+          <p:cNvSpPr/>
+          <p:nvPr/>
+        </p:nvSpPr>
+        <p:spPr>
+          <a:xfrm>
+            <a:off x="502006" y="1335024"/>
+            <a:ext cx="0" cy="512064"/>
+          </a:xfrm>
+          <a:prstGeom prst="line">
+            <a:avLst/>
+          </a:prstGeom>
+          <a:noFill/>
+          <a:ln w="25400">
+            <a:solidFill>
+              <a:srgbClr val="D0D0CE"/>
+            </a:solidFill>
+            <a:prstDash val="solid"/>
+          </a:ln>
+        </p:spPr>
+      </p:sp>
+      <p:sp>
+        <p:nvSpPr>
+          <p:cNvPr id="5" name="Text 3"/>
+          <p:cNvSpPr txBox="1"/>
+          <p:nvPr/>
+        </p:nvSpPr>
+        <p:spPr>
+          <a:xfrm>
+            <a:off x="648310" y="1335024"/>
+            <a:ext cx="11042294" cy="512064"/>
+          </a:xfrm>
+          <a:prstGeom prst="rect">
+            <a:avLst/>
+          </a:prstGeom>
+          <a:noFill/>
+          <a:ln/>
+        </p:spPr>
+        <p:txBody>
+          <a:bodyPr wrap="square" lIns="0" tIns="0" rIns="0" bIns="0" rtlCol="0" anchor="t"/>
+          <a:lstStyle/>
+          <a:p>
+            <a:pPr algn="l" indent="0" marL="0">
+              <a:lnSpc>
+                <a:spcPct val="106000"/>
+              </a:lnSpc>
+              <a:buNone/>
+            </a:pPr>
+            <a:r>
+              <a:rPr lang="en-US" sz="900" b="1" dirty="0">
+                <a:solidFill>
+                  <a:srgbClr val="046A38"/>
+                </a:solidFill>
+                <a:latin typeface="IBM Plex Mono" pitchFamily="34" charset="0"/>
+                <a:ea typeface="IBM Plex Mono" pitchFamily="34" charset="-122"/>
+                <a:cs typeface="IBM Plex Mono" pitchFamily="34" charset="-120"/>
+              </a:rPr>
+              <a:t>Q12  </a:t>
+            </a:r>
+            <a:pPr algn="l" indent="0" marL="0">
+              <a:lnSpc>
+                <a:spcPct val="106000"/>
+              </a:lnSpc>
+              <a:buNone/>
+            </a:pPr>
+            <a:r>
+              <a:rPr lang="en-US" sz="1000" i="1" dirty="0">
+                <a:solidFill>
+                  <a:srgbClr val="575757"/>
+                </a:solidFill>
+                <a:latin typeface="Calibri" pitchFamily="34" charset="0"/>
+                <a:ea typeface="Calibri" pitchFamily="34" charset="-122"/>
+                <a:cs typeface="Calibri" pitchFamily="34" charset="-120"/>
+              </a:rPr>
+              <a:t>“Looking ahead three years, what development do you believe will have the greatest impact on fraud risk management, and why? (open-ended)”</a:t>
+            </a:r>
+            <a:endParaRPr lang="en-US" sz="1000" dirty="0"/>
+          </a:p>
+        </p:txBody>
+      </p:sp>
+      <p:sp>
+        <p:nvSpPr>
+          <p:cNvPr id="6" name="Text 4"/>
+          <p:cNvSpPr txBox="1"/>
+          <p:nvPr/>
+        </p:nvSpPr>
+        <p:spPr>
+          <a:xfrm>
+            <a:off x="11346790" y="6537960"/>
+            <a:ext cx="343814" cy="182880"/>
+          </a:xfrm>
+          <a:prstGeom prst="rect">
+            <a:avLst/>
+          </a:prstGeom>
+          <a:noFill/>
+          <a:ln/>
+        </p:spPr>
+        <p:txBody>
+          <a:bodyPr wrap="square" rtlCol="0" anchor="ctr"/>
+          <a:lstStyle/>
+          <a:p>
+            <a:pPr algn="r" indent="0" marL="0">
+              <a:buNone/>
+            </a:pPr>
+            <a:r>
+              <a:rPr lang="en-US" sz="900" dirty="0">
+                <a:solidFill>
+                  <a:srgbClr val="53565A"/>
+                </a:solidFill>
+                <a:latin typeface="Calibri" pitchFamily="34" charset="0"/>
+                <a:ea typeface="Calibri" pitchFamily="34" charset="-122"/>
+                <a:cs typeface="Calibri" pitchFamily="34" charset="-120"/>
+              </a:rPr>
+              <a:t>39</a:t>
+            </a:r>
+            <a:endParaRPr lang="en-US" sz="900" dirty="0"/>
+          </a:p>
+        </p:txBody>
+      </p:sp>
+      <p:sp>
+        <p:nvSpPr>
+          <p:cNvPr id="7" name="Shape 5"/>
+          <p:cNvSpPr/>
+          <p:nvPr/>
+        </p:nvSpPr>
+        <p:spPr>
+          <a:xfrm>
+            <a:off x="502006" y="2011680"/>
+            <a:ext cx="11188598" cy="914400"/>
+          </a:xfrm>
+          <a:prstGeom prst="roundRect">
+            <a:avLst>
+              <a:gd name="adj" fmla="val 6000"/>
+            </a:avLst>
+          </a:prstGeom>
+          <a:solidFill>
+            <a:srgbClr val="F2F2F2"/>
+          </a:solidFill>
+          <a:ln/>
+        </p:spPr>
+      </p:sp>
+      <p:sp>
+        <p:nvSpPr>
+          <p:cNvPr id="8" name="Text 6"/>
+          <p:cNvSpPr txBox="1"/>
+          <p:nvPr/>
+        </p:nvSpPr>
+        <p:spPr>
+          <a:xfrm>
+            <a:off x="776326" y="2011680"/>
+            <a:ext cx="2011680" cy="914400"/>
+          </a:xfrm>
+          <a:prstGeom prst="rect">
+            <a:avLst/>
+          </a:prstGeom>
+          <a:noFill/>
+          <a:ln/>
+        </p:spPr>
+        <p:txBody>
+          <a:bodyPr wrap="square" rtlCol="0" anchor="ctr"/>
+          <a:lstStyle/>
+          <a:p>
+            <a:pPr indent="0" marL="0">
+              <a:buNone/>
+            </a:pPr>
+            <a:r>
+              <a:rPr lang="en-US" sz="3000" b="1" dirty="0">
+                <a:solidFill>
+                  <a:srgbClr val="046A38"/>
+                </a:solidFill>
+                <a:latin typeface="Calibri" pitchFamily="34" charset="0"/>
+                <a:ea typeface="Calibri" pitchFamily="34" charset="-122"/>
+                <a:cs typeface="Calibri" pitchFamily="34" charset="-120"/>
+              </a:rPr>
+              <a:t>100/100</a:t>
+            </a:r>
+            <a:endParaRPr lang="en-US" sz="3000" dirty="0"/>
+          </a:p>
+        </p:txBody>
+      </p:sp>
+      <p:sp>
+        <p:nvSpPr>
+          <p:cNvPr id="9" name="Text 7"/>
+          <p:cNvSpPr txBox="1"/>
+          <p:nvPr/>
+        </p:nvSpPr>
+        <p:spPr>
+          <a:xfrm>
+            <a:off x="2970886" y="2057400"/>
+            <a:ext cx="8445398" cy="822960"/>
+          </a:xfrm>
+          <a:prstGeom prst="rect">
+            <a:avLst/>
+          </a:prstGeom>
+          <a:noFill/>
+          <a:ln/>
+        </p:spPr>
+        <p:txBody>
+          <a:bodyPr wrap="square" rtlCol="0" anchor="ctr"/>
+          <a:lstStyle/>
+          <a:p>
+            <a:pPr indent="0" marL="0">
+              <a:lnSpc>
+                <a:spcPct val="110000"/>
+              </a:lnSpc>
+              <a:buNone/>
+            </a:pPr>
+            <a:r>
+              <a:rPr lang="en-US" sz="1150" dirty="0">
+                <a:solidFill>
+                  <a:srgbClr val="53565A"/>
+                </a:solidFill>
+                <a:latin typeface="Calibri" pitchFamily="34" charset="0"/>
+                <a:ea typeface="Calibri" pitchFamily="34" charset="-122"/>
+                <a:cs typeface="Calibri" pitchFamily="34" charset="-120"/>
+              </a:rPr>
+              <a:t>respondents answered in their own words — a full response rate on an open text field. The dominant unprompted theme: the convergence of GenAI, synthetic identity, and real-time payments — the same thread running through every closed-ended question above.</a:t>
+            </a:r>
+            <a:endParaRPr lang="en-US" sz="1150" dirty="0"/>
+          </a:p>
+        </p:txBody>
+      </p:sp>
+      <p:sp>
+        <p:nvSpPr>
+          <p:cNvPr id="10" name="Shape 8"/>
+          <p:cNvSpPr/>
+          <p:nvPr/>
+        </p:nvSpPr>
+        <p:spPr>
+          <a:xfrm>
+            <a:off x="502006" y="3154680"/>
+            <a:ext cx="5457139" cy="1600200"/>
+          </a:xfrm>
+          <a:prstGeom prst="roundRect">
+            <a:avLst>
+              <a:gd name="adj" fmla="val 2857"/>
+            </a:avLst>
+          </a:prstGeom>
+          <a:solidFill>
+            <a:srgbClr val="FFFFFF"/>
+          </a:solidFill>
+          <a:ln w="9525">
+            <a:solidFill>
+              <a:srgbClr val="D0D0CE"/>
+            </a:solidFill>
+            <a:prstDash val="solid"/>
+          </a:ln>
+        </p:spPr>
+      </p:sp>
+      <p:sp>
+        <p:nvSpPr>
+          <p:cNvPr id="11" name="Text 9"/>
+          <p:cNvSpPr txBox="1"/>
+          <p:nvPr/>
+        </p:nvSpPr>
+        <p:spPr>
+          <a:xfrm>
+            <a:off x="684886" y="3282696"/>
+            <a:ext cx="5091379" cy="1143000"/>
+          </a:xfrm>
+          <a:prstGeom prst="rect">
+            <a:avLst/>
+          </a:prstGeom>
+          <a:noFill/>
+          <a:ln/>
+        </p:spPr>
+        <p:txBody>
+          <a:bodyPr wrap="square" rtlCol="0" anchor="t"/>
+          <a:lstStyle/>
+          <a:p>
+            <a:pPr indent="0" marL="0">
+              <a:lnSpc>
+                <a:spcPct val="112000"/>
+              </a:lnSpc>
+              <a:buNone/>
+            </a:pPr>
+            <a:r>
+              <a:rPr lang="en-US" sz="1000" i="1" dirty="0">
+                <a:solidFill>
+                  <a:srgbClr val="000000"/>
+                </a:solidFill>
+                <a:latin typeface="Calibri" pitchFamily="34" charset="0"/>
+                <a:ea typeface="Calibri" pitchFamily="34" charset="-122"/>
+                <a:cs typeface="Calibri" pitchFamily="34" charset="-120"/>
+              </a:rPr>
+              <a:t>“The convergence of genAI, synthetic identities and real time digital identity verification. This will matter significantly because fraudsters will become AI-native, identity becomes the new battleground, fraud prevention will replace fraud detection, and the winners will use AI against AI.”</a:t>
+            </a:r>
+            <a:endParaRPr lang="en-US" sz="1000" dirty="0"/>
+          </a:p>
+        </p:txBody>
+      </p:sp>
+      <p:sp>
+        <p:nvSpPr>
+          <p:cNvPr id="12" name="Text 10"/>
+          <p:cNvSpPr txBox="1"/>
+          <p:nvPr/>
+        </p:nvSpPr>
+        <p:spPr>
+          <a:xfrm>
+            <a:off x="684886" y="4443984"/>
+            <a:ext cx="5091379" cy="256032"/>
+          </a:xfrm>
+          <a:prstGeom prst="rect">
+            <a:avLst/>
+          </a:prstGeom>
+          <a:noFill/>
+          <a:ln/>
+        </p:spPr>
+        <p:txBody>
+          <a:bodyPr wrap="square" rtlCol="0" anchor="ctr"/>
+          <a:lstStyle/>
+          <a:p>
+            <a:pPr indent="0" marL="0">
+              <a:buNone/>
+            </a:pPr>
+            <a:r>
+              <a:rPr lang="en-US" sz="900" dirty="0">
+                <a:solidFill>
+                  <a:srgbClr val="53565A"/>
+                </a:solidFill>
+                <a:latin typeface="IBM Plex Mono" pitchFamily="34" charset="0"/>
+                <a:ea typeface="IBM Plex Mono" pitchFamily="34" charset="-122"/>
+                <a:cs typeface="IBM Plex Mono" pitchFamily="34" charset="-120"/>
+              </a:rPr>
+              <a:t>Director · Insurance</a:t>
+            </a:r>
+            <a:endParaRPr lang="en-US" sz="900" dirty="0"/>
+          </a:p>
+        </p:txBody>
+      </p:sp>
+      <p:sp>
+        <p:nvSpPr>
+          <p:cNvPr id="13" name="Shape 11"/>
+          <p:cNvSpPr/>
+          <p:nvPr/>
+        </p:nvSpPr>
+        <p:spPr>
+          <a:xfrm>
+            <a:off x="6233465" y="3154680"/>
+            <a:ext cx="5457139" cy="1600200"/>
+          </a:xfrm>
+          <a:prstGeom prst="roundRect">
+            <a:avLst>
+              <a:gd name="adj" fmla="val 2857"/>
+            </a:avLst>
+          </a:prstGeom>
+          <a:solidFill>
+            <a:srgbClr val="FFFFFF"/>
+          </a:solidFill>
+          <a:ln w="9525">
+            <a:solidFill>
+              <a:srgbClr val="D0D0CE"/>
+            </a:solidFill>
+            <a:prstDash val="solid"/>
+          </a:ln>
+        </p:spPr>
+      </p:sp>
+      <p:sp>
+        <p:nvSpPr>
+          <p:cNvPr id="14" name="Text 12"/>
+          <p:cNvSpPr txBox="1"/>
+          <p:nvPr/>
+        </p:nvSpPr>
+        <p:spPr>
+          <a:xfrm>
+            <a:off x="6416345" y="3282696"/>
+            <a:ext cx="5091379" cy="1143000"/>
+          </a:xfrm>
+          <a:prstGeom prst="rect">
+            <a:avLst/>
+          </a:prstGeom>
+          <a:noFill/>
+          <a:ln/>
+        </p:spPr>
+        <p:txBody>
+          <a:bodyPr wrap="square" rtlCol="0" anchor="t"/>
+          <a:lstStyle/>
+          <a:p>
+            <a:pPr indent="0" marL="0">
+              <a:lnSpc>
+                <a:spcPct val="112000"/>
+              </a:lnSpc>
+              <a:buNone/>
+            </a:pPr>
+            <a:r>
+              <a:rPr lang="en-US" sz="1000" i="1" dirty="0">
+                <a:solidFill>
+                  <a:srgbClr val="000000"/>
+                </a:solidFill>
+                <a:latin typeface="Calibri" pitchFamily="34" charset="0"/>
+                <a:ea typeface="Calibri" pitchFamily="34" charset="-122"/>
+                <a:cs typeface="Calibri" pitchFamily="34" charset="-120"/>
+              </a:rPr>
+              <a:t>“The biggest development will be the convergence of GenAI, synthetic identity, and real-time payments. Fraud will become faster, more personalized, and harder to distinguish from legitimate customer behaviour.”</a:t>
+            </a:r>
+            <a:endParaRPr lang="en-US" sz="1000" dirty="0"/>
+          </a:p>
+        </p:txBody>
+      </p:sp>
+      <p:sp>
+        <p:nvSpPr>
+          <p:cNvPr id="15" name="Text 13"/>
+          <p:cNvSpPr txBox="1"/>
+          <p:nvPr/>
+        </p:nvSpPr>
+        <p:spPr>
+          <a:xfrm>
+            <a:off x="6416345" y="4443984"/>
+            <a:ext cx="5091379" cy="256032"/>
+          </a:xfrm>
+          <a:prstGeom prst="rect">
+            <a:avLst/>
+          </a:prstGeom>
+          <a:noFill/>
+          <a:ln/>
+        </p:spPr>
+        <p:txBody>
+          <a:bodyPr wrap="square" rtlCol="0" anchor="ctr"/>
+          <a:lstStyle/>
+          <a:p>
+            <a:pPr indent="0" marL="0">
+              <a:buNone/>
+            </a:pPr>
+            <a:r>
+              <a:rPr lang="en-US" sz="900" dirty="0">
+                <a:solidFill>
+                  <a:srgbClr val="53565A"/>
+                </a:solidFill>
+                <a:latin typeface="IBM Plex Mono" pitchFamily="34" charset="0"/>
+                <a:ea typeface="IBM Plex Mono" pitchFamily="34" charset="-122"/>
+                <a:cs typeface="IBM Plex Mono" pitchFamily="34" charset="-120"/>
+              </a:rPr>
+              <a:t>C-level · Banking</a:t>
+            </a:r>
+            <a:endParaRPr lang="en-US" sz="900" dirty="0"/>
+          </a:p>
+        </p:txBody>
+      </p:sp>
+      <p:sp>
+        <p:nvSpPr>
+          <p:cNvPr id="16" name="Shape 14"/>
+          <p:cNvSpPr/>
+          <p:nvPr/>
+        </p:nvSpPr>
+        <p:spPr>
+          <a:xfrm>
+            <a:off x="502006" y="4937760"/>
+            <a:ext cx="5457139" cy="1600200"/>
+          </a:xfrm>
+          <a:prstGeom prst="roundRect">
+            <a:avLst>
+              <a:gd name="adj" fmla="val 2857"/>
+            </a:avLst>
+          </a:prstGeom>
+          <a:solidFill>
+            <a:srgbClr val="FFFFFF"/>
+          </a:solidFill>
+          <a:ln w="9525">
+            <a:solidFill>
+              <a:srgbClr val="D0D0CE"/>
+            </a:solidFill>
+            <a:prstDash val="solid"/>
+          </a:ln>
+        </p:spPr>
+      </p:sp>
+      <p:sp>
+        <p:nvSpPr>
+          <p:cNvPr id="17" name="Text 15"/>
+          <p:cNvSpPr txBox="1"/>
+          <p:nvPr/>
+        </p:nvSpPr>
+        <p:spPr>
+          <a:xfrm>
+            <a:off x="684886" y="5065776"/>
+            <a:ext cx="5091379" cy="1143000"/>
+          </a:xfrm>
+          <a:prstGeom prst="rect">
+            <a:avLst/>
+          </a:prstGeom>
+          <a:noFill/>
+          <a:ln/>
+        </p:spPr>
+        <p:txBody>
+          <a:bodyPr wrap="square" rtlCol="0" anchor="t"/>
+          <a:lstStyle/>
+          <a:p>
+            <a:pPr indent="0" marL="0">
+              <a:lnSpc>
+                <a:spcPct val="112000"/>
+              </a:lnSpc>
+              <a:buNone/>
+            </a:pPr>
+            <a:r>
+              <a:rPr lang="en-US" sz="1000" i="1" dirty="0">
+                <a:solidFill>
+                  <a:srgbClr val="000000"/>
+                </a:solidFill>
+                <a:latin typeface="Calibri" pitchFamily="34" charset="0"/>
+                <a:ea typeface="Calibri" pitchFamily="34" charset="-122"/>
+                <a:cs typeface="Calibri" pitchFamily="34" charset="-120"/>
+              </a:rPr>
+              <a:t>“Companies are moving away from regular passwords towards decentralized digital credentials and biometric passkeys, as this would minimize phishing and account hacking.”</a:t>
+            </a:r>
+            <a:endParaRPr lang="en-US" sz="1000" dirty="0"/>
+          </a:p>
+        </p:txBody>
+      </p:sp>
+      <p:sp>
+        <p:nvSpPr>
+          <p:cNvPr id="18" name="Text 16"/>
+          <p:cNvSpPr txBox="1"/>
+          <p:nvPr/>
+        </p:nvSpPr>
+        <p:spPr>
+          <a:xfrm>
+            <a:off x="684886" y="6227064"/>
+            <a:ext cx="5091379" cy="256032"/>
+          </a:xfrm>
+          <a:prstGeom prst="rect">
+            <a:avLst/>
+          </a:prstGeom>
+          <a:noFill/>
+          <a:ln/>
+        </p:spPr>
+        <p:txBody>
+          <a:bodyPr wrap="square" rtlCol="0" anchor="ctr"/>
+          <a:lstStyle/>
+          <a:p>
+            <a:pPr indent="0" marL="0">
+              <a:buNone/>
+            </a:pPr>
+            <a:r>
+              <a:rPr lang="en-US" sz="900" dirty="0">
+                <a:solidFill>
+                  <a:srgbClr val="53565A"/>
+                </a:solidFill>
+                <a:latin typeface="IBM Plex Mono" pitchFamily="34" charset="0"/>
+                <a:ea typeface="IBM Plex Mono" pitchFamily="34" charset="-122"/>
+                <a:cs typeface="IBM Plex Mono" pitchFamily="34" charset="-120"/>
+              </a:rPr>
+              <a:t>Senior Manager · Banking</a:t>
+            </a:r>
+            <a:endParaRPr lang="en-US" sz="900" dirty="0"/>
+          </a:p>
+        </p:txBody>
+      </p:sp>
+      <p:sp>
+        <p:nvSpPr>
+          <p:cNvPr id="19" name="Shape 17"/>
+          <p:cNvSpPr/>
+          <p:nvPr/>
+        </p:nvSpPr>
+        <p:spPr>
+          <a:xfrm>
+            <a:off x="6233465" y="4937760"/>
+            <a:ext cx="5457139" cy="1600200"/>
+          </a:xfrm>
+          <a:prstGeom prst="roundRect">
+            <a:avLst>
+              <a:gd name="adj" fmla="val 2857"/>
+            </a:avLst>
+          </a:prstGeom>
+          <a:solidFill>
+            <a:srgbClr val="FFFFFF"/>
+          </a:solidFill>
+          <a:ln w="9525">
+            <a:solidFill>
+              <a:srgbClr val="D0D0CE"/>
+            </a:solidFill>
+            <a:prstDash val="solid"/>
+          </a:ln>
+        </p:spPr>
+      </p:sp>
+      <p:sp>
+        <p:nvSpPr>
+          <p:cNvPr id="20" name="Text 18"/>
+          <p:cNvSpPr txBox="1"/>
+          <p:nvPr/>
+        </p:nvSpPr>
+        <p:spPr>
+          <a:xfrm>
+            <a:off x="6416345" y="5065776"/>
+            <a:ext cx="5091379" cy="1143000"/>
+          </a:xfrm>
+          <a:prstGeom prst="rect">
+            <a:avLst/>
+          </a:prstGeom>
+          <a:noFill/>
+          <a:ln/>
+        </p:spPr>
+        <p:txBody>
+          <a:bodyPr wrap="square" rtlCol="0" anchor="t"/>
+          <a:lstStyle/>
+          <a:p>
+            <a:pPr indent="0" marL="0">
+              <a:lnSpc>
+                <a:spcPct val="112000"/>
+              </a:lnSpc>
+              <a:buNone/>
+            </a:pPr>
+            <a:r>
+              <a:rPr lang="en-US" sz="1000" i="1" dirty="0">
+                <a:solidFill>
+                  <a:srgbClr val="000000"/>
+                </a:solidFill>
+                <a:latin typeface="Calibri" pitchFamily="34" charset="0"/>
+                <a:ea typeface="Calibri" pitchFamily="34" charset="-122"/>
+                <a:cs typeface="Calibri" pitchFamily="34" charset="-120"/>
+              </a:rPr>
+              <a:t>“AI will shift fraud management from reactive investigation toward more predictive prevention, which should help us identify risks before losses occur.”</a:t>
+            </a:r>
+            <a:endParaRPr lang="en-US" sz="1000" dirty="0"/>
+          </a:p>
+        </p:txBody>
+      </p:sp>
+      <p:sp>
+        <p:nvSpPr>
+          <p:cNvPr id="21" name="Text 19"/>
+          <p:cNvSpPr txBox="1"/>
+          <p:nvPr/>
+        </p:nvSpPr>
+        <p:spPr>
+          <a:xfrm>
+            <a:off x="6416345" y="6227064"/>
+            <a:ext cx="5091379" cy="256032"/>
+          </a:xfrm>
+          <a:prstGeom prst="rect">
+            <a:avLst/>
+          </a:prstGeom>
+          <a:noFill/>
+          <a:ln/>
+        </p:spPr>
+        <p:txBody>
+          <a:bodyPr wrap="square" rtlCol="0" anchor="ctr"/>
+          <a:lstStyle/>
+          <a:p>
+            <a:pPr indent="0" marL="0">
+              <a:buNone/>
+            </a:pPr>
+            <a:r>
+              <a:rPr lang="en-US" sz="900" dirty="0">
+                <a:solidFill>
+                  <a:srgbClr val="53565A"/>
+                </a:solidFill>
+                <a:latin typeface="IBM Plex Mono" pitchFamily="34" charset="0"/>
+                <a:ea typeface="IBM Plex Mono" pitchFamily="34" charset="-122"/>
+                <a:cs typeface="IBM Plex Mono" pitchFamily="34" charset="-120"/>
+              </a:rPr>
+              <a:t>VP · Banking</a:t>
+            </a:r>
+            <a:endParaRPr lang="en-US" sz="900" dirty="0"/>
+          </a:p>
+        </p:txBody>
+      </p:sp>
+    </p:spTree>
+  </p:cSld>
+  <p:clrMapOvr>
+    <a:masterClrMapping/>
+  </p:clrMapOvr>
+</p:sld>
+</file>
+
+<file path=ppt/slides/slide41.xml><?xml version="1.0" encoding="utf-8"?>
+<p:sld xmlns:a="http://schemas.openxmlformats.org/drawingml/2006/main" xmlns:r="http://schemas.openxmlformats.org/officeDocument/2006/relationships" xmlns:p="http://schemas.openxmlformats.org/presentationml/2006/main">
+  <p:cSld name="Slide 41">
     <p:bg>
       <p:bgPr>
         <a:solidFill>

</xml_diff>

<commit_message>
Add region/tier sample sizes to stacked charts; simplify Q-tags
Every stacked bar chart now states the underlying n for each series/
segment (region-only charts already had this; sector x region, sector
x tier, and tier x region charts get a region/tier sample-size
breakdown in the footnote or chart legend). Also drops the "/ newS8"
and "/ S9" suffixes from question tags (e.g. "Q1 / newS8" -> "Q1") —
methodology detail stays in the footnotes where it belongs.

Co-Authored-By: Claude Sonnet 5 <noreply@anthropic.com>
Claude-Session: https://claude.ai/code/session_01F6YKjZtdH33RrHLpCiLALg
</commit_message>
<xml_diff>
--- a/Fraud in 2026 - Full Results.pptx
+++ b/Fraud in 2026 - Full Results.pptx
@@ -4427,7 +4427,7 @@
               <c:strCache>
                 <c:ptCount val="1"/>
                 <c:pt idx="0">
-                  <c:v>Top tier (Top 100 Banking / Top 50 Insurance)</c:v>
+                  <c:v>Top tier (Top 100 Banking n=40 / Top 50 Insurance n=15)</c:v>
                 </c:pt>
               </c:strCache>
             </c:strRef>
@@ -4553,7 +4553,7 @@
               <c:strCache>
                 <c:ptCount val="1"/>
                 <c:pt idx="0">
-                  <c:v>Large institution (outside Top 100 / Top 50)</c:v>
+                  <c:v>Large institution (Banking n=35 / Insurance n=10)</c:v>
                 </c:pt>
               </c:strCache>
             </c:strRef>
@@ -21823,7 +21823,7 @@
         <p:spPr>
           <a:xfrm>
             <a:off x="502006" y="5276088"/>
-            <a:ext cx="11188598" cy="713232"/>
+            <a:ext cx="11188598" cy="804672"/>
           </a:xfrm>
           <a:prstGeom prst="rect">
             <a:avLst/>
@@ -21867,7 +21867,7 @@
                 <a:ea typeface="Calibri" pitchFamily="34" charset="-122"/>
                 <a:cs typeface="Calibri" pitchFamily="34" charset="-120"/>
               </a:rPr>
-              <a:t>The % in each category label is the full sector-level figure; stacked region segments are rounded to the nearest whole percent and may sum to within ±1pt of that total. Banking/Australia (n=7) and Banking/Singapore (n=4) are thin samples shown directionally. Insurance/Europe (n=2, both United Kingdom) and Insurance/Australia (n=1) are extremely thin — each segment reflects just 1–2 respondents — and are shown for completeness, not as statistically reliable estimates. Insurance had zero Singapore respondents, so no segment appears there.</a:t>
+              <a:t>The % in each category label is the full sector-level figure; stacked region segments are rounded to the nearest whole percent and may sum to within ±1pt of that total. Region sample sizes — Banking: US n=34, Canada n=18, Europe n=12, Australia n=7, Singapore n=4. Insurance: US n=10, Canada n=12, Europe n=2 (both United Kingdom), Australia n=1, Singapore n=0. Banking/Australia, Banking/Singapore, and all Insurance cells outside US/Canada are thin samples and should be read directionally, not precisely.</a:t>
             </a:r>
             <a:endParaRPr lang="en-US" sz="850" dirty="0"/>
           </a:p>
@@ -21881,7 +21881,7 @@
         </p:nvSpPr>
         <p:spPr>
           <a:xfrm>
-            <a:off x="502006" y="6007608"/>
+            <a:off x="502006" y="6099048"/>
             <a:ext cx="11188598" cy="320040"/>
           </a:xfrm>
           <a:prstGeom prst="rect">
@@ -24783,7 +24783,7 @@
         <p:spPr>
           <a:xfrm>
             <a:off x="502006" y="5276088"/>
-            <a:ext cx="11188598" cy="566928"/>
+            <a:ext cx="11188598" cy="676656"/>
           </a:xfrm>
           <a:prstGeom prst="rect">
             <a:avLst/>
@@ -24827,7 +24827,7 @@
                 <a:ea typeface="Calibri" pitchFamily="34" charset="-122"/>
                 <a:cs typeface="Calibri" pitchFamily="34" charset="-120"/>
               </a:rPr>
-              <a:t>The % in each category label is the full sector-level figure; stacked region segments are rounded to the nearest whole percent and may sum to within ±1pt of that total. Banking/Australia (n=7) and Banking/Singapore (n=4) are thin samples shown directionally. Insurance/Europe (n=2, both United Kingdom) and Insurance/Australia (n=1) are extremely thin — each segment reflects just 1 respondent — and are shown for completeness, not as statistically reliable estimates. Insurance had zero Singapore respondents, so no segment appears there.</a:t>
+              <a:t>The % in each category label is the full sector-level figure; stacked region segments are rounded to the nearest whole percent and may sum to within ±1pt of that total. Region sample sizes — Banking: US n=34, Canada n=18, Europe n=12, Australia n=7, Singapore n=4. Insurance: US n=10, Canada n=12, Europe n=2 (both United Kingdom), Australia n=1, Singapore n=0. Banking/Australia, Banking/Singapore, and all Insurance cells outside US/Canada are thin samples and should be read directionally, not precisely.</a:t>
             </a:r>
             <a:endParaRPr lang="en-US" sz="850" dirty="0"/>
           </a:p>
@@ -24841,8 +24841,8 @@
         </p:nvSpPr>
         <p:spPr>
           <a:xfrm>
-            <a:off x="502006" y="5861304"/>
-            <a:ext cx="11188598" cy="365760"/>
+            <a:off x="502006" y="5971032"/>
+            <a:ext cx="11188598" cy="438912"/>
           </a:xfrm>
           <a:prstGeom prst="rect">
             <a:avLst/>
@@ -26637,7 +26637,7 @@
                 <a:ea typeface="IBM Plex Mono" pitchFamily="34" charset="-122"/>
                 <a:cs typeface="IBM Plex Mono" pitchFamily="34" charset="-120"/>
               </a:rPr>
-              <a:t>Q1 / newS8 / S9  </a:t>
+              <a:t>Q1  </a:t>
             </a:r>
             <a:pPr algn="l" indent="0" marL="0">
               <a:lnSpc>
@@ -27028,7 +27028,7 @@
                 <a:ea typeface="IBM Plex Mono" pitchFamily="34" charset="-122"/>
                 <a:cs typeface="IBM Plex Mono" pitchFamily="34" charset="-120"/>
               </a:rPr>
-              <a:t>Q1 / newS8  </a:t>
+              <a:t>Q1  </a:t>
             </a:r>
             <a:pPr algn="l" indent="0" marL="0">
               <a:lnSpc>
@@ -27138,7 +27138,7 @@
         <p:spPr>
           <a:xfrm>
             <a:off x="502006" y="5276088"/>
-            <a:ext cx="11188598" cy="566928"/>
+            <a:ext cx="11188598" cy="777240"/>
           </a:xfrm>
           <a:prstGeom prst="rect">
             <a:avLst/>
@@ -27182,7 +27182,7 @@
                 <a:ea typeface="Calibri" pitchFamily="34" charset="-122"/>
                 <a:cs typeface="Calibri" pitchFamily="34" charset="-120"/>
               </a:rPr>
-              <a:t>The % in each category label is the full tier-level figure (Top 100 n=40, Large n=35); region segments are rounded to the nearest whole percent. Australia (n=4 Top 100 / n=3 Large) and Singapore (n=2 / n=2) are thin samples shown directionally. Top 100 includes 5 respondents reclassified from their employer description elsewhere in the survey (see previous slide).</a:t>
+              <a:t>The % in each category label is the full tier-level figure (Top 100 n=40, Large n=35); region segments are rounded to the nearest whole percent. Region sample sizes — Top 100: US n=14, Canada n=13, Europe n=7, Australia n=4, Singapore n=2. Large: US n=20, Canada n=5, Europe n=5, Australia n=3, Singapore n=2. Australia and Singapore are thin samples shown directionally. Top 100 includes 5 respondents reclassified from their employer description elsewhere in the survey (see previous slide).</a:t>
             </a:r>
             <a:endParaRPr lang="en-US" sz="850" dirty="0"/>
           </a:p>
@@ -27196,7 +27196,7 @@
         </p:nvSpPr>
         <p:spPr>
           <a:xfrm>
-            <a:off x="502006" y="5861304"/>
+            <a:off x="502006" y="6071616"/>
             <a:ext cx="11188598" cy="365760"/>
           </a:xfrm>
           <a:prstGeom prst="rect">
@@ -27419,7 +27419,7 @@
                 <a:ea typeface="IBM Plex Mono" pitchFamily="34" charset="-122"/>
                 <a:cs typeface="IBM Plex Mono" pitchFamily="34" charset="-120"/>
               </a:rPr>
-              <a:t>Q1 / S9  </a:t>
+              <a:t>Q1  </a:t>
             </a:r>
             <a:pPr algn="l" indent="0" marL="0">
               <a:lnSpc>
@@ -27529,7 +27529,7 @@
         <p:spPr>
           <a:xfrm>
             <a:off x="502006" y="5276088"/>
-            <a:ext cx="11188598" cy="685800"/>
+            <a:ext cx="11188598" cy="777240"/>
           </a:xfrm>
           <a:prstGeom prst="rect">
             <a:avLst/>
@@ -27543,7 +27543,7 @@
           <a:p>
             <a:pPr algn="l" indent="0" marL="0">
               <a:lnSpc>
-                <a:spcPct val="112000"/>
+                <a:spcPct val="108000"/>
               </a:lnSpc>
               <a:buNone/>
             </a:pPr>
@@ -27560,7 +27560,7 @@
             </a:r>
             <a:pPr algn="l" indent="0" marL="0">
               <a:lnSpc>
-                <a:spcPct val="112000"/>
+                <a:spcPct val="108000"/>
               </a:lnSpc>
               <a:buNone/>
             </a:pPr>
@@ -27573,7 +27573,7 @@
                 <a:ea typeface="Calibri" pitchFamily="34" charset="-122"/>
                 <a:cs typeface="Calibri" pitchFamily="34" charset="-120"/>
               </a:rPr>
-              <a:t>The % in each category label is the full tier-level figure; region segments are rounded to the nearest whole percent. Insurance/Europe (n=1, United Kingdom) and Insurance/Australia (n=1) are extremely thin — each segment reflects a single respondent — and are shown for completeness, not as statistically reliable estimates. Insurance had zero Singapore respondents in either tier, so no segment appears there. Large includes 1 respondent (Canada) reclassified from their employer description elsewhere in the survey (see the sector x tier slide).</a:t>
+              <a:t>The % in each category label is the full tier-level figure; region segments are rounded to the nearest whole percent. Region sample sizes — Top 50: US n=7, Canada n=6, Europe n=1, Australia n=1. Large: US n=3, Canada n=6, Europe n=1 (no Australia; neither tier has Singapore respondents). Europe and Australia cells are extremely thin — each is a single UK/Australian respondent — shown for completeness, not statistical reliability. Large includes 1 respondent (Canada) reclassified from their employer description elsewhere in the survey (see the sector x tier slide).</a:t>
             </a:r>
             <a:endParaRPr lang="en-US" sz="850" dirty="0"/>
           </a:p>
@@ -27587,7 +27587,7 @@
         </p:nvSpPr>
         <p:spPr>
           <a:xfrm>
-            <a:off x="502006" y="6080760"/>
+            <a:off x="502006" y="6071616"/>
             <a:ext cx="11188598" cy="347472"/>
           </a:xfrm>
           <a:prstGeom prst="rect">
@@ -28329,7 +28329,7 @@
                 <a:ea typeface="IBM Plex Mono" pitchFamily="34" charset="-122"/>
                 <a:cs typeface="IBM Plex Mono" pitchFamily="34" charset="-120"/>
               </a:rPr>
-              <a:t>Q8 / Q9 / S9  </a:t>
+              <a:t>Q8 / Q9  </a:t>
             </a:r>
             <a:pPr algn="l" indent="0" marL="0">
               <a:lnSpc>
@@ -28772,7 +28772,7 @@
                 <a:ea typeface="IBM Plex Mono" pitchFamily="34" charset="-122"/>
                 <a:cs typeface="IBM Plex Mono" pitchFamily="34" charset="-120"/>
               </a:rPr>
-              <a:t>Q8 / S9  </a:t>
+              <a:t>Q8  </a:t>
             </a:r>
             <a:pPr algn="l" indent="0" marL="0">
               <a:lnSpc>
@@ -28882,7 +28882,7 @@
         <p:spPr>
           <a:xfrm>
             <a:off x="502006" y="5276088"/>
-            <a:ext cx="11188598" cy="548640"/>
+            <a:ext cx="11188598" cy="777240"/>
           </a:xfrm>
           <a:prstGeom prst="rect">
             <a:avLst/>
@@ -28896,7 +28896,7 @@
           <a:p>
             <a:pPr algn="l" indent="0" marL="0">
               <a:lnSpc>
-                <a:spcPct val="115000"/>
+                <a:spcPct val="110000"/>
               </a:lnSpc>
               <a:buNone/>
             </a:pPr>
@@ -28913,7 +28913,7 @@
             </a:r>
             <a:pPr algn="l" indent="0" marL="0">
               <a:lnSpc>
-                <a:spcPct val="115000"/>
+                <a:spcPct val="110000"/>
               </a:lnSpc>
               <a:buNone/>
             </a:pPr>
@@ -28926,7 +28926,7 @@
                 <a:ea typeface="Calibri" pitchFamily="34" charset="-122"/>
                 <a:cs typeface="Calibri" pitchFamily="34" charset="-120"/>
               </a:rPr>
-              <a:t>The % in each category label is the full tier-level figure; region segments are rounded to the nearest whole percent and may not sum exactly due to rounding. Every regional cell here is thin (n=1–7) and should be read directionally. Insurance had zero Singapore respondents in either tier, so no segment appears there.</a:t>
+              <a:t>The % in each category label is the full tier-level figure; region segments are rounded to the nearest whole percent and may not sum exactly due to rounding. Region sample sizes — Top 50: US n=7, Canada n=6, Europe n=1, Australia n=1. Large: US n=3, Canada n=6, Europe n=1 (no Australia; neither tier has Singapore respondents). Every regional cell here is thin (n=1–7) and should be read directionally.</a:t>
             </a:r>
             <a:endParaRPr lang="en-US" sz="850" dirty="0"/>
           </a:p>
@@ -28940,7 +28940,7 @@
         </p:nvSpPr>
         <p:spPr>
           <a:xfrm>
-            <a:off x="502006" y="5861304"/>
+            <a:off x="502006" y="6071616"/>
             <a:ext cx="11188598" cy="420624"/>
           </a:xfrm>
           <a:prstGeom prst="rect">
@@ -29163,7 +29163,7 @@
                 <a:ea typeface="IBM Plex Mono" pitchFamily="34" charset="-122"/>
                 <a:cs typeface="IBM Plex Mono" pitchFamily="34" charset="-120"/>
               </a:rPr>
-              <a:t>Q9 / S9  </a:t>
+              <a:t>Q9  </a:t>
             </a:r>
             <a:pPr algn="l" indent="0" marL="0">
               <a:lnSpc>
@@ -29273,7 +29273,7 @@
         <p:spPr>
           <a:xfrm>
             <a:off x="502006" y="5276088"/>
-            <a:ext cx="11188598" cy="548640"/>
+            <a:ext cx="11188598" cy="777240"/>
           </a:xfrm>
           <a:prstGeom prst="rect">
             <a:avLst/>
@@ -29287,7 +29287,7 @@
           <a:p>
             <a:pPr algn="l" indent="0" marL="0">
               <a:lnSpc>
-                <a:spcPct val="115000"/>
+                <a:spcPct val="110000"/>
               </a:lnSpc>
               <a:buNone/>
             </a:pPr>
@@ -29304,7 +29304,7 @@
             </a:r>
             <a:pPr algn="l" indent="0" marL="0">
               <a:lnSpc>
-                <a:spcPct val="115000"/>
+                <a:spcPct val="110000"/>
               </a:lnSpc>
               <a:buNone/>
             </a:pPr>
@@ -29317,7 +29317,7 @@
                 <a:ea typeface="Calibri" pitchFamily="34" charset="-122"/>
                 <a:cs typeface="Calibri" pitchFamily="34" charset="-120"/>
               </a:rPr>
-              <a:t>The % in each category label is the full tier-level figure; region segments are rounded to the nearest whole percent and may not sum exactly due to rounding. Every regional cell here is thin (n=1–7) and should be read directionally. Insurance had zero Singapore respondents in either tier, so no segment appears there.</a:t>
+              <a:t>The % in each category label is the full tier-level figure; region segments are rounded to the nearest whole percent and may not sum exactly due to rounding. Region sample sizes — Top 50: US n=7, Canada n=6, Europe n=1, Australia n=1. Large: US n=3, Canada n=6, Europe n=1 (no Australia; neither tier has Singapore respondents). Every regional cell here is thin (n=1–7) and should be read directionally.</a:t>
             </a:r>
             <a:endParaRPr lang="en-US" sz="850" dirty="0"/>
           </a:p>
@@ -29331,7 +29331,7 @@
         </p:nvSpPr>
         <p:spPr>
           <a:xfrm>
-            <a:off x="502006" y="5861304"/>
+            <a:off x="502006" y="6071616"/>
             <a:ext cx="11188598" cy="420624"/>
           </a:xfrm>
           <a:prstGeom prst="rect">
@@ -29554,7 +29554,7 @@
                 <a:ea typeface="IBM Plex Mono" pitchFamily="34" charset="-122"/>
                 <a:cs typeface="IBM Plex Mono" pitchFamily="34" charset="-120"/>
               </a:rPr>
-              <a:t>Q8 / Q9 / newS8  </a:t>
+              <a:t>Q8 / Q9  </a:t>
             </a:r>
             <a:pPr algn="l" indent="0" marL="0">
               <a:lnSpc>
@@ -30679,7 +30679,7 @@
                 <a:ea typeface="IBM Plex Mono" pitchFamily="34" charset="-122"/>
                 <a:cs typeface="IBM Plex Mono" pitchFamily="34" charset="-120"/>
               </a:rPr>
-              <a:t>Q8 / newS8  </a:t>
+              <a:t>Q8  </a:t>
             </a:r>
             <a:pPr algn="l" indent="0" marL="0">
               <a:lnSpc>
@@ -30789,7 +30789,7 @@
         <p:spPr>
           <a:xfrm>
             <a:off x="502006" y="5276088"/>
-            <a:ext cx="11188598" cy="548640"/>
+            <a:ext cx="11188598" cy="777240"/>
           </a:xfrm>
           <a:prstGeom prst="rect">
             <a:avLst/>
@@ -30803,7 +30803,7 @@
           <a:p>
             <a:pPr algn="l" indent="0" marL="0">
               <a:lnSpc>
-                <a:spcPct val="115000"/>
+                <a:spcPct val="110000"/>
               </a:lnSpc>
               <a:buNone/>
             </a:pPr>
@@ -30820,7 +30820,7 @@
             </a:r>
             <a:pPr algn="l" indent="0" marL="0">
               <a:lnSpc>
-                <a:spcPct val="115000"/>
+                <a:spcPct val="110000"/>
               </a:lnSpc>
               <a:buNone/>
             </a:pPr>
@@ -30833,7 +30833,7 @@
                 <a:ea typeface="Calibri" pitchFamily="34" charset="-122"/>
                 <a:cs typeface="Calibri" pitchFamily="34" charset="-120"/>
               </a:rPr>
-              <a:t>The % in each category label is the full tier-level figure; region segments are rounded to the nearest whole percent and may not sum exactly due to rounding. Australia (n=4 Top 100 / n=3 Large) and Singapore (n=2 / n=2) are thin samples shown directionally.</a:t>
+              <a:t>The % in each category label is the full tier-level figure; region segments are rounded to the nearest whole percent and may not sum exactly due to rounding. Region sample sizes — Top 100: US n=14, Canada n=13, Europe n=7, Australia n=4, Singapore n=2. Large: US n=20, Canada n=5, Europe n=5, Australia n=3, Singapore n=2. Australia and Singapore are thin samples shown directionally.</a:t>
             </a:r>
             <a:endParaRPr lang="en-US" sz="850" dirty="0"/>
           </a:p>
@@ -30847,7 +30847,7 @@
         </p:nvSpPr>
         <p:spPr>
           <a:xfrm>
-            <a:off x="502006" y="5861304"/>
+            <a:off x="502006" y="6071616"/>
             <a:ext cx="11188598" cy="420624"/>
           </a:xfrm>
           <a:prstGeom prst="rect">
@@ -31070,7 +31070,7 @@
                 <a:ea typeface="IBM Plex Mono" pitchFamily="34" charset="-122"/>
                 <a:cs typeface="IBM Plex Mono" pitchFamily="34" charset="-120"/>
               </a:rPr>
-              <a:t>Q9 / newS8  </a:t>
+              <a:t>Q9  </a:t>
             </a:r>
             <a:pPr algn="l" indent="0" marL="0">
               <a:lnSpc>
@@ -31180,7 +31180,7 @@
         <p:spPr>
           <a:xfrm>
             <a:off x="502006" y="5276088"/>
-            <a:ext cx="11188598" cy="548640"/>
+            <a:ext cx="11188598" cy="777240"/>
           </a:xfrm>
           <a:prstGeom prst="rect">
             <a:avLst/>
@@ -31194,7 +31194,7 @@
           <a:p>
             <a:pPr algn="l" indent="0" marL="0">
               <a:lnSpc>
-                <a:spcPct val="115000"/>
+                <a:spcPct val="110000"/>
               </a:lnSpc>
               <a:buNone/>
             </a:pPr>
@@ -31211,7 +31211,7 @@
             </a:r>
             <a:pPr algn="l" indent="0" marL="0">
               <a:lnSpc>
-                <a:spcPct val="115000"/>
+                <a:spcPct val="110000"/>
               </a:lnSpc>
               <a:buNone/>
             </a:pPr>
@@ -31224,7 +31224,7 @@
                 <a:ea typeface="Calibri" pitchFamily="34" charset="-122"/>
                 <a:cs typeface="Calibri" pitchFamily="34" charset="-120"/>
               </a:rPr>
-              <a:t>The % in each category label is the full tier-level figure; region segments are rounded to the nearest whole percent and may not sum exactly due to rounding. Australia (n=4 Top 100 / n=3 Large) and Singapore (n=2 / n=2) are thin samples shown directionally.</a:t>
+              <a:t>The % in each category label is the full tier-level figure; region segments are rounded to the nearest whole percent and may not sum exactly due to rounding. Region sample sizes — Top 100: US n=14, Canada n=13, Europe n=7, Australia n=4, Singapore n=2. Large: US n=20, Canada n=5, Europe n=5, Australia n=3, Singapore n=2. Australia and Singapore are thin samples shown directionally.</a:t>
             </a:r>
             <a:endParaRPr lang="en-US" sz="850" dirty="0"/>
           </a:p>
@@ -31238,7 +31238,7 @@
         </p:nvSpPr>
         <p:spPr>
           <a:xfrm>
-            <a:off x="502006" y="5861304"/>
+            <a:off x="502006" y="6071616"/>
             <a:ext cx="11188598" cy="420624"/>
           </a:xfrm>
           <a:prstGeom prst="rect">
@@ -32447,7 +32447,7 @@
                 <a:ea typeface="IBM Plex Mono" pitchFamily="34" charset="-122"/>
                 <a:cs typeface="IBM Plex Mono" pitchFamily="34" charset="-120"/>
               </a:rPr>
-              <a:t>Q10 / S9  </a:t>
+              <a:t>Q10  </a:t>
             </a:r>
             <a:pPr algn="l" indent="0" marL="0">
               <a:lnSpc>
@@ -32864,7 +32864,7 @@
                 <a:ea typeface="IBM Plex Mono" pitchFamily="34" charset="-122"/>
                 <a:cs typeface="IBM Plex Mono" pitchFamily="34" charset="-120"/>
               </a:rPr>
-              <a:t>Q10 / newS8  </a:t>
+              <a:t>Q10  </a:t>
             </a:r>
             <a:pPr algn="l" indent="0" marL="0">
               <a:lnSpc>
@@ -37588,7 +37588,7 @@
         <p:spPr>
           <a:xfrm>
             <a:off x="502006" y="5276088"/>
-            <a:ext cx="11188598" cy="566928"/>
+            <a:ext cx="11188598" cy="676656"/>
           </a:xfrm>
           <a:prstGeom prst="rect">
             <a:avLst/>
@@ -37602,7 +37602,7 @@
           <a:p>
             <a:pPr algn="l" indent="0" marL="0">
               <a:lnSpc>
-                <a:spcPct val="118000"/>
+                <a:spcPct val="115000"/>
               </a:lnSpc>
               <a:buNone/>
             </a:pPr>
@@ -37619,7 +37619,7 @@
             </a:r>
             <a:pPr algn="l" indent="0" marL="0">
               <a:lnSpc>
-                <a:spcPct val="118000"/>
+                <a:spcPct val="115000"/>
               </a:lnSpc>
               <a:buNone/>
             </a:pPr>
@@ -37632,7 +37632,7 @@
                 <a:ea typeface="Calibri" pitchFamily="34" charset="-122"/>
                 <a:cs typeface="Calibri" pitchFamily="34" charset="-120"/>
               </a:rPr>
-              <a:t>The % in each category label is the full sector-level figure; stacked region segments are rounded to the nearest whole percent and may sum to within ±1pt of that total. Banking/Australia (n=7) and Banking/Singapore (n=4) are thin samples shown directionally. Insurance/Europe (n=2, both United Kingdom) and Insurance/Australia (n=1) are extremely thin — each segment reflects just 1–2 respondents — and are shown for completeness, not as statistically reliable estimates. Insurance had zero Singapore respondents, so no segment appears there.</a:t>
+              <a:t>The % in each category label is the full sector-level figure; stacked region segments are rounded to the nearest whole percent and may sum to within ±1pt of that total. Region sample sizes — Banking: US n=34, Canada n=18, Europe n=12, Australia n=7, Singapore n=4. Insurance: US n=10, Canada n=12, Europe n=2 (both United Kingdom), Australia n=1, Singapore n=0. Banking/Australia, Banking/Singapore, and all Insurance cells outside US/Canada are thin samples and should be read directionally, not precisely.</a:t>
             </a:r>
             <a:endParaRPr lang="en-US" sz="850" dirty="0"/>
           </a:p>
@@ -37646,7 +37646,7 @@
         </p:nvSpPr>
         <p:spPr>
           <a:xfrm>
-            <a:off x="502006" y="5897880"/>
+            <a:off x="502006" y="5989320"/>
             <a:ext cx="11188598" cy="320040"/>
           </a:xfrm>
           <a:prstGeom prst="rect">

</xml_diff>